<commit_message>
Fill in sourced demand and pipeline figures
Co-Authored-By: Claude Sonnet 5.5 <noreply@anthropic.com>
Claude-Session: https://claude.ai/code/session_015HKS2PnjCizKc2aENrrpqs
</commit_message>
<xml_diff>
--- a/presentations/Anixter_PowerGen_Presentation_DRAFT.pptx
+++ b/presentations/Anixter_PowerGen_Presentation_DRAFT.pptx
@@ -3200,7 +3200,7 @@
                 <a:ea typeface="Cambria" pitchFamily="34" charset="-122"/>
                 <a:cs typeface="Cambria" pitchFamily="34" charset="-120"/>
               </a:rPr>
-              <a:t>Power demand is set to climb for 15 years</a:t>
+              <a:t>US power demand is climbing, and gas is answering</a:t>
             </a:r>
             <a:endParaRPr lang="en-US" sz="3200" dirty="0"/>
           </a:p>
@@ -3271,7 +3271,7 @@
                 <a:ea typeface="Cambria" pitchFamily="34" charset="-122"/>
                 <a:cs typeface="Cambria" pitchFamily="34" charset="-120"/>
               </a:rPr>
-              <a:t>[XX] GW</a:t>
+              <a:t>~166 GW</a:t>
             </a:r>
             <a:endParaRPr lang="en-US" sz="4000" dirty="0"/>
           </a:p>
@@ -3310,7 +3310,7 @@
                 <a:ea typeface="Calibri" pitchFamily="34" charset="-122"/>
                 <a:cs typeface="Calibri" pitchFamily="34" charset="-120"/>
               </a:rPr>
-              <a:t>Forecast added US generation demand by 2040</a:t>
+              <a:t>Forecast US peak load growth by 2030</a:t>
             </a:r>
             <a:endParaRPr lang="en-US" sz="1300" dirty="0"/>
           </a:p>
@@ -3381,7 +3381,7 @@
                 <a:ea typeface="Cambria" pitchFamily="34" charset="-122"/>
                 <a:cs typeface="Cambria" pitchFamily="34" charset="-120"/>
               </a:rPr>
-              <a:t>[XX]%</a:t>
+              <a:t>~90 GW</a:t>
             </a:r>
             <a:endParaRPr lang="en-US" sz="4000" dirty="0"/>
           </a:p>
@@ -3420,7 +3420,7 @@
                 <a:ea typeface="Calibri" pitchFamily="34" charset="-122"/>
                 <a:cs typeface="Calibri" pitchFamily="34" charset="-120"/>
               </a:rPr>
-              <a:t>Share of growth from data centers</a:t>
+              <a:t>Of that growth tied to data centers</a:t>
             </a:r>
             <a:endParaRPr lang="en-US" sz="1300" dirty="0"/>
           </a:p>
@@ -3491,7 +3491,7 @@
                 <a:ea typeface="Cambria" pitchFamily="34" charset="-122"/>
                 <a:cs typeface="Cambria" pitchFamily="34" charset="-120"/>
               </a:rPr>
-              <a:t>[XX] yrs</a:t>
+              <a:t>3+ yrs</a:t>
             </a:r>
             <a:endParaRPr lang="en-US" sz="4000" dirty="0"/>
           </a:p>
@@ -3530,7 +3530,7 @@
                 <a:ea typeface="Calibri" pitchFamily="34" charset="-122"/>
                 <a:cs typeface="Calibri" pitchFamily="34" charset="-120"/>
               </a:rPr>
-              <a:t>Typical gas plant lead time to COD</a:t>
+              <a:t>Gas turbine lead time; OEM backlogs run ~5 yrs</a:t>
             </a:r>
             <a:endParaRPr lang="en-US" sz="1300" dirty="0"/>
           </a:p>
@@ -3584,7 +3584,7 @@
         <p:spPr>
           <a:xfrm>
             <a:off x="457200" y="3474720"/>
-            <a:ext cx="8229600" cy="1097280"/>
+            <a:ext cx="8229600" cy="914400"/>
           </a:xfrm>
           <a:prstGeom prst="rect">
             <a:avLst/>
@@ -3668,8 +3668,8 @@
         </p:nvSpPr>
         <p:spPr>
           <a:xfrm>
-            <a:off x="457200" y="4754880"/>
-            <a:ext cx="5486400" cy="228600"/>
+            <a:off x="457200" y="4434840"/>
+            <a:ext cx="8229600" cy="274320"/>
           </a:xfrm>
           <a:prstGeom prst="rect">
             <a:avLst/>
@@ -3685,7 +3685,7 @@
               <a:buNone/>
             </a:pPr>
             <a:r>
-              <a:rPr lang="en-US" sz="1000" dirty="0">
+              <a:rPr lang="en-US" sz="900" dirty="0">
                 <a:solidFill>
                   <a:srgbClr val="5B6B7F"/>
                 </a:solidFill>
@@ -3693,6 +3693,45 @@
                 <a:ea typeface="Calibri" pitchFamily="34" charset="-122"/>
                 <a:cs typeface="Calibri" pitchFamily="34" charset="-120"/>
               </a:rPr>
+              <a:t>Sources: Grid Strategies National Load Growth Report 2025 (utility forecasts; analysts see data center growth nearer 65 GW); OEM backlog reports, 2026.</a:t>
+            </a:r>
+            <a:endParaRPr lang="en-US" sz="900" dirty="0"/>
+          </a:p>
+        </p:txBody>
+      </p:sp>
+      <p:sp>
+        <p:nvSpPr>
+          <p:cNvPr id="15" name="Text 13"/>
+          <p:cNvSpPr txBox="1"/>
+          <p:nvPr/>
+        </p:nvSpPr>
+        <p:spPr>
+          <a:xfrm>
+            <a:off x="457200" y="4754880"/>
+            <a:ext cx="5486400" cy="228600"/>
+          </a:xfrm>
+          <a:prstGeom prst="rect">
+            <a:avLst/>
+          </a:prstGeom>
+          <a:noFill/>
+          <a:ln/>
+        </p:spPr>
+        <p:txBody>
+          <a:bodyPr wrap="square" lIns="0" tIns="0" rIns="0" bIns="0" rtlCol="0" anchor="ctr"/>
+          <a:lstStyle/>
+          <a:p>
+            <a:pPr indent="0" marL="0">
+              <a:buNone/>
+            </a:pPr>
+            <a:r>
+              <a:rPr lang="en-US" sz="1000" dirty="0">
+                <a:solidFill>
+                  <a:srgbClr val="5B6B7F"/>
+                </a:solidFill>
+                <a:latin typeface="Calibri" pitchFamily="34" charset="0"/>
+                <a:ea typeface="Calibri" pitchFamily="34" charset="-122"/>
+                <a:cs typeface="Calibri" pitchFamily="34" charset="-120"/>
+              </a:rPr>
               <a:t>Southwire PowerGen  |  Anixter Global Accounts</a:t>
             </a:r>
             <a:endParaRPr lang="en-US" sz="1000" dirty="0"/>
@@ -3701,7 +3740,7 @@
       </p:sp>
       <p:sp>
         <p:nvSpPr>
-          <p:cNvPr id="15" name="Text 13"/>
+          <p:cNvPr id="16" name="Text 14"/>
           <p:cNvSpPr txBox="1"/>
           <p:nvPr/>
         </p:nvSpPr>
@@ -4864,7 +4903,7 @@
                 <a:ea typeface="Calibri" pitchFamily="34" charset="-122"/>
                 <a:cs typeface="Calibri" pitchFamily="34" charset="-120"/>
               </a:rPr>
-              <a:t>Projects in queue: [XX]</a:t>
+              <a:t>In development: ~378 GW</a:t>
             </a:r>
             <a:endParaRPr lang="en-US" sz="1300" dirty="0"/>
           </a:p>
@@ -4885,7 +4924,7 @@
                 <a:ea typeface="Calibri" pitchFamily="34" charset="-122"/>
                 <a:cs typeface="Calibri" pitchFamily="34" charset="-120"/>
               </a:rPr>
-              <a:t>Capacity: [XX] GW</a:t>
+              <a:t>Under construction: ~52 GW</a:t>
             </a:r>
             <a:endParaRPr lang="en-US" sz="1300" dirty="0"/>
           </a:p>
@@ -4906,7 +4945,7 @@
                 <a:ea typeface="Calibri" pitchFamily="34" charset="-122"/>
                 <a:cs typeface="Calibri" pitchFamily="34" charset="-120"/>
               </a:rPr>
-              <a:t>Est. wire &amp; cable market: $[XX]M</a:t>
+              <a:t>Tied to data centers: ~189 GW</a:t>
             </a:r>
             <a:endParaRPr lang="en-US" sz="1300" dirty="0"/>
           </a:p>
@@ -5438,8 +5477,8 @@
         </p:nvSpPr>
         <p:spPr>
           <a:xfrm>
-            <a:off x="457200" y="4754880"/>
-            <a:ext cx="5486400" cy="228600"/>
+            <a:off x="457200" y="4526280"/>
+            <a:ext cx="8229600" cy="201168"/>
           </a:xfrm>
           <a:prstGeom prst="rect">
             <a:avLst/>
@@ -5455,7 +5494,7 @@
               <a:buNone/>
             </a:pPr>
             <a:r>
-              <a:rPr lang="en-US" sz="1000" dirty="0">
+              <a:rPr lang="en-US" sz="900" dirty="0">
                 <a:solidFill>
                   <a:srgbClr val="5B6B7F"/>
                 </a:solidFill>
@@ -5463,6 +5502,45 @@
                 <a:ea typeface="Calibri" pitchFamily="34" charset="-122"/>
                 <a:cs typeface="Calibri" pitchFamily="34" charset="-120"/>
               </a:rPr>
+              <a:t>Sources: Global Energy Monitor, US gas plant tracker, H1 2026 (announced, pre-construction and construction phases). Wire &amp; cable $ sizing: Southwire estimate needed.</a:t>
+            </a:r>
+            <a:endParaRPr lang="en-US" sz="900" dirty="0"/>
+          </a:p>
+        </p:txBody>
+      </p:sp>
+      <p:sp>
+        <p:nvSpPr>
+          <p:cNvPr id="22" name="Text 20"/>
+          <p:cNvSpPr txBox="1"/>
+          <p:nvPr/>
+        </p:nvSpPr>
+        <p:spPr>
+          <a:xfrm>
+            <a:off x="457200" y="4754880"/>
+            <a:ext cx="5486400" cy="228600"/>
+          </a:xfrm>
+          <a:prstGeom prst="rect">
+            <a:avLst/>
+          </a:prstGeom>
+          <a:noFill/>
+          <a:ln/>
+        </p:spPr>
+        <p:txBody>
+          <a:bodyPr wrap="square" lIns="0" tIns="0" rIns="0" bIns="0" rtlCol="0" anchor="ctr"/>
+          <a:lstStyle/>
+          <a:p>
+            <a:pPr indent="0" marL="0">
+              <a:buNone/>
+            </a:pPr>
+            <a:r>
+              <a:rPr lang="en-US" sz="1000" dirty="0">
+                <a:solidFill>
+                  <a:srgbClr val="5B6B7F"/>
+                </a:solidFill>
+                <a:latin typeface="Calibri" pitchFamily="34" charset="0"/>
+                <a:ea typeface="Calibri" pitchFamily="34" charset="-122"/>
+                <a:cs typeface="Calibri" pitchFamily="34" charset="-120"/>
+              </a:rPr>
               <a:t>Southwire PowerGen  |  Anixter Global Accounts</a:t>
             </a:r>
             <a:endParaRPr lang="en-US" sz="1000" dirty="0"/>
@@ -5471,7 +5549,7 @@
       </p:sp>
       <p:sp>
         <p:nvSpPr>
-          <p:cNvPr id="22" name="Text 20"/>
+          <p:cNvPr id="23" name="Text 21"/>
           <p:cNvSpPr txBox="1"/>
           <p:nvPr/>
         </p:nvSpPr>

</xml_diff>

<commit_message>
Complete deck: plant schematic, OEM backlog chart, pipeline and product slides
Co-Authored-By: Claude Sonnet 5.5 <noreply@anthropic.com>
Claude-Session: https://claude.ai/code/session_015HKS2PnjCizKc2aENrrpqs
</commit_message>
<xml_diff>
--- a/presentations/Anixter_PowerGen_Presentation_DRAFT.pptx
+++ b/presentations/Anixter_PowerGen_Presentation_DRAFT.pptx
@@ -114,6 +114,237 @@
     </a:lvl9pPr>
   </p:defaultTextStyle>
 </p:presentation>
+</file>
+
+<file path=ppt/charts/chart1.xml><?xml version="1.0" encoding="utf-8"?>
+<c:chartSpace xmlns:c="http://schemas.openxmlformats.org/drawingml/2006/chart" xmlns:a="http://schemas.openxmlformats.org/drawingml/2006/main" xmlns:r="http://schemas.openxmlformats.org/officeDocument/2006/relationships">
+  <c:date1904 val="0"/>
+  <c:roundedCorners val="1"/>
+  <c:chart>
+    <c:autoTitleDeleted val="1"/>
+    <c:plotArea>
+      <c:layout/>
+      <c:barChart>
+        <c:barDir val="bar"/>
+        <c:grouping val="clustered"/>
+        <c:varyColors val="0"/>
+        <c:ser>
+          <c:idx val="0"/>
+          <c:order val="0"/>
+          <c:tx>
+            <c:strRef>
+              <c:f>Sheet1!$B$1</c:f>
+              <c:strCache>
+                <c:ptCount val="1"/>
+                <c:pt idx="0">
+                  <c:v>Backlog (GW)</c:v>
+                </c:pt>
+              </c:strCache>
+            </c:strRef>
+          </c:tx>
+          <c:spPr>
+            <a:solidFill>
+              <a:srgbClr val="C8742B"/>
+            </a:solidFill>
+            <a:effectLst/>
+          </c:spPr>
+          <c:invertIfNegative val="0"/>
+          <c:dLbls>
+            <c:numFmt formatCode="#,##0" sourceLinked="0"/>
+            <c:txPr>
+              <a:bodyPr/>
+              <a:lstStyle/>
+              <a:p>
+                <a:pPr>
+                  <a:defRPr b="0" i="0" strike="noStrike" sz="1200" u="none">
+                    <a:solidFill>
+                      <a:srgbClr val="1B2735"/>
+                    </a:solidFill>
+                    <a:latin typeface="Calibri"/>
+                  </a:defRPr>
+                </a:pPr>
+              </a:p>
+            </c:txPr>
+            <c:showLegendKey val="0"/>
+            <c:showVal val="1"/>
+            <c:showCatName val="0"/>
+            <c:showSerName val="0"/>
+            <c:showPercent val="0"/>
+            <c:showBubbleSize val="0"/>
+            <c:showLeaderLines val="0"/>
+          </c:dLbls>
+          <c:cat>
+            <c:multiLvlStrRef>
+              <c:f>Sheet1!$A$2:$A$4</c:f>
+              <c:multiLvlStrCache>
+                <c:ptCount val="3"/>
+                <c:lvl>
+                  <c:pt idx="0">
+                    <c:v>GE Vernova</c:v>
+                  </c:pt>
+                  <c:pt idx="1">
+                    <c:v>Siemens Energy</c:v>
+                  </c:pt>
+                  <c:pt idx="2">
+                    <c:v>Mitsubishi Heavy</c:v>
+                  </c:pt>
+                </c:lvl>
+              </c:multiLvlStrCache>
+            </c:multiLvlStrRef>
+          </c:cat>
+          <c:val>
+            <c:numRef>
+              <c:f>Sheet1!$B$2:$B$4</c:f>
+              <c:numCache>
+                <c:formatCode>General</c:formatCode>
+                <c:ptCount val="3"/>
+                <c:pt idx="0">
+                  <c:v>116</c:v>
+                </c:pt>
+                <c:pt idx="1">
+                  <c:v>69</c:v>
+                </c:pt>
+                <c:pt idx="2">
+                  <c:v>35</c:v>
+                </c:pt>
+              </c:numCache>
+            </c:numRef>
+          </c:val>
+        </c:ser>
+        <c:dLbls>
+          <c:numFmt formatCode="#,##0" sourceLinked="0"/>
+          <c:txPr>
+            <a:bodyPr/>
+            <a:lstStyle/>
+            <a:p>
+              <a:pPr>
+                <a:defRPr b="0" i="0" strike="noStrike" sz="1200" u="none">
+                  <a:solidFill>
+                    <a:srgbClr val="1B2735"/>
+                  </a:solidFill>
+                  <a:latin typeface="Calibri"/>
+                </a:defRPr>
+              </a:pPr>
+            </a:p>
+          </c:txPr>
+          <c:showLegendKey val="0"/>
+          <c:showVal val="1"/>
+          <c:showCatName val="0"/>
+          <c:showSerName val="0"/>
+          <c:showPercent val="0"/>
+          <c:showBubbleSize val="0"/>
+          <c:showLeaderLines val="0"/>
+        </c:dLbls>
+        <c:gapWidth val="150"/>
+        <c:overlap val="0"/>
+        <c:axId val="2094734554"/>
+        <c:axId val="2094734552"/>
+        <c:axId val="2094734556"/>
+      </c:barChart>
+      <c:catAx>
+        <c:axId val="2094734554"/>
+        <c:scaling>
+          <c:orientation val="maxMin"/>
+        </c:scaling>
+        <c:delete val="0"/>
+        <c:axPos val="l"/>
+        <c:numFmt formatCode="General" sourceLinked="1"/>
+        <c:majorTickMark val="out"/>
+        <c:minorTickMark val="none"/>
+        <c:tickLblPos val="nextTo"/>
+        <c:spPr>
+          <a:ln w="12700" cap="flat">
+            <a:solidFill>
+              <a:srgbClr val="888888"/>
+            </a:solidFill>
+            <a:prstDash val="solid"/>
+            <a:round/>
+          </a:ln>
+        </c:spPr>
+        <c:txPr>
+          <a:bodyPr/>
+          <a:lstStyle/>
+          <a:p>
+            <a:pPr>
+              <a:defRPr sz="1200" b="0" i="0" u="none" strike="noStrike">
+                <a:solidFill>
+                  <a:srgbClr val="1B2735"/>
+                </a:solidFill>
+                <a:latin typeface="Calibri"/>
+              </a:defRPr>
+            </a:pPr>
+            <a:endParaRPr lang="en-US"/>
+          </a:p>
+        </c:txPr>
+        <c:crossAx val="2094734552"/>
+        <c:crosses val="autoZero"/>
+        <c:auto val="1"/>
+        <c:lblAlgn val="ctr"/>
+        <c:noMultiLvlLbl val="1"/>
+      </c:catAx>
+      <c:valAx>
+        <c:axId val="2094734552"/>
+        <c:scaling>
+          <c:orientation val="minMax"/>
+          <c:max val="140"/>
+          <c:min val="0"/>
+        </c:scaling>
+        <c:delete val="1"/>
+        <c:axPos val="b"/>
+        <c:numFmt formatCode="General" sourceLinked="0"/>
+        <c:majorTickMark val="out"/>
+        <c:minorTickMark val="none"/>
+        <c:tickLblPos val="low"/>
+        <c:spPr>
+          <a:ln w="12700" cap="flat">
+            <a:solidFill>
+              <a:srgbClr val="888888"/>
+            </a:solidFill>
+            <a:prstDash val="solid"/>
+            <a:round/>
+          </a:ln>
+        </c:spPr>
+        <c:txPr>
+          <a:bodyPr/>
+          <a:lstStyle/>
+          <a:p>
+            <a:pPr>
+              <a:defRPr sz="1200" b="0" i="0" u="none" strike="noStrike">
+                <a:solidFill>
+                  <a:srgbClr val="000000"/>
+                </a:solidFill>
+                <a:latin typeface="Arial"/>
+              </a:defRPr>
+            </a:pPr>
+            <a:endParaRPr lang="en-US"/>
+          </a:p>
+        </c:txPr>
+        <c:crossAx val="2094734554"/>
+        <c:crosses val="autoZero"/>
+        <c:crossBetween val="between"/>
+      </c:valAx>
+      <c:spPr>
+        <a:noFill/>
+        <a:ln>
+          <a:noFill/>
+        </a:ln>
+        <a:effectLst/>
+      </c:spPr>
+    </c:plotArea>
+    <c:plotVisOnly val="1"/>
+    <c:dispBlanksAs val="span"/>
+  </c:chart>
+  <c:spPr>
+    <a:noFill/>
+    <a:ln>
+      <a:noFill/>
+    </a:ln>
+    <a:effectLst/>
+  </c:spPr>
+  <c:externalData r:id="rId1">
+    <c:autoUpdate val="0"/>
+  </c:externalData>
+</c:chartSpace>
 </file>
 
 <file path=ppt/notesMasters/notesMaster1.xml><?xml version="1.0" encoding="utf-8"?>
@@ -1039,7 +1270,7 @@
           <a:p>
             <a:r>
               <a:rPr lang="en-US" dirty="0"/>
-              <a:t>Replace this grid with a plant schematic graphic (new slide needed). Zone names and product mapping are draft: confirm with product team. Click through each callout.</a:t>
+              <a:t>Walk the plant left to right: fuel gas, gas turbine and generator, HRSG and steam turbine, then step-up transformer and switchyard to the grid. Numbered callouts are the cable applications, and match the product line card on the next slide. Schematic is a simplified combined-cycle plant. Confirm product mapping with the product team.</a:t>
             </a:r>
             <a:endParaRPr lang="en-US" dirty="0"/>
           </a:p>
@@ -1215,7 +1446,7 @@
           <a:p>
             <a:r>
               <a:rPr lang="en-US" dirty="0"/>
-              <a:t>Pull from the OEM equipment and plant zones work. The EPC column is an addition Marc did not list: cut it if it distracts.</a:t>
+              <a:t>Backlogs: GE Vernova 116 GW (June 2026), Siemens Energy 69 GW (June 30), Mitsubishi Heavy 35 GW large-frame (Aug 6). Behind-the-meter figure is from Cleanview via press. Verify before presenting.</a:t>
             </a:r>
             <a:endParaRPr lang="en-US" dirty="0"/>
           </a:p>
@@ -1999,7 +2230,7 @@
               <a:buNone/>
             </a:pPr>
             <a:r>
-              <a:rPr lang="en-US" sz="3200" b="1" dirty="0">
+              <a:rPr lang="en-US" sz="2600" b="1" dirty="0">
                 <a:solidFill>
                   <a:srgbClr val="0F1B2D"/>
                 </a:solidFill>
@@ -2009,7 +2240,7 @@
               </a:rPr>
               <a:t>Today's agenda</a:t>
             </a:r>
-            <a:endParaRPr lang="en-US" sz="3200" dirty="0"/>
+            <a:endParaRPr lang="en-US" sz="2600" dirty="0"/>
           </a:p>
         </p:txBody>
       </p:sp>
@@ -3192,7 +3423,7 @@
               <a:buNone/>
             </a:pPr>
             <a:r>
-              <a:rPr lang="en-US" sz="3200" b="1" dirty="0">
+              <a:rPr lang="en-US" sz="2600" b="1" dirty="0">
                 <a:solidFill>
                   <a:srgbClr val="0F1B2D"/>
                 </a:solidFill>
@@ -3200,9 +3431,9 @@
                 <a:ea typeface="Cambria" pitchFamily="34" charset="-122"/>
                 <a:cs typeface="Cambria" pitchFamily="34" charset="-120"/>
               </a:rPr>
-              <a:t>US power demand is climbing, and gas is answering</a:t>
-            </a:r>
-            <a:endParaRPr lang="en-US" sz="3200" dirty="0"/>
+              <a:t>US power demand is climbing, gas is answering</a:t>
+            </a:r>
+            <a:endParaRPr lang="en-US" sz="2600" dirty="0"/>
           </a:p>
         </p:txBody>
       </p:sp>
@@ -3834,7 +4065,7 @@
               <a:buNone/>
             </a:pPr>
             <a:r>
-              <a:rPr lang="en-US" sz="3200" b="1" dirty="0">
+              <a:rPr lang="en-US" sz="2600" b="1" dirty="0">
                 <a:solidFill>
                   <a:srgbClr val="0F1B2D"/>
                 </a:solidFill>
@@ -3844,7 +4075,7 @@
               </a:rPr>
               <a:t>Gas is the foundation of the power stack</a:t>
             </a:r>
-            <a:endParaRPr lang="en-US" sz="3200" dirty="0"/>
+            <a:endParaRPr lang="en-US" sz="2600" dirty="0"/>
           </a:p>
         </p:txBody>
       </p:sp>
@@ -4678,7 +4909,7 @@
               <a:buNone/>
             </a:pPr>
             <a:r>
-              <a:rPr lang="en-US" sz="3200" b="1" dirty="0">
+              <a:rPr lang="en-US" sz="2600" b="1" dirty="0">
                 <a:solidFill>
                   <a:srgbClr val="0F1B2D"/>
                 </a:solidFill>
@@ -4688,7 +4919,7 @@
               </a:rPr>
               <a:t>Projects in queue and the wire &amp; cable prize</a:t>
             </a:r>
-            <a:endParaRPr lang="en-US" sz="3200" dirty="0"/>
+            <a:endParaRPr lang="en-US" sz="2600" dirty="0"/>
           </a:p>
         </p:txBody>
       </p:sp>
@@ -4860,7 +5091,7 @@
                 <a:ea typeface="Calibri" pitchFamily="34" charset="-122"/>
                 <a:cs typeface="Calibri" pitchFamily="34" charset="-120"/>
               </a:rPr>
-              <a:t>Combined cycle and peakers</a:t>
+              <a:t>Utility and IPP build-out</a:t>
             </a:r>
             <a:endParaRPr lang="en-US" sz="1200" dirty="0"/>
           </a:p>
@@ -5080,7 +5311,7 @@
                 <a:ea typeface="Cambria" pitchFamily="34" charset="-122"/>
                 <a:cs typeface="Cambria" pitchFamily="34" charset="-120"/>
               </a:rPr>
-              <a:t>Other traditional PG</a:t>
+              <a:t>On-site and packaged gas</a:t>
             </a:r>
             <a:endParaRPr lang="en-US" sz="1600" dirty="0"/>
           </a:p>
@@ -5119,7 +5350,7 @@
                 <a:ea typeface="Calibri" pitchFamily="34" charset="-122"/>
                 <a:cs typeface="Calibri" pitchFamily="34" charset="-120"/>
               </a:rPr>
-              <a:t>Repowering, cogeneration, on-site</a:t>
+              <a:t>Behind-the-meter for data centers</a:t>
             </a:r>
             <a:endParaRPr lang="en-US" sz="1200" dirty="0"/>
           </a:p>
@@ -5162,7 +5393,7 @@
                 <a:ea typeface="Calibri" pitchFamily="34" charset="-122"/>
                 <a:cs typeface="Calibri" pitchFamily="34" charset="-120"/>
               </a:rPr>
-              <a:t>Projects in queue: [XX]</a:t>
+              <a:t>~56 GW planned, 46 projects</a:t>
             </a:r>
             <a:endParaRPr lang="en-US" sz="1300" dirty="0"/>
           </a:p>
@@ -5183,7 +5414,7 @@
                 <a:ea typeface="Calibri" pitchFamily="34" charset="-122"/>
                 <a:cs typeface="Calibri" pitchFamily="34" charset="-120"/>
               </a:rPr>
-              <a:t>Capacity: [XX] GW</a:t>
+              <a:t>Microsoft: 5+ GW signed in 2026</a:t>
             </a:r>
             <a:endParaRPr lang="en-US" sz="1300" dirty="0"/>
           </a:p>
@@ -5204,7 +5435,7 @@
                 <a:ea typeface="Calibri" pitchFamily="34" charset="-122"/>
                 <a:cs typeface="Calibri" pitchFamily="34" charset="-120"/>
               </a:rPr>
-              <a:t>Est. wire &amp; cable market: $[XX]M</a:t>
+              <a:t>Packaged units: 12-15 mo delivery</a:t>
             </a:r>
             <a:endParaRPr lang="en-US" sz="1300" dirty="0"/>
           </a:p>
@@ -5421,7 +5652,7 @@
                 <a:ea typeface="Calibri" pitchFamily="34" charset="-122"/>
                 <a:cs typeface="Calibri" pitchFamily="34" charset="-120"/>
               </a:rPr>
-              <a:t>AXE target list: [XX] projects</a:t>
+              <a:t>AXE target list: to be shared</a:t>
             </a:r>
             <a:endParaRPr lang="en-US" sz="1300" dirty="0"/>
           </a:p>
@@ -5442,7 +5673,7 @@
                 <a:ea typeface="Calibri" pitchFamily="34" charset="-122"/>
                 <a:cs typeface="Calibri" pitchFamily="34" charset="-120"/>
               </a:rPr>
-              <a:t>Regions of focus: [list]</a:t>
+              <a:t>Focus: data center-linked gas</a:t>
             </a:r>
             <a:endParaRPr lang="en-US" sz="1300" dirty="0"/>
           </a:p>
@@ -5463,7 +5694,7 @@
                 <a:ea typeface="Calibri" pitchFamily="34" charset="-122"/>
                 <a:cs typeface="Calibri" pitchFamily="34" charset="-120"/>
               </a:rPr>
-              <a:t>Near-term bids: [list]</a:t>
+              <a:t>Joint account plan per project</a:t>
             </a:r>
             <a:endParaRPr lang="en-US" sz="1300" dirty="0"/>
           </a:p>
@@ -5502,7 +5733,7 @@
                 <a:ea typeface="Calibri" pitchFamily="34" charset="-122"/>
                 <a:cs typeface="Calibri" pitchFamily="34" charset="-120"/>
               </a:rPr>
-              <a:t>Sources: Global Energy Monitor, US gas plant tracker, H1 2026 (announced, pre-construction and construction phases). Wire &amp; cable $ sizing: Southwire estimate needed.</a:t>
+              <a:t>Sources: Global Energy Monitor (H1 2026); Cleanview BTM tracker; press reports. Wire &amp; cable $ sizing: Southwire estimate.</a:t>
             </a:r>
             <a:endParaRPr lang="en-US" sz="900" dirty="0"/>
           </a:p>
@@ -5600,7 +5831,7 @@
     <p:bg>
       <p:bgPr>
         <a:solidFill>
-          <a:srgbClr val="0F1B2D"/>
+          <a:srgbClr val="F4F6F8"/>
         </a:solidFill>
       </p:bgPr>
     </p:bg>
@@ -5643,57 +5874,54 @@
               <a:buNone/>
             </a:pPr>
             <a:r>
-              <a:rPr lang="en-US" sz="3200" b="1" dirty="0">
-                <a:solidFill>
-                  <a:srgbClr val="FFFFFF"/>
+              <a:rPr lang="en-US" sz="2600" b="1" dirty="0">
+                <a:solidFill>
+                  <a:srgbClr val="0F1B2D"/>
                 </a:solidFill>
                 <a:latin typeface="Cambria" pitchFamily="34" charset="0"/>
                 <a:ea typeface="Cambria" pitchFamily="34" charset="-122"/>
                 <a:cs typeface="Cambria" pitchFamily="34" charset="-120"/>
               </a:rPr>
-              <a:t>Virtual tour: where Southwire shows up in a gas plant</a:t>
-            </a:r>
-            <a:endParaRPr lang="en-US" sz="3200" dirty="0"/>
-          </a:p>
-        </p:txBody>
-      </p:sp>
-      <p:sp>
-        <p:nvSpPr>
-          <p:cNvPr id="3" name="Shape 1"/>
+              <a:t>Virtual tour: Southwire across a gas plant</a:t>
+            </a:r>
+            <a:endParaRPr lang="en-US" sz="2600" dirty="0"/>
+          </a:p>
+        </p:txBody>
+      </p:sp>
+      <p:pic>
+        <p:nvPicPr>
+          <p:cNvPr id="3" name="Image 0" descr="/home/user/ln/presentations/plant_schematic.png">    </p:cNvPr>
+          <p:cNvPicPr>
+            <a:picLocks noChangeAspect="1"/>
+          </p:cNvPicPr>
+          <p:nvPr/>
+        </p:nvPicPr>
+        <p:blipFill>
+          <a:blip r:embed="rId1"/>
+          <a:stretch>
+            <a:fillRect/>
+          </a:stretch>
+        </p:blipFill>
+        <p:spPr>
+          <a:xfrm>
+            <a:off x="457200" y="1097280"/>
+            <a:ext cx="8229600" cy="2926080"/>
+          </a:xfrm>
+          <a:prstGeom prst="rect">
+            <a:avLst/>
+          </a:prstGeom>
+        </p:spPr>
+      </p:pic>
+      <p:sp>
+        <p:nvSpPr>
+          <p:cNvPr id="4" name="Shape 1"/>
           <p:cNvSpPr/>
           <p:nvPr/>
         </p:nvSpPr>
         <p:spPr>
           <a:xfrm>
-            <a:off x="457200" y="1280160"/>
-            <a:ext cx="2606040" cy="1417320"/>
-          </a:xfrm>
-          <a:prstGeom prst="roundRect">
-            <a:avLst>
-              <a:gd name="adj" fmla="val 6452"/>
-            </a:avLst>
-          </a:prstGeom>
-          <a:solidFill>
-            <a:srgbClr val="1B2C45"/>
-          </a:solidFill>
-          <a:ln w="12700">
-            <a:solidFill>
-              <a:srgbClr val="34496A"/>
-            </a:solidFill>
-            <a:prstDash val="solid"/>
-          </a:ln>
-        </p:spPr>
-      </p:sp>
-      <p:sp>
-        <p:nvSpPr>
-          <p:cNvPr id="4" name="Shape 2"/>
-          <p:cNvSpPr/>
-          <p:nvPr/>
-        </p:nvSpPr>
-        <p:spPr>
-          <a:xfrm>
-            <a:off x="621792" y="1444752"/>
-            <a:ext cx="411480" cy="411480"/>
+            <a:off x="457200" y="4160520"/>
+            <a:ext cx="274320" cy="274320"/>
           </a:xfrm>
           <a:prstGeom prst="ellipse">
             <a:avLst/>
@@ -5711,14 +5939,14 @@
       </p:sp>
       <p:sp>
         <p:nvSpPr>
-          <p:cNvPr id="5" name="Text 3"/>
-          <p:cNvSpPr txBox="1"/>
-          <p:nvPr/>
-        </p:nvSpPr>
-        <p:spPr>
-          <a:xfrm>
-            <a:off x="621792" y="1444752"/>
-            <a:ext cx="411480" cy="411480"/>
+          <p:cNvPr id="5" name="Text 2"/>
+          <p:cNvSpPr txBox="1"/>
+          <p:nvPr/>
+        </p:nvSpPr>
+        <p:spPr>
+          <a:xfrm>
+            <a:off x="457200" y="4160520"/>
+            <a:ext cx="274320" cy="274320"/>
           </a:xfrm>
           <a:prstGeom prst="rect">
             <a:avLst/>
@@ -5734,7 +5962,7 @@
               <a:buNone/>
             </a:pPr>
             <a:r>
-              <a:rPr lang="en-US" sz="1260" b="1" dirty="0">
+              <a:rPr lang="en-US" sz="840" b="1" dirty="0">
                 <a:solidFill>
                   <a:srgbClr val="FFFFFF"/>
                 </a:solidFill>
@@ -5744,20 +5972,20 @@
               </a:rPr>
               <a:t>1</a:t>
             </a:r>
-            <a:endParaRPr lang="en-US" sz="1260" dirty="0"/>
-          </a:p>
-        </p:txBody>
-      </p:sp>
-      <p:sp>
-        <p:nvSpPr>
-          <p:cNvPr id="6" name="Text 4"/>
-          <p:cNvSpPr txBox="1"/>
-          <p:nvPr/>
-        </p:nvSpPr>
-        <p:spPr>
-          <a:xfrm>
-            <a:off x="1143000" y="1408176"/>
-            <a:ext cx="1783080" cy="502920"/>
+            <a:endParaRPr lang="en-US" sz="840" dirty="0"/>
+          </a:p>
+        </p:txBody>
+      </p:sp>
+      <p:sp>
+        <p:nvSpPr>
+          <p:cNvPr id="6" name="Text 3"/>
+          <p:cNvSpPr txBox="1"/>
+          <p:nvPr/>
+        </p:nvSpPr>
+        <p:spPr>
+          <a:xfrm>
+            <a:off x="804672" y="4114800"/>
+            <a:ext cx="1234440" cy="365760"/>
           </a:xfrm>
           <a:prstGeom prst="rect">
             <a:avLst/>
@@ -5773,96 +6001,30 @@
               <a:buNone/>
             </a:pPr>
             <a:r>
-              <a:rPr lang="en-US" sz="1400" b="1" dirty="0">
-                <a:solidFill>
-                  <a:srgbClr val="FFFFFF"/>
-                </a:solidFill>
-                <a:latin typeface="Cambria" pitchFamily="34" charset="0"/>
-                <a:ea typeface="Cambria" pitchFamily="34" charset="-122"/>
-                <a:cs typeface="Cambria" pitchFamily="34" charset="-120"/>
-              </a:rPr>
-              <a:t>Gas turbine &amp; generator</a:t>
-            </a:r>
-            <a:endParaRPr lang="en-US" sz="1400" dirty="0"/>
-          </a:p>
-        </p:txBody>
-      </p:sp>
-      <p:sp>
-        <p:nvSpPr>
-          <p:cNvPr id="7" name="Text 5"/>
-          <p:cNvSpPr txBox="1"/>
-          <p:nvPr/>
-        </p:nvSpPr>
-        <p:spPr>
-          <a:xfrm>
-            <a:off x="621792" y="2057400"/>
-            <a:ext cx="2286000" cy="548640"/>
-          </a:xfrm>
-          <a:prstGeom prst="rect">
-            <a:avLst/>
-          </a:prstGeom>
-          <a:noFill/>
-          <a:ln/>
-        </p:spPr>
-        <p:txBody>
-          <a:bodyPr wrap="square" lIns="0" tIns="0" rIns="0" bIns="0" rtlCol="0" anchor="t"/>
-          <a:lstStyle/>
-          <a:p>
-            <a:pPr indent="0" marL="0">
-              <a:buNone/>
-            </a:pPr>
-            <a:r>
-              <a:rPr lang="en-US" sz="1300" dirty="0">
-                <a:solidFill>
-                  <a:srgbClr val="CADCFC"/>
+              <a:rPr lang="en-US" sz="1100" dirty="0">
+                <a:solidFill>
+                  <a:srgbClr val="1B2735"/>
                 </a:solidFill>
                 <a:latin typeface="Calibri" pitchFamily="34" charset="0"/>
                 <a:ea typeface="Calibri" pitchFamily="34" charset="-122"/>
                 <a:cs typeface="Calibri" pitchFamily="34" charset="-120"/>
               </a:rPr>
-              <a:t>MV / LV power and control cables</a:t>
-            </a:r>
-            <a:endParaRPr lang="en-US" sz="1300" dirty="0"/>
-          </a:p>
-        </p:txBody>
-      </p:sp>
-      <p:sp>
-        <p:nvSpPr>
-          <p:cNvPr id="8" name="Shape 6"/>
+              <a:t>MV / HV power</a:t>
+            </a:r>
+            <a:endParaRPr lang="en-US" sz="1100" dirty="0"/>
+          </a:p>
+        </p:txBody>
+      </p:sp>
+      <p:sp>
+        <p:nvSpPr>
+          <p:cNvPr id="7" name="Shape 4"/>
           <p:cNvSpPr/>
           <p:nvPr/>
         </p:nvSpPr>
         <p:spPr>
           <a:xfrm>
-            <a:off x="3246120" y="1280160"/>
-            <a:ext cx="2606040" cy="1417320"/>
-          </a:xfrm>
-          <a:prstGeom prst="roundRect">
-            <a:avLst>
-              <a:gd name="adj" fmla="val 6452"/>
-            </a:avLst>
-          </a:prstGeom>
-          <a:solidFill>
-            <a:srgbClr val="1B2C45"/>
-          </a:solidFill>
-          <a:ln w="12700">
-            <a:solidFill>
-              <a:srgbClr val="34496A"/>
-            </a:solidFill>
-            <a:prstDash val="solid"/>
-          </a:ln>
-        </p:spPr>
-      </p:sp>
-      <p:sp>
-        <p:nvSpPr>
-          <p:cNvPr id="9" name="Shape 7"/>
-          <p:cNvSpPr/>
-          <p:nvPr/>
-        </p:nvSpPr>
-        <p:spPr>
-          <a:xfrm>
-            <a:off x="3410712" y="1444752"/>
-            <a:ext cx="411480" cy="411480"/>
+            <a:off x="2103120" y="4160520"/>
+            <a:ext cx="274320" cy="274320"/>
           </a:xfrm>
           <a:prstGeom prst="ellipse">
             <a:avLst/>
@@ -5880,14 +6042,14 @@
       </p:sp>
       <p:sp>
         <p:nvSpPr>
-          <p:cNvPr id="10" name="Text 8"/>
-          <p:cNvSpPr txBox="1"/>
-          <p:nvPr/>
-        </p:nvSpPr>
-        <p:spPr>
-          <a:xfrm>
-            <a:off x="3410712" y="1444752"/>
-            <a:ext cx="411480" cy="411480"/>
+          <p:cNvPr id="8" name="Text 5"/>
+          <p:cNvSpPr txBox="1"/>
+          <p:nvPr/>
+        </p:nvSpPr>
+        <p:spPr>
+          <a:xfrm>
+            <a:off x="2103120" y="4160520"/>
+            <a:ext cx="274320" cy="274320"/>
           </a:xfrm>
           <a:prstGeom prst="rect">
             <a:avLst/>
@@ -5903,7 +6065,7 @@
               <a:buNone/>
             </a:pPr>
             <a:r>
-              <a:rPr lang="en-US" sz="1260" b="1" dirty="0">
+              <a:rPr lang="en-US" sz="840" b="1" dirty="0">
                 <a:solidFill>
                   <a:srgbClr val="FFFFFF"/>
                 </a:solidFill>
@@ -5913,20 +6075,20 @@
               </a:rPr>
               <a:t>2</a:t>
             </a:r>
-            <a:endParaRPr lang="en-US" sz="1260" dirty="0"/>
-          </a:p>
-        </p:txBody>
-      </p:sp>
-      <p:sp>
-        <p:nvSpPr>
-          <p:cNvPr id="11" name="Text 9"/>
-          <p:cNvSpPr txBox="1"/>
-          <p:nvPr/>
-        </p:nvSpPr>
-        <p:spPr>
-          <a:xfrm>
-            <a:off x="3931920" y="1408176"/>
-            <a:ext cx="1783080" cy="502920"/>
+            <a:endParaRPr lang="en-US" sz="840" dirty="0"/>
+          </a:p>
+        </p:txBody>
+      </p:sp>
+      <p:sp>
+        <p:nvSpPr>
+          <p:cNvPr id="9" name="Text 6"/>
+          <p:cNvSpPr txBox="1"/>
+          <p:nvPr/>
+        </p:nvSpPr>
+        <p:spPr>
+          <a:xfrm>
+            <a:off x="2450592" y="4114800"/>
+            <a:ext cx="1234440" cy="365760"/>
           </a:xfrm>
           <a:prstGeom prst="rect">
             <a:avLst/>
@@ -5942,96 +6104,30 @@
               <a:buNone/>
             </a:pPr>
             <a:r>
-              <a:rPr lang="en-US" sz="1400" b="1" dirty="0">
-                <a:solidFill>
-                  <a:srgbClr val="FFFFFF"/>
-                </a:solidFill>
-                <a:latin typeface="Cambria" pitchFamily="34" charset="0"/>
-                <a:ea typeface="Cambria" pitchFamily="34" charset="-122"/>
-                <a:cs typeface="Cambria" pitchFamily="34" charset="-120"/>
-              </a:rPr>
-              <a:t>Step-up &amp; switchyard</a:t>
-            </a:r>
-            <a:endParaRPr lang="en-US" sz="1400" dirty="0"/>
-          </a:p>
-        </p:txBody>
-      </p:sp>
-      <p:sp>
-        <p:nvSpPr>
-          <p:cNvPr id="12" name="Text 10"/>
-          <p:cNvSpPr txBox="1"/>
-          <p:nvPr/>
-        </p:nvSpPr>
-        <p:spPr>
-          <a:xfrm>
-            <a:off x="3410712" y="2057400"/>
-            <a:ext cx="2286000" cy="548640"/>
-          </a:xfrm>
-          <a:prstGeom prst="rect">
-            <a:avLst/>
-          </a:prstGeom>
-          <a:noFill/>
-          <a:ln/>
-        </p:spPr>
-        <p:txBody>
-          <a:bodyPr wrap="square" lIns="0" tIns="0" rIns="0" bIns="0" rtlCol="0" anchor="t"/>
-          <a:lstStyle/>
-          <a:p>
-            <a:pPr indent="0" marL="0">
-              <a:buNone/>
-            </a:pPr>
-            <a:r>
-              <a:rPr lang="en-US" sz="1300" dirty="0">
-                <a:solidFill>
-                  <a:srgbClr val="CADCFC"/>
+              <a:rPr lang="en-US" sz="1100" dirty="0">
+                <a:solidFill>
+                  <a:srgbClr val="1B2735"/>
                 </a:solidFill>
                 <a:latin typeface="Calibri" pitchFamily="34" charset="0"/>
                 <a:ea typeface="Calibri" pitchFamily="34" charset="-122"/>
                 <a:cs typeface="Calibri" pitchFamily="34" charset="-120"/>
               </a:rPr>
-              <a:t>Medium voltage and grounding</a:t>
-            </a:r>
-            <a:endParaRPr lang="en-US" sz="1300" dirty="0"/>
-          </a:p>
-        </p:txBody>
-      </p:sp>
-      <p:sp>
-        <p:nvSpPr>
-          <p:cNvPr id="13" name="Shape 11"/>
+              <a:t>Control &amp; instrumentation</a:t>
+            </a:r>
+            <a:endParaRPr lang="en-US" sz="1100" dirty="0"/>
+          </a:p>
+        </p:txBody>
+      </p:sp>
+      <p:sp>
+        <p:nvSpPr>
+          <p:cNvPr id="10" name="Shape 7"/>
           <p:cNvSpPr/>
           <p:nvPr/>
         </p:nvSpPr>
         <p:spPr>
           <a:xfrm>
-            <a:off x="6035040" y="1280160"/>
-            <a:ext cx="2606040" cy="1417320"/>
-          </a:xfrm>
-          <a:prstGeom prst="roundRect">
-            <a:avLst>
-              <a:gd name="adj" fmla="val 6452"/>
-            </a:avLst>
-          </a:prstGeom>
-          <a:solidFill>
-            <a:srgbClr val="1B2C45"/>
-          </a:solidFill>
-          <a:ln w="12700">
-            <a:solidFill>
-              <a:srgbClr val="34496A"/>
-            </a:solidFill>
-            <a:prstDash val="solid"/>
-          </a:ln>
-        </p:spPr>
-      </p:sp>
-      <p:sp>
-        <p:nvSpPr>
-          <p:cNvPr id="14" name="Shape 12"/>
-          <p:cNvSpPr/>
-          <p:nvPr/>
-        </p:nvSpPr>
-        <p:spPr>
-          <a:xfrm>
-            <a:off x="6199632" y="1444752"/>
-            <a:ext cx="411480" cy="411480"/>
+            <a:off x="3749040" y="4160520"/>
+            <a:ext cx="274320" cy="274320"/>
           </a:xfrm>
           <a:prstGeom prst="ellipse">
             <a:avLst/>
@@ -6049,14 +6145,14 @@
       </p:sp>
       <p:sp>
         <p:nvSpPr>
-          <p:cNvPr id="15" name="Text 13"/>
-          <p:cNvSpPr txBox="1"/>
-          <p:nvPr/>
-        </p:nvSpPr>
-        <p:spPr>
-          <a:xfrm>
-            <a:off x="6199632" y="1444752"/>
-            <a:ext cx="411480" cy="411480"/>
+          <p:cNvPr id="11" name="Text 8"/>
+          <p:cNvSpPr txBox="1"/>
+          <p:nvPr/>
+        </p:nvSpPr>
+        <p:spPr>
+          <a:xfrm>
+            <a:off x="3749040" y="4160520"/>
+            <a:ext cx="274320" cy="274320"/>
           </a:xfrm>
           <a:prstGeom prst="rect">
             <a:avLst/>
@@ -6072,7 +6168,7 @@
               <a:buNone/>
             </a:pPr>
             <a:r>
-              <a:rPr lang="en-US" sz="1260" b="1" dirty="0">
+              <a:rPr lang="en-US" sz="840" b="1" dirty="0">
                 <a:solidFill>
                   <a:srgbClr val="FFFFFF"/>
                 </a:solidFill>
@@ -6082,20 +6178,20 @@
               </a:rPr>
               <a:t>3</a:t>
             </a:r>
-            <a:endParaRPr lang="en-US" sz="1260" dirty="0"/>
-          </a:p>
-        </p:txBody>
-      </p:sp>
-      <p:sp>
-        <p:nvSpPr>
-          <p:cNvPr id="16" name="Text 14"/>
-          <p:cNvSpPr txBox="1"/>
-          <p:nvPr/>
-        </p:nvSpPr>
-        <p:spPr>
-          <a:xfrm>
-            <a:off x="6720840" y="1408176"/>
-            <a:ext cx="1783080" cy="502920"/>
+            <a:endParaRPr lang="en-US" sz="840" dirty="0"/>
+          </a:p>
+        </p:txBody>
+      </p:sp>
+      <p:sp>
+        <p:nvSpPr>
+          <p:cNvPr id="12" name="Text 9"/>
+          <p:cNvSpPr txBox="1"/>
+          <p:nvPr/>
+        </p:nvSpPr>
+        <p:spPr>
+          <a:xfrm>
+            <a:off x="4096512" y="4114800"/>
+            <a:ext cx="1234440" cy="365760"/>
           </a:xfrm>
           <a:prstGeom prst="rect">
             <a:avLst/>
@@ -6111,96 +6207,30 @@
               <a:buNone/>
             </a:pPr>
             <a:r>
-              <a:rPr lang="en-US" sz="1400" b="1" dirty="0">
-                <a:solidFill>
-                  <a:srgbClr val="FFFFFF"/>
-                </a:solidFill>
-                <a:latin typeface="Cambria" pitchFamily="34" charset="0"/>
-                <a:ea typeface="Cambria" pitchFamily="34" charset="-122"/>
-                <a:cs typeface="Cambria" pitchFamily="34" charset="-120"/>
-              </a:rPr>
-              <a:t>Balance of plant</a:t>
-            </a:r>
-            <a:endParaRPr lang="en-US" sz="1400" dirty="0"/>
-          </a:p>
-        </p:txBody>
-      </p:sp>
-      <p:sp>
-        <p:nvSpPr>
-          <p:cNvPr id="17" name="Text 15"/>
-          <p:cNvSpPr txBox="1"/>
-          <p:nvPr/>
-        </p:nvSpPr>
-        <p:spPr>
-          <a:xfrm>
-            <a:off x="6199632" y="2057400"/>
-            <a:ext cx="2286000" cy="548640"/>
-          </a:xfrm>
-          <a:prstGeom prst="rect">
-            <a:avLst/>
-          </a:prstGeom>
-          <a:noFill/>
-          <a:ln/>
-        </p:spPr>
-        <p:txBody>
-          <a:bodyPr wrap="square" lIns="0" tIns="0" rIns="0" bIns="0" rtlCol="0" anchor="t"/>
-          <a:lstStyle/>
-          <a:p>
-            <a:pPr indent="0" marL="0">
-              <a:buNone/>
-            </a:pPr>
-            <a:r>
-              <a:rPr lang="en-US" sz="1300" dirty="0">
-                <a:solidFill>
-                  <a:srgbClr val="CADCFC"/>
+              <a:rPr lang="en-US" sz="1100" dirty="0">
+                <a:solidFill>
+                  <a:srgbClr val="1B2735"/>
                 </a:solidFill>
                 <a:latin typeface="Calibri" pitchFamily="34" charset="0"/>
                 <a:ea typeface="Calibri" pitchFamily="34" charset="-122"/>
                 <a:cs typeface="Calibri" pitchFamily="34" charset="-120"/>
               </a:rPr>
-              <a:t>Power, lighting, communications</a:t>
-            </a:r>
-            <a:endParaRPr lang="en-US" sz="1300" dirty="0"/>
-          </a:p>
-        </p:txBody>
-      </p:sp>
-      <p:sp>
-        <p:nvSpPr>
-          <p:cNvPr id="18" name="Shape 16"/>
+              <a:t>LV power &amp; auxiliaries</a:t>
+            </a:r>
+            <a:endParaRPr lang="en-US" sz="1100" dirty="0"/>
+          </a:p>
+        </p:txBody>
+      </p:sp>
+      <p:sp>
+        <p:nvSpPr>
+          <p:cNvPr id="13" name="Shape 10"/>
           <p:cNvSpPr/>
           <p:nvPr/>
         </p:nvSpPr>
         <p:spPr>
           <a:xfrm>
-            <a:off x="457200" y="2880360"/>
-            <a:ext cx="2606040" cy="1417320"/>
-          </a:xfrm>
-          <a:prstGeom prst="roundRect">
-            <a:avLst>
-              <a:gd name="adj" fmla="val 6452"/>
-            </a:avLst>
-          </a:prstGeom>
-          <a:solidFill>
-            <a:srgbClr val="1B2C45"/>
-          </a:solidFill>
-          <a:ln w="12700">
-            <a:solidFill>
-              <a:srgbClr val="34496A"/>
-            </a:solidFill>
-            <a:prstDash val="solid"/>
-          </a:ln>
-        </p:spPr>
-      </p:sp>
-      <p:sp>
-        <p:nvSpPr>
-          <p:cNvPr id="19" name="Shape 17"/>
-          <p:cNvSpPr/>
-          <p:nvPr/>
-        </p:nvSpPr>
-        <p:spPr>
-          <a:xfrm>
-            <a:off x="621792" y="3044952"/>
-            <a:ext cx="411480" cy="411480"/>
+            <a:off x="5394960" y="4160520"/>
+            <a:ext cx="274320" cy="274320"/>
           </a:xfrm>
           <a:prstGeom prst="ellipse">
             <a:avLst/>
@@ -6218,14 +6248,14 @@
       </p:sp>
       <p:sp>
         <p:nvSpPr>
-          <p:cNvPr id="20" name="Text 18"/>
-          <p:cNvSpPr txBox="1"/>
-          <p:nvPr/>
-        </p:nvSpPr>
-        <p:spPr>
-          <a:xfrm>
-            <a:off x="621792" y="3044952"/>
-            <a:ext cx="411480" cy="411480"/>
+          <p:cNvPr id="14" name="Text 11"/>
+          <p:cNvSpPr txBox="1"/>
+          <p:nvPr/>
+        </p:nvSpPr>
+        <p:spPr>
+          <a:xfrm>
+            <a:off x="5394960" y="4160520"/>
+            <a:ext cx="274320" cy="274320"/>
           </a:xfrm>
           <a:prstGeom prst="rect">
             <a:avLst/>
@@ -6241,7 +6271,7 @@
               <a:buNone/>
             </a:pPr>
             <a:r>
-              <a:rPr lang="en-US" sz="1260" b="1" dirty="0">
+              <a:rPr lang="en-US" sz="840" b="1" dirty="0">
                 <a:solidFill>
                   <a:srgbClr val="FFFFFF"/>
                 </a:solidFill>
@@ -6251,20 +6281,20 @@
               </a:rPr>
               <a:t>4</a:t>
             </a:r>
-            <a:endParaRPr lang="en-US" sz="1260" dirty="0"/>
-          </a:p>
-        </p:txBody>
-      </p:sp>
-      <p:sp>
-        <p:nvSpPr>
-          <p:cNvPr id="21" name="Text 19"/>
-          <p:cNvSpPr txBox="1"/>
-          <p:nvPr/>
-        </p:nvSpPr>
-        <p:spPr>
-          <a:xfrm>
-            <a:off x="1143000" y="3008376"/>
-            <a:ext cx="1783080" cy="502920"/>
+            <a:endParaRPr lang="en-US" sz="840" dirty="0"/>
+          </a:p>
+        </p:txBody>
+      </p:sp>
+      <p:sp>
+        <p:nvSpPr>
+          <p:cNvPr id="15" name="Text 12"/>
+          <p:cNvSpPr txBox="1"/>
+          <p:nvPr/>
+        </p:nvSpPr>
+        <p:spPr>
+          <a:xfrm>
+            <a:off x="5742432" y="4114800"/>
+            <a:ext cx="1234440" cy="365760"/>
           </a:xfrm>
           <a:prstGeom prst="rect">
             <a:avLst/>
@@ -6280,96 +6310,30 @@
               <a:buNone/>
             </a:pPr>
             <a:r>
-              <a:rPr lang="en-US" sz="1400" b="1" dirty="0">
-                <a:solidFill>
-                  <a:srgbClr val="FFFFFF"/>
-                </a:solidFill>
-                <a:latin typeface="Cambria" pitchFamily="34" charset="0"/>
-                <a:ea typeface="Cambria" pitchFamily="34" charset="-122"/>
-                <a:cs typeface="Cambria" pitchFamily="34" charset="-120"/>
-              </a:rPr>
-              <a:t>Controls &amp; instrumentation</a:t>
-            </a:r>
-            <a:endParaRPr lang="en-US" sz="1400" dirty="0"/>
-          </a:p>
-        </p:txBody>
-      </p:sp>
-      <p:sp>
-        <p:nvSpPr>
-          <p:cNvPr id="22" name="Text 20"/>
-          <p:cNvSpPr txBox="1"/>
-          <p:nvPr/>
-        </p:nvSpPr>
-        <p:spPr>
-          <a:xfrm>
-            <a:off x="621792" y="3657600"/>
-            <a:ext cx="2286000" cy="548640"/>
-          </a:xfrm>
-          <a:prstGeom prst="rect">
-            <a:avLst/>
-          </a:prstGeom>
-          <a:noFill/>
-          <a:ln/>
-        </p:spPr>
-        <p:txBody>
-          <a:bodyPr wrap="square" lIns="0" tIns="0" rIns="0" bIns="0" rtlCol="0" anchor="t"/>
-          <a:lstStyle/>
-          <a:p>
-            <a:pPr indent="0" marL="0">
-              <a:buNone/>
-            </a:pPr>
-            <a:r>
-              <a:rPr lang="en-US" sz="1300" dirty="0">
-                <a:solidFill>
-                  <a:srgbClr val="CADCFC"/>
+              <a:rPr lang="en-US" sz="1100" dirty="0">
+                <a:solidFill>
+                  <a:srgbClr val="1B2735"/>
                 </a:solidFill>
                 <a:latin typeface="Calibri" pitchFamily="34" charset="0"/>
                 <a:ea typeface="Calibri" pitchFamily="34" charset="-122"/>
                 <a:cs typeface="Calibri" pitchFamily="34" charset="-120"/>
               </a:rPr>
-              <a:t>Instrumentation and control cable</a:t>
-            </a:r>
-            <a:endParaRPr lang="en-US" sz="1300" dirty="0"/>
-          </a:p>
-        </p:txBody>
-      </p:sp>
-      <p:sp>
-        <p:nvSpPr>
-          <p:cNvPr id="23" name="Shape 21"/>
+              <a:t>Grounding grid</a:t>
+            </a:r>
+            <a:endParaRPr lang="en-US" sz="1100" dirty="0"/>
+          </a:p>
+        </p:txBody>
+      </p:sp>
+      <p:sp>
+        <p:nvSpPr>
+          <p:cNvPr id="16" name="Shape 13"/>
           <p:cNvSpPr/>
           <p:nvPr/>
         </p:nvSpPr>
         <p:spPr>
           <a:xfrm>
-            <a:off x="3246120" y="2880360"/>
-            <a:ext cx="2606040" cy="1417320"/>
-          </a:xfrm>
-          <a:prstGeom prst="roundRect">
-            <a:avLst>
-              <a:gd name="adj" fmla="val 6452"/>
-            </a:avLst>
-          </a:prstGeom>
-          <a:solidFill>
-            <a:srgbClr val="1B2C45"/>
-          </a:solidFill>
-          <a:ln w="12700">
-            <a:solidFill>
-              <a:srgbClr val="34496A"/>
-            </a:solidFill>
-            <a:prstDash val="solid"/>
-          </a:ln>
-        </p:spPr>
-      </p:sp>
-      <p:sp>
-        <p:nvSpPr>
-          <p:cNvPr id="24" name="Shape 22"/>
-          <p:cNvSpPr/>
-          <p:nvPr/>
-        </p:nvSpPr>
-        <p:spPr>
-          <a:xfrm>
-            <a:off x="3410712" y="3044952"/>
-            <a:ext cx="411480" cy="411480"/>
+            <a:off x="7040880" y="4160520"/>
+            <a:ext cx="274320" cy="274320"/>
           </a:xfrm>
           <a:prstGeom prst="ellipse">
             <a:avLst/>
@@ -6387,14 +6351,14 @@
       </p:sp>
       <p:sp>
         <p:nvSpPr>
-          <p:cNvPr id="25" name="Text 23"/>
-          <p:cNvSpPr txBox="1"/>
-          <p:nvPr/>
-        </p:nvSpPr>
-        <p:spPr>
-          <a:xfrm>
-            <a:off x="3410712" y="3044952"/>
-            <a:ext cx="411480" cy="411480"/>
+          <p:cNvPr id="17" name="Text 14"/>
+          <p:cNvSpPr txBox="1"/>
+          <p:nvPr/>
+        </p:nvSpPr>
+        <p:spPr>
+          <a:xfrm>
+            <a:off x="7040880" y="4160520"/>
+            <a:ext cx="274320" cy="274320"/>
           </a:xfrm>
           <a:prstGeom prst="rect">
             <a:avLst/>
@@ -6410,7 +6374,7 @@
               <a:buNone/>
             </a:pPr>
             <a:r>
-              <a:rPr lang="en-US" sz="1260" b="1" dirty="0">
+              <a:rPr lang="en-US" sz="840" b="1" dirty="0">
                 <a:solidFill>
                   <a:srgbClr val="FFFFFF"/>
                 </a:solidFill>
@@ -6420,20 +6384,20 @@
               </a:rPr>
               <a:t>5</a:t>
             </a:r>
-            <a:endParaRPr lang="en-US" sz="1260" dirty="0"/>
-          </a:p>
-        </p:txBody>
-      </p:sp>
-      <p:sp>
-        <p:nvSpPr>
-          <p:cNvPr id="26" name="Text 24"/>
-          <p:cNvSpPr txBox="1"/>
-          <p:nvPr/>
-        </p:nvSpPr>
-        <p:spPr>
-          <a:xfrm>
-            <a:off x="3931920" y="3008376"/>
-            <a:ext cx="1783080" cy="502920"/>
+            <a:endParaRPr lang="en-US" sz="840" dirty="0"/>
+          </a:p>
+        </p:txBody>
+      </p:sp>
+      <p:sp>
+        <p:nvSpPr>
+          <p:cNvPr id="18" name="Text 15"/>
+          <p:cNvSpPr txBox="1"/>
+          <p:nvPr/>
+        </p:nvSpPr>
+        <p:spPr>
+          <a:xfrm>
+            <a:off x="7388352" y="4114800"/>
+            <a:ext cx="1234440" cy="365760"/>
           </a:xfrm>
           <a:prstGeom prst="rect">
             <a:avLst/>
@@ -6449,121 +6413,30 @@
               <a:buNone/>
             </a:pPr>
             <a:r>
-              <a:rPr lang="en-US" sz="1400" b="1" dirty="0">
-                <a:solidFill>
-                  <a:srgbClr val="FFFFFF"/>
-                </a:solidFill>
-                <a:latin typeface="Cambria" pitchFamily="34" charset="0"/>
-                <a:ea typeface="Cambria" pitchFamily="34" charset="-122"/>
-                <a:cs typeface="Cambria" pitchFamily="34" charset="-120"/>
-              </a:rPr>
-              <a:t>Fuel gas &amp; auxiliaries</a:t>
-            </a:r>
-            <a:endParaRPr lang="en-US" sz="1400" dirty="0"/>
-          </a:p>
-        </p:txBody>
-      </p:sp>
-      <p:sp>
-        <p:nvSpPr>
-          <p:cNvPr id="27" name="Text 25"/>
-          <p:cNvSpPr txBox="1"/>
-          <p:nvPr/>
-        </p:nvSpPr>
-        <p:spPr>
-          <a:xfrm>
-            <a:off x="3410712" y="3657600"/>
-            <a:ext cx="2286000" cy="548640"/>
-          </a:xfrm>
-          <a:prstGeom prst="rect">
-            <a:avLst/>
-          </a:prstGeom>
-          <a:noFill/>
-          <a:ln/>
-        </p:spPr>
-        <p:txBody>
-          <a:bodyPr wrap="square" lIns="0" tIns="0" rIns="0" bIns="0" rtlCol="0" anchor="t"/>
-          <a:lstStyle/>
-          <a:p>
-            <a:pPr indent="0" marL="0">
-              <a:buNone/>
-            </a:pPr>
-            <a:r>
-              <a:rPr lang="en-US" sz="1300" dirty="0">
-                <a:solidFill>
-                  <a:srgbClr val="CADCFC"/>
+              <a:rPr lang="en-US" sz="1100" dirty="0">
+                <a:solidFill>
+                  <a:srgbClr val="1B2735"/>
                 </a:solidFill>
                 <a:latin typeface="Calibri" pitchFamily="34" charset="0"/>
                 <a:ea typeface="Calibri" pitchFamily="34" charset="-122"/>
                 <a:cs typeface="Calibri" pitchFamily="34" charset="-120"/>
               </a:rPr>
-              <a:t>Hazardous-area rated cable</a:t>
-            </a:r>
-            <a:endParaRPr lang="en-US" sz="1300" dirty="0"/>
-          </a:p>
-        </p:txBody>
-      </p:sp>
-      <p:sp>
-        <p:nvSpPr>
-          <p:cNvPr id="28" name="Shape 26"/>
-          <p:cNvSpPr/>
-          <p:nvPr/>
-        </p:nvSpPr>
-        <p:spPr>
-          <a:xfrm>
-            <a:off x="6035040" y="2880360"/>
-            <a:ext cx="2606040" cy="1417320"/>
-          </a:xfrm>
-          <a:prstGeom prst="roundRect">
-            <a:avLst>
-              <a:gd name="adj" fmla="val 6452"/>
-            </a:avLst>
-          </a:prstGeom>
-          <a:solidFill>
-            <a:srgbClr val="1B2C45"/>
-          </a:solidFill>
-          <a:ln w="12700">
-            <a:solidFill>
-              <a:srgbClr val="34496A"/>
-            </a:solidFill>
-            <a:prstDash val="solid"/>
-          </a:ln>
-        </p:spPr>
-      </p:sp>
-      <p:sp>
-        <p:nvSpPr>
-          <p:cNvPr id="29" name="Shape 27"/>
-          <p:cNvSpPr/>
-          <p:nvPr/>
-        </p:nvSpPr>
-        <p:spPr>
-          <a:xfrm>
-            <a:off x="6199632" y="3044952"/>
-            <a:ext cx="411480" cy="411480"/>
-          </a:xfrm>
-          <a:prstGeom prst="ellipse">
-            <a:avLst/>
-          </a:prstGeom>
-          <a:solidFill>
-            <a:srgbClr val="C8742B"/>
-          </a:solidFill>
-          <a:ln w="12700">
-            <a:solidFill>
-              <a:srgbClr val="C8742B"/>
-            </a:solidFill>
-            <a:prstDash val="solid"/>
-          </a:ln>
-        </p:spPr>
-      </p:sp>
-      <p:sp>
-        <p:nvSpPr>
-          <p:cNvPr id="30" name="Text 28"/>
-          <p:cNvSpPr txBox="1"/>
-          <p:nvPr/>
-        </p:nvSpPr>
-        <p:spPr>
-          <a:xfrm>
-            <a:off x="6199632" y="3044952"/>
-            <a:ext cx="411480" cy="411480"/>
+              <a:t>Hazardous-area cable</a:t>
+            </a:r>
+            <a:endParaRPr lang="en-US" sz="1100" dirty="0"/>
+          </a:p>
+        </p:txBody>
+      </p:sp>
+      <p:sp>
+        <p:nvSpPr>
+          <p:cNvPr id="19" name="Text 16"/>
+          <p:cNvSpPr txBox="1"/>
+          <p:nvPr/>
+        </p:nvSpPr>
+        <p:spPr>
+          <a:xfrm>
+            <a:off x="457200" y="4754880"/>
+            <a:ext cx="5486400" cy="228600"/>
           </a:xfrm>
           <a:prstGeom prst="rect">
             <a:avLst/>
@@ -6575,135 +6448,18 @@
           <a:bodyPr wrap="square" lIns="0" tIns="0" rIns="0" bIns="0" rtlCol="0" anchor="ctr"/>
           <a:lstStyle/>
           <a:p>
-            <a:pPr algn="ctr" indent="0" marL="0">
-              <a:buNone/>
-            </a:pPr>
-            <a:r>
-              <a:rPr lang="en-US" sz="1260" b="1" dirty="0">
-                <a:solidFill>
-                  <a:srgbClr val="FFFFFF"/>
-                </a:solidFill>
-                <a:latin typeface="Cambria" pitchFamily="34" charset="0"/>
-                <a:ea typeface="Cambria" pitchFamily="34" charset="-122"/>
-                <a:cs typeface="Cambria" pitchFamily="34" charset="-120"/>
-              </a:rPr>
-              <a:t>6</a:t>
-            </a:r>
-            <a:endParaRPr lang="en-US" sz="1260" dirty="0"/>
-          </a:p>
-        </p:txBody>
-      </p:sp>
-      <p:sp>
-        <p:nvSpPr>
-          <p:cNvPr id="31" name="Text 29"/>
-          <p:cNvSpPr txBox="1"/>
-          <p:nvPr/>
-        </p:nvSpPr>
-        <p:spPr>
-          <a:xfrm>
-            <a:off x="6720840" y="3008376"/>
-            <a:ext cx="1783080" cy="502920"/>
-          </a:xfrm>
-          <a:prstGeom prst="rect">
-            <a:avLst/>
-          </a:prstGeom>
-          <a:noFill/>
-          <a:ln/>
-        </p:spPr>
-        <p:txBody>
-          <a:bodyPr wrap="square" lIns="0" tIns="0" rIns="0" bIns="0" rtlCol="0" anchor="ctr"/>
-          <a:lstStyle/>
-          <a:p>
             <a:pPr indent="0" marL="0">
               <a:buNone/>
             </a:pPr>
             <a:r>
-              <a:rPr lang="en-US" sz="1400" b="1" dirty="0">
-                <a:solidFill>
-                  <a:srgbClr val="FFFFFF"/>
-                </a:solidFill>
-                <a:latin typeface="Cambria" pitchFamily="34" charset="0"/>
-                <a:ea typeface="Cambria" pitchFamily="34" charset="-122"/>
-                <a:cs typeface="Cambria" pitchFamily="34" charset="-120"/>
-              </a:rPr>
-              <a:t>Plant electrical building</a:t>
-            </a:r>
-            <a:endParaRPr lang="en-US" sz="1400" dirty="0"/>
-          </a:p>
-        </p:txBody>
-      </p:sp>
-      <p:sp>
-        <p:nvSpPr>
-          <p:cNvPr id="32" name="Text 30"/>
-          <p:cNvSpPr txBox="1"/>
-          <p:nvPr/>
-        </p:nvSpPr>
-        <p:spPr>
-          <a:xfrm>
-            <a:off x="6199632" y="3657600"/>
-            <a:ext cx="2286000" cy="548640"/>
-          </a:xfrm>
-          <a:prstGeom prst="rect">
-            <a:avLst/>
-          </a:prstGeom>
-          <a:noFill/>
-          <a:ln/>
-        </p:spPr>
-        <p:txBody>
-          <a:bodyPr wrap="square" lIns="0" tIns="0" rIns="0" bIns="0" rtlCol="0" anchor="t"/>
-          <a:lstStyle/>
-          <a:p>
-            <a:pPr indent="0" marL="0">
-              <a:buNone/>
-            </a:pPr>
-            <a:r>
-              <a:rPr lang="en-US" sz="1300" dirty="0">
-                <a:solidFill>
-                  <a:srgbClr val="CADCFC"/>
+              <a:rPr lang="en-US" sz="1000" dirty="0">
+                <a:solidFill>
+                  <a:srgbClr val="5B6B7F"/>
                 </a:solidFill>
                 <a:latin typeface="Calibri" pitchFamily="34" charset="0"/>
                 <a:ea typeface="Calibri" pitchFamily="34" charset="-122"/>
                 <a:cs typeface="Calibri" pitchFamily="34" charset="-120"/>
               </a:rPr>
-              <a:t>Switchgear feeders and MCC</a:t>
-            </a:r>
-            <a:endParaRPr lang="en-US" sz="1300" dirty="0"/>
-          </a:p>
-        </p:txBody>
-      </p:sp>
-      <p:sp>
-        <p:nvSpPr>
-          <p:cNvPr id="33" name="Text 31"/>
-          <p:cNvSpPr txBox="1"/>
-          <p:nvPr/>
-        </p:nvSpPr>
-        <p:spPr>
-          <a:xfrm>
-            <a:off x="457200" y="4754880"/>
-            <a:ext cx="5486400" cy="228600"/>
-          </a:xfrm>
-          <a:prstGeom prst="rect">
-            <a:avLst/>
-          </a:prstGeom>
-          <a:noFill/>
-          <a:ln/>
-        </p:spPr>
-        <p:txBody>
-          <a:bodyPr wrap="square" lIns="0" tIns="0" rIns="0" bIns="0" rtlCol="0" anchor="ctr"/>
-          <a:lstStyle/>
-          <a:p>
-            <a:pPr indent="0" marL="0">
-              <a:buNone/>
-            </a:pPr>
-            <a:r>
-              <a:rPr lang="en-US" sz="1000" dirty="0">
-                <a:solidFill>
-                  <a:srgbClr val="9FB0C3"/>
-                </a:solidFill>
-                <a:latin typeface="Calibri" pitchFamily="34" charset="0"/>
-                <a:ea typeface="Calibri" pitchFamily="34" charset="-122"/>
-                <a:cs typeface="Calibri" pitchFamily="34" charset="-120"/>
-              </a:rPr>
               <a:t>Southwire PowerGen  |  Anixter Global Accounts</a:t>
             </a:r>
             <a:endParaRPr lang="en-US" sz="1000" dirty="0"/>
@@ -6712,7 +6468,7 @@
       </p:sp>
       <p:sp>
         <p:nvSpPr>
-          <p:cNvPr id="34" name="Text 32"/>
+          <p:cNvPr id="20" name="Text 17"/>
           <p:cNvSpPr txBox="1"/>
           <p:nvPr/>
         </p:nvSpPr>
@@ -6737,7 +6493,7 @@
             <a:r>
               <a:rPr lang="en-US" sz="1000" dirty="0">
                 <a:solidFill>
-                  <a:srgbClr val="9FB0C3"/>
+                  <a:srgbClr val="5B6B7F"/>
                 </a:solidFill>
                 <a:latin typeface="Calibri" pitchFamily="34" charset="0"/>
                 <a:ea typeface="Calibri" pitchFamily="34" charset="-122"/>
@@ -6806,7 +6562,7 @@
               <a:buNone/>
             </a:pPr>
             <a:r>
-              <a:rPr lang="en-US" sz="3200" b="1" dirty="0">
+              <a:rPr lang="en-US" sz="2600" b="1" dirty="0">
                 <a:solidFill>
                   <a:srgbClr val="0F1B2D"/>
                 </a:solidFill>
@@ -6816,7 +6572,7 @@
               </a:rPr>
               <a:t>PowerGen product line card</a:t>
             </a:r>
-            <a:endParaRPr lang="en-US" sz="3200" dirty="0"/>
+            <a:endParaRPr lang="en-US" sz="2600" dirty="0"/>
           </a:p>
         </p:txBody>
       </p:sp>
@@ -7084,7 +6840,7 @@
                 <a:ea typeface="Cambria" pitchFamily="34" charset="-122"/>
                 <a:cs typeface="Cambria" pitchFamily="34" charset="-120"/>
               </a:rPr>
-              <a:t>Low voltage power cable</a:t>
+              <a:t>Control and instrumentation cable</a:t>
             </a:r>
             <a:endParaRPr lang="en-US" sz="1500" dirty="0"/>
           </a:p>
@@ -7219,7 +6975,7 @@
                 <a:ea typeface="Cambria" pitchFamily="34" charset="-122"/>
                 <a:cs typeface="Cambria" pitchFamily="34" charset="-120"/>
               </a:rPr>
-              <a:t>Control and instrumentation cable</a:t>
+              <a:t>Low voltage power and auxiliary cable</a:t>
             </a:r>
             <a:endParaRPr lang="en-US" sz="1500" dirty="0"/>
           </a:p>
@@ -7489,7 +7245,7 @@
                 <a:ea typeface="Cambria" pitchFamily="34" charset="-122"/>
                 <a:cs typeface="Cambria" pitchFamily="34" charset="-120"/>
               </a:rPr>
-              <a:t>Building wire and MC cable</a:t>
+              <a:t>Hazardous-area and specialty cable</a:t>
             </a:r>
             <a:endParaRPr lang="en-US" sz="1500" dirty="0"/>
           </a:p>
@@ -7624,7 +7380,7 @@
                 <a:ea typeface="Cambria" pitchFamily="34" charset="-122"/>
                 <a:cs typeface="Cambria" pitchFamily="34" charset="-120"/>
               </a:rPr>
-              <a:t>Specialty and hazardous-area cable</a:t>
+              <a:t>Building wire and MC cable</a:t>
             </a:r>
             <a:endParaRPr lang="en-US" sz="1500" dirty="0"/>
           </a:p>
@@ -7638,8 +7394,8 @@
         </p:nvSpPr>
         <p:spPr>
           <a:xfrm>
-            <a:off x="457200" y="4754880"/>
-            <a:ext cx="5486400" cy="228600"/>
+            <a:off x="457200" y="4434840"/>
+            <a:ext cx="8229600" cy="228600"/>
           </a:xfrm>
           <a:prstGeom prst="rect">
             <a:avLst/>
@@ -7655,7 +7411,7 @@
               <a:buNone/>
             </a:pPr>
             <a:r>
-              <a:rPr lang="en-US" sz="1000" dirty="0">
+              <a:rPr lang="en-US" sz="1100" i="1" dirty="0">
                 <a:solidFill>
                   <a:srgbClr val="5B6B7F"/>
                 </a:solidFill>
@@ -7663,6 +7419,45 @@
                 <a:ea typeface="Calibri" pitchFamily="34" charset="-122"/>
                 <a:cs typeface="Calibri" pitchFamily="34" charset="-120"/>
               </a:rPr>
+              <a:t>Numbers 1-5 match the plant diagram.</a:t>
+            </a:r>
+            <a:endParaRPr lang="en-US" sz="1100" dirty="0"/>
+          </a:p>
+        </p:txBody>
+      </p:sp>
+      <p:sp>
+        <p:nvSpPr>
+          <p:cNvPr id="28" name="Text 26"/>
+          <p:cNvSpPr txBox="1"/>
+          <p:nvPr/>
+        </p:nvSpPr>
+        <p:spPr>
+          <a:xfrm>
+            <a:off x="457200" y="4754880"/>
+            <a:ext cx="5486400" cy="228600"/>
+          </a:xfrm>
+          <a:prstGeom prst="rect">
+            <a:avLst/>
+          </a:prstGeom>
+          <a:noFill/>
+          <a:ln/>
+        </p:spPr>
+        <p:txBody>
+          <a:bodyPr wrap="square" lIns="0" tIns="0" rIns="0" bIns="0" rtlCol="0" anchor="ctr"/>
+          <a:lstStyle/>
+          <a:p>
+            <a:pPr indent="0" marL="0">
+              <a:buNone/>
+            </a:pPr>
+            <a:r>
+              <a:rPr lang="en-US" sz="1000" dirty="0">
+                <a:solidFill>
+                  <a:srgbClr val="5B6B7F"/>
+                </a:solidFill>
+                <a:latin typeface="Calibri" pitchFamily="34" charset="0"/>
+                <a:ea typeface="Calibri" pitchFamily="34" charset="-122"/>
+                <a:cs typeface="Calibri" pitchFamily="34" charset="-120"/>
+              </a:rPr>
               <a:t>Southwire PowerGen  |  Anixter Global Accounts</a:t>
             </a:r>
             <a:endParaRPr lang="en-US" sz="1000" dirty="0"/>
@@ -7671,7 +7466,7 @@
       </p:sp>
       <p:sp>
         <p:nvSpPr>
-          <p:cNvPr id="28" name="Text 26"/>
+          <p:cNvPr id="29" name="Text 27"/>
           <p:cNvSpPr txBox="1"/>
           <p:nvPr/>
         </p:nvSpPr>
@@ -7765,7 +7560,7 @@
               <a:buNone/>
             </a:pPr>
             <a:r>
-              <a:rPr lang="en-US" sz="3200" b="1" dirty="0">
+              <a:rPr lang="en-US" sz="2600" b="1" dirty="0">
                 <a:solidFill>
                   <a:srgbClr val="0F1B2D"/>
                 </a:solidFill>
@@ -7773,9 +7568,9 @@
                 <a:ea typeface="Cambria" pitchFamily="34" charset="-122"/>
                 <a:cs typeface="Cambria" pitchFamily="34" charset="-120"/>
               </a:rPr>
-              <a:t>OEM market: from equipment makers to packagers</a:t>
-            </a:r>
-            <a:endParaRPr lang="en-US" sz="3200" dirty="0"/>
+              <a:t>OEM market: who builds the plant</a:t>
+            </a:r>
+            <a:endParaRPr lang="en-US" sz="2600" dirty="0"/>
           </a:p>
         </p:txBody>
       </p:sp>
@@ -7788,7 +7583,7 @@
         <p:spPr>
           <a:xfrm>
             <a:off x="457200" y="1280160"/>
-            <a:ext cx="2606040" cy="2377440"/>
+            <a:ext cx="3840480" cy="2743200"/>
           </a:xfrm>
           <a:prstGeom prst="rect">
             <a:avLst/>
@@ -7819,24 +7614,24 @@
         </p:nvSpPr>
         <p:spPr>
           <a:xfrm>
-            <a:off x="640080" y="1417320"/>
-            <a:ext cx="2240280" cy="548640"/>
-          </a:xfrm>
-          <a:prstGeom prst="rect">
-            <a:avLst/>
-          </a:prstGeom>
-          <a:noFill/>
-          <a:ln/>
-        </p:spPr>
-        <p:txBody>
-          <a:bodyPr wrap="square" lIns="0" tIns="0" rIns="0" bIns="0" rtlCol="0" anchor="t"/>
+            <a:off x="640080" y="1371600"/>
+            <a:ext cx="3474720" cy="274320"/>
+          </a:xfrm>
+          <a:prstGeom prst="rect">
+            <a:avLst/>
+          </a:prstGeom>
+          <a:noFill/>
+          <a:ln/>
+        </p:spPr>
+        <p:txBody>
+          <a:bodyPr wrap="square" lIns="0" tIns="0" rIns="0" bIns="0" rtlCol="0" anchor="ctr"/>
           <a:lstStyle/>
           <a:p>
             <a:pPr indent="0" marL="0">
               <a:buNone/>
             </a:pPr>
             <a:r>
-              <a:rPr lang="en-US" sz="1700" b="1" dirty="0">
+              <a:rPr lang="en-US" sz="1400" b="1" dirty="0">
                 <a:solidFill>
                   <a:srgbClr val="0F1B2D"/>
                 </a:solidFill>
@@ -7844,217 +7639,38 @@
                 <a:ea typeface="Cambria" pitchFamily="34" charset="-122"/>
                 <a:cs typeface="Cambria" pitchFamily="34" charset="-120"/>
               </a:rPr>
-              <a:t>Equipment manufacturers</a:t>
-            </a:r>
-            <a:endParaRPr lang="en-US" sz="1700" dirty="0"/>
-          </a:p>
-        </p:txBody>
-      </p:sp>
-      <p:sp>
-        <p:nvSpPr>
-          <p:cNvPr id="5" name="Text 3"/>
-          <p:cNvSpPr txBox="1"/>
-          <p:nvPr/>
-        </p:nvSpPr>
-        <p:spPr>
-          <a:xfrm>
-            <a:off x="640080" y="2011680"/>
-            <a:ext cx="2240280" cy="228600"/>
-          </a:xfrm>
-          <a:prstGeom prst="rect">
-            <a:avLst/>
-          </a:prstGeom>
-          <a:noFill/>
-          <a:ln/>
-        </p:spPr>
-        <p:txBody>
-          <a:bodyPr wrap="square" lIns="0" tIns="0" rIns="0" bIns="0" rtlCol="0" anchor="ctr"/>
-          <a:lstStyle/>
-          <a:p>
-            <a:pPr indent="0" marL="0">
-              <a:buNone/>
-            </a:pPr>
-            <a:r>
-              <a:rPr lang="en-US" sz="1100" b="1" dirty="0">
-                <a:solidFill>
-                  <a:srgbClr val="C8742B"/>
-                </a:solidFill>
-                <a:latin typeface="Calibri" pitchFamily="34" charset="0"/>
-                <a:ea typeface="Calibri" pitchFamily="34" charset="-122"/>
-                <a:cs typeface="Calibri" pitchFamily="34" charset="-120"/>
-              </a:rPr>
-              <a:t>Who they are</a:t>
-            </a:r>
-            <a:endParaRPr lang="en-US" sz="1100" dirty="0"/>
-          </a:p>
-        </p:txBody>
-      </p:sp>
-      <p:sp>
-        <p:nvSpPr>
-          <p:cNvPr id="6" name="Text 4"/>
-          <p:cNvSpPr txBox="1"/>
-          <p:nvPr/>
-        </p:nvSpPr>
-        <p:spPr>
-          <a:xfrm>
-            <a:off x="640080" y="2240280"/>
-            <a:ext cx="2240280" cy="548640"/>
-          </a:xfrm>
-          <a:prstGeom prst="rect">
-            <a:avLst/>
-          </a:prstGeom>
-          <a:noFill/>
-          <a:ln/>
-        </p:spPr>
-        <p:txBody>
-          <a:bodyPr wrap="square" lIns="0" tIns="0" rIns="0" bIns="0" rtlCol="0" anchor="t"/>
-          <a:lstStyle/>
-          <a:p>
-            <a:pPr indent="0" marL="0">
-              <a:buNone/>
-            </a:pPr>
-            <a:r>
-              <a:rPr lang="en-US" sz="1300" dirty="0">
-                <a:solidFill>
-                  <a:srgbClr val="1B2735"/>
-                </a:solidFill>
-                <a:latin typeface="Calibri" pitchFamily="34" charset="0"/>
-                <a:ea typeface="Calibri" pitchFamily="34" charset="-122"/>
-                <a:cs typeface="Calibri" pitchFamily="34" charset="-120"/>
-              </a:rPr>
-              <a:t>Turbines, generators, switchgear, transformers</a:t>
-            </a:r>
-            <a:endParaRPr lang="en-US" sz="1300" dirty="0"/>
-          </a:p>
-        </p:txBody>
-      </p:sp>
-      <p:sp>
-        <p:nvSpPr>
-          <p:cNvPr id="7" name="Text 5"/>
-          <p:cNvSpPr txBox="1"/>
-          <p:nvPr/>
-        </p:nvSpPr>
-        <p:spPr>
-          <a:xfrm>
-            <a:off x="640080" y="2834640"/>
-            <a:ext cx="2240280" cy="228600"/>
-          </a:xfrm>
-          <a:prstGeom prst="rect">
-            <a:avLst/>
-          </a:prstGeom>
-          <a:noFill/>
-          <a:ln/>
-        </p:spPr>
-        <p:txBody>
-          <a:bodyPr wrap="square" lIns="0" tIns="0" rIns="0" bIns="0" rtlCol="0" anchor="ctr"/>
-          <a:lstStyle/>
-          <a:p>
-            <a:pPr indent="0" marL="0">
-              <a:buNone/>
-            </a:pPr>
-            <a:r>
-              <a:rPr lang="en-US" sz="1100" b="1" dirty="0">
-                <a:solidFill>
-                  <a:srgbClr val="C8742B"/>
-                </a:solidFill>
-                <a:latin typeface="Calibri" pitchFamily="34" charset="0"/>
-                <a:ea typeface="Calibri" pitchFamily="34" charset="-122"/>
-                <a:cs typeface="Calibri" pitchFamily="34" charset="-120"/>
-              </a:rPr>
-              <a:t>Southwire offering</a:t>
-            </a:r>
-            <a:endParaRPr lang="en-US" sz="1100" dirty="0"/>
-          </a:p>
-        </p:txBody>
-      </p:sp>
-      <p:sp>
-        <p:nvSpPr>
-          <p:cNvPr id="8" name="Text 6"/>
-          <p:cNvSpPr txBox="1"/>
-          <p:nvPr/>
-        </p:nvSpPr>
-        <p:spPr>
-          <a:xfrm>
-            <a:off x="640080" y="3063240"/>
-            <a:ext cx="2240280" cy="548640"/>
-          </a:xfrm>
-          <a:prstGeom prst="rect">
-            <a:avLst/>
-          </a:prstGeom>
-          <a:noFill/>
-          <a:ln/>
-        </p:spPr>
-        <p:txBody>
-          <a:bodyPr wrap="square" lIns="0" tIns="0" rIns="0" bIns="0" rtlCol="0" anchor="t"/>
-          <a:lstStyle/>
-          <a:p>
-            <a:pPr indent="0" marL="0">
-              <a:buNone/>
-            </a:pPr>
-            <a:r>
-              <a:rPr lang="en-US" sz="1300" dirty="0">
-                <a:solidFill>
-                  <a:srgbClr val="1B2735"/>
-                </a:solidFill>
-                <a:latin typeface="Calibri" pitchFamily="34" charset="0"/>
-                <a:ea typeface="Calibri" pitchFamily="34" charset="-122"/>
-                <a:cs typeface="Calibri" pitchFamily="34" charset="-120"/>
-              </a:rPr>
-              <a:t>Cable for OEM-built equipment and skids</a:t>
-            </a:r>
-            <a:endParaRPr lang="en-US" sz="1300" dirty="0"/>
-          </a:p>
-        </p:txBody>
-      </p:sp>
-      <p:sp>
-        <p:nvSpPr>
-          <p:cNvPr id="9" name="Text 7"/>
-          <p:cNvSpPr txBox="1"/>
-          <p:nvPr/>
-        </p:nvSpPr>
-        <p:spPr>
-          <a:xfrm>
-            <a:off x="3063240" y="2194560"/>
-            <a:ext cx="182880" cy="365760"/>
-          </a:xfrm>
-          <a:prstGeom prst="rect">
-            <a:avLst/>
-          </a:prstGeom>
-          <a:noFill/>
-          <a:ln/>
-        </p:spPr>
-        <p:txBody>
-          <a:bodyPr wrap="square" lIns="0" tIns="0" rIns="0" bIns="0" rtlCol="0" anchor="ctr"/>
-          <a:lstStyle/>
-          <a:p>
-            <a:pPr algn="ctr" indent="0" marL="0">
-              <a:buNone/>
-            </a:pPr>
-            <a:r>
-              <a:rPr lang="en-US" sz="2000" b="1" dirty="0">
-                <a:solidFill>
-                  <a:srgbClr val="C8742B"/>
-                </a:solidFill>
-                <a:latin typeface="Cambria" pitchFamily="34" charset="0"/>
-                <a:ea typeface="Cambria" pitchFamily="34" charset="-122"/>
-                <a:cs typeface="Cambria" pitchFamily="34" charset="-120"/>
-              </a:rPr>
-              <a:t>&gt;</a:t>
-            </a:r>
-            <a:endParaRPr lang="en-US" sz="2000" dirty="0"/>
-          </a:p>
-        </p:txBody>
-      </p:sp>
-      <p:sp>
-        <p:nvSpPr>
-          <p:cNvPr id="10" name="Shape 8"/>
+              <a:t>Large gas turbine backlog (GW)</a:t>
+            </a:r>
+            <a:endParaRPr lang="en-US" sz="1400" dirty="0"/>
+          </a:p>
+        </p:txBody>
+      </p:sp>
+      <p:graphicFrame>
+        <p:nvGraphicFramePr>
+          <p:cNvPr id="5" name="Chart 0" descr=""/>
+          <p:cNvGraphicFramePr/>
+          <p:nvPr/>
+        </p:nvGraphicFramePr>
+        <p:xfrm>
+          <a:off x="548640" y="1691640"/>
+          <a:ext cx="3657600" cy="2240280"/>
+        </p:xfrm>
+        <a:graphic xmlns:a="http://schemas.openxmlformats.org/drawingml/2006/main">
+          <a:graphicData uri="http://schemas.openxmlformats.org/drawingml/2006/chart">
+            <c:chart xmlns:c="http://schemas.openxmlformats.org/drawingml/2006/chart" r:id="rId1"/>
+          </a:graphicData>
+        </a:graphic>
+      </p:graphicFrame>
+      <p:sp>
+        <p:nvSpPr>
+          <p:cNvPr id="6" name="Shape 3"/>
           <p:cNvSpPr/>
           <p:nvPr/>
         </p:nvSpPr>
         <p:spPr>
           <a:xfrm>
-            <a:off x="3246120" y="1280160"/>
-            <a:ext cx="2606040" cy="2377440"/>
+            <a:off x="4572000" y="1280160"/>
+            <a:ext cx="4114800" cy="822960"/>
           </a:xfrm>
           <a:prstGeom prst="rect">
             <a:avLst/>
@@ -8079,30 +7695,30 @@
       </p:sp>
       <p:sp>
         <p:nvSpPr>
-          <p:cNvPr id="11" name="Text 9"/>
-          <p:cNvSpPr txBox="1"/>
-          <p:nvPr/>
-        </p:nvSpPr>
-        <p:spPr>
-          <a:xfrm>
-            <a:off x="3429000" y="1417320"/>
-            <a:ext cx="2240280" cy="548640"/>
-          </a:xfrm>
-          <a:prstGeom prst="rect">
-            <a:avLst/>
-          </a:prstGeom>
-          <a:noFill/>
-          <a:ln/>
-        </p:spPr>
-        <p:txBody>
-          <a:bodyPr wrap="square" lIns="0" tIns="0" rIns="0" bIns="0" rtlCol="0" anchor="t"/>
+          <p:cNvPr id="7" name="Text 4"/>
+          <p:cNvSpPr txBox="1"/>
+          <p:nvPr/>
+        </p:nvSpPr>
+        <p:spPr>
+          <a:xfrm>
+            <a:off x="4709160" y="1325880"/>
+            <a:ext cx="3840480" cy="731520"/>
+          </a:xfrm>
+          <a:prstGeom prst="rect">
+            <a:avLst/>
+          </a:prstGeom>
+          <a:noFill/>
+          <a:ln/>
+        </p:spPr>
+        <p:txBody>
+          <a:bodyPr wrap="square" lIns="0" tIns="0" rIns="0" bIns="0" rtlCol="0" anchor="ctr"/>
           <a:lstStyle/>
           <a:p>
             <a:pPr indent="0" marL="0">
               <a:buNone/>
             </a:pPr>
             <a:r>
-              <a:rPr lang="en-US" sz="1700" b="1" dirty="0">
+              <a:rPr lang="en-US" sz="1300" b="1" dirty="0">
                 <a:solidFill>
                   <a:srgbClr val="0F1B2D"/>
                 </a:solidFill>
@@ -8110,85 +7726,41 @@
                 <a:ea typeface="Cambria" pitchFamily="34" charset="-122"/>
                 <a:cs typeface="Cambria" pitchFamily="34" charset="-120"/>
               </a:rPr>
-              <a:t>Power packagers</a:t>
-            </a:r>
-            <a:endParaRPr lang="en-US" sz="1700" dirty="0"/>
-          </a:p>
-        </p:txBody>
-      </p:sp>
-      <p:sp>
-        <p:nvSpPr>
-          <p:cNvPr id="12" name="Text 10"/>
-          <p:cNvSpPr txBox="1"/>
-          <p:nvPr/>
-        </p:nvSpPr>
-        <p:spPr>
-          <a:xfrm>
-            <a:off x="3429000" y="2011680"/>
-            <a:ext cx="2240280" cy="228600"/>
-          </a:xfrm>
-          <a:prstGeom prst="rect">
-            <a:avLst/>
-          </a:prstGeom>
-          <a:noFill/>
-          <a:ln/>
-        </p:spPr>
-        <p:txBody>
-          <a:bodyPr wrap="square" lIns="0" tIns="0" rIns="0" bIns="0" rtlCol="0" anchor="ctr"/>
-          <a:lstStyle/>
+              <a:t>Turbine OEMs</a:t>
+            </a:r>
+            <a:endParaRPr lang="en-US" sz="1300" dirty="0"/>
+          </a:p>
           <a:p>
             <a:pPr indent="0" marL="0">
               <a:buNone/>
             </a:pPr>
             <a:r>
-              <a:rPr lang="en-US" sz="1100" b="1" dirty="0">
-                <a:solidFill>
-                  <a:srgbClr val="C8742B"/>
+              <a:rPr lang="en-US" sz="1100" dirty="0">
+                <a:solidFill>
+                  <a:srgbClr val="5B6B7F"/>
                 </a:solidFill>
                 <a:latin typeface="Calibri" pitchFamily="34" charset="0"/>
                 <a:ea typeface="Calibri" pitchFamily="34" charset="-122"/>
                 <a:cs typeface="Calibri" pitchFamily="34" charset="-120"/>
               </a:rPr>
-              <a:t>Who they are</a:t>
-            </a:r>
-            <a:endParaRPr lang="en-US" sz="1100" dirty="0"/>
-          </a:p>
-        </p:txBody>
-      </p:sp>
-      <p:sp>
-        <p:nvSpPr>
-          <p:cNvPr id="13" name="Text 11"/>
-          <p:cNvSpPr txBox="1"/>
-          <p:nvPr/>
-        </p:nvSpPr>
-        <p:spPr>
-          <a:xfrm>
-            <a:off x="3429000" y="2240280"/>
-            <a:ext cx="2240280" cy="548640"/>
-          </a:xfrm>
-          <a:prstGeom prst="rect">
-            <a:avLst/>
-          </a:prstGeom>
-          <a:noFill/>
-          <a:ln/>
-        </p:spPr>
-        <p:txBody>
-          <a:bodyPr wrap="square" lIns="0" tIns="0" rIns="0" bIns="0" rtlCol="0" anchor="t"/>
-          <a:lstStyle/>
+              <a:t>GE Vernova, Siemens Energy, Mitsubishi Heavy</a:t>
+            </a:r>
+            <a:endParaRPr lang="en-US" sz="1300" dirty="0"/>
+          </a:p>
           <a:p>
             <a:pPr indent="0" marL="0">
               <a:buNone/>
             </a:pPr>
             <a:r>
-              <a:rPr lang="en-US" sz="1300" dirty="0">
-                <a:solidFill>
-                  <a:srgbClr val="1B2735"/>
+              <a:rPr lang="en-US" sz="1100" b="1" dirty="0">
+                <a:solidFill>
+                  <a:srgbClr val="C8742B"/>
                 </a:solidFill>
                 <a:latin typeface="Calibri" pitchFamily="34" charset="0"/>
                 <a:ea typeface="Calibri" pitchFamily="34" charset="-122"/>
                 <a:cs typeface="Calibri" pitchFamily="34" charset="-120"/>
               </a:rPr>
-              <a:t>Skid-mounted and modular power systems</a:t>
+              <a:t>Southwire: MV, LV and control cable for OEM-built equipment</a:t>
             </a:r>
             <a:endParaRPr lang="en-US" sz="1300" dirty="0"/>
           </a:p>
@@ -8196,131 +7768,14 @@
       </p:sp>
       <p:sp>
         <p:nvSpPr>
-          <p:cNvPr id="14" name="Text 12"/>
-          <p:cNvSpPr txBox="1"/>
-          <p:nvPr/>
-        </p:nvSpPr>
-        <p:spPr>
-          <a:xfrm>
-            <a:off x="3429000" y="2834640"/>
-            <a:ext cx="2240280" cy="228600"/>
-          </a:xfrm>
-          <a:prstGeom prst="rect">
-            <a:avLst/>
-          </a:prstGeom>
-          <a:noFill/>
-          <a:ln/>
-        </p:spPr>
-        <p:txBody>
-          <a:bodyPr wrap="square" lIns="0" tIns="0" rIns="0" bIns="0" rtlCol="0" anchor="ctr"/>
-          <a:lstStyle/>
-          <a:p>
-            <a:pPr indent="0" marL="0">
-              <a:buNone/>
-            </a:pPr>
-            <a:r>
-              <a:rPr lang="en-US" sz="1100" b="1" dirty="0">
-                <a:solidFill>
-                  <a:srgbClr val="C8742B"/>
-                </a:solidFill>
-                <a:latin typeface="Calibri" pitchFamily="34" charset="0"/>
-                <a:ea typeface="Calibri" pitchFamily="34" charset="-122"/>
-                <a:cs typeface="Calibri" pitchFamily="34" charset="-120"/>
-              </a:rPr>
-              <a:t>Southwire offering</a:t>
-            </a:r>
-            <a:endParaRPr lang="en-US" sz="1100" dirty="0"/>
-          </a:p>
-        </p:txBody>
-      </p:sp>
-      <p:sp>
-        <p:nvSpPr>
-          <p:cNvPr id="15" name="Text 13"/>
-          <p:cNvSpPr txBox="1"/>
-          <p:nvPr/>
-        </p:nvSpPr>
-        <p:spPr>
-          <a:xfrm>
-            <a:off x="3429000" y="3063240"/>
-            <a:ext cx="2240280" cy="548640"/>
-          </a:xfrm>
-          <a:prstGeom prst="rect">
-            <a:avLst/>
-          </a:prstGeom>
-          <a:noFill/>
-          <a:ln/>
-        </p:spPr>
-        <p:txBody>
-          <a:bodyPr wrap="square" lIns="0" tIns="0" rIns="0" bIns="0" rtlCol="0" anchor="t"/>
-          <a:lstStyle/>
-          <a:p>
-            <a:pPr indent="0" marL="0">
-              <a:buNone/>
-            </a:pPr>
-            <a:r>
-              <a:rPr lang="en-US" sz="1300" dirty="0">
-                <a:solidFill>
-                  <a:srgbClr val="1B2735"/>
-                </a:solidFill>
-                <a:latin typeface="Calibri" pitchFamily="34" charset="0"/>
-                <a:ea typeface="Calibri" pitchFamily="34" charset="-122"/>
-                <a:cs typeface="Calibri" pitchFamily="34" charset="-120"/>
-              </a:rPr>
-              <a:t>Packaged and pre-terminated solutions</a:t>
-            </a:r>
-            <a:endParaRPr lang="en-US" sz="1300" dirty="0"/>
-          </a:p>
-        </p:txBody>
-      </p:sp>
-      <p:sp>
-        <p:nvSpPr>
-          <p:cNvPr id="16" name="Text 14"/>
-          <p:cNvSpPr txBox="1"/>
-          <p:nvPr/>
-        </p:nvSpPr>
-        <p:spPr>
-          <a:xfrm>
-            <a:off x="5852160" y="2194560"/>
-            <a:ext cx="182880" cy="365760"/>
-          </a:xfrm>
-          <a:prstGeom prst="rect">
-            <a:avLst/>
-          </a:prstGeom>
-          <a:noFill/>
-          <a:ln/>
-        </p:spPr>
-        <p:txBody>
-          <a:bodyPr wrap="square" lIns="0" tIns="0" rIns="0" bIns="0" rtlCol="0" anchor="ctr"/>
-          <a:lstStyle/>
-          <a:p>
-            <a:pPr algn="ctr" indent="0" marL="0">
-              <a:buNone/>
-            </a:pPr>
-            <a:r>
-              <a:rPr lang="en-US" sz="2000" b="1" dirty="0">
-                <a:solidFill>
-                  <a:srgbClr val="C8742B"/>
-                </a:solidFill>
-                <a:latin typeface="Cambria" pitchFamily="34" charset="0"/>
-                <a:ea typeface="Cambria" pitchFamily="34" charset="-122"/>
-                <a:cs typeface="Cambria" pitchFamily="34" charset="-120"/>
-              </a:rPr>
-              <a:t>&gt;</a:t>
-            </a:r>
-            <a:endParaRPr lang="en-US" sz="2000" dirty="0"/>
-          </a:p>
-        </p:txBody>
-      </p:sp>
-      <p:sp>
-        <p:nvSpPr>
-          <p:cNvPr id="17" name="Shape 15"/>
+          <p:cNvPr id="8" name="Shape 5"/>
           <p:cNvSpPr/>
           <p:nvPr/>
         </p:nvSpPr>
         <p:spPr>
           <a:xfrm>
-            <a:off x="6035040" y="1280160"/>
-            <a:ext cx="2606040" cy="2377440"/>
+            <a:off x="4572000" y="2240280"/>
+            <a:ext cx="4114800" cy="822960"/>
           </a:xfrm>
           <a:prstGeom prst="rect">
             <a:avLst/>
@@ -8345,30 +7800,30 @@
       </p:sp>
       <p:sp>
         <p:nvSpPr>
-          <p:cNvPr id="18" name="Text 16"/>
-          <p:cNvSpPr txBox="1"/>
-          <p:nvPr/>
-        </p:nvSpPr>
-        <p:spPr>
-          <a:xfrm>
-            <a:off x="6217920" y="1417320"/>
-            <a:ext cx="2240280" cy="548640"/>
-          </a:xfrm>
-          <a:prstGeom prst="rect">
-            <a:avLst/>
-          </a:prstGeom>
-          <a:noFill/>
-          <a:ln/>
-        </p:spPr>
-        <p:txBody>
-          <a:bodyPr wrap="square" lIns="0" tIns="0" rIns="0" bIns="0" rtlCol="0" anchor="t"/>
+          <p:cNvPr id="9" name="Text 6"/>
+          <p:cNvSpPr txBox="1"/>
+          <p:nvPr/>
+        </p:nvSpPr>
+        <p:spPr>
+          <a:xfrm>
+            <a:off x="4709160" y="2286000"/>
+            <a:ext cx="3840480" cy="731520"/>
+          </a:xfrm>
+          <a:prstGeom prst="rect">
+            <a:avLst/>
+          </a:prstGeom>
+          <a:noFill/>
+          <a:ln/>
+        </p:spPr>
+        <p:txBody>
+          <a:bodyPr wrap="square" lIns="0" tIns="0" rIns="0" bIns="0" rtlCol="0" anchor="ctr"/>
           <a:lstStyle/>
           <a:p>
             <a:pPr indent="0" marL="0">
               <a:buNone/>
             </a:pPr>
             <a:r>
-              <a:rPr lang="en-US" sz="1700" b="1" dirty="0">
+              <a:rPr lang="en-US" sz="1300" b="1" dirty="0">
                 <a:solidFill>
                   <a:srgbClr val="0F1B2D"/>
                 </a:solidFill>
@@ -8376,85 +7831,41 @@
                 <a:ea typeface="Cambria" pitchFamily="34" charset="-122"/>
                 <a:cs typeface="Cambria" pitchFamily="34" charset="-120"/>
               </a:rPr>
-              <a:t>EPCs and owners</a:t>
-            </a:r>
-            <a:endParaRPr lang="en-US" sz="1700" dirty="0"/>
-          </a:p>
-        </p:txBody>
-      </p:sp>
-      <p:sp>
-        <p:nvSpPr>
-          <p:cNvPr id="19" name="Text 17"/>
-          <p:cNvSpPr txBox="1"/>
-          <p:nvPr/>
-        </p:nvSpPr>
-        <p:spPr>
-          <a:xfrm>
-            <a:off x="6217920" y="2011680"/>
-            <a:ext cx="2240280" cy="228600"/>
-          </a:xfrm>
-          <a:prstGeom prst="rect">
-            <a:avLst/>
-          </a:prstGeom>
-          <a:noFill/>
-          <a:ln/>
-        </p:spPr>
-        <p:txBody>
-          <a:bodyPr wrap="square" lIns="0" tIns="0" rIns="0" bIns="0" rtlCol="0" anchor="ctr"/>
-          <a:lstStyle/>
+              <a:t>Packagers and engine makers</a:t>
+            </a:r>
+            <a:endParaRPr lang="en-US" sz="1300" dirty="0"/>
+          </a:p>
           <a:p>
             <a:pPr indent="0" marL="0">
               <a:buNone/>
             </a:pPr>
             <a:r>
-              <a:rPr lang="en-US" sz="1100" b="1" dirty="0">
-                <a:solidFill>
-                  <a:srgbClr val="C8742B"/>
+              <a:rPr lang="en-US" sz="1100" dirty="0">
+                <a:solidFill>
+                  <a:srgbClr val="5B6B7F"/>
                 </a:solidFill>
                 <a:latin typeface="Calibri" pitchFamily="34" charset="0"/>
                 <a:ea typeface="Calibri" pitchFamily="34" charset="-122"/>
                 <a:cs typeface="Calibri" pitchFamily="34" charset="-120"/>
               </a:rPr>
-              <a:t>Who they are</a:t>
-            </a:r>
-            <a:endParaRPr lang="en-US" sz="1100" dirty="0"/>
-          </a:p>
-        </p:txBody>
-      </p:sp>
-      <p:sp>
-        <p:nvSpPr>
-          <p:cNvPr id="20" name="Text 18"/>
-          <p:cNvSpPr txBox="1"/>
-          <p:nvPr/>
-        </p:nvSpPr>
-        <p:spPr>
-          <a:xfrm>
-            <a:off x="6217920" y="2240280"/>
-            <a:ext cx="2240280" cy="548640"/>
-          </a:xfrm>
-          <a:prstGeom prst="rect">
-            <a:avLst/>
-          </a:prstGeom>
-          <a:noFill/>
-          <a:ln/>
-        </p:spPr>
-        <p:txBody>
-          <a:bodyPr wrap="square" lIns="0" tIns="0" rIns="0" bIns="0" rtlCol="0" anchor="t"/>
-          <a:lstStyle/>
+              <a:t>Solar Turbines (Caterpillar), Wartsila, energy-as-a-service developers</a:t>
+            </a:r>
+            <a:endParaRPr lang="en-US" sz="1300" dirty="0"/>
+          </a:p>
           <a:p>
             <a:pPr indent="0" marL="0">
               <a:buNone/>
             </a:pPr>
             <a:r>
-              <a:rPr lang="en-US" sz="1300" dirty="0">
-                <a:solidFill>
-                  <a:srgbClr val="1B2735"/>
+              <a:rPr lang="en-US" sz="1100" b="1" dirty="0">
+                <a:solidFill>
+                  <a:srgbClr val="C8742B"/>
                 </a:solidFill>
                 <a:latin typeface="Calibri" pitchFamily="34" charset="0"/>
                 <a:ea typeface="Calibri" pitchFamily="34" charset="-122"/>
                 <a:cs typeface="Calibri" pitchFamily="34" charset="-120"/>
               </a:rPr>
-              <a:t>Specify and procure for the full plant</a:t>
+              <a:t>Southwire: packaged and pre-terminated cable</a:t>
             </a:r>
             <a:endParaRPr lang="en-US" sz="1300" dirty="0"/>
           </a:p>
@@ -8462,14 +7873,46 @@
       </p:sp>
       <p:sp>
         <p:nvSpPr>
-          <p:cNvPr id="21" name="Text 19"/>
-          <p:cNvSpPr txBox="1"/>
-          <p:nvPr/>
-        </p:nvSpPr>
-        <p:spPr>
-          <a:xfrm>
-            <a:off x="6217920" y="2834640"/>
-            <a:ext cx="2240280" cy="228600"/>
+          <p:cNvPr id="10" name="Shape 7"/>
+          <p:cNvSpPr/>
+          <p:nvPr/>
+        </p:nvSpPr>
+        <p:spPr>
+          <a:xfrm>
+            <a:off x="4572000" y="3200400"/>
+            <a:ext cx="4114800" cy="822960"/>
+          </a:xfrm>
+          <a:prstGeom prst="rect">
+            <a:avLst/>
+          </a:prstGeom>
+          <a:solidFill>
+            <a:srgbClr val="0F1B2D"/>
+          </a:solidFill>
+          <a:ln w="9525">
+            <a:solidFill>
+              <a:srgbClr val="0F1B2D"/>
+            </a:solidFill>
+            <a:prstDash val="solid"/>
+          </a:ln>
+          <a:effectLst>
+            <a:outerShdw sx="100000" sy="100000" kx="0" ky="0" algn="bl" rotWithShape="0" blurRad="76200" dist="25400" dir="5400000">
+              <a:srgbClr val="000000">
+                <a:alpha val="12000"/>
+              </a:srgbClr>
+            </a:outerShdw>
+          </a:effectLst>
+        </p:spPr>
+      </p:sp>
+      <p:sp>
+        <p:nvSpPr>
+          <p:cNvPr id="11" name="Text 8"/>
+          <p:cNvSpPr txBox="1"/>
+          <p:nvPr/>
+        </p:nvSpPr>
+        <p:spPr>
+          <a:xfrm>
+            <a:off x="4709160" y="3246120"/>
+            <a:ext cx="3840480" cy="731520"/>
           </a:xfrm>
           <a:prstGeom prst="rect">
             <a:avLst/>
@@ -8485,54 +7928,49 @@
               <a:buNone/>
             </a:pPr>
             <a:r>
-              <a:rPr lang="en-US" sz="1100" b="1" dirty="0">
-                <a:solidFill>
-                  <a:srgbClr val="C8742B"/>
+              <a:rPr lang="en-US" sz="1300" b="1" dirty="0">
+                <a:solidFill>
+                  <a:srgbClr val="FFFFFF"/>
+                </a:solidFill>
+                <a:latin typeface="Cambria" pitchFamily="34" charset="0"/>
+                <a:ea typeface="Cambria" pitchFamily="34" charset="-122"/>
+                <a:cs typeface="Cambria" pitchFamily="34" charset="-120"/>
+              </a:rPr>
+              <a:t>Data center on-site power</a:t>
+            </a:r>
+            <a:endParaRPr lang="en-US" sz="1300" dirty="0"/>
+          </a:p>
+          <a:p>
+            <a:pPr indent="0" marL="0">
+              <a:buNone/>
+            </a:pPr>
+            <a:r>
+              <a:rPr lang="en-US" sz="1100" dirty="0">
+                <a:solidFill>
+                  <a:srgbClr val="CADCFC"/>
                 </a:solidFill>
                 <a:latin typeface="Calibri" pitchFamily="34" charset="0"/>
                 <a:ea typeface="Calibri" pitchFamily="34" charset="-122"/>
                 <a:cs typeface="Calibri" pitchFamily="34" charset="-120"/>
               </a:rPr>
-              <a:t>Southwire offering</a:t>
-            </a:r>
-            <a:endParaRPr lang="en-US" sz="1100" dirty="0"/>
-          </a:p>
-        </p:txBody>
-      </p:sp>
-      <p:sp>
-        <p:nvSpPr>
-          <p:cNvPr id="22" name="Text 20"/>
-          <p:cNvSpPr txBox="1"/>
-          <p:nvPr/>
-        </p:nvSpPr>
-        <p:spPr>
-          <a:xfrm>
-            <a:off x="6217920" y="3063240"/>
-            <a:ext cx="2240280" cy="548640"/>
-          </a:xfrm>
-          <a:prstGeom prst="rect">
-            <a:avLst/>
-          </a:prstGeom>
-          <a:noFill/>
-          <a:ln/>
-        </p:spPr>
-        <p:txBody>
-          <a:bodyPr wrap="square" lIns="0" tIns="0" rIns="0" bIns="0" rtlCol="0" anchor="t"/>
-          <a:lstStyle/>
+              <a:t>~56 GW planned behind-the-meter, 46 projects</a:t>
+            </a:r>
+            <a:endParaRPr lang="en-US" sz="1300" dirty="0"/>
+          </a:p>
           <a:p>
             <a:pPr indent="0" marL="0">
               <a:buNone/>
             </a:pPr>
             <a:r>
-              <a:rPr lang="en-US" sz="1300" dirty="0">
-                <a:solidFill>
-                  <a:srgbClr val="1B2735"/>
+              <a:rPr lang="en-US" sz="1100" b="1" dirty="0">
+                <a:solidFill>
+                  <a:srgbClr val="C8742B"/>
                 </a:solidFill>
                 <a:latin typeface="Calibri" pitchFamily="34" charset="0"/>
                 <a:ea typeface="Calibri" pitchFamily="34" charset="-122"/>
                 <a:cs typeface="Calibri" pitchFamily="34" charset="-120"/>
               </a:rPr>
-              <a:t>Approved-vendor status and project support</a:t>
+              <a:t>Southwire: full plant cable package</a:t>
             </a:r>
             <a:endParaRPr lang="en-US" sz="1300" dirty="0"/>
           </a:p>
@@ -8540,30 +7978,30 @@
       </p:sp>
       <p:sp>
         <p:nvSpPr>
-          <p:cNvPr id="23" name="Text 21"/>
-          <p:cNvSpPr txBox="1"/>
-          <p:nvPr/>
-        </p:nvSpPr>
-        <p:spPr>
-          <a:xfrm>
-            <a:off x="457200" y="3840480"/>
-            <a:ext cx="8229600" cy="548640"/>
-          </a:xfrm>
-          <a:prstGeom prst="rect">
-            <a:avLst/>
-          </a:prstGeom>
-          <a:noFill/>
-          <a:ln/>
-        </p:spPr>
-        <p:txBody>
-          <a:bodyPr wrap="square" lIns="0" tIns="0" rIns="0" bIns="0" rtlCol="0" anchor="t"/>
+          <p:cNvPr id="12" name="Text 9"/>
+          <p:cNvSpPr txBox="1"/>
+          <p:nvPr/>
+        </p:nvSpPr>
+        <p:spPr>
+          <a:xfrm>
+            <a:off x="457200" y="4114800"/>
+            <a:ext cx="8229600" cy="274320"/>
+          </a:xfrm>
+          <a:prstGeom prst="rect">
+            <a:avLst/>
+          </a:prstGeom>
+          <a:noFill/>
+          <a:ln/>
+        </p:spPr>
+        <p:txBody>
+          <a:bodyPr wrap="square" lIns="0" tIns="0" rIns="0" bIns="0" rtlCol="0" anchor="ctr"/>
           <a:lstStyle/>
           <a:p>
             <a:pPr indent="0" marL="0">
               <a:buNone/>
             </a:pPr>
             <a:r>
-              <a:rPr lang="en-US" sz="1400" i="1" dirty="0">
+              <a:rPr lang="en-US" sz="1300" i="1" dirty="0">
                 <a:solidFill>
                   <a:srgbClr val="5B6B7F"/>
                 </a:solidFill>
@@ -8571,22 +8009,22 @@
                 <a:ea typeface="Calibri" pitchFamily="34" charset="-122"/>
                 <a:cs typeface="Calibri" pitchFamily="34" charset="-120"/>
               </a:rPr>
-              <a:t>Where AXE adds value: logistics, inventory and project coordination at the OEM level [confirm with Phil/Bob]</a:t>
-            </a:r>
-            <a:endParaRPr lang="en-US" sz="1400" dirty="0"/>
-          </a:p>
-        </p:txBody>
-      </p:sp>
-      <p:sp>
-        <p:nvSpPr>
-          <p:cNvPr id="24" name="Text 22"/>
-          <p:cNvSpPr txBox="1"/>
-          <p:nvPr/>
-        </p:nvSpPr>
-        <p:spPr>
-          <a:xfrm>
-            <a:off x="457200" y="4754880"/>
-            <a:ext cx="5486400" cy="228600"/>
+              <a:t>Where AXE adds value: logistics, inventory and project coordination for OEMs and packagers (to discuss).</a:t>
+            </a:r>
+            <a:endParaRPr lang="en-US" sz="1300" dirty="0"/>
+          </a:p>
+        </p:txBody>
+      </p:sp>
+      <p:sp>
+        <p:nvSpPr>
+          <p:cNvPr id="13" name="Text 10"/>
+          <p:cNvSpPr txBox="1"/>
+          <p:nvPr/>
+        </p:nvSpPr>
+        <p:spPr>
+          <a:xfrm>
+            <a:off x="457200" y="4462272"/>
+            <a:ext cx="8229600" cy="201168"/>
           </a:xfrm>
           <a:prstGeom prst="rect">
             <a:avLst/>
@@ -8602,7 +8040,7 @@
               <a:buNone/>
             </a:pPr>
             <a:r>
-              <a:rPr lang="en-US" sz="1000" dirty="0">
+              <a:rPr lang="en-US" sz="900" dirty="0">
                 <a:solidFill>
                   <a:srgbClr val="5B6B7F"/>
                 </a:solidFill>
@@ -8610,6 +8048,45 @@
                 <a:ea typeface="Calibri" pitchFamily="34" charset="-122"/>
                 <a:cs typeface="Calibri" pitchFamily="34" charset="-120"/>
               </a:rPr>
+              <a:t>Sources: OEM Q2 2026 reports (GE Vernova, Siemens Energy, Mitsubishi Heavy); Cleanview BTM tracker; press reports.</a:t>
+            </a:r>
+            <a:endParaRPr lang="en-US" sz="900" dirty="0"/>
+          </a:p>
+        </p:txBody>
+      </p:sp>
+      <p:sp>
+        <p:nvSpPr>
+          <p:cNvPr id="14" name="Text 11"/>
+          <p:cNvSpPr txBox="1"/>
+          <p:nvPr/>
+        </p:nvSpPr>
+        <p:spPr>
+          <a:xfrm>
+            <a:off x="457200" y="4754880"/>
+            <a:ext cx="5486400" cy="228600"/>
+          </a:xfrm>
+          <a:prstGeom prst="rect">
+            <a:avLst/>
+          </a:prstGeom>
+          <a:noFill/>
+          <a:ln/>
+        </p:spPr>
+        <p:txBody>
+          <a:bodyPr wrap="square" lIns="0" tIns="0" rIns="0" bIns="0" rtlCol="0" anchor="ctr"/>
+          <a:lstStyle/>
+          <a:p>
+            <a:pPr indent="0" marL="0">
+              <a:buNone/>
+            </a:pPr>
+            <a:r>
+              <a:rPr lang="en-US" sz="1000" dirty="0">
+                <a:solidFill>
+                  <a:srgbClr val="5B6B7F"/>
+                </a:solidFill>
+                <a:latin typeface="Calibri" pitchFamily="34" charset="0"/>
+                <a:ea typeface="Calibri" pitchFamily="34" charset="-122"/>
+                <a:cs typeface="Calibri" pitchFamily="34" charset="-120"/>
+              </a:rPr>
               <a:t>Southwire PowerGen  |  Anixter Global Accounts</a:t>
             </a:r>
             <a:endParaRPr lang="en-US" sz="1000" dirty="0"/>
@@ -8618,7 +8095,7 @@
       </p:sp>
       <p:sp>
         <p:nvSpPr>
-          <p:cNvPr id="25" name="Text 23"/>
+          <p:cNvPr id="15" name="Text 12"/>
           <p:cNvSpPr txBox="1"/>
           <p:nvPr/>
         </p:nvSpPr>
@@ -8712,7 +8189,7 @@
               <a:buNone/>
             </a:pPr>
             <a:r>
-              <a:rPr lang="en-US" sz="3200" b="1" dirty="0">
+              <a:rPr lang="en-US" sz="2600" b="1" dirty="0">
                 <a:solidFill>
                   <a:srgbClr val="FFFFFF"/>
                 </a:solidFill>
@@ -8722,7 +8199,7 @@
               </a:rPr>
               <a:t>Key takeaways and partnership opportunities</a:t>
             </a:r>
-            <a:endParaRPr lang="en-US" sz="3200" dirty="0"/>
+            <a:endParaRPr lang="en-US" sz="2600" dirty="0"/>
           </a:p>
         </p:txBody>
       </p:sp>

</xml_diff>

<commit_message>
Use Southwire plant map and HRSG render in virtual tour slides
Co-Authored-By: Claude Sonnet 5.5 <noreply@anthropic.com>
Claude-Session: https://claude.ai/code/session_015HKS2PnjCizKc2aENrrpqs
</commit_message>
<xml_diff>
--- a/presentations/Anixter_PowerGen_Presentation_DRAFT.pptx
+++ b/presentations/Anixter_PowerGen_Presentation_DRAFT.pptx
@@ -15,9 +15,10 @@
     <p:sldId id="263" r:id="rId9"/>
     <p:sldId id="264" r:id="rId10"/>
     <p:sldId id="265" r:id="rId11"/>
+    <p:sldId id="266" r:id="rId12"/>
   </p:sldIdLst>
   <p:notesMasterIdLst>
-    <p:notesMasterId r:id="rId12"/>
+    <p:notesMasterId r:id="rId13"/>
   </p:notesMasterIdLst>
   <p:sldSz cx="9144000" cy="5143500"/>
   <p:notesSz cx="5143500" cy="9144000"/>
@@ -830,7 +831,7 @@
           <a:p>
             <a:r>
               <a:rPr lang="en-US" dirty="0"/>
-              <a:t>Phil and Bob help field questions.</a:t>
+              <a:t>The ask is from Stephan's reply to Marc. Agree with Marc on other expectations of AXE before Friday and add here.</a:t>
             </a:r>
             <a:endParaRPr lang="en-US" dirty="0"/>
           </a:p>
@@ -854,6 +855,94 @@
             <a:fld id="{F7021451-1387-4CA6-816F-3879F97B5CBC}" type="slidenum">
               <a:rPr lang="en-US"/>
               <a:t>10</a:t>
+            </a:fld>
+            <a:endParaRPr lang="en-US"/>
+          </a:p>
+        </p:txBody>
+      </p:sp>
+    </p:spTree>
+    <p:extLst>
+      <p:ext uri="{BB962C8B-B14F-4D97-AF65-F5344CB8AC3E}">
+        <p14:creationId xmlns:p14="http://schemas.microsoft.com/office/powerpoint/2010/main" val="1024086991"/>
+      </p:ext>
+    </p:extLst>
+  </p:cSld>
+  <p:clrMapOvr>
+    <a:masterClrMapping/>
+  </p:clrMapOvr>
+</p:notes>
+</file>
+
+<file path=ppt/notesSlides/notesSlide11.xml><?xml version="1.0" encoding="utf-8"?>
+<p:notes xmlns:a="http://schemas.openxmlformats.org/drawingml/2006/main" xmlns:r="http://schemas.openxmlformats.org/officeDocument/2006/relationships" xmlns:p="http://schemas.openxmlformats.org/presentationml/2006/main">
+  <p:cSld>
+    <p:spTree>
+      <p:nvGrpSpPr>
+        <p:cNvPr id="1" name=""/>
+        <p:cNvGrpSpPr/>
+        <p:nvPr/>
+      </p:nvGrpSpPr>
+      <p:grpSpPr>
+        <a:xfrm>
+          <a:off x="0" y="0"/>
+          <a:ext cx="0" cy="0"/>
+          <a:chOff x="0" y="0"/>
+          <a:chExt cx="0" cy="0"/>
+        </a:xfrm>
+      </p:grpSpPr>
+      <p:sp>
+        <p:nvSpPr>
+          <p:cNvPr id="2" name="Slide Image Placeholder 1"/>
+          <p:cNvSpPr>
+            <a:spLocks noGrp="1" noRot="1" noChangeAspect="1"/>
+          </p:cNvSpPr>
+          <p:nvPr>
+            <p:ph type="sldImg"/>
+          </p:nvPr>
+        </p:nvSpPr>
+        <p:spPr/>
+      </p:sp>
+      <p:sp>
+        <p:nvSpPr>
+          <p:cNvPr id="3" name="Notes Placeholder 2"/>
+          <p:cNvSpPr>
+            <a:spLocks noGrp="1"/>
+          </p:cNvSpPr>
+          <p:nvPr>
+            <p:ph type="body" idx="1"/>
+          </p:nvPr>
+        </p:nvSpPr>
+        <p:spPr/>
+        <p:txBody>
+          <a:bodyPr/>
+          <a:lstStyle/>
+          <a:p>
+            <a:r>
+              <a:rPr lang="en-US" dirty="0"/>
+              <a:t>Phil and Bob help field questions.</a:t>
+            </a:r>
+            <a:endParaRPr lang="en-US" dirty="0"/>
+          </a:p>
+        </p:txBody>
+      </p:sp>
+      <p:sp>
+        <p:nvSpPr>
+          <p:cNvPr id="4" name="Slide Number Placeholder 3"/>
+          <p:cNvSpPr>
+            <a:spLocks noGrp="1"/>
+          </p:cNvSpPr>
+          <p:nvPr>
+            <p:ph type="sldNum" sz="quarter" idx="10"/>
+          </p:nvPr>
+        </p:nvSpPr>
+        <p:spPr/>
+        <p:txBody>
+          <a:bodyPr/>
+          <a:lstStyle/>
+          <a:p>
+            <a:fld id="{F7021451-1387-4CA6-816F-3879F97B5CBC}" type="slidenum">
+              <a:rPr lang="en-US"/>
+              <a:t>11</a:t>
             </a:fld>
             <a:endParaRPr lang="en-US"/>
           </a:p>
@@ -1270,7 +1359,7 @@
           <a:p>
             <a:r>
               <a:rPr lang="en-US" dirty="0"/>
-              <a:t>Walk the plant left to right: fuel gas, gas turbine and generator, HRSG and steam turbine, then step-up transformer and switchyard to the grid. Numbered callouts are the cable applications, and match the product line card on the next slide. Schematic is a simplified combined-cycle plant. Confirm product mapping with the product team.</a:t>
+              <a:t>Walk the plant map by area number: 01 gas turbines and generators, 02 steam turbine, 03 HRSGs, 04 MCC/VFD/UPS/DC/I&amp;C, 05 E-house, 09 fuel gas, 13 GSUs and switchyard, and so on. Each area is a cable application; the application guide has a page for each (page references are in the list on the slide). Next slide zooms into the HRSG.</a:t>
             </a:r>
             <a:endParaRPr lang="en-US" dirty="0"/>
           </a:p>
@@ -1358,7 +1447,7 @@
           <a:p>
             <a:r>
               <a:rPr lang="en-US" dirty="0"/>
-              <a:t>Placeholder categories. Swap in the official one-page PowerGen line card and attach it as a leave-behind.</a:t>
+              <a:t>Source: HRSG Blender views (3 pages). Page 2 shows the pressure parts and segregated cable routes; page 3 shows the local power, controls and field connections. Ratings, protection and final circuit design remain project-specific.</a:t>
             </a:r>
             <a:endParaRPr lang="en-US" dirty="0"/>
           </a:p>
@@ -1446,7 +1535,7 @@
           <a:p>
             <a:r>
               <a:rPr lang="en-US" dirty="0"/>
-              <a:t>Backlogs: GE Vernova 116 GW (June 2026), Siemens Energy 69 GW (June 30), Mitsubishi Heavy 35 GW large-frame (Aug 6). Behind-the-meter figure is from Cleanview via press. Verify before presenting.</a:t>
+              <a:t>Placeholder categories. Swap in the official one-page PowerGen line card and attach it as a leave-behind.</a:t>
             </a:r>
             <a:endParaRPr lang="en-US" dirty="0"/>
           </a:p>
@@ -1534,7 +1623,7 @@
           <a:p>
             <a:r>
               <a:rPr lang="en-US" dirty="0"/>
-              <a:t>The ask is from Stephan's reply to Marc. Agree with Marc on other expectations of AXE before Friday and add here.</a:t>
+              <a:t>Backlogs: GE Vernova 116 GW (June 2026), Siemens Energy 69 GW (June 30), Mitsubishi Heavy 35 GW large-frame (Aug 6). Behind-the-meter figure is from Cleanview via press. Verify before presenting.</a:t>
             </a:r>
             <a:endParaRPr lang="en-US" dirty="0"/>
           </a:p>
@@ -2103,6 +2192,569 @@
         </p:nvSpPr>
         <p:spPr>
           <a:xfrm>
+            <a:off x="457200" y="320040"/>
+            <a:ext cx="8229600" cy="731520"/>
+          </a:xfrm>
+          <a:prstGeom prst="rect">
+            <a:avLst/>
+          </a:prstGeom>
+          <a:noFill/>
+          <a:ln/>
+        </p:spPr>
+        <p:txBody>
+          <a:bodyPr wrap="square" lIns="0" tIns="0" rIns="0" bIns="0" rtlCol="0" anchor="ctr"/>
+          <a:lstStyle/>
+          <a:p>
+            <a:pPr indent="0" marL="0">
+              <a:buNone/>
+            </a:pPr>
+            <a:r>
+              <a:rPr lang="en-US" sz="2600" b="1" dirty="0">
+                <a:solidFill>
+                  <a:srgbClr val="FFFFFF"/>
+                </a:solidFill>
+                <a:latin typeface="Cambria" pitchFamily="34" charset="0"/>
+                <a:ea typeface="Cambria" pitchFamily="34" charset="-122"/>
+                <a:cs typeface="Cambria" pitchFamily="34" charset="-120"/>
+              </a:rPr>
+              <a:t>Key takeaways and partnership opportunities</a:t>
+            </a:r>
+            <a:endParaRPr lang="en-US" sz="2600" dirty="0"/>
+          </a:p>
+        </p:txBody>
+      </p:sp>
+      <p:sp>
+        <p:nvSpPr>
+          <p:cNvPr id="3" name="Shape 1"/>
+          <p:cNvSpPr/>
+          <p:nvPr/>
+        </p:nvSpPr>
+        <p:spPr>
+          <a:xfrm>
+            <a:off x="457200" y="1234440"/>
+            <a:ext cx="457200" cy="457200"/>
+          </a:xfrm>
+          <a:prstGeom prst="ellipse">
+            <a:avLst/>
+          </a:prstGeom>
+          <a:solidFill>
+            <a:srgbClr val="C8742B"/>
+          </a:solidFill>
+          <a:ln w="12700">
+            <a:solidFill>
+              <a:srgbClr val="C8742B"/>
+            </a:solidFill>
+            <a:prstDash val="solid"/>
+          </a:ln>
+        </p:spPr>
+      </p:sp>
+      <p:sp>
+        <p:nvSpPr>
+          <p:cNvPr id="4" name="Text 2"/>
+          <p:cNvSpPr txBox="1"/>
+          <p:nvPr/>
+        </p:nvSpPr>
+        <p:spPr>
+          <a:xfrm>
+            <a:off x="457200" y="1234440"/>
+            <a:ext cx="457200" cy="457200"/>
+          </a:xfrm>
+          <a:prstGeom prst="rect">
+            <a:avLst/>
+          </a:prstGeom>
+          <a:noFill/>
+          <a:ln/>
+        </p:spPr>
+        <p:txBody>
+          <a:bodyPr wrap="square" lIns="0" tIns="0" rIns="0" bIns="0" rtlCol="0" anchor="ctr"/>
+          <a:lstStyle/>
+          <a:p>
+            <a:pPr algn="ctr" indent="0" marL="0">
+              <a:buNone/>
+            </a:pPr>
+            <a:r>
+              <a:rPr lang="en-US" sz="1400" b="1" dirty="0">
+                <a:solidFill>
+                  <a:srgbClr val="FFFFFF"/>
+                </a:solidFill>
+                <a:latin typeface="Cambria" pitchFamily="34" charset="0"/>
+                <a:ea typeface="Cambria" pitchFamily="34" charset="-122"/>
+                <a:cs typeface="Cambria" pitchFamily="34" charset="-120"/>
+              </a:rPr>
+              <a:t>1</a:t>
+            </a:r>
+            <a:endParaRPr lang="en-US" sz="1400" dirty="0"/>
+          </a:p>
+        </p:txBody>
+      </p:sp>
+      <p:sp>
+        <p:nvSpPr>
+          <p:cNvPr id="5" name="Text 3"/>
+          <p:cNvSpPr txBox="1"/>
+          <p:nvPr/>
+        </p:nvSpPr>
+        <p:spPr>
+          <a:xfrm>
+            <a:off x="1097280" y="1234440"/>
+            <a:ext cx="7589520" cy="457200"/>
+          </a:xfrm>
+          <a:prstGeom prst="rect">
+            <a:avLst/>
+          </a:prstGeom>
+          <a:noFill/>
+          <a:ln/>
+        </p:spPr>
+        <p:txBody>
+          <a:bodyPr wrap="square" lIns="0" tIns="0" rIns="0" bIns="0" rtlCol="0" anchor="ctr"/>
+          <a:lstStyle/>
+          <a:p>
+            <a:pPr indent="0" marL="0">
+              <a:buNone/>
+            </a:pPr>
+            <a:r>
+              <a:rPr lang="en-US" sz="1700" dirty="0">
+                <a:solidFill>
+                  <a:srgbClr val="FFFFFF"/>
+                </a:solidFill>
+                <a:latin typeface="Calibri" pitchFamily="34" charset="0"/>
+                <a:ea typeface="Calibri" pitchFamily="34" charset="-122"/>
+                <a:cs typeface="Calibri" pitchFamily="34" charset="-120"/>
+              </a:rPr>
+              <a:t>Demand growth is long-lived and gas-heavy</a:t>
+            </a:r>
+            <a:endParaRPr lang="en-US" sz="1700" dirty="0"/>
+          </a:p>
+        </p:txBody>
+      </p:sp>
+      <p:sp>
+        <p:nvSpPr>
+          <p:cNvPr id="6" name="Shape 4"/>
+          <p:cNvSpPr/>
+          <p:nvPr/>
+        </p:nvSpPr>
+        <p:spPr>
+          <a:xfrm>
+            <a:off x="457200" y="1920240"/>
+            <a:ext cx="457200" cy="457200"/>
+          </a:xfrm>
+          <a:prstGeom prst="ellipse">
+            <a:avLst/>
+          </a:prstGeom>
+          <a:solidFill>
+            <a:srgbClr val="C8742B"/>
+          </a:solidFill>
+          <a:ln w="12700">
+            <a:solidFill>
+              <a:srgbClr val="C8742B"/>
+            </a:solidFill>
+            <a:prstDash val="solid"/>
+          </a:ln>
+        </p:spPr>
+      </p:sp>
+      <p:sp>
+        <p:nvSpPr>
+          <p:cNvPr id="7" name="Text 5"/>
+          <p:cNvSpPr txBox="1"/>
+          <p:nvPr/>
+        </p:nvSpPr>
+        <p:spPr>
+          <a:xfrm>
+            <a:off x="457200" y="1920240"/>
+            <a:ext cx="457200" cy="457200"/>
+          </a:xfrm>
+          <a:prstGeom prst="rect">
+            <a:avLst/>
+          </a:prstGeom>
+          <a:noFill/>
+          <a:ln/>
+        </p:spPr>
+        <p:txBody>
+          <a:bodyPr wrap="square" lIns="0" tIns="0" rIns="0" bIns="0" rtlCol="0" anchor="ctr"/>
+          <a:lstStyle/>
+          <a:p>
+            <a:pPr algn="ctr" indent="0" marL="0">
+              <a:buNone/>
+            </a:pPr>
+            <a:r>
+              <a:rPr lang="en-US" sz="1400" b="1" dirty="0">
+                <a:solidFill>
+                  <a:srgbClr val="FFFFFF"/>
+                </a:solidFill>
+                <a:latin typeface="Cambria" pitchFamily="34" charset="0"/>
+                <a:ea typeface="Cambria" pitchFamily="34" charset="-122"/>
+                <a:cs typeface="Cambria" pitchFamily="34" charset="-120"/>
+              </a:rPr>
+              <a:t>2</a:t>
+            </a:r>
+            <a:endParaRPr lang="en-US" sz="1400" dirty="0"/>
+          </a:p>
+        </p:txBody>
+      </p:sp>
+      <p:sp>
+        <p:nvSpPr>
+          <p:cNvPr id="8" name="Text 6"/>
+          <p:cNvSpPr txBox="1"/>
+          <p:nvPr/>
+        </p:nvSpPr>
+        <p:spPr>
+          <a:xfrm>
+            <a:off x="1097280" y="1920240"/>
+            <a:ext cx="7589520" cy="457200"/>
+          </a:xfrm>
+          <a:prstGeom prst="rect">
+            <a:avLst/>
+          </a:prstGeom>
+          <a:noFill/>
+          <a:ln/>
+        </p:spPr>
+        <p:txBody>
+          <a:bodyPr wrap="square" lIns="0" tIns="0" rIns="0" bIns="0" rtlCol="0" anchor="ctr"/>
+          <a:lstStyle/>
+          <a:p>
+            <a:pPr indent="0" marL="0">
+              <a:buNone/>
+            </a:pPr>
+            <a:r>
+              <a:rPr lang="en-US" sz="1700" dirty="0">
+                <a:solidFill>
+                  <a:srgbClr val="FFFFFF"/>
+                </a:solidFill>
+                <a:latin typeface="Calibri" pitchFamily="34" charset="0"/>
+                <a:ea typeface="Calibri" pitchFamily="34" charset="-122"/>
+                <a:cs typeface="Calibri" pitchFamily="34" charset="-120"/>
+              </a:rPr>
+              <a:t>Southwire is strong across the plant, and on the OEM side</a:t>
+            </a:r>
+            <a:endParaRPr lang="en-US" sz="1700" dirty="0"/>
+          </a:p>
+        </p:txBody>
+      </p:sp>
+      <p:sp>
+        <p:nvSpPr>
+          <p:cNvPr id="9" name="Shape 7"/>
+          <p:cNvSpPr/>
+          <p:nvPr/>
+        </p:nvSpPr>
+        <p:spPr>
+          <a:xfrm>
+            <a:off x="457200" y="2606040"/>
+            <a:ext cx="457200" cy="457200"/>
+          </a:xfrm>
+          <a:prstGeom prst="ellipse">
+            <a:avLst/>
+          </a:prstGeom>
+          <a:solidFill>
+            <a:srgbClr val="C8742B"/>
+          </a:solidFill>
+          <a:ln w="12700">
+            <a:solidFill>
+              <a:srgbClr val="C8742B"/>
+            </a:solidFill>
+            <a:prstDash val="solid"/>
+          </a:ln>
+        </p:spPr>
+      </p:sp>
+      <p:sp>
+        <p:nvSpPr>
+          <p:cNvPr id="10" name="Text 8"/>
+          <p:cNvSpPr txBox="1"/>
+          <p:nvPr/>
+        </p:nvSpPr>
+        <p:spPr>
+          <a:xfrm>
+            <a:off x="457200" y="2606040"/>
+            <a:ext cx="457200" cy="457200"/>
+          </a:xfrm>
+          <a:prstGeom prst="rect">
+            <a:avLst/>
+          </a:prstGeom>
+          <a:noFill/>
+          <a:ln/>
+        </p:spPr>
+        <p:txBody>
+          <a:bodyPr wrap="square" lIns="0" tIns="0" rIns="0" bIns="0" rtlCol="0" anchor="ctr"/>
+          <a:lstStyle/>
+          <a:p>
+            <a:pPr algn="ctr" indent="0" marL="0">
+              <a:buNone/>
+            </a:pPr>
+            <a:r>
+              <a:rPr lang="en-US" sz="1400" b="1" dirty="0">
+                <a:solidFill>
+                  <a:srgbClr val="FFFFFF"/>
+                </a:solidFill>
+                <a:latin typeface="Cambria" pitchFamily="34" charset="0"/>
+                <a:ea typeface="Cambria" pitchFamily="34" charset="-122"/>
+                <a:cs typeface="Cambria" pitchFamily="34" charset="-120"/>
+              </a:rPr>
+              <a:t>3</a:t>
+            </a:r>
+            <a:endParaRPr lang="en-US" sz="1400" dirty="0"/>
+          </a:p>
+        </p:txBody>
+      </p:sp>
+      <p:sp>
+        <p:nvSpPr>
+          <p:cNvPr id="11" name="Text 9"/>
+          <p:cNvSpPr txBox="1"/>
+          <p:nvPr/>
+        </p:nvSpPr>
+        <p:spPr>
+          <a:xfrm>
+            <a:off x="1097280" y="2606040"/>
+            <a:ext cx="7589520" cy="457200"/>
+          </a:xfrm>
+          <a:prstGeom prst="rect">
+            <a:avLst/>
+          </a:prstGeom>
+          <a:noFill/>
+          <a:ln/>
+        </p:spPr>
+        <p:txBody>
+          <a:bodyPr wrap="square" lIns="0" tIns="0" rIns="0" bIns="0" rtlCol="0" anchor="ctr"/>
+          <a:lstStyle/>
+          <a:p>
+            <a:pPr indent="0" marL="0">
+              <a:buNone/>
+            </a:pPr>
+            <a:r>
+              <a:rPr lang="en-US" sz="1700" dirty="0">
+                <a:solidFill>
+                  <a:srgbClr val="FFFFFF"/>
+                </a:solidFill>
+                <a:latin typeface="Calibri" pitchFamily="34" charset="0"/>
+                <a:ea typeface="Calibri" pitchFamily="34" charset="-122"/>
+                <a:cs typeface="Calibri" pitchFamily="34" charset="-120"/>
+              </a:rPr>
+              <a:t>A joint plan beats parallel pursuits of the same projects</a:t>
+            </a:r>
+            <a:endParaRPr lang="en-US" sz="1700" dirty="0"/>
+          </a:p>
+        </p:txBody>
+      </p:sp>
+      <p:sp>
+        <p:nvSpPr>
+          <p:cNvPr id="12" name="Shape 10"/>
+          <p:cNvSpPr/>
+          <p:nvPr/>
+        </p:nvSpPr>
+        <p:spPr>
+          <a:xfrm>
+            <a:off x="457200" y="3383280"/>
+            <a:ext cx="8229600" cy="1143000"/>
+          </a:xfrm>
+          <a:prstGeom prst="roundRect">
+            <a:avLst>
+              <a:gd name="adj" fmla="val 8000"/>
+            </a:avLst>
+          </a:prstGeom>
+          <a:solidFill>
+            <a:srgbClr val="C8742B"/>
+          </a:solidFill>
+          <a:ln w="12700">
+            <a:solidFill>
+              <a:srgbClr val="C8742B"/>
+            </a:solidFill>
+            <a:prstDash val="solid"/>
+          </a:ln>
+        </p:spPr>
+      </p:sp>
+      <p:sp>
+        <p:nvSpPr>
+          <p:cNvPr id="13" name="Text 11"/>
+          <p:cNvSpPr txBox="1"/>
+          <p:nvPr/>
+        </p:nvSpPr>
+        <p:spPr>
+          <a:xfrm>
+            <a:off x="685800" y="3456432"/>
+            <a:ext cx="2743200" cy="274320"/>
+          </a:xfrm>
+          <a:prstGeom prst="rect">
+            <a:avLst/>
+          </a:prstGeom>
+          <a:noFill/>
+          <a:ln/>
+        </p:spPr>
+        <p:txBody>
+          <a:bodyPr wrap="square" lIns="0" tIns="0" rIns="0" bIns="0" rtlCol="0" anchor="ctr"/>
+          <a:lstStyle/>
+          <a:p>
+            <a:pPr indent="0" marL="0">
+              <a:buNone/>
+            </a:pPr>
+            <a:r>
+              <a:rPr lang="en-US" sz="1200" b="1" spc="400" kern="0" dirty="0">
+                <a:solidFill>
+                  <a:srgbClr val="FFFFFF"/>
+                </a:solidFill>
+                <a:latin typeface="Calibri" pitchFamily="34" charset="0"/>
+                <a:ea typeface="Calibri" pitchFamily="34" charset="-122"/>
+                <a:cs typeface="Calibri" pitchFamily="34" charset="-120"/>
+              </a:rPr>
+              <a:t>OUR ASK</a:t>
+            </a:r>
+            <a:endParaRPr lang="en-US" sz="1200" dirty="0"/>
+          </a:p>
+        </p:txBody>
+      </p:sp>
+      <p:sp>
+        <p:nvSpPr>
+          <p:cNvPr id="14" name="Text 12"/>
+          <p:cNvSpPr txBox="1"/>
+          <p:nvPr/>
+        </p:nvSpPr>
+        <p:spPr>
+          <a:xfrm>
+            <a:off x="685800" y="3749040"/>
+            <a:ext cx="7772400" cy="685800"/>
+          </a:xfrm>
+          <a:prstGeom prst="rect">
+            <a:avLst/>
+          </a:prstGeom>
+          <a:noFill/>
+          <a:ln/>
+        </p:spPr>
+        <p:txBody>
+          <a:bodyPr wrap="square" lIns="0" tIns="0" rIns="0" bIns="0" rtlCol="0" anchor="t"/>
+          <a:lstStyle/>
+          <a:p>
+            <a:pPr indent="0" marL="0">
+              <a:buNone/>
+            </a:pPr>
+            <a:r>
+              <a:rPr lang="en-US" sz="1800" b="1" dirty="0">
+                <a:solidFill>
+                  <a:srgbClr val="FFFFFF"/>
+                </a:solidFill>
+                <a:latin typeface="Cambria" pitchFamily="34" charset="0"/>
+                <a:ea typeface="Cambria" pitchFamily="34" charset="-122"/>
+                <a:cs typeface="Cambria" pitchFamily="34" charset="-120"/>
+              </a:rPr>
+              <a:t>Loop Southwire into AXE's Gas Power Projects and build a joint strategy around their target list.</a:t>
+            </a:r>
+            <a:endParaRPr lang="en-US" sz="1800" dirty="0"/>
+          </a:p>
+        </p:txBody>
+      </p:sp>
+      <p:sp>
+        <p:nvSpPr>
+          <p:cNvPr id="15" name="Text 13"/>
+          <p:cNvSpPr txBox="1"/>
+          <p:nvPr/>
+        </p:nvSpPr>
+        <p:spPr>
+          <a:xfrm>
+            <a:off x="457200" y="4754880"/>
+            <a:ext cx="5486400" cy="228600"/>
+          </a:xfrm>
+          <a:prstGeom prst="rect">
+            <a:avLst/>
+          </a:prstGeom>
+          <a:noFill/>
+          <a:ln/>
+        </p:spPr>
+        <p:txBody>
+          <a:bodyPr wrap="square" lIns="0" tIns="0" rIns="0" bIns="0" rtlCol="0" anchor="ctr"/>
+          <a:lstStyle/>
+          <a:p>
+            <a:pPr indent="0" marL="0">
+              <a:buNone/>
+            </a:pPr>
+            <a:r>
+              <a:rPr lang="en-US" sz="1000" dirty="0">
+                <a:solidFill>
+                  <a:srgbClr val="9FB0C3"/>
+                </a:solidFill>
+                <a:latin typeface="Calibri" pitchFamily="34" charset="0"/>
+                <a:ea typeface="Calibri" pitchFamily="34" charset="-122"/>
+                <a:cs typeface="Calibri" pitchFamily="34" charset="-120"/>
+              </a:rPr>
+              <a:t>Southwire PowerGen  |  Anixter Global Accounts</a:t>
+            </a:r>
+            <a:endParaRPr lang="en-US" sz="1000" dirty="0"/>
+          </a:p>
+        </p:txBody>
+      </p:sp>
+      <p:sp>
+        <p:nvSpPr>
+          <p:cNvPr id="16" name="Text 14"/>
+          <p:cNvSpPr txBox="1"/>
+          <p:nvPr/>
+        </p:nvSpPr>
+        <p:spPr>
+          <a:xfrm>
+            <a:off x="8229600" y="4754880"/>
+            <a:ext cx="457200" cy="228600"/>
+          </a:xfrm>
+          <a:prstGeom prst="rect">
+            <a:avLst/>
+          </a:prstGeom>
+          <a:noFill/>
+          <a:ln/>
+        </p:spPr>
+        <p:txBody>
+          <a:bodyPr wrap="square" lIns="0" tIns="0" rIns="0" bIns="0" rtlCol="0" anchor="ctr"/>
+          <a:lstStyle/>
+          <a:p>
+            <a:pPr algn="r" indent="0" marL="0">
+              <a:buNone/>
+            </a:pPr>
+            <a:r>
+              <a:rPr lang="en-US" sz="1000" dirty="0">
+                <a:solidFill>
+                  <a:srgbClr val="9FB0C3"/>
+                </a:solidFill>
+                <a:latin typeface="Calibri" pitchFamily="34" charset="0"/>
+                <a:ea typeface="Calibri" pitchFamily="34" charset="-122"/>
+                <a:cs typeface="Calibri" pitchFamily="34" charset="-120"/>
+              </a:rPr>
+              <a:t>10</a:t>
+            </a:r>
+            <a:endParaRPr lang="en-US" sz="1000" dirty="0"/>
+          </a:p>
+        </p:txBody>
+      </p:sp>
+    </p:spTree>
+  </p:cSld>
+  <p:clrMapOvr>
+    <a:masterClrMapping/>
+  </p:clrMapOvr>
+</p:sld>
+</file>
+
+<file path=ppt/slides/slide11.xml><?xml version="1.0" encoding="utf-8"?>
+<p:sld xmlns:a="http://schemas.openxmlformats.org/drawingml/2006/main" xmlns:r="http://schemas.openxmlformats.org/officeDocument/2006/relationships" xmlns:p="http://schemas.openxmlformats.org/presentationml/2006/main">
+  <p:cSld name="Slide 11">
+    <p:bg>
+      <p:bgPr>
+        <a:solidFill>
+          <a:srgbClr val="0F1B2D"/>
+        </a:solidFill>
+      </p:bgPr>
+    </p:bg>
+    <p:spTree>
+      <p:nvGrpSpPr>
+        <p:cNvPr id="1" name=""/>
+        <p:cNvGrpSpPr/>
+        <p:nvPr/>
+      </p:nvGrpSpPr>
+      <p:grpSpPr>
+        <a:xfrm>
+          <a:off x="0" y="0"/>
+          <a:ext cx="0" cy="0"/>
+          <a:chOff x="0" y="0"/>
+          <a:chExt cx="0" cy="0"/>
+        </a:xfrm>
+      </p:grpSpPr>
+      <p:sp>
+        <p:nvSpPr>
+          <p:cNvPr id="2" name="Text 0"/>
+          <p:cNvSpPr txBox="1"/>
+          <p:nvPr/>
+        </p:nvSpPr>
+        <p:spPr>
+          <a:xfrm>
             <a:off x="548640" y="1737360"/>
             <a:ext cx="7315200" cy="914400"/>
           </a:xfrm>
@@ -5890,7 +6542,7 @@
       </p:sp>
       <p:pic>
         <p:nvPicPr>
-          <p:cNvPr id="3" name="Image 0" descr="/home/user/ln/presentations/plant_schematic.png">    </p:cNvPr>
+          <p:cNvPr id="3" name="Image 0" descr="/home/user/ln/presentations/plant_map.jpg">    </p:cNvPr>
           <p:cNvPicPr>
             <a:picLocks noChangeAspect="1"/>
           </p:cNvPicPr>
@@ -5904,8 +6556,8 @@
         </p:blipFill>
         <p:spPr>
           <a:xfrm>
-            <a:off x="457200" y="1097280"/>
-            <a:ext cx="8229600" cy="2926080"/>
+            <a:off x="457200" y="1143000"/>
+            <a:ext cx="8229600" cy="3145536"/>
           </a:xfrm>
           <a:prstGeom prst="rect">
             <a:avLst/>
@@ -5914,78 +6566,14 @@
       </p:pic>
       <p:sp>
         <p:nvSpPr>
-          <p:cNvPr id="4" name="Shape 1"/>
-          <p:cNvSpPr/>
-          <p:nvPr/>
-        </p:nvSpPr>
-        <p:spPr>
-          <a:xfrm>
-            <a:off x="457200" y="4160520"/>
-            <a:ext cx="274320" cy="274320"/>
-          </a:xfrm>
-          <a:prstGeom prst="ellipse">
-            <a:avLst/>
-          </a:prstGeom>
-          <a:solidFill>
-            <a:srgbClr val="C8742B"/>
-          </a:solidFill>
-          <a:ln w="12700">
-            <a:solidFill>
-              <a:srgbClr val="C8742B"/>
-            </a:solidFill>
-            <a:prstDash val="solid"/>
-          </a:ln>
-        </p:spPr>
-      </p:sp>
-      <p:sp>
-        <p:nvSpPr>
-          <p:cNvPr id="5" name="Text 2"/>
-          <p:cNvSpPr txBox="1"/>
-          <p:nvPr/>
-        </p:nvSpPr>
-        <p:spPr>
-          <a:xfrm>
-            <a:off x="457200" y="4160520"/>
-            <a:ext cx="274320" cy="274320"/>
-          </a:xfrm>
-          <a:prstGeom prst="rect">
-            <a:avLst/>
-          </a:prstGeom>
-          <a:noFill/>
-          <a:ln/>
-        </p:spPr>
-        <p:txBody>
-          <a:bodyPr wrap="square" lIns="0" tIns="0" rIns="0" bIns="0" rtlCol="0" anchor="ctr"/>
-          <a:lstStyle/>
-          <a:p>
-            <a:pPr algn="ctr" indent="0" marL="0">
-              <a:buNone/>
-            </a:pPr>
-            <a:r>
-              <a:rPr lang="en-US" sz="840" b="1" dirty="0">
-                <a:solidFill>
-                  <a:srgbClr val="FFFFFF"/>
-                </a:solidFill>
-                <a:latin typeface="Cambria" pitchFamily="34" charset="0"/>
-                <a:ea typeface="Cambria" pitchFamily="34" charset="-122"/>
-                <a:cs typeface="Cambria" pitchFamily="34" charset="-120"/>
-              </a:rPr>
-              <a:t>1</a:t>
-            </a:r>
-            <a:endParaRPr lang="en-US" sz="840" dirty="0"/>
-          </a:p>
-        </p:txBody>
-      </p:sp>
-      <p:sp>
-        <p:nvSpPr>
-          <p:cNvPr id="6" name="Text 3"/>
-          <p:cNvSpPr txBox="1"/>
-          <p:nvPr/>
-        </p:nvSpPr>
-        <p:spPr>
-          <a:xfrm>
-            <a:off x="804672" y="4114800"/>
-            <a:ext cx="1234440" cy="365760"/>
+          <p:cNvPr id="4" name="Text 1"/>
+          <p:cNvSpPr txBox="1"/>
+          <p:nvPr/>
+        </p:nvSpPr>
+        <p:spPr>
+          <a:xfrm>
+            <a:off x="457200" y="4434840"/>
+            <a:ext cx="8229600" cy="201168"/>
           </a:xfrm>
           <a:prstGeom prst="rect">
             <a:avLst/>
@@ -6001,94 +6589,30 @@
               <a:buNone/>
             </a:pPr>
             <a:r>
-              <a:rPr lang="en-US" sz="1100" dirty="0">
-                <a:solidFill>
-                  <a:srgbClr val="1B2735"/>
+              <a:rPr lang="en-US" sz="900" dirty="0">
+                <a:solidFill>
+                  <a:srgbClr val="5B6B7F"/>
                 </a:solidFill>
                 <a:latin typeface="Calibri" pitchFamily="34" charset="0"/>
                 <a:ea typeface="Calibri" pitchFamily="34" charset="-122"/>
                 <a:cs typeface="Calibri" pitchFamily="34" charset="-120"/>
               </a:rPr>
-              <a:t>MV / HV power</a:t>
-            </a:r>
-            <a:endParaRPr lang="en-US" sz="1100" dirty="0"/>
-          </a:p>
-        </p:txBody>
-      </p:sp>
-      <p:sp>
-        <p:nvSpPr>
-          <p:cNvPr id="7" name="Shape 4"/>
-          <p:cNvSpPr/>
-          <p:nvPr/>
-        </p:nvSpPr>
-        <p:spPr>
-          <a:xfrm>
-            <a:off x="2103120" y="4160520"/>
-            <a:ext cx="274320" cy="274320"/>
-          </a:xfrm>
-          <a:prstGeom prst="ellipse">
-            <a:avLst/>
-          </a:prstGeom>
-          <a:solidFill>
-            <a:srgbClr val="C8742B"/>
-          </a:solidFill>
-          <a:ln w="12700">
-            <a:solidFill>
-              <a:srgbClr val="C8742B"/>
-            </a:solidFill>
-            <a:prstDash val="solid"/>
-          </a:ln>
-        </p:spPr>
-      </p:sp>
-      <p:sp>
-        <p:nvSpPr>
-          <p:cNvPr id="8" name="Text 5"/>
-          <p:cNvSpPr txBox="1"/>
-          <p:nvPr/>
-        </p:nvSpPr>
-        <p:spPr>
-          <a:xfrm>
-            <a:off x="2103120" y="4160520"/>
-            <a:ext cx="274320" cy="274320"/>
-          </a:xfrm>
-          <a:prstGeom prst="rect">
-            <a:avLst/>
-          </a:prstGeom>
-          <a:noFill/>
-          <a:ln/>
-        </p:spPr>
-        <p:txBody>
-          <a:bodyPr wrap="square" lIns="0" tIns="0" rIns="0" bIns="0" rtlCol="0" anchor="ctr"/>
-          <a:lstStyle/>
-          <a:p>
-            <a:pPr algn="ctr" indent="0" marL="0">
-              <a:buNone/>
-            </a:pPr>
-            <a:r>
-              <a:rPr lang="en-US" sz="840" b="1" dirty="0">
-                <a:solidFill>
-                  <a:srgbClr val="FFFFFF"/>
-                </a:solidFill>
-                <a:latin typeface="Cambria" pitchFamily="34" charset="0"/>
-                <a:ea typeface="Cambria" pitchFamily="34" charset="-122"/>
-                <a:cs typeface="Cambria" pitchFamily="34" charset="-120"/>
-              </a:rPr>
-              <a:t>2</a:t>
-            </a:r>
-            <a:endParaRPr lang="en-US" sz="840" dirty="0"/>
-          </a:p>
-        </p:txBody>
-      </p:sp>
-      <p:sp>
-        <p:nvSpPr>
-          <p:cNvPr id="9" name="Text 6"/>
-          <p:cNvSpPr txBox="1"/>
-          <p:nvPr/>
-        </p:nvSpPr>
-        <p:spPr>
-          <a:xfrm>
-            <a:off x="2450592" y="4114800"/>
-            <a:ext cx="1234440" cy="365760"/>
+              <a:t>Source: Southwire combined-cycle wire &amp; cable application guide. Generic 3x1 plant, illustrative.</a:t>
+            </a:r>
+            <a:endParaRPr lang="en-US" sz="900" dirty="0"/>
+          </a:p>
+        </p:txBody>
+      </p:sp>
+      <p:sp>
+        <p:nvSpPr>
+          <p:cNvPr id="5" name="Text 2"/>
+          <p:cNvSpPr txBox="1"/>
+          <p:nvPr/>
+        </p:nvSpPr>
+        <p:spPr>
+          <a:xfrm>
+            <a:off x="457200" y="4754880"/>
+            <a:ext cx="5486400" cy="228600"/>
           </a:xfrm>
           <a:prstGeom prst="rect">
             <a:avLst/>
@@ -6104,362 +6628,14 @@
               <a:buNone/>
             </a:pPr>
             <a:r>
-              <a:rPr lang="en-US" sz="1100" dirty="0">
-                <a:solidFill>
-                  <a:srgbClr val="1B2735"/>
+              <a:rPr lang="en-US" sz="1000" dirty="0">
+                <a:solidFill>
+                  <a:srgbClr val="5B6B7F"/>
                 </a:solidFill>
                 <a:latin typeface="Calibri" pitchFamily="34" charset="0"/>
                 <a:ea typeface="Calibri" pitchFamily="34" charset="-122"/>
                 <a:cs typeface="Calibri" pitchFamily="34" charset="-120"/>
               </a:rPr>
-              <a:t>Control &amp; instrumentation</a:t>
-            </a:r>
-            <a:endParaRPr lang="en-US" sz="1100" dirty="0"/>
-          </a:p>
-        </p:txBody>
-      </p:sp>
-      <p:sp>
-        <p:nvSpPr>
-          <p:cNvPr id="10" name="Shape 7"/>
-          <p:cNvSpPr/>
-          <p:nvPr/>
-        </p:nvSpPr>
-        <p:spPr>
-          <a:xfrm>
-            <a:off x="3749040" y="4160520"/>
-            <a:ext cx="274320" cy="274320"/>
-          </a:xfrm>
-          <a:prstGeom prst="ellipse">
-            <a:avLst/>
-          </a:prstGeom>
-          <a:solidFill>
-            <a:srgbClr val="C8742B"/>
-          </a:solidFill>
-          <a:ln w="12700">
-            <a:solidFill>
-              <a:srgbClr val="C8742B"/>
-            </a:solidFill>
-            <a:prstDash val="solid"/>
-          </a:ln>
-        </p:spPr>
-      </p:sp>
-      <p:sp>
-        <p:nvSpPr>
-          <p:cNvPr id="11" name="Text 8"/>
-          <p:cNvSpPr txBox="1"/>
-          <p:nvPr/>
-        </p:nvSpPr>
-        <p:spPr>
-          <a:xfrm>
-            <a:off x="3749040" y="4160520"/>
-            <a:ext cx="274320" cy="274320"/>
-          </a:xfrm>
-          <a:prstGeom prst="rect">
-            <a:avLst/>
-          </a:prstGeom>
-          <a:noFill/>
-          <a:ln/>
-        </p:spPr>
-        <p:txBody>
-          <a:bodyPr wrap="square" lIns="0" tIns="0" rIns="0" bIns="0" rtlCol="0" anchor="ctr"/>
-          <a:lstStyle/>
-          <a:p>
-            <a:pPr algn="ctr" indent="0" marL="0">
-              <a:buNone/>
-            </a:pPr>
-            <a:r>
-              <a:rPr lang="en-US" sz="840" b="1" dirty="0">
-                <a:solidFill>
-                  <a:srgbClr val="FFFFFF"/>
-                </a:solidFill>
-                <a:latin typeface="Cambria" pitchFamily="34" charset="0"/>
-                <a:ea typeface="Cambria" pitchFamily="34" charset="-122"/>
-                <a:cs typeface="Cambria" pitchFamily="34" charset="-120"/>
-              </a:rPr>
-              <a:t>3</a:t>
-            </a:r>
-            <a:endParaRPr lang="en-US" sz="840" dirty="0"/>
-          </a:p>
-        </p:txBody>
-      </p:sp>
-      <p:sp>
-        <p:nvSpPr>
-          <p:cNvPr id="12" name="Text 9"/>
-          <p:cNvSpPr txBox="1"/>
-          <p:nvPr/>
-        </p:nvSpPr>
-        <p:spPr>
-          <a:xfrm>
-            <a:off x="4096512" y="4114800"/>
-            <a:ext cx="1234440" cy="365760"/>
-          </a:xfrm>
-          <a:prstGeom prst="rect">
-            <a:avLst/>
-          </a:prstGeom>
-          <a:noFill/>
-          <a:ln/>
-        </p:spPr>
-        <p:txBody>
-          <a:bodyPr wrap="square" lIns="0" tIns="0" rIns="0" bIns="0" rtlCol="0" anchor="ctr"/>
-          <a:lstStyle/>
-          <a:p>
-            <a:pPr indent="0" marL="0">
-              <a:buNone/>
-            </a:pPr>
-            <a:r>
-              <a:rPr lang="en-US" sz="1100" dirty="0">
-                <a:solidFill>
-                  <a:srgbClr val="1B2735"/>
-                </a:solidFill>
-                <a:latin typeface="Calibri" pitchFamily="34" charset="0"/>
-                <a:ea typeface="Calibri" pitchFamily="34" charset="-122"/>
-                <a:cs typeface="Calibri" pitchFamily="34" charset="-120"/>
-              </a:rPr>
-              <a:t>LV power &amp; auxiliaries</a:t>
-            </a:r>
-            <a:endParaRPr lang="en-US" sz="1100" dirty="0"/>
-          </a:p>
-        </p:txBody>
-      </p:sp>
-      <p:sp>
-        <p:nvSpPr>
-          <p:cNvPr id="13" name="Shape 10"/>
-          <p:cNvSpPr/>
-          <p:nvPr/>
-        </p:nvSpPr>
-        <p:spPr>
-          <a:xfrm>
-            <a:off x="5394960" y="4160520"/>
-            <a:ext cx="274320" cy="274320"/>
-          </a:xfrm>
-          <a:prstGeom prst="ellipse">
-            <a:avLst/>
-          </a:prstGeom>
-          <a:solidFill>
-            <a:srgbClr val="C8742B"/>
-          </a:solidFill>
-          <a:ln w="12700">
-            <a:solidFill>
-              <a:srgbClr val="C8742B"/>
-            </a:solidFill>
-            <a:prstDash val="solid"/>
-          </a:ln>
-        </p:spPr>
-      </p:sp>
-      <p:sp>
-        <p:nvSpPr>
-          <p:cNvPr id="14" name="Text 11"/>
-          <p:cNvSpPr txBox="1"/>
-          <p:nvPr/>
-        </p:nvSpPr>
-        <p:spPr>
-          <a:xfrm>
-            <a:off x="5394960" y="4160520"/>
-            <a:ext cx="274320" cy="274320"/>
-          </a:xfrm>
-          <a:prstGeom prst="rect">
-            <a:avLst/>
-          </a:prstGeom>
-          <a:noFill/>
-          <a:ln/>
-        </p:spPr>
-        <p:txBody>
-          <a:bodyPr wrap="square" lIns="0" tIns="0" rIns="0" bIns="0" rtlCol="0" anchor="ctr"/>
-          <a:lstStyle/>
-          <a:p>
-            <a:pPr algn="ctr" indent="0" marL="0">
-              <a:buNone/>
-            </a:pPr>
-            <a:r>
-              <a:rPr lang="en-US" sz="840" b="1" dirty="0">
-                <a:solidFill>
-                  <a:srgbClr val="FFFFFF"/>
-                </a:solidFill>
-                <a:latin typeface="Cambria" pitchFamily="34" charset="0"/>
-                <a:ea typeface="Cambria" pitchFamily="34" charset="-122"/>
-                <a:cs typeface="Cambria" pitchFamily="34" charset="-120"/>
-              </a:rPr>
-              <a:t>4</a:t>
-            </a:r>
-            <a:endParaRPr lang="en-US" sz="840" dirty="0"/>
-          </a:p>
-        </p:txBody>
-      </p:sp>
-      <p:sp>
-        <p:nvSpPr>
-          <p:cNvPr id="15" name="Text 12"/>
-          <p:cNvSpPr txBox="1"/>
-          <p:nvPr/>
-        </p:nvSpPr>
-        <p:spPr>
-          <a:xfrm>
-            <a:off x="5742432" y="4114800"/>
-            <a:ext cx="1234440" cy="365760"/>
-          </a:xfrm>
-          <a:prstGeom prst="rect">
-            <a:avLst/>
-          </a:prstGeom>
-          <a:noFill/>
-          <a:ln/>
-        </p:spPr>
-        <p:txBody>
-          <a:bodyPr wrap="square" lIns="0" tIns="0" rIns="0" bIns="0" rtlCol="0" anchor="ctr"/>
-          <a:lstStyle/>
-          <a:p>
-            <a:pPr indent="0" marL="0">
-              <a:buNone/>
-            </a:pPr>
-            <a:r>
-              <a:rPr lang="en-US" sz="1100" dirty="0">
-                <a:solidFill>
-                  <a:srgbClr val="1B2735"/>
-                </a:solidFill>
-                <a:latin typeface="Calibri" pitchFamily="34" charset="0"/>
-                <a:ea typeface="Calibri" pitchFamily="34" charset="-122"/>
-                <a:cs typeface="Calibri" pitchFamily="34" charset="-120"/>
-              </a:rPr>
-              <a:t>Grounding grid</a:t>
-            </a:r>
-            <a:endParaRPr lang="en-US" sz="1100" dirty="0"/>
-          </a:p>
-        </p:txBody>
-      </p:sp>
-      <p:sp>
-        <p:nvSpPr>
-          <p:cNvPr id="16" name="Shape 13"/>
-          <p:cNvSpPr/>
-          <p:nvPr/>
-        </p:nvSpPr>
-        <p:spPr>
-          <a:xfrm>
-            <a:off x="7040880" y="4160520"/>
-            <a:ext cx="274320" cy="274320"/>
-          </a:xfrm>
-          <a:prstGeom prst="ellipse">
-            <a:avLst/>
-          </a:prstGeom>
-          <a:solidFill>
-            <a:srgbClr val="C8742B"/>
-          </a:solidFill>
-          <a:ln w="12700">
-            <a:solidFill>
-              <a:srgbClr val="C8742B"/>
-            </a:solidFill>
-            <a:prstDash val="solid"/>
-          </a:ln>
-        </p:spPr>
-      </p:sp>
-      <p:sp>
-        <p:nvSpPr>
-          <p:cNvPr id="17" name="Text 14"/>
-          <p:cNvSpPr txBox="1"/>
-          <p:nvPr/>
-        </p:nvSpPr>
-        <p:spPr>
-          <a:xfrm>
-            <a:off x="7040880" y="4160520"/>
-            <a:ext cx="274320" cy="274320"/>
-          </a:xfrm>
-          <a:prstGeom prst="rect">
-            <a:avLst/>
-          </a:prstGeom>
-          <a:noFill/>
-          <a:ln/>
-        </p:spPr>
-        <p:txBody>
-          <a:bodyPr wrap="square" lIns="0" tIns="0" rIns="0" bIns="0" rtlCol="0" anchor="ctr"/>
-          <a:lstStyle/>
-          <a:p>
-            <a:pPr algn="ctr" indent="0" marL="0">
-              <a:buNone/>
-            </a:pPr>
-            <a:r>
-              <a:rPr lang="en-US" sz="840" b="1" dirty="0">
-                <a:solidFill>
-                  <a:srgbClr val="FFFFFF"/>
-                </a:solidFill>
-                <a:latin typeface="Cambria" pitchFamily="34" charset="0"/>
-                <a:ea typeface="Cambria" pitchFamily="34" charset="-122"/>
-                <a:cs typeface="Cambria" pitchFamily="34" charset="-120"/>
-              </a:rPr>
-              <a:t>5</a:t>
-            </a:r>
-            <a:endParaRPr lang="en-US" sz="840" dirty="0"/>
-          </a:p>
-        </p:txBody>
-      </p:sp>
-      <p:sp>
-        <p:nvSpPr>
-          <p:cNvPr id="18" name="Text 15"/>
-          <p:cNvSpPr txBox="1"/>
-          <p:nvPr/>
-        </p:nvSpPr>
-        <p:spPr>
-          <a:xfrm>
-            <a:off x="7388352" y="4114800"/>
-            <a:ext cx="1234440" cy="365760"/>
-          </a:xfrm>
-          <a:prstGeom prst="rect">
-            <a:avLst/>
-          </a:prstGeom>
-          <a:noFill/>
-          <a:ln/>
-        </p:spPr>
-        <p:txBody>
-          <a:bodyPr wrap="square" lIns="0" tIns="0" rIns="0" bIns="0" rtlCol="0" anchor="ctr"/>
-          <a:lstStyle/>
-          <a:p>
-            <a:pPr indent="0" marL="0">
-              <a:buNone/>
-            </a:pPr>
-            <a:r>
-              <a:rPr lang="en-US" sz="1100" dirty="0">
-                <a:solidFill>
-                  <a:srgbClr val="1B2735"/>
-                </a:solidFill>
-                <a:latin typeface="Calibri" pitchFamily="34" charset="0"/>
-                <a:ea typeface="Calibri" pitchFamily="34" charset="-122"/>
-                <a:cs typeface="Calibri" pitchFamily="34" charset="-120"/>
-              </a:rPr>
-              <a:t>Hazardous-area cable</a:t>
-            </a:r>
-            <a:endParaRPr lang="en-US" sz="1100" dirty="0"/>
-          </a:p>
-        </p:txBody>
-      </p:sp>
-      <p:sp>
-        <p:nvSpPr>
-          <p:cNvPr id="19" name="Text 16"/>
-          <p:cNvSpPr txBox="1"/>
-          <p:nvPr/>
-        </p:nvSpPr>
-        <p:spPr>
-          <a:xfrm>
-            <a:off x="457200" y="4754880"/>
-            <a:ext cx="5486400" cy="228600"/>
-          </a:xfrm>
-          <a:prstGeom prst="rect">
-            <a:avLst/>
-          </a:prstGeom>
-          <a:noFill/>
-          <a:ln/>
-        </p:spPr>
-        <p:txBody>
-          <a:bodyPr wrap="square" lIns="0" tIns="0" rIns="0" bIns="0" rtlCol="0" anchor="ctr"/>
-          <a:lstStyle/>
-          <a:p>
-            <a:pPr indent="0" marL="0">
-              <a:buNone/>
-            </a:pPr>
-            <a:r>
-              <a:rPr lang="en-US" sz="1000" dirty="0">
-                <a:solidFill>
-                  <a:srgbClr val="5B6B7F"/>
-                </a:solidFill>
-                <a:latin typeface="Calibri" pitchFamily="34" charset="0"/>
-                <a:ea typeface="Calibri" pitchFamily="34" charset="-122"/>
-                <a:cs typeface="Calibri" pitchFamily="34" charset="-120"/>
-              </a:rPr>
               <a:t>Southwire PowerGen  |  Anixter Global Accounts</a:t>
             </a:r>
             <a:endParaRPr lang="en-US" sz="1000" dirty="0"/>
@@ -6468,7 +6644,7 @@
       </p:sp>
       <p:sp>
         <p:nvSpPr>
-          <p:cNvPr id="20" name="Text 17"/>
+          <p:cNvPr id="6" name="Text 3"/>
           <p:cNvSpPr txBox="1"/>
           <p:nvPr/>
         </p:nvSpPr>
@@ -6570,7 +6746,7 @@
                 <a:ea typeface="Cambria" pitchFamily="34" charset="-122"/>
                 <a:cs typeface="Cambria" pitchFamily="34" charset="-120"/>
               </a:rPr>
-              <a:t>PowerGen product line card</a:t>
+              <a:t>Zoom in: the heat recovery steam generator</a:t>
             </a:r>
             <a:endParaRPr lang="en-US" sz="2600" dirty="0"/>
           </a:p>
@@ -6584,8 +6760,8 @@
         </p:nvSpPr>
         <p:spPr>
           <a:xfrm>
-            <a:off x="457200" y="1280160"/>
-            <a:ext cx="2606040" cy="1417320"/>
+            <a:off x="457200" y="1188720"/>
+            <a:ext cx="4297680" cy="3291840"/>
           </a:xfrm>
           <a:prstGeom prst="rect">
             <a:avLst/>
@@ -6608,16 +6784,40 @@
           </a:effectLst>
         </p:spPr>
       </p:sp>
-      <p:sp>
-        <p:nvSpPr>
-          <p:cNvPr id="4" name="Shape 2"/>
+      <p:pic>
+        <p:nvPicPr>
+          <p:cNvPr id="4" name="Image 0" descr="/home/user/ln/presentations/hrsg_view.jpg">    </p:cNvPr>
+          <p:cNvPicPr>
+            <a:picLocks noChangeAspect="1"/>
+          </p:cNvPicPr>
+          <p:nvPr/>
+        </p:nvPicPr>
+        <p:blipFill>
+          <a:blip r:embed="rId1"/>
+          <a:stretch>
+            <a:fillRect/>
+          </a:stretch>
+        </p:blipFill>
+        <p:spPr>
+          <a:xfrm>
+            <a:off x="548640" y="1234440"/>
+            <a:ext cx="4114800" cy="3218688"/>
+          </a:xfrm>
+          <a:prstGeom prst="rect">
+            <a:avLst/>
+          </a:prstGeom>
+        </p:spPr>
+      </p:pic>
+      <p:sp>
+        <p:nvSpPr>
+          <p:cNvPr id="5" name="Shape 2"/>
           <p:cNvSpPr/>
           <p:nvPr/>
         </p:nvSpPr>
         <p:spPr>
           <a:xfrm>
-            <a:off x="640080" y="1463040"/>
-            <a:ext cx="411480" cy="411480"/>
+            <a:off x="5029200" y="1188720"/>
+            <a:ext cx="256032" cy="256032"/>
           </a:xfrm>
           <a:prstGeom prst="ellipse">
             <a:avLst/>
@@ -6635,14 +6835,14 @@
       </p:sp>
       <p:sp>
         <p:nvSpPr>
-          <p:cNvPr id="5" name="Text 3"/>
-          <p:cNvSpPr txBox="1"/>
-          <p:nvPr/>
-        </p:nvSpPr>
-        <p:spPr>
-          <a:xfrm>
-            <a:off x="640080" y="1463040"/>
-            <a:ext cx="411480" cy="411480"/>
+          <p:cNvPr id="6" name="Text 3"/>
+          <p:cNvSpPr txBox="1"/>
+          <p:nvPr/>
+        </p:nvSpPr>
+        <p:spPr>
+          <a:xfrm>
+            <a:off x="5029200" y="1188720"/>
+            <a:ext cx="256032" cy="256032"/>
           </a:xfrm>
           <a:prstGeom prst="rect">
             <a:avLst/>
@@ -6658,7 +6858,7 @@
               <a:buNone/>
             </a:pPr>
             <a:r>
-              <a:rPr lang="en-US" sz="1260" b="1" dirty="0">
+              <a:rPr lang="en-US" sz="784" b="1" dirty="0">
                 <a:solidFill>
                   <a:srgbClr val="FFFFFF"/>
                 </a:solidFill>
@@ -6668,91 +6868,59 @@
               </a:rPr>
               <a:t>1</a:t>
             </a:r>
-            <a:endParaRPr lang="en-US" sz="1260" dirty="0"/>
-          </a:p>
-        </p:txBody>
-      </p:sp>
-      <p:sp>
-        <p:nvSpPr>
-          <p:cNvPr id="6" name="Text 4"/>
-          <p:cNvSpPr txBox="1"/>
-          <p:nvPr/>
-        </p:nvSpPr>
-        <p:spPr>
-          <a:xfrm>
-            <a:off x="640080" y="2011680"/>
-            <a:ext cx="2240280" cy="594360"/>
-          </a:xfrm>
-          <a:prstGeom prst="rect">
-            <a:avLst/>
-          </a:prstGeom>
-          <a:noFill/>
-          <a:ln/>
-        </p:spPr>
-        <p:txBody>
-          <a:bodyPr wrap="square" lIns="0" tIns="0" rIns="0" bIns="0" rtlCol="0" anchor="t"/>
+            <a:endParaRPr lang="en-US" sz="784" dirty="0"/>
+          </a:p>
+        </p:txBody>
+      </p:sp>
+      <p:sp>
+        <p:nvSpPr>
+          <p:cNvPr id="7" name="Text 4"/>
+          <p:cNvSpPr txBox="1"/>
+          <p:nvPr/>
+        </p:nvSpPr>
+        <p:spPr>
+          <a:xfrm>
+            <a:off x="5394960" y="1188720"/>
+            <a:ext cx="3291840" cy="256032"/>
+          </a:xfrm>
+          <a:prstGeom prst="rect">
+            <a:avLst/>
+          </a:prstGeom>
+          <a:noFill/>
+          <a:ln/>
+        </p:spPr>
+        <p:txBody>
+          <a:bodyPr wrap="square" lIns="0" tIns="0" rIns="0" bIns="0" rtlCol="0" anchor="ctr"/>
           <a:lstStyle/>
           <a:p>
             <a:pPr indent="0" marL="0">
               <a:buNone/>
             </a:pPr>
             <a:r>
-              <a:rPr lang="en-US" sz="1500" b="1" dirty="0">
-                <a:solidFill>
-                  <a:srgbClr val="0F1B2D"/>
-                </a:solidFill>
-                <a:latin typeface="Cambria" pitchFamily="34" charset="0"/>
-                <a:ea typeface="Cambria" pitchFamily="34" charset="-122"/>
-                <a:cs typeface="Cambria" pitchFamily="34" charset="-120"/>
-              </a:rPr>
-              <a:t>Medium voltage power cable</a:t>
-            </a:r>
-            <a:endParaRPr lang="en-US" sz="1500" dirty="0"/>
-          </a:p>
-        </p:txBody>
-      </p:sp>
-      <p:sp>
-        <p:nvSpPr>
-          <p:cNvPr id="7" name="Shape 5"/>
+              <a:rPr lang="en-US" sz="1300" dirty="0">
+                <a:solidFill>
+                  <a:srgbClr val="1B2735"/>
+                </a:solidFill>
+                <a:latin typeface="Calibri" pitchFamily="34" charset="0"/>
+                <a:ea typeface="Calibri" pitchFamily="34" charset="-122"/>
+                <a:cs typeface="Calibri" pitchFamily="34" charset="-120"/>
+              </a:rPr>
+              <a:t>Turbine exhaust interface</a:t>
+            </a:r>
+            <a:endParaRPr lang="en-US" sz="1300" dirty="0"/>
+          </a:p>
+        </p:txBody>
+      </p:sp>
+      <p:sp>
+        <p:nvSpPr>
+          <p:cNvPr id="8" name="Shape 5"/>
           <p:cNvSpPr/>
           <p:nvPr/>
         </p:nvSpPr>
         <p:spPr>
           <a:xfrm>
-            <a:off x="3246120" y="1280160"/>
-            <a:ext cx="2606040" cy="1417320"/>
-          </a:xfrm>
-          <a:prstGeom prst="rect">
-            <a:avLst/>
-          </a:prstGeom>
-          <a:solidFill>
-            <a:srgbClr val="FFFFFF"/>
-          </a:solidFill>
-          <a:ln w="9525">
-            <a:solidFill>
-              <a:srgbClr val="E3E8EE"/>
-            </a:solidFill>
-            <a:prstDash val="solid"/>
-          </a:ln>
-          <a:effectLst>
-            <a:outerShdw sx="100000" sy="100000" kx="0" ky="0" algn="bl" rotWithShape="0" blurRad="76200" dist="25400" dir="5400000">
-              <a:srgbClr val="000000">
-                <a:alpha val="12000"/>
-              </a:srgbClr>
-            </a:outerShdw>
-          </a:effectLst>
-        </p:spPr>
-      </p:sp>
-      <p:sp>
-        <p:nvSpPr>
-          <p:cNvPr id="8" name="Shape 6"/>
-          <p:cNvSpPr/>
-          <p:nvPr/>
-        </p:nvSpPr>
-        <p:spPr>
-          <a:xfrm>
-            <a:off x="3429000" y="1463040"/>
-            <a:ext cx="411480" cy="411480"/>
+            <a:off x="5029200" y="1517904"/>
+            <a:ext cx="256032" cy="256032"/>
           </a:xfrm>
           <a:prstGeom prst="ellipse">
             <a:avLst/>
@@ -6770,14 +6938,14 @@
       </p:sp>
       <p:sp>
         <p:nvSpPr>
-          <p:cNvPr id="9" name="Text 7"/>
-          <p:cNvSpPr txBox="1"/>
-          <p:nvPr/>
-        </p:nvSpPr>
-        <p:spPr>
-          <a:xfrm>
-            <a:off x="3429000" y="1463040"/>
-            <a:ext cx="411480" cy="411480"/>
+          <p:cNvPr id="9" name="Text 6"/>
+          <p:cNvSpPr txBox="1"/>
+          <p:nvPr/>
+        </p:nvSpPr>
+        <p:spPr>
+          <a:xfrm>
+            <a:off x="5029200" y="1517904"/>
+            <a:ext cx="256032" cy="256032"/>
           </a:xfrm>
           <a:prstGeom prst="rect">
             <a:avLst/>
@@ -6793,7 +6961,7 @@
               <a:buNone/>
             </a:pPr>
             <a:r>
-              <a:rPr lang="en-US" sz="1260" b="1" dirty="0">
+              <a:rPr lang="en-US" sz="784" b="1" dirty="0">
                 <a:solidFill>
                   <a:srgbClr val="FFFFFF"/>
                 </a:solidFill>
@@ -6803,91 +6971,59 @@
               </a:rPr>
               <a:t>2</a:t>
             </a:r>
-            <a:endParaRPr lang="en-US" sz="1260" dirty="0"/>
-          </a:p>
-        </p:txBody>
-      </p:sp>
-      <p:sp>
-        <p:nvSpPr>
-          <p:cNvPr id="10" name="Text 8"/>
-          <p:cNvSpPr txBox="1"/>
-          <p:nvPr/>
-        </p:nvSpPr>
-        <p:spPr>
-          <a:xfrm>
-            <a:off x="3429000" y="2011680"/>
-            <a:ext cx="2240280" cy="594360"/>
-          </a:xfrm>
-          <a:prstGeom prst="rect">
-            <a:avLst/>
-          </a:prstGeom>
-          <a:noFill/>
-          <a:ln/>
-        </p:spPr>
-        <p:txBody>
-          <a:bodyPr wrap="square" lIns="0" tIns="0" rIns="0" bIns="0" rtlCol="0" anchor="t"/>
+            <a:endParaRPr lang="en-US" sz="784" dirty="0"/>
+          </a:p>
+        </p:txBody>
+      </p:sp>
+      <p:sp>
+        <p:nvSpPr>
+          <p:cNvPr id="10" name="Text 7"/>
+          <p:cNvSpPr txBox="1"/>
+          <p:nvPr/>
+        </p:nvSpPr>
+        <p:spPr>
+          <a:xfrm>
+            <a:off x="5394960" y="1517904"/>
+            <a:ext cx="3291840" cy="256032"/>
+          </a:xfrm>
+          <a:prstGeom prst="rect">
+            <a:avLst/>
+          </a:prstGeom>
+          <a:noFill/>
+          <a:ln/>
+        </p:spPr>
+        <p:txBody>
+          <a:bodyPr wrap="square" lIns="0" tIns="0" rIns="0" bIns="0" rtlCol="0" anchor="ctr"/>
           <a:lstStyle/>
           <a:p>
             <a:pPr indent="0" marL="0">
               <a:buNone/>
             </a:pPr>
             <a:r>
-              <a:rPr lang="en-US" sz="1500" b="1" dirty="0">
-                <a:solidFill>
-                  <a:srgbClr val="0F1B2D"/>
-                </a:solidFill>
-                <a:latin typeface="Cambria" pitchFamily="34" charset="0"/>
-                <a:ea typeface="Cambria" pitchFamily="34" charset="-122"/>
-                <a:cs typeface="Cambria" pitchFamily="34" charset="-120"/>
-              </a:rPr>
-              <a:t>Control and instrumentation cable</a:t>
-            </a:r>
-            <a:endParaRPr lang="en-US" sz="1500" dirty="0"/>
-          </a:p>
-        </p:txBody>
-      </p:sp>
-      <p:sp>
-        <p:nvSpPr>
-          <p:cNvPr id="11" name="Shape 9"/>
+              <a:rPr lang="en-US" sz="1300" dirty="0">
+                <a:solidFill>
+                  <a:srgbClr val="1B2735"/>
+                </a:solidFill>
+                <a:latin typeface="Calibri" pitchFamily="34" charset="0"/>
+                <a:ea typeface="Calibri" pitchFamily="34" charset="-122"/>
+                <a:cs typeface="Calibri" pitchFamily="34" charset="-120"/>
+              </a:rPr>
+              <a:t>Inlet diffuser</a:t>
+            </a:r>
+            <a:endParaRPr lang="en-US" sz="1300" dirty="0"/>
+          </a:p>
+        </p:txBody>
+      </p:sp>
+      <p:sp>
+        <p:nvSpPr>
+          <p:cNvPr id="11" name="Shape 8"/>
           <p:cNvSpPr/>
           <p:nvPr/>
         </p:nvSpPr>
         <p:spPr>
           <a:xfrm>
-            <a:off x="6035040" y="1280160"/>
-            <a:ext cx="2606040" cy="1417320"/>
-          </a:xfrm>
-          <a:prstGeom prst="rect">
-            <a:avLst/>
-          </a:prstGeom>
-          <a:solidFill>
-            <a:srgbClr val="FFFFFF"/>
-          </a:solidFill>
-          <a:ln w="9525">
-            <a:solidFill>
-              <a:srgbClr val="E3E8EE"/>
-            </a:solidFill>
-            <a:prstDash val="solid"/>
-          </a:ln>
-          <a:effectLst>
-            <a:outerShdw sx="100000" sy="100000" kx="0" ky="0" algn="bl" rotWithShape="0" blurRad="76200" dist="25400" dir="5400000">
-              <a:srgbClr val="000000">
-                <a:alpha val="12000"/>
-              </a:srgbClr>
-            </a:outerShdw>
-          </a:effectLst>
-        </p:spPr>
-      </p:sp>
-      <p:sp>
-        <p:nvSpPr>
-          <p:cNvPr id="12" name="Shape 10"/>
-          <p:cNvSpPr/>
-          <p:nvPr/>
-        </p:nvSpPr>
-        <p:spPr>
-          <a:xfrm>
-            <a:off x="6217920" y="1463040"/>
-            <a:ext cx="411480" cy="411480"/>
+            <a:off x="5029200" y="1847088"/>
+            <a:ext cx="256032" cy="256032"/>
           </a:xfrm>
           <a:prstGeom prst="ellipse">
             <a:avLst/>
@@ -6905,14 +7041,14 @@
       </p:sp>
       <p:sp>
         <p:nvSpPr>
-          <p:cNvPr id="13" name="Text 11"/>
-          <p:cNvSpPr txBox="1"/>
-          <p:nvPr/>
-        </p:nvSpPr>
-        <p:spPr>
-          <a:xfrm>
-            <a:off x="6217920" y="1463040"/>
-            <a:ext cx="411480" cy="411480"/>
+          <p:cNvPr id="12" name="Text 9"/>
+          <p:cNvSpPr txBox="1"/>
+          <p:nvPr/>
+        </p:nvSpPr>
+        <p:spPr>
+          <a:xfrm>
+            <a:off x="5029200" y="1847088"/>
+            <a:ext cx="256032" cy="256032"/>
           </a:xfrm>
           <a:prstGeom prst="rect">
             <a:avLst/>
@@ -6928,7 +7064,7 @@
               <a:buNone/>
             </a:pPr>
             <a:r>
-              <a:rPr lang="en-US" sz="1260" b="1" dirty="0">
+              <a:rPr lang="en-US" sz="784" b="1" dirty="0">
                 <a:solidFill>
                   <a:srgbClr val="FFFFFF"/>
                 </a:solidFill>
@@ -6938,91 +7074,59 @@
               </a:rPr>
               <a:t>3</a:t>
             </a:r>
-            <a:endParaRPr lang="en-US" sz="1260" dirty="0"/>
-          </a:p>
-        </p:txBody>
-      </p:sp>
-      <p:sp>
-        <p:nvSpPr>
-          <p:cNvPr id="14" name="Text 12"/>
-          <p:cNvSpPr txBox="1"/>
-          <p:nvPr/>
-        </p:nvSpPr>
-        <p:spPr>
-          <a:xfrm>
-            <a:off x="6217920" y="2011680"/>
-            <a:ext cx="2240280" cy="594360"/>
-          </a:xfrm>
-          <a:prstGeom prst="rect">
-            <a:avLst/>
-          </a:prstGeom>
-          <a:noFill/>
-          <a:ln/>
-        </p:spPr>
-        <p:txBody>
-          <a:bodyPr wrap="square" lIns="0" tIns="0" rIns="0" bIns="0" rtlCol="0" anchor="t"/>
+            <a:endParaRPr lang="en-US" sz="784" dirty="0"/>
+          </a:p>
+        </p:txBody>
+      </p:sp>
+      <p:sp>
+        <p:nvSpPr>
+          <p:cNvPr id="13" name="Text 10"/>
+          <p:cNvSpPr txBox="1"/>
+          <p:nvPr/>
+        </p:nvSpPr>
+        <p:spPr>
+          <a:xfrm>
+            <a:off x="5394960" y="1847088"/>
+            <a:ext cx="3291840" cy="256032"/>
+          </a:xfrm>
+          <a:prstGeom prst="rect">
+            <a:avLst/>
+          </a:prstGeom>
+          <a:noFill/>
+          <a:ln/>
+        </p:spPr>
+        <p:txBody>
+          <a:bodyPr wrap="square" lIns="0" tIns="0" rIns="0" bIns="0" rtlCol="0" anchor="ctr"/>
           <a:lstStyle/>
           <a:p>
             <a:pPr indent="0" marL="0">
               <a:buNone/>
             </a:pPr>
             <a:r>
-              <a:rPr lang="en-US" sz="1500" b="1" dirty="0">
-                <a:solidFill>
-                  <a:srgbClr val="0F1B2D"/>
-                </a:solidFill>
-                <a:latin typeface="Cambria" pitchFamily="34" charset="0"/>
-                <a:ea typeface="Cambria" pitchFamily="34" charset="-122"/>
-                <a:cs typeface="Cambria" pitchFamily="34" charset="-120"/>
-              </a:rPr>
-              <a:t>Low voltage power and auxiliary cable</a:t>
-            </a:r>
-            <a:endParaRPr lang="en-US" sz="1500" dirty="0"/>
-          </a:p>
-        </p:txBody>
-      </p:sp>
-      <p:sp>
-        <p:nvSpPr>
-          <p:cNvPr id="15" name="Shape 13"/>
+              <a:rPr lang="en-US" sz="1300" dirty="0">
+                <a:solidFill>
+                  <a:srgbClr val="1B2735"/>
+                </a:solidFill>
+                <a:latin typeface="Calibri" pitchFamily="34" charset="0"/>
+                <a:ea typeface="Calibri" pitchFamily="34" charset="-122"/>
+                <a:cs typeface="Calibri" pitchFamily="34" charset="-120"/>
+              </a:rPr>
+              <a:t>Insulated HRSG casing</a:t>
+            </a:r>
+            <a:endParaRPr lang="en-US" sz="1300" dirty="0"/>
+          </a:p>
+        </p:txBody>
+      </p:sp>
+      <p:sp>
+        <p:nvSpPr>
+          <p:cNvPr id="14" name="Shape 11"/>
           <p:cNvSpPr/>
           <p:nvPr/>
         </p:nvSpPr>
         <p:spPr>
           <a:xfrm>
-            <a:off x="457200" y="2880360"/>
-            <a:ext cx="2606040" cy="1417320"/>
-          </a:xfrm>
-          <a:prstGeom prst="rect">
-            <a:avLst/>
-          </a:prstGeom>
-          <a:solidFill>
-            <a:srgbClr val="FFFFFF"/>
-          </a:solidFill>
-          <a:ln w="9525">
-            <a:solidFill>
-              <a:srgbClr val="E3E8EE"/>
-            </a:solidFill>
-            <a:prstDash val="solid"/>
-          </a:ln>
-          <a:effectLst>
-            <a:outerShdw sx="100000" sy="100000" kx="0" ky="0" algn="bl" rotWithShape="0" blurRad="76200" dist="25400" dir="5400000">
-              <a:srgbClr val="000000">
-                <a:alpha val="12000"/>
-              </a:srgbClr>
-            </a:outerShdw>
-          </a:effectLst>
-        </p:spPr>
-      </p:sp>
-      <p:sp>
-        <p:nvSpPr>
-          <p:cNvPr id="16" name="Shape 14"/>
-          <p:cNvSpPr/>
-          <p:nvPr/>
-        </p:nvSpPr>
-        <p:spPr>
-          <a:xfrm>
-            <a:off x="640080" y="3063240"/>
-            <a:ext cx="411480" cy="411480"/>
+            <a:off x="5029200" y="2176272"/>
+            <a:ext cx="256032" cy="256032"/>
           </a:xfrm>
           <a:prstGeom prst="ellipse">
             <a:avLst/>
@@ -7040,14 +7144,14 @@
       </p:sp>
       <p:sp>
         <p:nvSpPr>
-          <p:cNvPr id="17" name="Text 15"/>
-          <p:cNvSpPr txBox="1"/>
-          <p:nvPr/>
-        </p:nvSpPr>
-        <p:spPr>
-          <a:xfrm>
-            <a:off x="640080" y="3063240"/>
-            <a:ext cx="411480" cy="411480"/>
+          <p:cNvPr id="15" name="Text 12"/>
+          <p:cNvSpPr txBox="1"/>
+          <p:nvPr/>
+        </p:nvSpPr>
+        <p:spPr>
+          <a:xfrm>
+            <a:off x="5029200" y="2176272"/>
+            <a:ext cx="256032" cy="256032"/>
           </a:xfrm>
           <a:prstGeom prst="rect">
             <a:avLst/>
@@ -7063,7 +7167,7 @@
               <a:buNone/>
             </a:pPr>
             <a:r>
-              <a:rPr lang="en-US" sz="1260" b="1" dirty="0">
+              <a:rPr lang="en-US" sz="784" b="1" dirty="0">
                 <a:solidFill>
                   <a:srgbClr val="FFFFFF"/>
                 </a:solidFill>
@@ -7073,91 +7177,59 @@
               </a:rPr>
               <a:t>4</a:t>
             </a:r>
-            <a:endParaRPr lang="en-US" sz="1260" dirty="0"/>
-          </a:p>
-        </p:txBody>
-      </p:sp>
-      <p:sp>
-        <p:nvSpPr>
-          <p:cNvPr id="18" name="Text 16"/>
-          <p:cNvSpPr txBox="1"/>
-          <p:nvPr/>
-        </p:nvSpPr>
-        <p:spPr>
-          <a:xfrm>
-            <a:off x="640080" y="3611880"/>
-            <a:ext cx="2240280" cy="594360"/>
-          </a:xfrm>
-          <a:prstGeom prst="rect">
-            <a:avLst/>
-          </a:prstGeom>
-          <a:noFill/>
-          <a:ln/>
-        </p:spPr>
-        <p:txBody>
-          <a:bodyPr wrap="square" lIns="0" tIns="0" rIns="0" bIns="0" rtlCol="0" anchor="t"/>
+            <a:endParaRPr lang="en-US" sz="784" dirty="0"/>
+          </a:p>
+        </p:txBody>
+      </p:sp>
+      <p:sp>
+        <p:nvSpPr>
+          <p:cNvPr id="16" name="Text 13"/>
+          <p:cNvSpPr txBox="1"/>
+          <p:nvPr/>
+        </p:nvSpPr>
+        <p:spPr>
+          <a:xfrm>
+            <a:off x="5394960" y="2176272"/>
+            <a:ext cx="3291840" cy="256032"/>
+          </a:xfrm>
+          <a:prstGeom prst="rect">
+            <a:avLst/>
+          </a:prstGeom>
+          <a:noFill/>
+          <a:ln/>
+        </p:spPr>
+        <p:txBody>
+          <a:bodyPr wrap="square" lIns="0" tIns="0" rIns="0" bIns="0" rtlCol="0" anchor="ctr"/>
           <a:lstStyle/>
           <a:p>
             <a:pPr indent="0" marL="0">
               <a:buNone/>
             </a:pPr>
             <a:r>
-              <a:rPr lang="en-US" sz="1500" b="1" dirty="0">
-                <a:solidFill>
-                  <a:srgbClr val="0F1B2D"/>
-                </a:solidFill>
-                <a:latin typeface="Cambria" pitchFamily="34" charset="0"/>
-                <a:ea typeface="Cambria" pitchFamily="34" charset="-122"/>
-                <a:cs typeface="Cambria" pitchFamily="34" charset="-120"/>
-              </a:rPr>
-              <a:t>Grounding and bare conductor</a:t>
-            </a:r>
-            <a:endParaRPr lang="en-US" sz="1500" dirty="0"/>
-          </a:p>
-        </p:txBody>
-      </p:sp>
-      <p:sp>
-        <p:nvSpPr>
-          <p:cNvPr id="19" name="Shape 17"/>
+              <a:rPr lang="en-US" sz="1300" dirty="0">
+                <a:solidFill>
+                  <a:srgbClr val="1B2735"/>
+                </a:solidFill>
+                <a:latin typeface="Calibri" pitchFamily="34" charset="0"/>
+                <a:ea typeface="Calibri" pitchFamily="34" charset="-122"/>
+                <a:cs typeface="Calibri" pitchFamily="34" charset="-120"/>
+              </a:rPr>
+              <a:t>Steam drums</a:t>
+            </a:r>
+            <a:endParaRPr lang="en-US" sz="1300" dirty="0"/>
+          </a:p>
+        </p:txBody>
+      </p:sp>
+      <p:sp>
+        <p:nvSpPr>
+          <p:cNvPr id="17" name="Shape 14"/>
           <p:cNvSpPr/>
           <p:nvPr/>
         </p:nvSpPr>
         <p:spPr>
           <a:xfrm>
-            <a:off x="3246120" y="2880360"/>
-            <a:ext cx="2606040" cy="1417320"/>
-          </a:xfrm>
-          <a:prstGeom prst="rect">
-            <a:avLst/>
-          </a:prstGeom>
-          <a:solidFill>
-            <a:srgbClr val="FFFFFF"/>
-          </a:solidFill>
-          <a:ln w="9525">
-            <a:solidFill>
-              <a:srgbClr val="E3E8EE"/>
-            </a:solidFill>
-            <a:prstDash val="solid"/>
-          </a:ln>
-          <a:effectLst>
-            <a:outerShdw sx="100000" sy="100000" kx="0" ky="0" algn="bl" rotWithShape="0" blurRad="76200" dist="25400" dir="5400000">
-              <a:srgbClr val="000000">
-                <a:alpha val="12000"/>
-              </a:srgbClr>
-            </a:outerShdw>
-          </a:effectLst>
-        </p:spPr>
-      </p:sp>
-      <p:sp>
-        <p:nvSpPr>
-          <p:cNvPr id="20" name="Shape 18"/>
-          <p:cNvSpPr/>
-          <p:nvPr/>
-        </p:nvSpPr>
-        <p:spPr>
-          <a:xfrm>
-            <a:off x="3429000" y="3063240"/>
-            <a:ext cx="411480" cy="411480"/>
+            <a:off x="5029200" y="2505456"/>
+            <a:ext cx="256032" cy="256032"/>
           </a:xfrm>
           <a:prstGeom prst="ellipse">
             <a:avLst/>
@@ -7175,14 +7247,14 @@
       </p:sp>
       <p:sp>
         <p:nvSpPr>
-          <p:cNvPr id="21" name="Text 19"/>
-          <p:cNvSpPr txBox="1"/>
-          <p:nvPr/>
-        </p:nvSpPr>
-        <p:spPr>
-          <a:xfrm>
-            <a:off x="3429000" y="3063240"/>
-            <a:ext cx="411480" cy="411480"/>
+          <p:cNvPr id="18" name="Text 15"/>
+          <p:cNvSpPr txBox="1"/>
+          <p:nvPr/>
+        </p:nvSpPr>
+        <p:spPr>
+          <a:xfrm>
+            <a:off x="5029200" y="2505456"/>
+            <a:ext cx="256032" cy="256032"/>
           </a:xfrm>
           <a:prstGeom prst="rect">
             <a:avLst/>
@@ -7198,7 +7270,7 @@
               <a:buNone/>
             </a:pPr>
             <a:r>
-              <a:rPr lang="en-US" sz="1260" b="1" dirty="0">
+              <a:rPr lang="en-US" sz="784" b="1" dirty="0">
                 <a:solidFill>
                   <a:srgbClr val="FFFFFF"/>
                 </a:solidFill>
@@ -7208,91 +7280,59 @@
               </a:rPr>
               <a:t>5</a:t>
             </a:r>
-            <a:endParaRPr lang="en-US" sz="1260" dirty="0"/>
-          </a:p>
-        </p:txBody>
-      </p:sp>
-      <p:sp>
-        <p:nvSpPr>
-          <p:cNvPr id="22" name="Text 20"/>
-          <p:cNvSpPr txBox="1"/>
-          <p:nvPr/>
-        </p:nvSpPr>
-        <p:spPr>
-          <a:xfrm>
-            <a:off x="3429000" y="3611880"/>
-            <a:ext cx="2240280" cy="594360"/>
-          </a:xfrm>
-          <a:prstGeom prst="rect">
-            <a:avLst/>
-          </a:prstGeom>
-          <a:noFill/>
-          <a:ln/>
-        </p:spPr>
-        <p:txBody>
-          <a:bodyPr wrap="square" lIns="0" tIns="0" rIns="0" bIns="0" rtlCol="0" anchor="t"/>
+            <a:endParaRPr lang="en-US" sz="784" dirty="0"/>
+          </a:p>
+        </p:txBody>
+      </p:sp>
+      <p:sp>
+        <p:nvSpPr>
+          <p:cNvPr id="19" name="Text 16"/>
+          <p:cNvSpPr txBox="1"/>
+          <p:nvPr/>
+        </p:nvSpPr>
+        <p:spPr>
+          <a:xfrm>
+            <a:off x="5394960" y="2505456"/>
+            <a:ext cx="3291840" cy="256032"/>
+          </a:xfrm>
+          <a:prstGeom prst="rect">
+            <a:avLst/>
+          </a:prstGeom>
+          <a:noFill/>
+          <a:ln/>
+        </p:spPr>
+        <p:txBody>
+          <a:bodyPr wrap="square" lIns="0" tIns="0" rIns="0" bIns="0" rtlCol="0" anchor="ctr"/>
           <a:lstStyle/>
           <a:p>
             <a:pPr indent="0" marL="0">
               <a:buNone/>
             </a:pPr>
             <a:r>
-              <a:rPr lang="en-US" sz="1500" b="1" dirty="0">
-                <a:solidFill>
-                  <a:srgbClr val="0F1B2D"/>
-                </a:solidFill>
-                <a:latin typeface="Cambria" pitchFamily="34" charset="0"/>
-                <a:ea typeface="Cambria" pitchFamily="34" charset="-122"/>
-                <a:cs typeface="Cambria" pitchFamily="34" charset="-120"/>
-              </a:rPr>
-              <a:t>Hazardous-area and specialty cable</a:t>
-            </a:r>
-            <a:endParaRPr lang="en-US" sz="1500" dirty="0"/>
-          </a:p>
-        </p:txBody>
-      </p:sp>
-      <p:sp>
-        <p:nvSpPr>
-          <p:cNvPr id="23" name="Shape 21"/>
+              <a:rPr lang="en-US" sz="1300" dirty="0">
+                <a:solidFill>
+                  <a:srgbClr val="1B2735"/>
+                </a:solidFill>
+                <a:latin typeface="Calibri" pitchFamily="34" charset="0"/>
+                <a:ea typeface="Calibri" pitchFamily="34" charset="-122"/>
+                <a:cs typeface="Calibri" pitchFamily="34" charset="-120"/>
+              </a:rPr>
+              <a:t>Access stair tower</a:t>
+            </a:r>
+            <a:endParaRPr lang="en-US" sz="1300" dirty="0"/>
+          </a:p>
+        </p:txBody>
+      </p:sp>
+      <p:sp>
+        <p:nvSpPr>
+          <p:cNvPr id="20" name="Shape 17"/>
           <p:cNvSpPr/>
           <p:nvPr/>
         </p:nvSpPr>
         <p:spPr>
           <a:xfrm>
-            <a:off x="6035040" y="2880360"/>
-            <a:ext cx="2606040" cy="1417320"/>
-          </a:xfrm>
-          <a:prstGeom prst="rect">
-            <a:avLst/>
-          </a:prstGeom>
-          <a:solidFill>
-            <a:srgbClr val="FFFFFF"/>
-          </a:solidFill>
-          <a:ln w="9525">
-            <a:solidFill>
-              <a:srgbClr val="E3E8EE"/>
-            </a:solidFill>
-            <a:prstDash val="solid"/>
-          </a:ln>
-          <a:effectLst>
-            <a:outerShdw sx="100000" sy="100000" kx="0" ky="0" algn="bl" rotWithShape="0" blurRad="76200" dist="25400" dir="5400000">
-              <a:srgbClr val="000000">
-                <a:alpha val="12000"/>
-              </a:srgbClr>
-            </a:outerShdw>
-          </a:effectLst>
-        </p:spPr>
-      </p:sp>
-      <p:sp>
-        <p:nvSpPr>
-          <p:cNvPr id="24" name="Shape 22"/>
-          <p:cNvSpPr/>
-          <p:nvPr/>
-        </p:nvSpPr>
-        <p:spPr>
-          <a:xfrm>
-            <a:off x="6217920" y="3063240"/>
-            <a:ext cx="411480" cy="411480"/>
+            <a:off x="5029200" y="2834640"/>
+            <a:ext cx="256032" cy="256032"/>
           </a:xfrm>
           <a:prstGeom prst="ellipse">
             <a:avLst/>
@@ -7310,14 +7350,14 @@
       </p:sp>
       <p:sp>
         <p:nvSpPr>
-          <p:cNvPr id="25" name="Text 23"/>
-          <p:cNvSpPr txBox="1"/>
-          <p:nvPr/>
-        </p:nvSpPr>
-        <p:spPr>
-          <a:xfrm>
-            <a:off x="6217920" y="3063240"/>
-            <a:ext cx="411480" cy="411480"/>
+          <p:cNvPr id="21" name="Text 18"/>
+          <p:cNvSpPr txBox="1"/>
+          <p:nvPr/>
+        </p:nvSpPr>
+        <p:spPr>
+          <a:xfrm>
+            <a:off x="5029200" y="2834640"/>
+            <a:ext cx="256032" cy="256032"/>
           </a:xfrm>
           <a:prstGeom prst="rect">
             <a:avLst/>
@@ -7333,7 +7373,7 @@
               <a:buNone/>
             </a:pPr>
             <a:r>
-              <a:rPr lang="en-US" sz="1260" b="1" dirty="0">
+              <a:rPr lang="en-US" sz="784" b="1" dirty="0">
                 <a:solidFill>
                   <a:srgbClr val="FFFFFF"/>
                 </a:solidFill>
@@ -7343,59 +7383,123 @@
               </a:rPr>
               <a:t>6</a:t>
             </a:r>
-            <a:endParaRPr lang="en-US" sz="1260" dirty="0"/>
-          </a:p>
-        </p:txBody>
-      </p:sp>
-      <p:sp>
-        <p:nvSpPr>
-          <p:cNvPr id="26" name="Text 24"/>
-          <p:cNvSpPr txBox="1"/>
-          <p:nvPr/>
-        </p:nvSpPr>
-        <p:spPr>
-          <a:xfrm>
-            <a:off x="6217920" y="3611880"/>
-            <a:ext cx="2240280" cy="594360"/>
-          </a:xfrm>
-          <a:prstGeom prst="rect">
-            <a:avLst/>
-          </a:prstGeom>
-          <a:noFill/>
-          <a:ln/>
-        </p:spPr>
-        <p:txBody>
-          <a:bodyPr wrap="square" lIns="0" tIns="0" rIns="0" bIns="0" rtlCol="0" anchor="t"/>
+            <a:endParaRPr lang="en-US" sz="784" dirty="0"/>
+          </a:p>
+        </p:txBody>
+      </p:sp>
+      <p:sp>
+        <p:nvSpPr>
+          <p:cNvPr id="22" name="Text 19"/>
+          <p:cNvSpPr txBox="1"/>
+          <p:nvPr/>
+        </p:nvSpPr>
+        <p:spPr>
+          <a:xfrm>
+            <a:off x="5394960" y="2834640"/>
+            <a:ext cx="3291840" cy="256032"/>
+          </a:xfrm>
+          <a:prstGeom prst="rect">
+            <a:avLst/>
+          </a:prstGeom>
+          <a:noFill/>
+          <a:ln/>
+        </p:spPr>
+        <p:txBody>
+          <a:bodyPr wrap="square" lIns="0" tIns="0" rIns="0" bIns="0" rtlCol="0" anchor="ctr"/>
           <a:lstStyle/>
           <a:p>
             <a:pPr indent="0" marL="0">
               <a:buNone/>
             </a:pPr>
             <a:r>
-              <a:rPr lang="en-US" sz="1500" b="1" dirty="0">
-                <a:solidFill>
-                  <a:srgbClr val="0F1B2D"/>
+              <a:rPr lang="en-US" sz="1300" dirty="0">
+                <a:solidFill>
+                  <a:srgbClr val="1B2735"/>
+                </a:solidFill>
+                <a:latin typeface="Calibri" pitchFamily="34" charset="0"/>
+                <a:ea typeface="Calibri" pitchFamily="34" charset="-122"/>
+                <a:cs typeface="Calibri" pitchFamily="34" charset="-120"/>
+              </a:rPr>
+              <a:t>Outlet plenum</a:t>
+            </a:r>
+            <a:endParaRPr lang="en-US" sz="1300" dirty="0"/>
+          </a:p>
+        </p:txBody>
+      </p:sp>
+      <p:sp>
+        <p:nvSpPr>
+          <p:cNvPr id="23" name="Shape 20"/>
+          <p:cNvSpPr/>
+          <p:nvPr/>
+        </p:nvSpPr>
+        <p:spPr>
+          <a:xfrm>
+            <a:off x="5029200" y="3163824"/>
+            <a:ext cx="256032" cy="256032"/>
+          </a:xfrm>
+          <a:prstGeom prst="ellipse">
+            <a:avLst/>
+          </a:prstGeom>
+          <a:solidFill>
+            <a:srgbClr val="C8742B"/>
+          </a:solidFill>
+          <a:ln w="12700">
+            <a:solidFill>
+              <a:srgbClr val="C8742B"/>
+            </a:solidFill>
+            <a:prstDash val="solid"/>
+          </a:ln>
+        </p:spPr>
+      </p:sp>
+      <p:sp>
+        <p:nvSpPr>
+          <p:cNvPr id="24" name="Text 21"/>
+          <p:cNvSpPr txBox="1"/>
+          <p:nvPr/>
+        </p:nvSpPr>
+        <p:spPr>
+          <a:xfrm>
+            <a:off x="5029200" y="3163824"/>
+            <a:ext cx="256032" cy="256032"/>
+          </a:xfrm>
+          <a:prstGeom prst="rect">
+            <a:avLst/>
+          </a:prstGeom>
+          <a:noFill/>
+          <a:ln/>
+        </p:spPr>
+        <p:txBody>
+          <a:bodyPr wrap="square" lIns="0" tIns="0" rIns="0" bIns="0" rtlCol="0" anchor="ctr"/>
+          <a:lstStyle/>
+          <a:p>
+            <a:pPr algn="ctr" indent="0" marL="0">
+              <a:buNone/>
+            </a:pPr>
+            <a:r>
+              <a:rPr lang="en-US" sz="784" b="1" dirty="0">
+                <a:solidFill>
+                  <a:srgbClr val="FFFFFF"/>
                 </a:solidFill>
                 <a:latin typeface="Cambria" pitchFamily="34" charset="0"/>
                 <a:ea typeface="Cambria" pitchFamily="34" charset="-122"/>
                 <a:cs typeface="Cambria" pitchFamily="34" charset="-120"/>
               </a:rPr>
-              <a:t>Building wire and MC cable</a:t>
-            </a:r>
-            <a:endParaRPr lang="en-US" sz="1500" dirty="0"/>
-          </a:p>
-        </p:txBody>
-      </p:sp>
-      <p:sp>
-        <p:nvSpPr>
-          <p:cNvPr id="27" name="Text 25"/>
-          <p:cNvSpPr txBox="1"/>
-          <p:nvPr/>
-        </p:nvSpPr>
-        <p:spPr>
-          <a:xfrm>
-            <a:off x="457200" y="4434840"/>
-            <a:ext cx="8229600" cy="228600"/>
+              <a:t>7</a:t>
+            </a:r>
+            <a:endParaRPr lang="en-US" sz="784" dirty="0"/>
+          </a:p>
+        </p:txBody>
+      </p:sp>
+      <p:sp>
+        <p:nvSpPr>
+          <p:cNvPr id="25" name="Text 22"/>
+          <p:cNvSpPr txBox="1"/>
+          <p:nvPr/>
+        </p:nvSpPr>
+        <p:spPr>
+          <a:xfrm>
+            <a:off x="5394960" y="3163824"/>
+            <a:ext cx="3291840" cy="256032"/>
           </a:xfrm>
           <a:prstGeom prst="rect">
             <a:avLst/>
@@ -7411,30 +7515,94 @@
               <a:buNone/>
             </a:pPr>
             <a:r>
-              <a:rPr lang="en-US" sz="1100" i="1" dirty="0">
-                <a:solidFill>
-                  <a:srgbClr val="5B6B7F"/>
+              <a:rPr lang="en-US" sz="1300" dirty="0">
+                <a:solidFill>
+                  <a:srgbClr val="1B2735"/>
                 </a:solidFill>
                 <a:latin typeface="Calibri" pitchFamily="34" charset="0"/>
                 <a:ea typeface="Calibri" pitchFamily="34" charset="-122"/>
                 <a:cs typeface="Calibri" pitchFamily="34" charset="-120"/>
               </a:rPr>
-              <a:t>Numbers 1-5 match the plant diagram.</a:t>
-            </a:r>
-            <a:endParaRPr lang="en-US" sz="1100" dirty="0"/>
-          </a:p>
-        </p:txBody>
-      </p:sp>
-      <p:sp>
-        <p:nvSpPr>
-          <p:cNvPr id="28" name="Text 26"/>
-          <p:cNvSpPr txBox="1"/>
-          <p:nvPr/>
-        </p:nvSpPr>
-        <p:spPr>
-          <a:xfrm>
-            <a:off x="457200" y="4754880"/>
-            <a:ext cx="5486400" cy="228600"/>
+              <a:t>Exhaust stack</a:t>
+            </a:r>
+            <a:endParaRPr lang="en-US" sz="1300" dirty="0"/>
+          </a:p>
+        </p:txBody>
+      </p:sp>
+      <p:sp>
+        <p:nvSpPr>
+          <p:cNvPr id="26" name="Shape 23"/>
+          <p:cNvSpPr/>
+          <p:nvPr/>
+        </p:nvSpPr>
+        <p:spPr>
+          <a:xfrm>
+            <a:off x="5029200" y="3493008"/>
+            <a:ext cx="256032" cy="256032"/>
+          </a:xfrm>
+          <a:prstGeom prst="ellipse">
+            <a:avLst/>
+          </a:prstGeom>
+          <a:solidFill>
+            <a:srgbClr val="C8742B"/>
+          </a:solidFill>
+          <a:ln w="12700">
+            <a:solidFill>
+              <a:srgbClr val="C8742B"/>
+            </a:solidFill>
+            <a:prstDash val="solid"/>
+          </a:ln>
+        </p:spPr>
+      </p:sp>
+      <p:sp>
+        <p:nvSpPr>
+          <p:cNvPr id="27" name="Text 24"/>
+          <p:cNvSpPr txBox="1"/>
+          <p:nvPr/>
+        </p:nvSpPr>
+        <p:spPr>
+          <a:xfrm>
+            <a:off x="5029200" y="3493008"/>
+            <a:ext cx="256032" cy="256032"/>
+          </a:xfrm>
+          <a:prstGeom prst="rect">
+            <a:avLst/>
+          </a:prstGeom>
+          <a:noFill/>
+          <a:ln/>
+        </p:spPr>
+        <p:txBody>
+          <a:bodyPr wrap="square" lIns="0" tIns="0" rIns="0" bIns="0" rtlCol="0" anchor="ctr"/>
+          <a:lstStyle/>
+          <a:p>
+            <a:pPr algn="ctr" indent="0" marL="0">
+              <a:buNone/>
+            </a:pPr>
+            <a:r>
+              <a:rPr lang="en-US" sz="784" b="1" dirty="0">
+                <a:solidFill>
+                  <a:srgbClr val="FFFFFF"/>
+                </a:solidFill>
+                <a:latin typeface="Cambria" pitchFamily="34" charset="0"/>
+                <a:ea typeface="Cambria" pitchFamily="34" charset="-122"/>
+                <a:cs typeface="Cambria" pitchFamily="34" charset="-120"/>
+              </a:rPr>
+              <a:t>8</a:t>
+            </a:r>
+            <a:endParaRPr lang="en-US" sz="784" dirty="0"/>
+          </a:p>
+        </p:txBody>
+      </p:sp>
+      <p:sp>
+        <p:nvSpPr>
+          <p:cNvPr id="28" name="Text 25"/>
+          <p:cNvSpPr txBox="1"/>
+          <p:nvPr/>
+        </p:nvSpPr>
+        <p:spPr>
+          <a:xfrm>
+            <a:off x="5394960" y="3493008"/>
+            <a:ext cx="3291840" cy="256032"/>
           </a:xfrm>
           <a:prstGeom prst="rect">
             <a:avLst/>
@@ -7450,14 +7618,131 @@
               <a:buNone/>
             </a:pPr>
             <a:r>
-              <a:rPr lang="en-US" sz="1000" dirty="0">
-                <a:solidFill>
-                  <a:srgbClr val="5B6B7F"/>
+              <a:rPr lang="en-US" sz="1300" dirty="0">
+                <a:solidFill>
+                  <a:srgbClr val="1B2735"/>
                 </a:solidFill>
                 <a:latin typeface="Calibri" pitchFamily="34" charset="0"/>
                 <a:ea typeface="Calibri" pitchFamily="34" charset="-122"/>
                 <a:cs typeface="Calibri" pitchFamily="34" charset="-120"/>
               </a:rPr>
+              <a:t>Auxiliary power and controls</a:t>
+            </a:r>
+            <a:endParaRPr lang="en-US" sz="1300" dirty="0"/>
+          </a:p>
+        </p:txBody>
+      </p:sp>
+      <p:sp>
+        <p:nvSpPr>
+          <p:cNvPr id="29" name="Text 26"/>
+          <p:cNvSpPr txBox="1"/>
+          <p:nvPr/>
+        </p:nvSpPr>
+        <p:spPr>
+          <a:xfrm>
+            <a:off x="5029200" y="3886200"/>
+            <a:ext cx="3657600" cy="594360"/>
+          </a:xfrm>
+          <a:prstGeom prst="rect">
+            <a:avLst/>
+          </a:prstGeom>
+          <a:noFill/>
+          <a:ln/>
+        </p:spPr>
+        <p:txBody>
+          <a:bodyPr wrap="square" lIns="0" tIns="0" rIns="0" bIns="0" rtlCol="0" anchor="t"/>
+          <a:lstStyle/>
+          <a:p>
+            <a:pPr indent="0" marL="0">
+              <a:buNone/>
+            </a:pPr>
+            <a:r>
+              <a:rPr lang="en-US" sz="1200" i="1" dirty="0">
+                <a:solidFill>
+                  <a:srgbClr val="5B6B7F"/>
+                </a:solidFill>
+                <a:latin typeface="Calibri" pitchFamily="34" charset="0"/>
+                <a:ea typeface="Calibri" pitchFamily="34" charset="-122"/>
+                <a:cs typeface="Calibri" pitchFamily="34" charset="-120"/>
+              </a:rPr>
+              <a:t>Cable touchpoints: auxiliary MCC, control and I/O panel, power and control trays, field junction boxes, protective bonding.</a:t>
+            </a:r>
+            <a:endParaRPr lang="en-US" sz="1200" dirty="0"/>
+          </a:p>
+        </p:txBody>
+      </p:sp>
+      <p:sp>
+        <p:nvSpPr>
+          <p:cNvPr id="30" name="Text 27"/>
+          <p:cNvSpPr txBox="1"/>
+          <p:nvPr/>
+        </p:nvSpPr>
+        <p:spPr>
+          <a:xfrm>
+            <a:off x="457200" y="4526280"/>
+            <a:ext cx="8229600" cy="182880"/>
+          </a:xfrm>
+          <a:prstGeom prst="rect">
+            <a:avLst/>
+          </a:prstGeom>
+          <a:noFill/>
+          <a:ln/>
+        </p:spPr>
+        <p:txBody>
+          <a:bodyPr wrap="square" lIns="0" tIns="0" rIns="0" bIns="0" rtlCol="0" anchor="ctr"/>
+          <a:lstStyle/>
+          <a:p>
+            <a:pPr indent="0" marL="0">
+              <a:buNone/>
+            </a:pPr>
+            <a:r>
+              <a:rPr lang="en-US" sz="900" dirty="0">
+                <a:solidFill>
+                  <a:srgbClr val="5B6B7F"/>
+                </a:solidFill>
+                <a:latin typeface="Calibri" pitchFamily="34" charset="0"/>
+                <a:ea typeface="Calibri" pitchFamily="34" charset="-122"/>
+                <a:cs typeface="Calibri" pitchFamily="34" charset="-120"/>
+              </a:rPr>
+              <a:t>Illustrative model; not a construction drawing.</a:t>
+            </a:r>
+            <a:endParaRPr lang="en-US" sz="900" dirty="0"/>
+          </a:p>
+        </p:txBody>
+      </p:sp>
+      <p:sp>
+        <p:nvSpPr>
+          <p:cNvPr id="31" name="Text 28"/>
+          <p:cNvSpPr txBox="1"/>
+          <p:nvPr/>
+        </p:nvSpPr>
+        <p:spPr>
+          <a:xfrm>
+            <a:off x="457200" y="4754880"/>
+            <a:ext cx="5486400" cy="228600"/>
+          </a:xfrm>
+          <a:prstGeom prst="rect">
+            <a:avLst/>
+          </a:prstGeom>
+          <a:noFill/>
+          <a:ln/>
+        </p:spPr>
+        <p:txBody>
+          <a:bodyPr wrap="square" lIns="0" tIns="0" rIns="0" bIns="0" rtlCol="0" anchor="ctr"/>
+          <a:lstStyle/>
+          <a:p>
+            <a:pPr indent="0" marL="0">
+              <a:buNone/>
+            </a:pPr>
+            <a:r>
+              <a:rPr lang="en-US" sz="1000" dirty="0">
+                <a:solidFill>
+                  <a:srgbClr val="5B6B7F"/>
+                </a:solidFill>
+                <a:latin typeface="Calibri" pitchFamily="34" charset="0"/>
+                <a:ea typeface="Calibri" pitchFamily="34" charset="-122"/>
+                <a:cs typeface="Calibri" pitchFamily="34" charset="-120"/>
+              </a:rPr>
               <a:t>Southwire PowerGen  |  Anixter Global Accounts</a:t>
             </a:r>
             <a:endParaRPr lang="en-US" sz="1000" dirty="0"/>
@@ -7466,7 +7751,7 @@
       </p:sp>
       <p:sp>
         <p:nvSpPr>
-          <p:cNvPr id="29" name="Text 27"/>
+          <p:cNvPr id="32" name="Text 29"/>
           <p:cNvSpPr txBox="1"/>
           <p:nvPr/>
         </p:nvSpPr>
@@ -7568,7 +7853,7 @@
                 <a:ea typeface="Cambria" pitchFamily="34" charset="-122"/>
                 <a:cs typeface="Cambria" pitchFamily="34" charset="-120"/>
               </a:rPr>
-              <a:t>OEM market: who builds the plant</a:t>
+              <a:t>PowerGen product line card</a:t>
             </a:r>
             <a:endParaRPr lang="en-US" sz="2600" dirty="0"/>
           </a:p>
@@ -7583,7 +7868,7 @@
         <p:spPr>
           <a:xfrm>
             <a:off x="457200" y="1280160"/>
-            <a:ext cx="3840480" cy="2743200"/>
+            <a:ext cx="2606040" cy="1417320"/>
           </a:xfrm>
           <a:prstGeom prst="rect">
             <a:avLst/>
@@ -7608,69 +7893,117 @@
       </p:sp>
       <p:sp>
         <p:nvSpPr>
-          <p:cNvPr id="4" name="Text 2"/>
-          <p:cNvSpPr txBox="1"/>
-          <p:nvPr/>
-        </p:nvSpPr>
-        <p:spPr>
-          <a:xfrm>
-            <a:off x="640080" y="1371600"/>
-            <a:ext cx="3474720" cy="274320"/>
-          </a:xfrm>
-          <a:prstGeom prst="rect">
-            <a:avLst/>
-          </a:prstGeom>
-          <a:noFill/>
-          <a:ln/>
-        </p:spPr>
-        <p:txBody>
-          <a:bodyPr wrap="square" lIns="0" tIns="0" rIns="0" bIns="0" rtlCol="0" anchor="ctr"/>
-          <a:lstStyle/>
-          <a:p>
-            <a:pPr indent="0" marL="0">
-              <a:buNone/>
-            </a:pPr>
-            <a:r>
-              <a:rPr lang="en-US" sz="1400" b="1" dirty="0">
-                <a:solidFill>
-                  <a:srgbClr val="0F1B2D"/>
+          <p:cNvPr id="4" name="Shape 2"/>
+          <p:cNvSpPr/>
+          <p:nvPr/>
+        </p:nvSpPr>
+        <p:spPr>
+          <a:xfrm>
+            <a:off x="640080" y="1463040"/>
+            <a:ext cx="411480" cy="411480"/>
+          </a:xfrm>
+          <a:prstGeom prst="ellipse">
+            <a:avLst/>
+          </a:prstGeom>
+          <a:solidFill>
+            <a:srgbClr val="C8742B"/>
+          </a:solidFill>
+          <a:ln w="12700">
+            <a:solidFill>
+              <a:srgbClr val="C8742B"/>
+            </a:solidFill>
+            <a:prstDash val="solid"/>
+          </a:ln>
+        </p:spPr>
+      </p:sp>
+      <p:sp>
+        <p:nvSpPr>
+          <p:cNvPr id="5" name="Text 3"/>
+          <p:cNvSpPr txBox="1"/>
+          <p:nvPr/>
+        </p:nvSpPr>
+        <p:spPr>
+          <a:xfrm>
+            <a:off x="640080" y="1463040"/>
+            <a:ext cx="411480" cy="411480"/>
+          </a:xfrm>
+          <a:prstGeom prst="rect">
+            <a:avLst/>
+          </a:prstGeom>
+          <a:noFill/>
+          <a:ln/>
+        </p:spPr>
+        <p:txBody>
+          <a:bodyPr wrap="square" lIns="0" tIns="0" rIns="0" bIns="0" rtlCol="0" anchor="ctr"/>
+          <a:lstStyle/>
+          <a:p>
+            <a:pPr algn="ctr" indent="0" marL="0">
+              <a:buNone/>
+            </a:pPr>
+            <a:r>
+              <a:rPr lang="en-US" sz="1260" b="1" dirty="0">
+                <a:solidFill>
+                  <a:srgbClr val="FFFFFF"/>
                 </a:solidFill>
                 <a:latin typeface="Cambria" pitchFamily="34" charset="0"/>
                 <a:ea typeface="Cambria" pitchFamily="34" charset="-122"/>
                 <a:cs typeface="Cambria" pitchFamily="34" charset="-120"/>
               </a:rPr>
-              <a:t>Large gas turbine backlog (GW)</a:t>
-            </a:r>
-            <a:endParaRPr lang="en-US" sz="1400" dirty="0"/>
-          </a:p>
-        </p:txBody>
-      </p:sp>
-      <p:graphicFrame>
-        <p:nvGraphicFramePr>
-          <p:cNvPr id="5" name="Chart 0" descr=""/>
-          <p:cNvGraphicFramePr/>
-          <p:nvPr/>
-        </p:nvGraphicFramePr>
-        <p:xfrm>
-          <a:off x="548640" y="1691640"/>
-          <a:ext cx="3657600" cy="2240280"/>
-        </p:xfrm>
-        <a:graphic xmlns:a="http://schemas.openxmlformats.org/drawingml/2006/main">
-          <a:graphicData uri="http://schemas.openxmlformats.org/drawingml/2006/chart">
-            <c:chart xmlns:c="http://schemas.openxmlformats.org/drawingml/2006/chart" r:id="rId1"/>
-          </a:graphicData>
-        </a:graphic>
-      </p:graphicFrame>
-      <p:sp>
-        <p:nvSpPr>
-          <p:cNvPr id="6" name="Shape 3"/>
+              <a:t>1</a:t>
+            </a:r>
+            <a:endParaRPr lang="en-US" sz="1260" dirty="0"/>
+          </a:p>
+        </p:txBody>
+      </p:sp>
+      <p:sp>
+        <p:nvSpPr>
+          <p:cNvPr id="6" name="Text 4"/>
+          <p:cNvSpPr txBox="1"/>
+          <p:nvPr/>
+        </p:nvSpPr>
+        <p:spPr>
+          <a:xfrm>
+            <a:off x="640080" y="2011680"/>
+            <a:ext cx="2240280" cy="594360"/>
+          </a:xfrm>
+          <a:prstGeom prst="rect">
+            <a:avLst/>
+          </a:prstGeom>
+          <a:noFill/>
+          <a:ln/>
+        </p:spPr>
+        <p:txBody>
+          <a:bodyPr wrap="square" lIns="0" tIns="0" rIns="0" bIns="0" rtlCol="0" anchor="t"/>
+          <a:lstStyle/>
+          <a:p>
+            <a:pPr indent="0" marL="0">
+              <a:buNone/>
+            </a:pPr>
+            <a:r>
+              <a:rPr lang="en-US" sz="1500" b="1" dirty="0">
+                <a:solidFill>
+                  <a:srgbClr val="0F1B2D"/>
+                </a:solidFill>
+                <a:latin typeface="Cambria" pitchFamily="34" charset="0"/>
+                <a:ea typeface="Cambria" pitchFamily="34" charset="-122"/>
+                <a:cs typeface="Cambria" pitchFamily="34" charset="-120"/>
+              </a:rPr>
+              <a:t>Medium voltage power cable</a:t>
+            </a:r>
+            <a:endParaRPr lang="en-US" sz="1500" dirty="0"/>
+          </a:p>
+        </p:txBody>
+      </p:sp>
+      <p:sp>
+        <p:nvSpPr>
+          <p:cNvPr id="7" name="Shape 5"/>
           <p:cNvSpPr/>
           <p:nvPr/>
         </p:nvSpPr>
         <p:spPr>
           <a:xfrm>
-            <a:off x="4572000" y="1280160"/>
-            <a:ext cx="4114800" cy="822960"/>
+            <a:off x="3246120" y="1280160"/>
+            <a:ext cx="2606040" cy="1417320"/>
           </a:xfrm>
           <a:prstGeom prst="rect">
             <a:avLst/>
@@ -7695,87 +8028,117 @@
       </p:sp>
       <p:sp>
         <p:nvSpPr>
-          <p:cNvPr id="7" name="Text 4"/>
-          <p:cNvSpPr txBox="1"/>
-          <p:nvPr/>
-        </p:nvSpPr>
-        <p:spPr>
-          <a:xfrm>
-            <a:off x="4709160" y="1325880"/>
-            <a:ext cx="3840480" cy="731520"/>
-          </a:xfrm>
-          <a:prstGeom prst="rect">
-            <a:avLst/>
-          </a:prstGeom>
-          <a:noFill/>
-          <a:ln/>
-        </p:spPr>
-        <p:txBody>
-          <a:bodyPr wrap="square" lIns="0" tIns="0" rIns="0" bIns="0" rtlCol="0" anchor="ctr"/>
-          <a:lstStyle/>
-          <a:p>
-            <a:pPr indent="0" marL="0">
-              <a:buNone/>
-            </a:pPr>
-            <a:r>
-              <a:rPr lang="en-US" sz="1300" b="1" dirty="0">
-                <a:solidFill>
-                  <a:srgbClr val="0F1B2D"/>
+          <p:cNvPr id="8" name="Shape 6"/>
+          <p:cNvSpPr/>
+          <p:nvPr/>
+        </p:nvSpPr>
+        <p:spPr>
+          <a:xfrm>
+            <a:off x="3429000" y="1463040"/>
+            <a:ext cx="411480" cy="411480"/>
+          </a:xfrm>
+          <a:prstGeom prst="ellipse">
+            <a:avLst/>
+          </a:prstGeom>
+          <a:solidFill>
+            <a:srgbClr val="C8742B"/>
+          </a:solidFill>
+          <a:ln w="12700">
+            <a:solidFill>
+              <a:srgbClr val="C8742B"/>
+            </a:solidFill>
+            <a:prstDash val="solid"/>
+          </a:ln>
+        </p:spPr>
+      </p:sp>
+      <p:sp>
+        <p:nvSpPr>
+          <p:cNvPr id="9" name="Text 7"/>
+          <p:cNvSpPr txBox="1"/>
+          <p:nvPr/>
+        </p:nvSpPr>
+        <p:spPr>
+          <a:xfrm>
+            <a:off x="3429000" y="1463040"/>
+            <a:ext cx="411480" cy="411480"/>
+          </a:xfrm>
+          <a:prstGeom prst="rect">
+            <a:avLst/>
+          </a:prstGeom>
+          <a:noFill/>
+          <a:ln/>
+        </p:spPr>
+        <p:txBody>
+          <a:bodyPr wrap="square" lIns="0" tIns="0" rIns="0" bIns="0" rtlCol="0" anchor="ctr"/>
+          <a:lstStyle/>
+          <a:p>
+            <a:pPr algn="ctr" indent="0" marL="0">
+              <a:buNone/>
+            </a:pPr>
+            <a:r>
+              <a:rPr lang="en-US" sz="1260" b="1" dirty="0">
+                <a:solidFill>
+                  <a:srgbClr val="FFFFFF"/>
                 </a:solidFill>
                 <a:latin typeface="Cambria" pitchFamily="34" charset="0"/>
                 <a:ea typeface="Cambria" pitchFamily="34" charset="-122"/>
                 <a:cs typeface="Cambria" pitchFamily="34" charset="-120"/>
               </a:rPr>
-              <a:t>Turbine OEMs</a:t>
-            </a:r>
-            <a:endParaRPr lang="en-US" sz="1300" dirty="0"/>
-          </a:p>
+              <a:t>2</a:t>
+            </a:r>
+            <a:endParaRPr lang="en-US" sz="1260" dirty="0"/>
+          </a:p>
+        </p:txBody>
+      </p:sp>
+      <p:sp>
+        <p:nvSpPr>
+          <p:cNvPr id="10" name="Text 8"/>
+          <p:cNvSpPr txBox="1"/>
+          <p:nvPr/>
+        </p:nvSpPr>
+        <p:spPr>
+          <a:xfrm>
+            <a:off x="3429000" y="2011680"/>
+            <a:ext cx="2240280" cy="594360"/>
+          </a:xfrm>
+          <a:prstGeom prst="rect">
+            <a:avLst/>
+          </a:prstGeom>
+          <a:noFill/>
+          <a:ln/>
+        </p:spPr>
+        <p:txBody>
+          <a:bodyPr wrap="square" lIns="0" tIns="0" rIns="0" bIns="0" rtlCol="0" anchor="t"/>
+          <a:lstStyle/>
           <a:p>
             <a:pPr indent="0" marL="0">
               <a:buNone/>
             </a:pPr>
             <a:r>
-              <a:rPr lang="en-US" sz="1100" dirty="0">
-                <a:solidFill>
-                  <a:srgbClr val="5B6B7F"/>
-                </a:solidFill>
-                <a:latin typeface="Calibri" pitchFamily="34" charset="0"/>
-                <a:ea typeface="Calibri" pitchFamily="34" charset="-122"/>
-                <a:cs typeface="Calibri" pitchFamily="34" charset="-120"/>
-              </a:rPr>
-              <a:t>GE Vernova, Siemens Energy, Mitsubishi Heavy</a:t>
-            </a:r>
-            <a:endParaRPr lang="en-US" sz="1300" dirty="0"/>
-          </a:p>
-          <a:p>
-            <a:pPr indent="0" marL="0">
-              <a:buNone/>
-            </a:pPr>
-            <a:r>
-              <a:rPr lang="en-US" sz="1100" b="1" dirty="0">
-                <a:solidFill>
-                  <a:srgbClr val="C8742B"/>
-                </a:solidFill>
-                <a:latin typeface="Calibri" pitchFamily="34" charset="0"/>
-                <a:ea typeface="Calibri" pitchFamily="34" charset="-122"/>
-                <a:cs typeface="Calibri" pitchFamily="34" charset="-120"/>
-              </a:rPr>
-              <a:t>Southwire: MV, LV and control cable for OEM-built equipment</a:t>
-            </a:r>
-            <a:endParaRPr lang="en-US" sz="1300" dirty="0"/>
-          </a:p>
-        </p:txBody>
-      </p:sp>
-      <p:sp>
-        <p:nvSpPr>
-          <p:cNvPr id="8" name="Shape 5"/>
+              <a:rPr lang="en-US" sz="1500" b="1" dirty="0">
+                <a:solidFill>
+                  <a:srgbClr val="0F1B2D"/>
+                </a:solidFill>
+                <a:latin typeface="Cambria" pitchFamily="34" charset="0"/>
+                <a:ea typeface="Cambria" pitchFamily="34" charset="-122"/>
+                <a:cs typeface="Cambria" pitchFamily="34" charset="-120"/>
+              </a:rPr>
+              <a:t>Control and instrumentation cable</a:t>
+            </a:r>
+            <a:endParaRPr lang="en-US" sz="1500" dirty="0"/>
+          </a:p>
+        </p:txBody>
+      </p:sp>
+      <p:sp>
+        <p:nvSpPr>
+          <p:cNvPr id="11" name="Shape 9"/>
           <p:cNvSpPr/>
           <p:nvPr/>
         </p:nvSpPr>
         <p:spPr>
           <a:xfrm>
-            <a:off x="4572000" y="2240280"/>
-            <a:ext cx="4114800" cy="822960"/>
+            <a:off x="6035040" y="1280160"/>
+            <a:ext cx="2606040" cy="1417320"/>
           </a:xfrm>
           <a:prstGeom prst="rect">
             <a:avLst/>
@@ -7800,97 +8163,127 @@
       </p:sp>
       <p:sp>
         <p:nvSpPr>
-          <p:cNvPr id="9" name="Text 6"/>
-          <p:cNvSpPr txBox="1"/>
-          <p:nvPr/>
-        </p:nvSpPr>
-        <p:spPr>
-          <a:xfrm>
-            <a:off x="4709160" y="2286000"/>
-            <a:ext cx="3840480" cy="731520"/>
-          </a:xfrm>
-          <a:prstGeom prst="rect">
-            <a:avLst/>
-          </a:prstGeom>
-          <a:noFill/>
-          <a:ln/>
-        </p:spPr>
-        <p:txBody>
-          <a:bodyPr wrap="square" lIns="0" tIns="0" rIns="0" bIns="0" rtlCol="0" anchor="ctr"/>
-          <a:lstStyle/>
-          <a:p>
-            <a:pPr indent="0" marL="0">
-              <a:buNone/>
-            </a:pPr>
-            <a:r>
-              <a:rPr lang="en-US" sz="1300" b="1" dirty="0">
-                <a:solidFill>
-                  <a:srgbClr val="0F1B2D"/>
+          <p:cNvPr id="12" name="Shape 10"/>
+          <p:cNvSpPr/>
+          <p:nvPr/>
+        </p:nvSpPr>
+        <p:spPr>
+          <a:xfrm>
+            <a:off x="6217920" y="1463040"/>
+            <a:ext cx="411480" cy="411480"/>
+          </a:xfrm>
+          <a:prstGeom prst="ellipse">
+            <a:avLst/>
+          </a:prstGeom>
+          <a:solidFill>
+            <a:srgbClr val="C8742B"/>
+          </a:solidFill>
+          <a:ln w="12700">
+            <a:solidFill>
+              <a:srgbClr val="C8742B"/>
+            </a:solidFill>
+            <a:prstDash val="solid"/>
+          </a:ln>
+        </p:spPr>
+      </p:sp>
+      <p:sp>
+        <p:nvSpPr>
+          <p:cNvPr id="13" name="Text 11"/>
+          <p:cNvSpPr txBox="1"/>
+          <p:nvPr/>
+        </p:nvSpPr>
+        <p:spPr>
+          <a:xfrm>
+            <a:off x="6217920" y="1463040"/>
+            <a:ext cx="411480" cy="411480"/>
+          </a:xfrm>
+          <a:prstGeom prst="rect">
+            <a:avLst/>
+          </a:prstGeom>
+          <a:noFill/>
+          <a:ln/>
+        </p:spPr>
+        <p:txBody>
+          <a:bodyPr wrap="square" lIns="0" tIns="0" rIns="0" bIns="0" rtlCol="0" anchor="ctr"/>
+          <a:lstStyle/>
+          <a:p>
+            <a:pPr algn="ctr" indent="0" marL="0">
+              <a:buNone/>
+            </a:pPr>
+            <a:r>
+              <a:rPr lang="en-US" sz="1260" b="1" dirty="0">
+                <a:solidFill>
+                  <a:srgbClr val="FFFFFF"/>
                 </a:solidFill>
                 <a:latin typeface="Cambria" pitchFamily="34" charset="0"/>
                 <a:ea typeface="Cambria" pitchFamily="34" charset="-122"/>
                 <a:cs typeface="Cambria" pitchFamily="34" charset="-120"/>
               </a:rPr>
-              <a:t>Packagers and engine makers</a:t>
-            </a:r>
-            <a:endParaRPr lang="en-US" sz="1300" dirty="0"/>
-          </a:p>
+              <a:t>3</a:t>
+            </a:r>
+            <a:endParaRPr lang="en-US" sz="1260" dirty="0"/>
+          </a:p>
+        </p:txBody>
+      </p:sp>
+      <p:sp>
+        <p:nvSpPr>
+          <p:cNvPr id="14" name="Text 12"/>
+          <p:cNvSpPr txBox="1"/>
+          <p:nvPr/>
+        </p:nvSpPr>
+        <p:spPr>
+          <a:xfrm>
+            <a:off x="6217920" y="2011680"/>
+            <a:ext cx="2240280" cy="594360"/>
+          </a:xfrm>
+          <a:prstGeom prst="rect">
+            <a:avLst/>
+          </a:prstGeom>
+          <a:noFill/>
+          <a:ln/>
+        </p:spPr>
+        <p:txBody>
+          <a:bodyPr wrap="square" lIns="0" tIns="0" rIns="0" bIns="0" rtlCol="0" anchor="t"/>
+          <a:lstStyle/>
           <a:p>
             <a:pPr indent="0" marL="0">
               <a:buNone/>
             </a:pPr>
             <a:r>
-              <a:rPr lang="en-US" sz="1100" dirty="0">
-                <a:solidFill>
-                  <a:srgbClr val="5B6B7F"/>
-                </a:solidFill>
-                <a:latin typeface="Calibri" pitchFamily="34" charset="0"/>
-                <a:ea typeface="Calibri" pitchFamily="34" charset="-122"/>
-                <a:cs typeface="Calibri" pitchFamily="34" charset="-120"/>
-              </a:rPr>
-              <a:t>Solar Turbines (Caterpillar), Wartsila, energy-as-a-service developers</a:t>
-            </a:r>
-            <a:endParaRPr lang="en-US" sz="1300" dirty="0"/>
-          </a:p>
-          <a:p>
-            <a:pPr indent="0" marL="0">
-              <a:buNone/>
-            </a:pPr>
-            <a:r>
-              <a:rPr lang="en-US" sz="1100" b="1" dirty="0">
-                <a:solidFill>
-                  <a:srgbClr val="C8742B"/>
-                </a:solidFill>
-                <a:latin typeface="Calibri" pitchFamily="34" charset="0"/>
-                <a:ea typeface="Calibri" pitchFamily="34" charset="-122"/>
-                <a:cs typeface="Calibri" pitchFamily="34" charset="-120"/>
-              </a:rPr>
-              <a:t>Southwire: packaged and pre-terminated cable</a:t>
-            </a:r>
-            <a:endParaRPr lang="en-US" sz="1300" dirty="0"/>
-          </a:p>
-        </p:txBody>
-      </p:sp>
-      <p:sp>
-        <p:nvSpPr>
-          <p:cNvPr id="10" name="Shape 7"/>
+              <a:rPr lang="en-US" sz="1500" b="1" dirty="0">
+                <a:solidFill>
+                  <a:srgbClr val="0F1B2D"/>
+                </a:solidFill>
+                <a:latin typeface="Cambria" pitchFamily="34" charset="0"/>
+                <a:ea typeface="Cambria" pitchFamily="34" charset="-122"/>
+                <a:cs typeface="Cambria" pitchFamily="34" charset="-120"/>
+              </a:rPr>
+              <a:t>Low voltage power and auxiliary cable</a:t>
+            </a:r>
+            <a:endParaRPr lang="en-US" sz="1500" dirty="0"/>
+          </a:p>
+        </p:txBody>
+      </p:sp>
+      <p:sp>
+        <p:nvSpPr>
+          <p:cNvPr id="15" name="Shape 13"/>
           <p:cNvSpPr/>
           <p:nvPr/>
         </p:nvSpPr>
         <p:spPr>
           <a:xfrm>
-            <a:off x="4572000" y="3200400"/>
-            <a:ext cx="4114800" cy="822960"/>
+            <a:off x="457200" y="2880360"/>
+            <a:ext cx="2606040" cy="1417320"/>
           </a:xfrm>
           <a:prstGeom prst="rect">
             <a:avLst/>
           </a:prstGeom>
           <a:solidFill>
-            <a:srgbClr val="0F1B2D"/>
+            <a:srgbClr val="FFFFFF"/>
           </a:solidFill>
           <a:ln w="9525">
             <a:solidFill>
-              <a:srgbClr val="0F1B2D"/>
+              <a:srgbClr val="E3E8EE"/>
             </a:solidFill>
             <a:prstDash val="solid"/>
           </a:ln>
@@ -7905,30 +8298,55 @@
       </p:sp>
       <p:sp>
         <p:nvSpPr>
-          <p:cNvPr id="11" name="Text 8"/>
-          <p:cNvSpPr txBox="1"/>
-          <p:nvPr/>
-        </p:nvSpPr>
-        <p:spPr>
-          <a:xfrm>
-            <a:off x="4709160" y="3246120"/>
-            <a:ext cx="3840480" cy="731520"/>
-          </a:xfrm>
-          <a:prstGeom prst="rect">
-            <a:avLst/>
-          </a:prstGeom>
-          <a:noFill/>
-          <a:ln/>
-        </p:spPr>
-        <p:txBody>
-          <a:bodyPr wrap="square" lIns="0" tIns="0" rIns="0" bIns="0" rtlCol="0" anchor="ctr"/>
-          <a:lstStyle/>
-          <a:p>
-            <a:pPr indent="0" marL="0">
-              <a:buNone/>
-            </a:pPr>
-            <a:r>
-              <a:rPr lang="en-US" sz="1300" b="1" dirty="0">
+          <p:cNvPr id="16" name="Shape 14"/>
+          <p:cNvSpPr/>
+          <p:nvPr/>
+        </p:nvSpPr>
+        <p:spPr>
+          <a:xfrm>
+            <a:off x="640080" y="3063240"/>
+            <a:ext cx="411480" cy="411480"/>
+          </a:xfrm>
+          <a:prstGeom prst="ellipse">
+            <a:avLst/>
+          </a:prstGeom>
+          <a:solidFill>
+            <a:srgbClr val="C8742B"/>
+          </a:solidFill>
+          <a:ln w="12700">
+            <a:solidFill>
+              <a:srgbClr val="C8742B"/>
+            </a:solidFill>
+            <a:prstDash val="solid"/>
+          </a:ln>
+        </p:spPr>
+      </p:sp>
+      <p:sp>
+        <p:nvSpPr>
+          <p:cNvPr id="17" name="Text 15"/>
+          <p:cNvSpPr txBox="1"/>
+          <p:nvPr/>
+        </p:nvSpPr>
+        <p:spPr>
+          <a:xfrm>
+            <a:off x="640080" y="3063240"/>
+            <a:ext cx="411480" cy="411480"/>
+          </a:xfrm>
+          <a:prstGeom prst="rect">
+            <a:avLst/>
+          </a:prstGeom>
+          <a:noFill/>
+          <a:ln/>
+        </p:spPr>
+        <p:txBody>
+          <a:bodyPr wrap="square" lIns="0" tIns="0" rIns="0" bIns="0" rtlCol="0" anchor="ctr"/>
+          <a:lstStyle/>
+          <a:p>
+            <a:pPr algn="ctr" indent="0" marL="0">
+              <a:buNone/>
+            </a:pPr>
+            <a:r>
+              <a:rPr lang="en-US" sz="1260" b="1" dirty="0">
                 <a:solidFill>
                   <a:srgbClr val="FFFFFF"/>
                 </a:solidFill>
@@ -7936,157 +8354,393 @@
                 <a:ea typeface="Cambria" pitchFamily="34" charset="-122"/>
                 <a:cs typeface="Cambria" pitchFamily="34" charset="-120"/>
               </a:rPr>
-              <a:t>Data center on-site power</a:t>
-            </a:r>
-            <a:endParaRPr lang="en-US" sz="1300" dirty="0"/>
-          </a:p>
+              <a:t>4</a:t>
+            </a:r>
+            <a:endParaRPr lang="en-US" sz="1260" dirty="0"/>
+          </a:p>
+        </p:txBody>
+      </p:sp>
+      <p:sp>
+        <p:nvSpPr>
+          <p:cNvPr id="18" name="Text 16"/>
+          <p:cNvSpPr txBox="1"/>
+          <p:nvPr/>
+        </p:nvSpPr>
+        <p:spPr>
+          <a:xfrm>
+            <a:off x="640080" y="3611880"/>
+            <a:ext cx="2240280" cy="594360"/>
+          </a:xfrm>
+          <a:prstGeom prst="rect">
+            <a:avLst/>
+          </a:prstGeom>
+          <a:noFill/>
+          <a:ln/>
+        </p:spPr>
+        <p:txBody>
+          <a:bodyPr wrap="square" lIns="0" tIns="0" rIns="0" bIns="0" rtlCol="0" anchor="t"/>
+          <a:lstStyle/>
           <a:p>
             <a:pPr indent="0" marL="0">
               <a:buNone/>
             </a:pPr>
             <a:r>
-              <a:rPr lang="en-US" sz="1100" dirty="0">
-                <a:solidFill>
-                  <a:srgbClr val="CADCFC"/>
+              <a:rPr lang="en-US" sz="1500" b="1" dirty="0">
+                <a:solidFill>
+                  <a:srgbClr val="0F1B2D"/>
+                </a:solidFill>
+                <a:latin typeface="Cambria" pitchFamily="34" charset="0"/>
+                <a:ea typeface="Cambria" pitchFamily="34" charset="-122"/>
+                <a:cs typeface="Cambria" pitchFamily="34" charset="-120"/>
+              </a:rPr>
+              <a:t>Grounding and bare conductor</a:t>
+            </a:r>
+            <a:endParaRPr lang="en-US" sz="1500" dirty="0"/>
+          </a:p>
+        </p:txBody>
+      </p:sp>
+      <p:sp>
+        <p:nvSpPr>
+          <p:cNvPr id="19" name="Shape 17"/>
+          <p:cNvSpPr/>
+          <p:nvPr/>
+        </p:nvSpPr>
+        <p:spPr>
+          <a:xfrm>
+            <a:off x="3246120" y="2880360"/>
+            <a:ext cx="2606040" cy="1417320"/>
+          </a:xfrm>
+          <a:prstGeom prst="rect">
+            <a:avLst/>
+          </a:prstGeom>
+          <a:solidFill>
+            <a:srgbClr val="FFFFFF"/>
+          </a:solidFill>
+          <a:ln w="9525">
+            <a:solidFill>
+              <a:srgbClr val="E3E8EE"/>
+            </a:solidFill>
+            <a:prstDash val="solid"/>
+          </a:ln>
+          <a:effectLst>
+            <a:outerShdw sx="100000" sy="100000" kx="0" ky="0" algn="bl" rotWithShape="0" blurRad="76200" dist="25400" dir="5400000">
+              <a:srgbClr val="000000">
+                <a:alpha val="12000"/>
+              </a:srgbClr>
+            </a:outerShdw>
+          </a:effectLst>
+        </p:spPr>
+      </p:sp>
+      <p:sp>
+        <p:nvSpPr>
+          <p:cNvPr id="20" name="Shape 18"/>
+          <p:cNvSpPr/>
+          <p:nvPr/>
+        </p:nvSpPr>
+        <p:spPr>
+          <a:xfrm>
+            <a:off x="3429000" y="3063240"/>
+            <a:ext cx="411480" cy="411480"/>
+          </a:xfrm>
+          <a:prstGeom prst="ellipse">
+            <a:avLst/>
+          </a:prstGeom>
+          <a:solidFill>
+            <a:srgbClr val="C8742B"/>
+          </a:solidFill>
+          <a:ln w="12700">
+            <a:solidFill>
+              <a:srgbClr val="C8742B"/>
+            </a:solidFill>
+            <a:prstDash val="solid"/>
+          </a:ln>
+        </p:spPr>
+      </p:sp>
+      <p:sp>
+        <p:nvSpPr>
+          <p:cNvPr id="21" name="Text 19"/>
+          <p:cNvSpPr txBox="1"/>
+          <p:nvPr/>
+        </p:nvSpPr>
+        <p:spPr>
+          <a:xfrm>
+            <a:off x="3429000" y="3063240"/>
+            <a:ext cx="411480" cy="411480"/>
+          </a:xfrm>
+          <a:prstGeom prst="rect">
+            <a:avLst/>
+          </a:prstGeom>
+          <a:noFill/>
+          <a:ln/>
+        </p:spPr>
+        <p:txBody>
+          <a:bodyPr wrap="square" lIns="0" tIns="0" rIns="0" bIns="0" rtlCol="0" anchor="ctr"/>
+          <a:lstStyle/>
+          <a:p>
+            <a:pPr algn="ctr" indent="0" marL="0">
+              <a:buNone/>
+            </a:pPr>
+            <a:r>
+              <a:rPr lang="en-US" sz="1260" b="1" dirty="0">
+                <a:solidFill>
+                  <a:srgbClr val="FFFFFF"/>
+                </a:solidFill>
+                <a:latin typeface="Cambria" pitchFamily="34" charset="0"/>
+                <a:ea typeface="Cambria" pitchFamily="34" charset="-122"/>
+                <a:cs typeface="Cambria" pitchFamily="34" charset="-120"/>
+              </a:rPr>
+              <a:t>5</a:t>
+            </a:r>
+            <a:endParaRPr lang="en-US" sz="1260" dirty="0"/>
+          </a:p>
+        </p:txBody>
+      </p:sp>
+      <p:sp>
+        <p:nvSpPr>
+          <p:cNvPr id="22" name="Text 20"/>
+          <p:cNvSpPr txBox="1"/>
+          <p:nvPr/>
+        </p:nvSpPr>
+        <p:spPr>
+          <a:xfrm>
+            <a:off x="3429000" y="3611880"/>
+            <a:ext cx="2240280" cy="594360"/>
+          </a:xfrm>
+          <a:prstGeom prst="rect">
+            <a:avLst/>
+          </a:prstGeom>
+          <a:noFill/>
+          <a:ln/>
+        </p:spPr>
+        <p:txBody>
+          <a:bodyPr wrap="square" lIns="0" tIns="0" rIns="0" bIns="0" rtlCol="0" anchor="t"/>
+          <a:lstStyle/>
+          <a:p>
+            <a:pPr indent="0" marL="0">
+              <a:buNone/>
+            </a:pPr>
+            <a:r>
+              <a:rPr lang="en-US" sz="1500" b="1" dirty="0">
+                <a:solidFill>
+                  <a:srgbClr val="0F1B2D"/>
+                </a:solidFill>
+                <a:latin typeface="Cambria" pitchFamily="34" charset="0"/>
+                <a:ea typeface="Cambria" pitchFamily="34" charset="-122"/>
+                <a:cs typeface="Cambria" pitchFamily="34" charset="-120"/>
+              </a:rPr>
+              <a:t>Hazardous-area and specialty cable</a:t>
+            </a:r>
+            <a:endParaRPr lang="en-US" sz="1500" dirty="0"/>
+          </a:p>
+        </p:txBody>
+      </p:sp>
+      <p:sp>
+        <p:nvSpPr>
+          <p:cNvPr id="23" name="Shape 21"/>
+          <p:cNvSpPr/>
+          <p:nvPr/>
+        </p:nvSpPr>
+        <p:spPr>
+          <a:xfrm>
+            <a:off x="6035040" y="2880360"/>
+            <a:ext cx="2606040" cy="1417320"/>
+          </a:xfrm>
+          <a:prstGeom prst="rect">
+            <a:avLst/>
+          </a:prstGeom>
+          <a:solidFill>
+            <a:srgbClr val="FFFFFF"/>
+          </a:solidFill>
+          <a:ln w="9525">
+            <a:solidFill>
+              <a:srgbClr val="E3E8EE"/>
+            </a:solidFill>
+            <a:prstDash val="solid"/>
+          </a:ln>
+          <a:effectLst>
+            <a:outerShdw sx="100000" sy="100000" kx="0" ky="0" algn="bl" rotWithShape="0" blurRad="76200" dist="25400" dir="5400000">
+              <a:srgbClr val="000000">
+                <a:alpha val="12000"/>
+              </a:srgbClr>
+            </a:outerShdw>
+          </a:effectLst>
+        </p:spPr>
+      </p:sp>
+      <p:sp>
+        <p:nvSpPr>
+          <p:cNvPr id="24" name="Shape 22"/>
+          <p:cNvSpPr/>
+          <p:nvPr/>
+        </p:nvSpPr>
+        <p:spPr>
+          <a:xfrm>
+            <a:off x="6217920" y="3063240"/>
+            <a:ext cx="411480" cy="411480"/>
+          </a:xfrm>
+          <a:prstGeom prst="ellipse">
+            <a:avLst/>
+          </a:prstGeom>
+          <a:solidFill>
+            <a:srgbClr val="C8742B"/>
+          </a:solidFill>
+          <a:ln w="12700">
+            <a:solidFill>
+              <a:srgbClr val="C8742B"/>
+            </a:solidFill>
+            <a:prstDash val="solid"/>
+          </a:ln>
+        </p:spPr>
+      </p:sp>
+      <p:sp>
+        <p:nvSpPr>
+          <p:cNvPr id="25" name="Text 23"/>
+          <p:cNvSpPr txBox="1"/>
+          <p:nvPr/>
+        </p:nvSpPr>
+        <p:spPr>
+          <a:xfrm>
+            <a:off x="6217920" y="3063240"/>
+            <a:ext cx="411480" cy="411480"/>
+          </a:xfrm>
+          <a:prstGeom prst="rect">
+            <a:avLst/>
+          </a:prstGeom>
+          <a:noFill/>
+          <a:ln/>
+        </p:spPr>
+        <p:txBody>
+          <a:bodyPr wrap="square" lIns="0" tIns="0" rIns="0" bIns="0" rtlCol="0" anchor="ctr"/>
+          <a:lstStyle/>
+          <a:p>
+            <a:pPr algn="ctr" indent="0" marL="0">
+              <a:buNone/>
+            </a:pPr>
+            <a:r>
+              <a:rPr lang="en-US" sz="1260" b="1" dirty="0">
+                <a:solidFill>
+                  <a:srgbClr val="FFFFFF"/>
+                </a:solidFill>
+                <a:latin typeface="Cambria" pitchFamily="34" charset="0"/>
+                <a:ea typeface="Cambria" pitchFamily="34" charset="-122"/>
+                <a:cs typeface="Cambria" pitchFamily="34" charset="-120"/>
+              </a:rPr>
+              <a:t>6</a:t>
+            </a:r>
+            <a:endParaRPr lang="en-US" sz="1260" dirty="0"/>
+          </a:p>
+        </p:txBody>
+      </p:sp>
+      <p:sp>
+        <p:nvSpPr>
+          <p:cNvPr id="26" name="Text 24"/>
+          <p:cNvSpPr txBox="1"/>
+          <p:nvPr/>
+        </p:nvSpPr>
+        <p:spPr>
+          <a:xfrm>
+            <a:off x="6217920" y="3611880"/>
+            <a:ext cx="2240280" cy="594360"/>
+          </a:xfrm>
+          <a:prstGeom prst="rect">
+            <a:avLst/>
+          </a:prstGeom>
+          <a:noFill/>
+          <a:ln/>
+        </p:spPr>
+        <p:txBody>
+          <a:bodyPr wrap="square" lIns="0" tIns="0" rIns="0" bIns="0" rtlCol="0" anchor="t"/>
+          <a:lstStyle/>
+          <a:p>
+            <a:pPr indent="0" marL="0">
+              <a:buNone/>
+            </a:pPr>
+            <a:r>
+              <a:rPr lang="en-US" sz="1500" b="1" dirty="0">
+                <a:solidFill>
+                  <a:srgbClr val="0F1B2D"/>
+                </a:solidFill>
+                <a:latin typeface="Cambria" pitchFamily="34" charset="0"/>
+                <a:ea typeface="Cambria" pitchFamily="34" charset="-122"/>
+                <a:cs typeface="Cambria" pitchFamily="34" charset="-120"/>
+              </a:rPr>
+              <a:t>Building wire and MC cable</a:t>
+            </a:r>
+            <a:endParaRPr lang="en-US" sz="1500" dirty="0"/>
+          </a:p>
+        </p:txBody>
+      </p:sp>
+      <p:sp>
+        <p:nvSpPr>
+          <p:cNvPr id="27" name="Text 25"/>
+          <p:cNvSpPr txBox="1"/>
+          <p:nvPr/>
+        </p:nvSpPr>
+        <p:spPr>
+          <a:xfrm>
+            <a:off x="457200" y="4434840"/>
+            <a:ext cx="8229600" cy="228600"/>
+          </a:xfrm>
+          <a:prstGeom prst="rect">
+            <a:avLst/>
+          </a:prstGeom>
+          <a:noFill/>
+          <a:ln/>
+        </p:spPr>
+        <p:txBody>
+          <a:bodyPr wrap="square" lIns="0" tIns="0" rIns="0" bIns="0" rtlCol="0" anchor="ctr"/>
+          <a:lstStyle/>
+          <a:p>
+            <a:pPr indent="0" marL="0">
+              <a:buNone/>
+            </a:pPr>
+            <a:r>
+              <a:rPr lang="en-US" sz="1100" i="1" dirty="0">
+                <a:solidFill>
+                  <a:srgbClr val="5B6B7F"/>
                 </a:solidFill>
                 <a:latin typeface="Calibri" pitchFamily="34" charset="0"/>
                 <a:ea typeface="Calibri" pitchFamily="34" charset="-122"/>
                 <a:cs typeface="Calibri" pitchFamily="34" charset="-120"/>
               </a:rPr>
-              <a:t>~56 GW planned behind-the-meter, 46 projects</a:t>
-            </a:r>
-            <a:endParaRPr lang="en-US" sz="1300" dirty="0"/>
-          </a:p>
+              <a:t>Full detail: Southwire combined-cycle wire &amp; cable application guide.</a:t>
+            </a:r>
+            <a:endParaRPr lang="en-US" sz="1100" dirty="0"/>
+          </a:p>
+        </p:txBody>
+      </p:sp>
+      <p:sp>
+        <p:nvSpPr>
+          <p:cNvPr id="28" name="Text 26"/>
+          <p:cNvSpPr txBox="1"/>
+          <p:nvPr/>
+        </p:nvSpPr>
+        <p:spPr>
+          <a:xfrm>
+            <a:off x="457200" y="4754880"/>
+            <a:ext cx="5486400" cy="228600"/>
+          </a:xfrm>
+          <a:prstGeom prst="rect">
+            <a:avLst/>
+          </a:prstGeom>
+          <a:noFill/>
+          <a:ln/>
+        </p:spPr>
+        <p:txBody>
+          <a:bodyPr wrap="square" lIns="0" tIns="0" rIns="0" bIns="0" rtlCol="0" anchor="ctr"/>
+          <a:lstStyle/>
           <a:p>
             <a:pPr indent="0" marL="0">
               <a:buNone/>
             </a:pPr>
             <a:r>
-              <a:rPr lang="en-US" sz="1100" b="1" dirty="0">
-                <a:solidFill>
-                  <a:srgbClr val="C8742B"/>
+              <a:rPr lang="en-US" sz="1000" dirty="0">
+                <a:solidFill>
+                  <a:srgbClr val="5B6B7F"/>
                 </a:solidFill>
                 <a:latin typeface="Calibri" pitchFamily="34" charset="0"/>
                 <a:ea typeface="Calibri" pitchFamily="34" charset="-122"/>
                 <a:cs typeface="Calibri" pitchFamily="34" charset="-120"/>
               </a:rPr>
-              <a:t>Southwire: full plant cable package</a:t>
-            </a:r>
-            <a:endParaRPr lang="en-US" sz="1300" dirty="0"/>
-          </a:p>
-        </p:txBody>
-      </p:sp>
-      <p:sp>
-        <p:nvSpPr>
-          <p:cNvPr id="12" name="Text 9"/>
-          <p:cNvSpPr txBox="1"/>
-          <p:nvPr/>
-        </p:nvSpPr>
-        <p:spPr>
-          <a:xfrm>
-            <a:off x="457200" y="4114800"/>
-            <a:ext cx="8229600" cy="274320"/>
-          </a:xfrm>
-          <a:prstGeom prst="rect">
-            <a:avLst/>
-          </a:prstGeom>
-          <a:noFill/>
-          <a:ln/>
-        </p:spPr>
-        <p:txBody>
-          <a:bodyPr wrap="square" lIns="0" tIns="0" rIns="0" bIns="0" rtlCol="0" anchor="ctr"/>
-          <a:lstStyle/>
-          <a:p>
-            <a:pPr indent="0" marL="0">
-              <a:buNone/>
-            </a:pPr>
-            <a:r>
-              <a:rPr lang="en-US" sz="1300" i="1" dirty="0">
-                <a:solidFill>
-                  <a:srgbClr val="5B6B7F"/>
-                </a:solidFill>
-                <a:latin typeface="Calibri" pitchFamily="34" charset="0"/>
-                <a:ea typeface="Calibri" pitchFamily="34" charset="-122"/>
-                <a:cs typeface="Calibri" pitchFamily="34" charset="-120"/>
-              </a:rPr>
-              <a:t>Where AXE adds value: logistics, inventory and project coordination for OEMs and packagers (to discuss).</a:t>
-            </a:r>
-            <a:endParaRPr lang="en-US" sz="1300" dirty="0"/>
-          </a:p>
-        </p:txBody>
-      </p:sp>
-      <p:sp>
-        <p:nvSpPr>
-          <p:cNvPr id="13" name="Text 10"/>
-          <p:cNvSpPr txBox="1"/>
-          <p:nvPr/>
-        </p:nvSpPr>
-        <p:spPr>
-          <a:xfrm>
-            <a:off x="457200" y="4462272"/>
-            <a:ext cx="8229600" cy="201168"/>
-          </a:xfrm>
-          <a:prstGeom prst="rect">
-            <a:avLst/>
-          </a:prstGeom>
-          <a:noFill/>
-          <a:ln/>
-        </p:spPr>
-        <p:txBody>
-          <a:bodyPr wrap="square" lIns="0" tIns="0" rIns="0" bIns="0" rtlCol="0" anchor="ctr"/>
-          <a:lstStyle/>
-          <a:p>
-            <a:pPr indent="0" marL="0">
-              <a:buNone/>
-            </a:pPr>
-            <a:r>
-              <a:rPr lang="en-US" sz="900" dirty="0">
-                <a:solidFill>
-                  <a:srgbClr val="5B6B7F"/>
-                </a:solidFill>
-                <a:latin typeface="Calibri" pitchFamily="34" charset="0"/>
-                <a:ea typeface="Calibri" pitchFamily="34" charset="-122"/>
-                <a:cs typeface="Calibri" pitchFamily="34" charset="-120"/>
-              </a:rPr>
-              <a:t>Sources: OEM Q2 2026 reports (GE Vernova, Siemens Energy, Mitsubishi Heavy); Cleanview BTM tracker; press reports.</a:t>
-            </a:r>
-            <a:endParaRPr lang="en-US" sz="900" dirty="0"/>
-          </a:p>
-        </p:txBody>
-      </p:sp>
-      <p:sp>
-        <p:nvSpPr>
-          <p:cNvPr id="14" name="Text 11"/>
-          <p:cNvSpPr txBox="1"/>
-          <p:nvPr/>
-        </p:nvSpPr>
-        <p:spPr>
-          <a:xfrm>
-            <a:off x="457200" y="4754880"/>
-            <a:ext cx="5486400" cy="228600"/>
-          </a:xfrm>
-          <a:prstGeom prst="rect">
-            <a:avLst/>
-          </a:prstGeom>
-          <a:noFill/>
-          <a:ln/>
-        </p:spPr>
-        <p:txBody>
-          <a:bodyPr wrap="square" lIns="0" tIns="0" rIns="0" bIns="0" rtlCol="0" anchor="ctr"/>
-          <a:lstStyle/>
-          <a:p>
-            <a:pPr indent="0" marL="0">
-              <a:buNone/>
-            </a:pPr>
-            <a:r>
-              <a:rPr lang="en-US" sz="1000" dirty="0">
-                <a:solidFill>
-                  <a:srgbClr val="5B6B7F"/>
-                </a:solidFill>
-                <a:latin typeface="Calibri" pitchFamily="34" charset="0"/>
-                <a:ea typeface="Calibri" pitchFamily="34" charset="-122"/>
-                <a:cs typeface="Calibri" pitchFamily="34" charset="-120"/>
-              </a:rPr>
               <a:t>Southwire PowerGen  |  Anixter Global Accounts</a:t>
             </a:r>
             <a:endParaRPr lang="en-US" sz="1000" dirty="0"/>
@@ -8095,7 +8749,7 @@
       </p:sp>
       <p:sp>
         <p:nvSpPr>
-          <p:cNvPr id="15" name="Text 12"/>
+          <p:cNvPr id="29" name="Text 27"/>
           <p:cNvSpPr txBox="1"/>
           <p:nvPr/>
         </p:nvSpPr>
@@ -8146,7 +8800,7 @@
     <p:bg>
       <p:bgPr>
         <a:solidFill>
-          <a:srgbClr val="0F1B2D"/>
+          <a:srgbClr val="F4F6F8"/>
         </a:solidFill>
       </p:bgPr>
     </p:bg>
@@ -8191,13 +8845,13 @@
             <a:r>
               <a:rPr lang="en-US" sz="2600" b="1" dirty="0">
                 <a:solidFill>
-                  <a:srgbClr val="FFFFFF"/>
+                  <a:srgbClr val="0F1B2D"/>
                 </a:solidFill>
                 <a:latin typeface="Cambria" pitchFamily="34" charset="0"/>
                 <a:ea typeface="Cambria" pitchFamily="34" charset="-122"/>
                 <a:cs typeface="Cambria" pitchFamily="34" charset="-120"/>
               </a:rPr>
-              <a:t>Key takeaways and partnership opportunities</a:t>
+              <a:t>OEM market: who builds the plant</a:t>
             </a:r>
             <a:endParaRPr lang="en-US" sz="2600" dirty="0"/>
           </a:p>
@@ -8211,21 +8865,28 @@
         </p:nvSpPr>
         <p:spPr>
           <a:xfrm>
-            <a:off x="457200" y="1234440"/>
-            <a:ext cx="457200" cy="457200"/>
-          </a:xfrm>
-          <a:prstGeom prst="ellipse">
+            <a:off x="457200" y="1280160"/>
+            <a:ext cx="3840480" cy="2743200"/>
+          </a:xfrm>
+          <a:prstGeom prst="rect">
             <a:avLst/>
           </a:prstGeom>
           <a:solidFill>
-            <a:srgbClr val="C8742B"/>
+            <a:srgbClr val="FFFFFF"/>
           </a:solidFill>
-          <a:ln w="12700">
+          <a:ln w="9525">
             <a:solidFill>
-              <a:srgbClr val="C8742B"/>
+              <a:srgbClr val="E3E8EE"/>
             </a:solidFill>
             <a:prstDash val="solid"/>
           </a:ln>
+          <a:effectLst>
+            <a:outerShdw sx="100000" sy="100000" kx="0" ky="0" algn="bl" rotWithShape="0" blurRad="76200" dist="25400" dir="5400000">
+              <a:srgbClr val="000000">
+                <a:alpha val="12000"/>
+              </a:srgbClr>
+            </a:outerShdw>
+          </a:effectLst>
         </p:spPr>
       </p:sp>
       <p:sp>
@@ -8236,47 +8897,95 @@
         </p:nvSpPr>
         <p:spPr>
           <a:xfrm>
-            <a:off x="457200" y="1234440"/>
-            <a:ext cx="457200" cy="457200"/>
-          </a:xfrm>
-          <a:prstGeom prst="rect">
-            <a:avLst/>
-          </a:prstGeom>
-          <a:noFill/>
-          <a:ln/>
-        </p:spPr>
-        <p:txBody>
-          <a:bodyPr wrap="square" lIns="0" tIns="0" rIns="0" bIns="0" rtlCol="0" anchor="ctr"/>
-          <a:lstStyle/>
-          <a:p>
-            <a:pPr algn="ctr" indent="0" marL="0">
+            <a:off x="640080" y="1371600"/>
+            <a:ext cx="3474720" cy="274320"/>
+          </a:xfrm>
+          <a:prstGeom prst="rect">
+            <a:avLst/>
+          </a:prstGeom>
+          <a:noFill/>
+          <a:ln/>
+        </p:spPr>
+        <p:txBody>
+          <a:bodyPr wrap="square" lIns="0" tIns="0" rIns="0" bIns="0" rtlCol="0" anchor="ctr"/>
+          <a:lstStyle/>
+          <a:p>
+            <a:pPr indent="0" marL="0">
               <a:buNone/>
             </a:pPr>
             <a:r>
               <a:rPr lang="en-US" sz="1400" b="1" dirty="0">
                 <a:solidFill>
-                  <a:srgbClr val="FFFFFF"/>
+                  <a:srgbClr val="0F1B2D"/>
                 </a:solidFill>
                 <a:latin typeface="Cambria" pitchFamily="34" charset="0"/>
                 <a:ea typeface="Cambria" pitchFamily="34" charset="-122"/>
                 <a:cs typeface="Cambria" pitchFamily="34" charset="-120"/>
               </a:rPr>
-              <a:t>1</a:t>
+              <a:t>Large gas turbine backlog (GW)</a:t>
             </a:r>
             <a:endParaRPr lang="en-US" sz="1400" dirty="0"/>
           </a:p>
         </p:txBody>
       </p:sp>
-      <p:sp>
-        <p:nvSpPr>
-          <p:cNvPr id="5" name="Text 3"/>
-          <p:cNvSpPr txBox="1"/>
-          <p:nvPr/>
-        </p:nvSpPr>
-        <p:spPr>
-          <a:xfrm>
-            <a:off x="1097280" y="1234440"/>
-            <a:ext cx="7589520" cy="457200"/>
+      <p:graphicFrame>
+        <p:nvGraphicFramePr>
+          <p:cNvPr id="5" name="Chart 0" descr=""/>
+          <p:cNvGraphicFramePr/>
+          <p:nvPr/>
+        </p:nvGraphicFramePr>
+        <p:xfrm>
+          <a:off x="548640" y="1691640"/>
+          <a:ext cx="3657600" cy="2240280"/>
+        </p:xfrm>
+        <a:graphic xmlns:a="http://schemas.openxmlformats.org/drawingml/2006/main">
+          <a:graphicData uri="http://schemas.openxmlformats.org/drawingml/2006/chart">
+            <c:chart xmlns:c="http://schemas.openxmlformats.org/drawingml/2006/chart" r:id="rId1"/>
+          </a:graphicData>
+        </a:graphic>
+      </p:graphicFrame>
+      <p:sp>
+        <p:nvSpPr>
+          <p:cNvPr id="6" name="Shape 3"/>
+          <p:cNvSpPr/>
+          <p:nvPr/>
+        </p:nvSpPr>
+        <p:spPr>
+          <a:xfrm>
+            <a:off x="4572000" y="1280160"/>
+            <a:ext cx="4114800" cy="822960"/>
+          </a:xfrm>
+          <a:prstGeom prst="rect">
+            <a:avLst/>
+          </a:prstGeom>
+          <a:solidFill>
+            <a:srgbClr val="FFFFFF"/>
+          </a:solidFill>
+          <a:ln w="9525">
+            <a:solidFill>
+              <a:srgbClr val="E3E8EE"/>
+            </a:solidFill>
+            <a:prstDash val="solid"/>
+          </a:ln>
+          <a:effectLst>
+            <a:outerShdw sx="100000" sy="100000" kx="0" ky="0" algn="bl" rotWithShape="0" blurRad="76200" dist="25400" dir="5400000">
+              <a:srgbClr val="000000">
+                <a:alpha val="12000"/>
+              </a:srgbClr>
+            </a:outerShdw>
+          </a:effectLst>
+        </p:spPr>
+      </p:sp>
+      <p:sp>
+        <p:nvSpPr>
+          <p:cNvPr id="7" name="Text 4"/>
+          <p:cNvSpPr txBox="1"/>
+          <p:nvPr/>
+        </p:nvSpPr>
+        <p:spPr>
+          <a:xfrm>
+            <a:off x="4709160" y="1325880"/>
+            <a:ext cx="3840480" cy="731520"/>
           </a:xfrm>
           <a:prstGeom prst="rect">
             <a:avLst/>
@@ -8292,174 +9001,217 @@
               <a:buNone/>
             </a:pPr>
             <a:r>
-              <a:rPr lang="en-US" sz="1700" dirty="0">
-                <a:solidFill>
-                  <a:srgbClr val="FFFFFF"/>
+              <a:rPr lang="en-US" sz="1300" b="1" dirty="0">
+                <a:solidFill>
+                  <a:srgbClr val="0F1B2D"/>
+                </a:solidFill>
+                <a:latin typeface="Cambria" pitchFamily="34" charset="0"/>
+                <a:ea typeface="Cambria" pitchFamily="34" charset="-122"/>
+                <a:cs typeface="Cambria" pitchFamily="34" charset="-120"/>
+              </a:rPr>
+              <a:t>Turbine OEMs</a:t>
+            </a:r>
+            <a:endParaRPr lang="en-US" sz="1300" dirty="0"/>
+          </a:p>
+          <a:p>
+            <a:pPr indent="0" marL="0">
+              <a:buNone/>
+            </a:pPr>
+            <a:r>
+              <a:rPr lang="en-US" sz="1100" dirty="0">
+                <a:solidFill>
+                  <a:srgbClr val="5B6B7F"/>
                 </a:solidFill>
                 <a:latin typeface="Calibri" pitchFamily="34" charset="0"/>
                 <a:ea typeface="Calibri" pitchFamily="34" charset="-122"/>
                 <a:cs typeface="Calibri" pitchFamily="34" charset="-120"/>
               </a:rPr>
-              <a:t>Demand growth is long-lived and gas-heavy</a:t>
-            </a:r>
-            <a:endParaRPr lang="en-US" sz="1700" dirty="0"/>
-          </a:p>
-        </p:txBody>
-      </p:sp>
-      <p:sp>
-        <p:nvSpPr>
-          <p:cNvPr id="6" name="Shape 4"/>
+              <a:t>GE Vernova, Siemens Energy, Mitsubishi Heavy</a:t>
+            </a:r>
+            <a:endParaRPr lang="en-US" sz="1300" dirty="0"/>
+          </a:p>
+          <a:p>
+            <a:pPr indent="0" marL="0">
+              <a:buNone/>
+            </a:pPr>
+            <a:r>
+              <a:rPr lang="en-US" sz="1100" b="1" dirty="0">
+                <a:solidFill>
+                  <a:srgbClr val="C8742B"/>
+                </a:solidFill>
+                <a:latin typeface="Calibri" pitchFamily="34" charset="0"/>
+                <a:ea typeface="Calibri" pitchFamily="34" charset="-122"/>
+                <a:cs typeface="Calibri" pitchFamily="34" charset="-120"/>
+              </a:rPr>
+              <a:t>Southwire: MV, LV and control cable for OEM-built equipment</a:t>
+            </a:r>
+            <a:endParaRPr lang="en-US" sz="1300" dirty="0"/>
+          </a:p>
+        </p:txBody>
+      </p:sp>
+      <p:sp>
+        <p:nvSpPr>
+          <p:cNvPr id="8" name="Shape 5"/>
           <p:cNvSpPr/>
           <p:nvPr/>
         </p:nvSpPr>
         <p:spPr>
           <a:xfrm>
-            <a:off x="457200" y="1920240"/>
-            <a:ext cx="457200" cy="457200"/>
-          </a:xfrm>
-          <a:prstGeom prst="ellipse">
+            <a:off x="4572000" y="2240280"/>
+            <a:ext cx="4114800" cy="822960"/>
+          </a:xfrm>
+          <a:prstGeom prst="rect">
             <a:avLst/>
           </a:prstGeom>
           <a:solidFill>
-            <a:srgbClr val="C8742B"/>
+            <a:srgbClr val="FFFFFF"/>
           </a:solidFill>
-          <a:ln w="12700">
+          <a:ln w="9525">
             <a:solidFill>
-              <a:srgbClr val="C8742B"/>
+              <a:srgbClr val="E3E8EE"/>
             </a:solidFill>
             <a:prstDash val="solid"/>
           </a:ln>
-        </p:spPr>
-      </p:sp>
-      <p:sp>
-        <p:nvSpPr>
-          <p:cNvPr id="7" name="Text 5"/>
-          <p:cNvSpPr txBox="1"/>
-          <p:nvPr/>
-        </p:nvSpPr>
-        <p:spPr>
-          <a:xfrm>
-            <a:off x="457200" y="1920240"/>
-            <a:ext cx="457200" cy="457200"/>
-          </a:xfrm>
-          <a:prstGeom prst="rect">
-            <a:avLst/>
-          </a:prstGeom>
-          <a:noFill/>
-          <a:ln/>
-        </p:spPr>
-        <p:txBody>
-          <a:bodyPr wrap="square" lIns="0" tIns="0" rIns="0" bIns="0" rtlCol="0" anchor="ctr"/>
-          <a:lstStyle/>
-          <a:p>
-            <a:pPr algn="ctr" indent="0" marL="0">
-              <a:buNone/>
-            </a:pPr>
-            <a:r>
-              <a:rPr lang="en-US" sz="1400" b="1" dirty="0">
-                <a:solidFill>
-                  <a:srgbClr val="FFFFFF"/>
+          <a:effectLst>
+            <a:outerShdw sx="100000" sy="100000" kx="0" ky="0" algn="bl" rotWithShape="0" blurRad="76200" dist="25400" dir="5400000">
+              <a:srgbClr val="000000">
+                <a:alpha val="12000"/>
+              </a:srgbClr>
+            </a:outerShdw>
+          </a:effectLst>
+        </p:spPr>
+      </p:sp>
+      <p:sp>
+        <p:nvSpPr>
+          <p:cNvPr id="9" name="Text 6"/>
+          <p:cNvSpPr txBox="1"/>
+          <p:nvPr/>
+        </p:nvSpPr>
+        <p:spPr>
+          <a:xfrm>
+            <a:off x="4709160" y="2286000"/>
+            <a:ext cx="3840480" cy="731520"/>
+          </a:xfrm>
+          <a:prstGeom prst="rect">
+            <a:avLst/>
+          </a:prstGeom>
+          <a:noFill/>
+          <a:ln/>
+        </p:spPr>
+        <p:txBody>
+          <a:bodyPr wrap="square" lIns="0" tIns="0" rIns="0" bIns="0" rtlCol="0" anchor="ctr"/>
+          <a:lstStyle/>
+          <a:p>
+            <a:pPr indent="0" marL="0">
+              <a:buNone/>
+            </a:pPr>
+            <a:r>
+              <a:rPr lang="en-US" sz="1300" b="1" dirty="0">
+                <a:solidFill>
+                  <a:srgbClr val="0F1B2D"/>
                 </a:solidFill>
                 <a:latin typeface="Cambria" pitchFamily="34" charset="0"/>
                 <a:ea typeface="Cambria" pitchFamily="34" charset="-122"/>
                 <a:cs typeface="Cambria" pitchFamily="34" charset="-120"/>
               </a:rPr>
-              <a:t>2</a:t>
-            </a:r>
-            <a:endParaRPr lang="en-US" sz="1400" dirty="0"/>
-          </a:p>
-        </p:txBody>
-      </p:sp>
-      <p:sp>
-        <p:nvSpPr>
-          <p:cNvPr id="8" name="Text 6"/>
-          <p:cNvSpPr txBox="1"/>
-          <p:nvPr/>
-        </p:nvSpPr>
-        <p:spPr>
-          <a:xfrm>
-            <a:off x="1097280" y="1920240"/>
-            <a:ext cx="7589520" cy="457200"/>
-          </a:xfrm>
-          <a:prstGeom prst="rect">
-            <a:avLst/>
-          </a:prstGeom>
-          <a:noFill/>
-          <a:ln/>
-        </p:spPr>
-        <p:txBody>
-          <a:bodyPr wrap="square" lIns="0" tIns="0" rIns="0" bIns="0" rtlCol="0" anchor="ctr"/>
-          <a:lstStyle/>
+              <a:t>Packagers and engine makers</a:t>
+            </a:r>
+            <a:endParaRPr lang="en-US" sz="1300" dirty="0"/>
+          </a:p>
           <a:p>
             <a:pPr indent="0" marL="0">
               <a:buNone/>
             </a:pPr>
             <a:r>
-              <a:rPr lang="en-US" sz="1700" dirty="0">
-                <a:solidFill>
-                  <a:srgbClr val="FFFFFF"/>
+              <a:rPr lang="en-US" sz="1100" dirty="0">
+                <a:solidFill>
+                  <a:srgbClr val="5B6B7F"/>
                 </a:solidFill>
                 <a:latin typeface="Calibri" pitchFamily="34" charset="0"/>
                 <a:ea typeface="Calibri" pitchFamily="34" charset="-122"/>
                 <a:cs typeface="Calibri" pitchFamily="34" charset="-120"/>
               </a:rPr>
-              <a:t>Southwire is strong across the plant, and on the OEM side</a:t>
-            </a:r>
-            <a:endParaRPr lang="en-US" sz="1700" dirty="0"/>
-          </a:p>
-        </p:txBody>
-      </p:sp>
-      <p:sp>
-        <p:nvSpPr>
-          <p:cNvPr id="9" name="Shape 7"/>
+              <a:t>Solar Turbines (Caterpillar), Wartsila, energy-as-a-service developers</a:t>
+            </a:r>
+            <a:endParaRPr lang="en-US" sz="1300" dirty="0"/>
+          </a:p>
+          <a:p>
+            <a:pPr indent="0" marL="0">
+              <a:buNone/>
+            </a:pPr>
+            <a:r>
+              <a:rPr lang="en-US" sz="1100" b="1" dirty="0">
+                <a:solidFill>
+                  <a:srgbClr val="C8742B"/>
+                </a:solidFill>
+                <a:latin typeface="Calibri" pitchFamily="34" charset="0"/>
+                <a:ea typeface="Calibri" pitchFamily="34" charset="-122"/>
+                <a:cs typeface="Calibri" pitchFamily="34" charset="-120"/>
+              </a:rPr>
+              <a:t>Southwire: packaged and pre-terminated cable</a:t>
+            </a:r>
+            <a:endParaRPr lang="en-US" sz="1300" dirty="0"/>
+          </a:p>
+        </p:txBody>
+      </p:sp>
+      <p:sp>
+        <p:nvSpPr>
+          <p:cNvPr id="10" name="Shape 7"/>
           <p:cNvSpPr/>
           <p:nvPr/>
         </p:nvSpPr>
         <p:spPr>
           <a:xfrm>
-            <a:off x="457200" y="2606040"/>
-            <a:ext cx="457200" cy="457200"/>
-          </a:xfrm>
-          <a:prstGeom prst="ellipse">
+            <a:off x="4572000" y="3200400"/>
+            <a:ext cx="4114800" cy="822960"/>
+          </a:xfrm>
+          <a:prstGeom prst="rect">
             <a:avLst/>
           </a:prstGeom>
           <a:solidFill>
-            <a:srgbClr val="C8742B"/>
+            <a:srgbClr val="0F1B2D"/>
           </a:solidFill>
-          <a:ln w="12700">
+          <a:ln w="9525">
             <a:solidFill>
-              <a:srgbClr val="C8742B"/>
+              <a:srgbClr val="0F1B2D"/>
             </a:solidFill>
             <a:prstDash val="solid"/>
           </a:ln>
-        </p:spPr>
-      </p:sp>
-      <p:sp>
-        <p:nvSpPr>
-          <p:cNvPr id="10" name="Text 8"/>
-          <p:cNvSpPr txBox="1"/>
-          <p:nvPr/>
-        </p:nvSpPr>
-        <p:spPr>
-          <a:xfrm>
-            <a:off x="457200" y="2606040"/>
-            <a:ext cx="457200" cy="457200"/>
-          </a:xfrm>
-          <a:prstGeom prst="rect">
-            <a:avLst/>
-          </a:prstGeom>
-          <a:noFill/>
-          <a:ln/>
-        </p:spPr>
-        <p:txBody>
-          <a:bodyPr wrap="square" lIns="0" tIns="0" rIns="0" bIns="0" rtlCol="0" anchor="ctr"/>
-          <a:lstStyle/>
-          <a:p>
-            <a:pPr algn="ctr" indent="0" marL="0">
-              <a:buNone/>
-            </a:pPr>
-            <a:r>
-              <a:rPr lang="en-US" sz="1400" b="1" dirty="0">
+          <a:effectLst>
+            <a:outerShdw sx="100000" sy="100000" kx="0" ky="0" algn="bl" rotWithShape="0" blurRad="76200" dist="25400" dir="5400000">
+              <a:srgbClr val="000000">
+                <a:alpha val="12000"/>
+              </a:srgbClr>
+            </a:outerShdw>
+          </a:effectLst>
+        </p:spPr>
+      </p:sp>
+      <p:sp>
+        <p:nvSpPr>
+          <p:cNvPr id="11" name="Text 8"/>
+          <p:cNvSpPr txBox="1"/>
+          <p:nvPr/>
+        </p:nvSpPr>
+        <p:spPr>
+          <a:xfrm>
+            <a:off x="4709160" y="3246120"/>
+            <a:ext cx="3840480" cy="731520"/>
+          </a:xfrm>
+          <a:prstGeom prst="rect">
+            <a:avLst/>
+          </a:prstGeom>
+          <a:noFill/>
+          <a:ln/>
+        </p:spPr>
+        <p:txBody>
+          <a:bodyPr wrap="square" lIns="0" tIns="0" rIns="0" bIns="0" rtlCol="0" anchor="ctr"/>
+          <a:lstStyle/>
+          <a:p>
+            <a:pPr indent="0" marL="0">
+              <a:buNone/>
+            </a:pPr>
+            <a:r>
+              <a:rPr lang="en-US" sz="1300" b="1" dirty="0">
                 <a:solidFill>
                   <a:srgbClr val="FFFFFF"/>
                 </a:solidFill>
@@ -8467,189 +9219,157 @@
                 <a:ea typeface="Cambria" pitchFamily="34" charset="-122"/>
                 <a:cs typeface="Cambria" pitchFamily="34" charset="-120"/>
               </a:rPr>
-              <a:t>3</a:t>
-            </a:r>
-            <a:endParaRPr lang="en-US" sz="1400" dirty="0"/>
-          </a:p>
-        </p:txBody>
-      </p:sp>
-      <p:sp>
-        <p:nvSpPr>
-          <p:cNvPr id="11" name="Text 9"/>
-          <p:cNvSpPr txBox="1"/>
-          <p:nvPr/>
-        </p:nvSpPr>
-        <p:spPr>
-          <a:xfrm>
-            <a:off x="1097280" y="2606040"/>
-            <a:ext cx="7589520" cy="457200"/>
-          </a:xfrm>
-          <a:prstGeom prst="rect">
-            <a:avLst/>
-          </a:prstGeom>
-          <a:noFill/>
-          <a:ln/>
-        </p:spPr>
-        <p:txBody>
-          <a:bodyPr wrap="square" lIns="0" tIns="0" rIns="0" bIns="0" rtlCol="0" anchor="ctr"/>
-          <a:lstStyle/>
+              <a:t>Data center on-site power</a:t>
+            </a:r>
+            <a:endParaRPr lang="en-US" sz="1300" dirty="0"/>
+          </a:p>
           <a:p>
             <a:pPr indent="0" marL="0">
               <a:buNone/>
             </a:pPr>
             <a:r>
-              <a:rPr lang="en-US" sz="1700" dirty="0">
-                <a:solidFill>
-                  <a:srgbClr val="FFFFFF"/>
+              <a:rPr lang="en-US" sz="1100" dirty="0">
+                <a:solidFill>
+                  <a:srgbClr val="CADCFC"/>
                 </a:solidFill>
                 <a:latin typeface="Calibri" pitchFamily="34" charset="0"/>
                 <a:ea typeface="Calibri" pitchFamily="34" charset="-122"/>
                 <a:cs typeface="Calibri" pitchFamily="34" charset="-120"/>
               </a:rPr>
-              <a:t>A joint plan beats parallel pursuits of the same projects</a:t>
-            </a:r>
-            <a:endParaRPr lang="en-US" sz="1700" dirty="0"/>
-          </a:p>
-        </p:txBody>
-      </p:sp>
-      <p:sp>
-        <p:nvSpPr>
-          <p:cNvPr id="12" name="Shape 10"/>
-          <p:cNvSpPr/>
-          <p:nvPr/>
-        </p:nvSpPr>
-        <p:spPr>
-          <a:xfrm>
-            <a:off x="457200" y="3383280"/>
-            <a:ext cx="8229600" cy="1143000"/>
-          </a:xfrm>
-          <a:prstGeom prst="roundRect">
-            <a:avLst>
-              <a:gd name="adj" fmla="val 8000"/>
-            </a:avLst>
-          </a:prstGeom>
-          <a:solidFill>
-            <a:srgbClr val="C8742B"/>
-          </a:solidFill>
-          <a:ln w="12700">
-            <a:solidFill>
-              <a:srgbClr val="C8742B"/>
-            </a:solidFill>
-            <a:prstDash val="solid"/>
-          </a:ln>
-        </p:spPr>
-      </p:sp>
-      <p:sp>
-        <p:nvSpPr>
-          <p:cNvPr id="13" name="Text 11"/>
-          <p:cNvSpPr txBox="1"/>
-          <p:nvPr/>
-        </p:nvSpPr>
-        <p:spPr>
-          <a:xfrm>
-            <a:off x="685800" y="3456432"/>
-            <a:ext cx="2743200" cy="274320"/>
-          </a:xfrm>
-          <a:prstGeom prst="rect">
-            <a:avLst/>
-          </a:prstGeom>
-          <a:noFill/>
-          <a:ln/>
-        </p:spPr>
-        <p:txBody>
-          <a:bodyPr wrap="square" lIns="0" tIns="0" rIns="0" bIns="0" rtlCol="0" anchor="ctr"/>
-          <a:lstStyle/>
+              <a:t>~56 GW planned behind-the-meter, 46 projects</a:t>
+            </a:r>
+            <a:endParaRPr lang="en-US" sz="1300" dirty="0"/>
+          </a:p>
           <a:p>
             <a:pPr indent="0" marL="0">
               <a:buNone/>
             </a:pPr>
             <a:r>
-              <a:rPr lang="en-US" sz="1200" b="1" spc="400" kern="0" dirty="0">
-                <a:solidFill>
-                  <a:srgbClr val="FFFFFF"/>
+              <a:rPr lang="en-US" sz="1100" b="1" dirty="0">
+                <a:solidFill>
+                  <a:srgbClr val="C8742B"/>
                 </a:solidFill>
                 <a:latin typeface="Calibri" pitchFamily="34" charset="0"/>
                 <a:ea typeface="Calibri" pitchFamily="34" charset="-122"/>
                 <a:cs typeface="Calibri" pitchFamily="34" charset="-120"/>
               </a:rPr>
-              <a:t>OUR ASK</a:t>
-            </a:r>
-            <a:endParaRPr lang="en-US" sz="1200" dirty="0"/>
-          </a:p>
-        </p:txBody>
-      </p:sp>
-      <p:sp>
-        <p:nvSpPr>
-          <p:cNvPr id="14" name="Text 12"/>
-          <p:cNvSpPr txBox="1"/>
-          <p:nvPr/>
-        </p:nvSpPr>
-        <p:spPr>
-          <a:xfrm>
-            <a:off x="685800" y="3749040"/>
-            <a:ext cx="7772400" cy="685800"/>
-          </a:xfrm>
-          <a:prstGeom prst="rect">
-            <a:avLst/>
-          </a:prstGeom>
-          <a:noFill/>
-          <a:ln/>
-        </p:spPr>
-        <p:txBody>
-          <a:bodyPr wrap="square" lIns="0" tIns="0" rIns="0" bIns="0" rtlCol="0" anchor="t"/>
+              <a:t>Southwire: full plant cable package</a:t>
+            </a:r>
+            <a:endParaRPr lang="en-US" sz="1300" dirty="0"/>
+          </a:p>
+        </p:txBody>
+      </p:sp>
+      <p:sp>
+        <p:nvSpPr>
+          <p:cNvPr id="12" name="Text 9"/>
+          <p:cNvSpPr txBox="1"/>
+          <p:nvPr/>
+        </p:nvSpPr>
+        <p:spPr>
+          <a:xfrm>
+            <a:off x="457200" y="4114800"/>
+            <a:ext cx="8229600" cy="274320"/>
+          </a:xfrm>
+          <a:prstGeom prst="rect">
+            <a:avLst/>
+          </a:prstGeom>
+          <a:noFill/>
+          <a:ln/>
+        </p:spPr>
+        <p:txBody>
+          <a:bodyPr wrap="square" lIns="0" tIns="0" rIns="0" bIns="0" rtlCol="0" anchor="ctr"/>
           <a:lstStyle/>
           <a:p>
             <a:pPr indent="0" marL="0">
               <a:buNone/>
             </a:pPr>
             <a:r>
-              <a:rPr lang="en-US" sz="1800" b="1" dirty="0">
-                <a:solidFill>
-                  <a:srgbClr val="FFFFFF"/>
-                </a:solidFill>
-                <a:latin typeface="Cambria" pitchFamily="34" charset="0"/>
-                <a:ea typeface="Cambria" pitchFamily="34" charset="-122"/>
-                <a:cs typeface="Cambria" pitchFamily="34" charset="-120"/>
-              </a:rPr>
-              <a:t>Loop Southwire into AXE's Gas Power Projects and build a joint strategy around their target list.</a:t>
-            </a:r>
-            <a:endParaRPr lang="en-US" sz="1800" dirty="0"/>
-          </a:p>
-        </p:txBody>
-      </p:sp>
-      <p:sp>
-        <p:nvSpPr>
-          <p:cNvPr id="15" name="Text 13"/>
-          <p:cNvSpPr txBox="1"/>
-          <p:nvPr/>
-        </p:nvSpPr>
-        <p:spPr>
-          <a:xfrm>
-            <a:off x="457200" y="4754880"/>
-            <a:ext cx="5486400" cy="228600"/>
-          </a:xfrm>
-          <a:prstGeom prst="rect">
-            <a:avLst/>
-          </a:prstGeom>
-          <a:noFill/>
-          <a:ln/>
-        </p:spPr>
-        <p:txBody>
-          <a:bodyPr wrap="square" lIns="0" tIns="0" rIns="0" bIns="0" rtlCol="0" anchor="ctr"/>
-          <a:lstStyle/>
-          <a:p>
-            <a:pPr indent="0" marL="0">
-              <a:buNone/>
-            </a:pPr>
-            <a:r>
-              <a:rPr lang="en-US" sz="1000" dirty="0">
-                <a:solidFill>
-                  <a:srgbClr val="9FB0C3"/>
+              <a:rPr lang="en-US" sz="1300" i="1" dirty="0">
+                <a:solidFill>
+                  <a:srgbClr val="5B6B7F"/>
                 </a:solidFill>
                 <a:latin typeface="Calibri" pitchFamily="34" charset="0"/>
                 <a:ea typeface="Calibri" pitchFamily="34" charset="-122"/>
                 <a:cs typeface="Calibri" pitchFamily="34" charset="-120"/>
               </a:rPr>
+              <a:t>Where AXE adds value: logistics, inventory and project coordination for OEMs and packagers (to discuss).</a:t>
+            </a:r>
+            <a:endParaRPr lang="en-US" sz="1300" dirty="0"/>
+          </a:p>
+        </p:txBody>
+      </p:sp>
+      <p:sp>
+        <p:nvSpPr>
+          <p:cNvPr id="13" name="Text 10"/>
+          <p:cNvSpPr txBox="1"/>
+          <p:nvPr/>
+        </p:nvSpPr>
+        <p:spPr>
+          <a:xfrm>
+            <a:off x="457200" y="4462272"/>
+            <a:ext cx="8229600" cy="201168"/>
+          </a:xfrm>
+          <a:prstGeom prst="rect">
+            <a:avLst/>
+          </a:prstGeom>
+          <a:noFill/>
+          <a:ln/>
+        </p:spPr>
+        <p:txBody>
+          <a:bodyPr wrap="square" lIns="0" tIns="0" rIns="0" bIns="0" rtlCol="0" anchor="ctr"/>
+          <a:lstStyle/>
+          <a:p>
+            <a:pPr indent="0" marL="0">
+              <a:buNone/>
+            </a:pPr>
+            <a:r>
+              <a:rPr lang="en-US" sz="900" dirty="0">
+                <a:solidFill>
+                  <a:srgbClr val="5B6B7F"/>
+                </a:solidFill>
+                <a:latin typeface="Calibri" pitchFamily="34" charset="0"/>
+                <a:ea typeface="Calibri" pitchFamily="34" charset="-122"/>
+                <a:cs typeface="Calibri" pitchFamily="34" charset="-120"/>
+              </a:rPr>
+              <a:t>Sources: OEM Q2 2026 reports (GE Vernova, Siemens Energy, Mitsubishi Heavy); Cleanview BTM tracker; press reports.</a:t>
+            </a:r>
+            <a:endParaRPr lang="en-US" sz="900" dirty="0"/>
+          </a:p>
+        </p:txBody>
+      </p:sp>
+      <p:sp>
+        <p:nvSpPr>
+          <p:cNvPr id="14" name="Text 11"/>
+          <p:cNvSpPr txBox="1"/>
+          <p:nvPr/>
+        </p:nvSpPr>
+        <p:spPr>
+          <a:xfrm>
+            <a:off x="457200" y="4754880"/>
+            <a:ext cx="5486400" cy="228600"/>
+          </a:xfrm>
+          <a:prstGeom prst="rect">
+            <a:avLst/>
+          </a:prstGeom>
+          <a:noFill/>
+          <a:ln/>
+        </p:spPr>
+        <p:txBody>
+          <a:bodyPr wrap="square" lIns="0" tIns="0" rIns="0" bIns="0" rtlCol="0" anchor="ctr"/>
+          <a:lstStyle/>
+          <a:p>
+            <a:pPr indent="0" marL="0">
+              <a:buNone/>
+            </a:pPr>
+            <a:r>
+              <a:rPr lang="en-US" sz="1000" dirty="0">
+                <a:solidFill>
+                  <a:srgbClr val="5B6B7F"/>
+                </a:solidFill>
+                <a:latin typeface="Calibri" pitchFamily="34" charset="0"/>
+                <a:ea typeface="Calibri" pitchFamily="34" charset="-122"/>
+                <a:cs typeface="Calibri" pitchFamily="34" charset="-120"/>
+              </a:rPr>
               <a:t>Southwire PowerGen  |  Anixter Global Accounts</a:t>
             </a:r>
             <a:endParaRPr lang="en-US" sz="1000" dirty="0"/>
@@ -8658,7 +9378,7 @@
       </p:sp>
       <p:sp>
         <p:nvSpPr>
-          <p:cNvPr id="16" name="Text 14"/>
+          <p:cNvPr id="15" name="Text 12"/>
           <p:cNvSpPr txBox="1"/>
           <p:nvPr/>
         </p:nvSpPr>
@@ -8683,7 +9403,7 @@
             <a:r>
               <a:rPr lang="en-US" sz="1000" dirty="0">
                 <a:solidFill>
-                  <a:srgbClr val="9FB0C3"/>
+                  <a:srgbClr val="5B6B7F"/>
                 </a:solidFill>
                 <a:latin typeface="Calibri" pitchFamily="34" charset="0"/>
                 <a:ea typeface="Calibri" pitchFamily="34" charset="-122"/>

</xml_diff>

<commit_message>
Replace fly-through with two catalog-style zone summary slides
Co-Authored-By: Claude Sonnet 5.5 <noreply@anthropic.com>
Claude-Session: https://claude.ai/code/session_015HKS2PnjCizKc2aENrrpqs
</commit_message>
<xml_diff>
--- a/presentations/Anixter_PowerGen_Presentation_DRAFT.pptx
+++ b/presentations/Anixter_PowerGen_Presentation_DRAFT.pptx
@@ -19,17 +19,9 @@
     <p:sldId id="267" r:id="rId13"/>
     <p:sldId id="268" r:id="rId14"/>
     <p:sldId id="269" r:id="rId15"/>
-    <p:sldId id="270" r:id="rId16"/>
-    <p:sldId id="271" r:id="rId17"/>
-    <p:sldId id="272" r:id="rId18"/>
-    <p:sldId id="273" r:id="rId19"/>
-    <p:sldId id="274" r:id="rId20"/>
-    <p:sldId id="275" r:id="rId21"/>
-    <p:sldId id="276" r:id="rId22"/>
-    <p:sldId id="277" r:id="rId23"/>
   </p:sldIdLst>
   <p:notesMasterIdLst>
-    <p:notesMasterId r:id="rId24"/>
+    <p:notesMasterId r:id="rId16"/>
   </p:notesMasterIdLst>
   <p:sldSz cx="9144000" cy="5143500"/>
   <p:notesSz cx="5143500" cy="9144000"/>
@@ -842,7 +834,7 @@
           <a:p>
             <a:r>
               <a:rPr lang="en-US" dirty="0"/>
-              <a:t>Fly-through 2: inside the HRSG. Pressure parts and segregated cable routes (HRSG views p.2). Source: Southwire combined-cycle wire &amp; cable application guide and HRSG views.</a:t>
+              <a:t>Areas 05, 13 and 17: E-house and MV/LV distribution (guide p.10), GSUs and auxiliary transformers (p.20), switchyard, protection and export (p.21), grounding, bonding and cable shields (p.23). Source: Southwire combined-cycle wire &amp; cable application guide.</a:t>
             </a:r>
             <a:endParaRPr lang="en-US" dirty="0"/>
           </a:p>
@@ -930,7 +922,7 @@
           <a:p>
             <a:r>
               <a:rPr lang="en-US" dirty="0"/>
-              <a:t>Fly-through 3: HRSG local equipment. Auxiliary MCC, control and I/O panel, power and control trays, junction boxes, bonding (HRSG views p.3). Source: Southwire combined-cycle wire &amp; cable application guide and HRSG views.</a:t>
+              <a:t>Placeholder categories. Swap in the official one-page PowerGen line card and attach it as a leave-behind.</a:t>
             </a:r>
             <a:endParaRPr lang="en-US" dirty="0"/>
           </a:p>
@@ -1018,7 +1010,7 @@
           <a:p>
             <a:r>
               <a:rPr lang="en-US" dirty="0"/>
-              <a:t>Fly-through 4: HRSGs and field instrumentation. Actuators and local power, process loops, multipair field collection (application guide p.7). Source: Southwire combined-cycle wire &amp; cable application guide and HRSG views.</a:t>
+              <a:t>Backlogs: GE Vernova 116 GW (June 2026), Siemens Energy 69 GW (June 30), Mitsubishi Heavy 35 GW large-frame (Aug 6). Behind-the-meter figure is from Cleanview via press. Verify before presenting.</a:t>
             </a:r>
             <a:endParaRPr lang="en-US" dirty="0"/>
           </a:p>
@@ -1106,7 +1098,7 @@
           <a:p>
             <a:r>
               <a:rPr lang="en-US" dirty="0"/>
-              <a:t>Fly-through 5: steam turbine auxiliaries. Lube oil and turning gear, essential DC loads, monitoring and trip interfaces (application guide p.8). Source: Southwire combined-cycle wire &amp; cable application guide and HRSG views.</a:t>
+              <a:t>The ask is from Stephan's reply to Marc. Agree with Marc on other expectations of AXE before Friday and add here.</a:t>
             </a:r>
             <a:endParaRPr lang="en-US" dirty="0"/>
           </a:p>
@@ -1194,7 +1186,7 @@
           <a:p>
             <a:r>
               <a:rPr lang="en-US" dirty="0"/>
-              <a:t>Fly-through 6: fuel-gas metering and conditioning. Heater and skid auxiliaries, valves and shutdown interfaces, armored instrumentation (application guide p.19). Source: Southwire combined-cycle wire &amp; cable application guide and HRSG views.</a:t>
+              <a:t>Phil and Bob help field questions.</a:t>
             </a:r>
             <a:endParaRPr lang="en-US" dirty="0"/>
           </a:p>
@@ -1218,446 +1210,6 @@
             <a:fld id="{F7021451-1387-4CA6-816F-3879F97B5CBC}" type="slidenum">
               <a:rPr lang="en-US"/>
               <a:t>14</a:t>
-            </a:fld>
-            <a:endParaRPr lang="en-US"/>
-          </a:p>
-        </p:txBody>
-      </p:sp>
-    </p:spTree>
-    <p:extLst>
-      <p:ext uri="{BB962C8B-B14F-4D97-AF65-F5344CB8AC3E}">
-        <p14:creationId xmlns:p14="http://schemas.microsoft.com/office/powerpoint/2010/main" val="1024086991"/>
-      </p:ext>
-    </p:extLst>
-  </p:cSld>
-  <p:clrMapOvr>
-    <a:masterClrMapping/>
-  </p:clrMapOvr>
-</p:notes>
-</file>
-
-<file path=ppt/notesSlides/notesSlide15.xml><?xml version="1.0" encoding="utf-8"?>
-<p:notes xmlns:a="http://schemas.openxmlformats.org/drawingml/2006/main" xmlns:r="http://schemas.openxmlformats.org/officeDocument/2006/relationships" xmlns:p="http://schemas.openxmlformats.org/presentationml/2006/main">
-  <p:cSld>
-    <p:spTree>
-      <p:nvGrpSpPr>
-        <p:cNvPr id="1" name=""/>
-        <p:cNvGrpSpPr/>
-        <p:nvPr/>
-      </p:nvGrpSpPr>
-      <p:grpSpPr>
-        <a:xfrm>
-          <a:off x="0" y="0"/>
-          <a:ext cx="0" cy="0"/>
-          <a:chOff x="0" y="0"/>
-          <a:chExt cx="0" cy="0"/>
-        </a:xfrm>
-      </p:grpSpPr>
-      <p:sp>
-        <p:nvSpPr>
-          <p:cNvPr id="2" name="Slide Image Placeholder 1"/>
-          <p:cNvSpPr>
-            <a:spLocks noGrp="1" noRot="1" noChangeAspect="1"/>
-          </p:cNvSpPr>
-          <p:nvPr>
-            <p:ph type="sldImg"/>
-          </p:nvPr>
-        </p:nvSpPr>
-        <p:spPr/>
-      </p:sp>
-      <p:sp>
-        <p:nvSpPr>
-          <p:cNvPr id="3" name="Notes Placeholder 2"/>
-          <p:cNvSpPr>
-            <a:spLocks noGrp="1"/>
-          </p:cNvSpPr>
-          <p:nvPr>
-            <p:ph type="body" idx="1"/>
-          </p:nvPr>
-        </p:nvSpPr>
-        <p:spPr/>
-        <p:txBody>
-          <a:bodyPr/>
-          <a:lstStyle/>
-          <a:p>
-            <a:r>
-              <a:rPr lang="en-US" dirty="0"/>
-              <a:t>Fly-through 7: E-house and MV/LV distribution. MV feeders, LV distribution, switchgear control interfaces (application guide p.10). This is the OEM and module-builder story. Source: Southwire combined-cycle wire &amp; cable application guide and HRSG views.</a:t>
-            </a:r>
-            <a:endParaRPr lang="en-US" dirty="0"/>
-          </a:p>
-        </p:txBody>
-      </p:sp>
-      <p:sp>
-        <p:nvSpPr>
-          <p:cNvPr id="4" name="Slide Number Placeholder 3"/>
-          <p:cNvSpPr>
-            <a:spLocks noGrp="1"/>
-          </p:cNvSpPr>
-          <p:nvPr>
-            <p:ph type="sldNum" sz="quarter" idx="10"/>
-          </p:nvPr>
-        </p:nvSpPr>
-        <p:spPr/>
-        <p:txBody>
-          <a:bodyPr/>
-          <a:lstStyle/>
-          <a:p>
-            <a:fld id="{F7021451-1387-4CA6-816F-3879F97B5CBC}" type="slidenum">
-              <a:rPr lang="en-US"/>
-              <a:t>15</a:t>
-            </a:fld>
-            <a:endParaRPr lang="en-US"/>
-          </a:p>
-        </p:txBody>
-      </p:sp>
-    </p:spTree>
-    <p:extLst>
-      <p:ext uri="{BB962C8B-B14F-4D97-AF65-F5344CB8AC3E}">
-        <p14:creationId xmlns:p14="http://schemas.microsoft.com/office/powerpoint/2010/main" val="1024086991"/>
-      </p:ext>
-    </p:extLst>
-  </p:cSld>
-  <p:clrMapOvr>
-    <a:masterClrMapping/>
-  </p:clrMapOvr>
-</p:notes>
-</file>
-
-<file path=ppt/notesSlides/notesSlide16.xml><?xml version="1.0" encoding="utf-8"?>
-<p:notes xmlns:a="http://schemas.openxmlformats.org/drawingml/2006/main" xmlns:r="http://schemas.openxmlformats.org/officeDocument/2006/relationships" xmlns:p="http://schemas.openxmlformats.org/presentationml/2006/main">
-  <p:cSld>
-    <p:spTree>
-      <p:nvGrpSpPr>
-        <p:cNvPr id="1" name=""/>
-        <p:cNvGrpSpPr/>
-        <p:nvPr/>
-      </p:nvGrpSpPr>
-      <p:grpSpPr>
-        <a:xfrm>
-          <a:off x="0" y="0"/>
-          <a:ext cx="0" cy="0"/>
-          <a:chOff x="0" y="0"/>
-          <a:chExt cx="0" cy="0"/>
-        </a:xfrm>
-      </p:grpSpPr>
-      <p:sp>
-        <p:nvSpPr>
-          <p:cNvPr id="2" name="Slide Image Placeholder 1"/>
-          <p:cNvSpPr>
-            <a:spLocks noGrp="1" noRot="1" noChangeAspect="1"/>
-          </p:cNvSpPr>
-          <p:nvPr>
-            <p:ph type="sldImg"/>
-          </p:nvPr>
-        </p:nvSpPr>
-        <p:spPr/>
-      </p:sp>
-      <p:sp>
-        <p:nvSpPr>
-          <p:cNvPr id="3" name="Notes Placeholder 2"/>
-          <p:cNvSpPr>
-            <a:spLocks noGrp="1"/>
-          </p:cNvSpPr>
-          <p:nvPr>
-            <p:ph type="body" idx="1"/>
-          </p:nvPr>
-        </p:nvSpPr>
-        <p:spPr/>
-        <p:txBody>
-          <a:bodyPr/>
-          <a:lstStyle/>
-          <a:p>
-            <a:r>
-              <a:rPr lang="en-US" dirty="0"/>
-              <a:t>Fly-through 8: GSUs and auxiliary transformers. Generator and HV connection, cooling and cabinet supply, alarms and protection (application guide p.20). Source: Southwire combined-cycle wire &amp; cable application guide and HRSG views.</a:t>
-            </a:r>
-            <a:endParaRPr lang="en-US" dirty="0"/>
-          </a:p>
-        </p:txBody>
-      </p:sp>
-      <p:sp>
-        <p:nvSpPr>
-          <p:cNvPr id="4" name="Slide Number Placeholder 3"/>
-          <p:cNvSpPr>
-            <a:spLocks noGrp="1"/>
-          </p:cNvSpPr>
-          <p:nvPr>
-            <p:ph type="sldNum" sz="quarter" idx="10"/>
-          </p:nvPr>
-        </p:nvSpPr>
-        <p:spPr/>
-        <p:txBody>
-          <a:bodyPr/>
-          <a:lstStyle/>
-          <a:p>
-            <a:fld id="{F7021451-1387-4CA6-816F-3879F97B5CBC}" type="slidenum">
-              <a:rPr lang="en-US"/>
-              <a:t>16</a:t>
-            </a:fld>
-            <a:endParaRPr lang="en-US"/>
-          </a:p>
-        </p:txBody>
-      </p:sp>
-    </p:spTree>
-    <p:extLst>
-      <p:ext uri="{BB962C8B-B14F-4D97-AF65-F5344CB8AC3E}">
-        <p14:creationId xmlns:p14="http://schemas.microsoft.com/office/powerpoint/2010/main" val="1024086991"/>
-      </p:ext>
-    </p:extLst>
-  </p:cSld>
-  <p:clrMapOvr>
-    <a:masterClrMapping/>
-  </p:clrMapOvr>
-</p:notes>
-</file>
-
-<file path=ppt/notesSlides/notesSlide17.xml><?xml version="1.0" encoding="utf-8"?>
-<p:notes xmlns:a="http://schemas.openxmlformats.org/drawingml/2006/main" xmlns:r="http://schemas.openxmlformats.org/officeDocument/2006/relationships" xmlns:p="http://schemas.openxmlformats.org/presentationml/2006/main">
-  <p:cSld>
-    <p:spTree>
-      <p:nvGrpSpPr>
-        <p:cNvPr id="1" name=""/>
-        <p:cNvGrpSpPr/>
-        <p:nvPr/>
-      </p:nvGrpSpPr>
-      <p:grpSpPr>
-        <a:xfrm>
-          <a:off x="0" y="0"/>
-          <a:ext cx="0" cy="0"/>
-          <a:chOff x="0" y="0"/>
-          <a:chExt cx="0" cy="0"/>
-        </a:xfrm>
-      </p:grpSpPr>
-      <p:sp>
-        <p:nvSpPr>
-          <p:cNvPr id="2" name="Slide Image Placeholder 1"/>
-          <p:cNvSpPr>
-            <a:spLocks noGrp="1" noRot="1" noChangeAspect="1"/>
-          </p:cNvSpPr>
-          <p:nvPr>
-            <p:ph type="sldImg"/>
-          </p:nvPr>
-        </p:nvSpPr>
-        <p:spPr/>
-      </p:sp>
-      <p:sp>
-        <p:nvSpPr>
-          <p:cNvPr id="3" name="Notes Placeholder 2"/>
-          <p:cNvSpPr>
-            <a:spLocks noGrp="1"/>
-          </p:cNvSpPr>
-          <p:nvPr>
-            <p:ph type="body" idx="1"/>
-          </p:nvPr>
-        </p:nvSpPr>
-        <p:spPr/>
-        <p:txBody>
-          <a:bodyPr/>
-          <a:lstStyle/>
-          <a:p>
-            <a:r>
-              <a:rPr lang="en-US" dirty="0"/>
-              <a:t>Fly-through 9: switchyard, protection and export. Utility export, breaker control, protection and telecom (application guide p.21). Source: Southwire combined-cycle wire &amp; cable application guide and HRSG views.</a:t>
-            </a:r>
-            <a:endParaRPr lang="en-US" dirty="0"/>
-          </a:p>
-        </p:txBody>
-      </p:sp>
-      <p:sp>
-        <p:nvSpPr>
-          <p:cNvPr id="4" name="Slide Number Placeholder 3"/>
-          <p:cNvSpPr>
-            <a:spLocks noGrp="1"/>
-          </p:cNvSpPr>
-          <p:nvPr>
-            <p:ph type="sldNum" sz="quarter" idx="10"/>
-          </p:nvPr>
-        </p:nvSpPr>
-        <p:spPr/>
-        <p:txBody>
-          <a:bodyPr/>
-          <a:lstStyle/>
-          <a:p>
-            <a:fld id="{F7021451-1387-4CA6-816F-3879F97B5CBC}" type="slidenum">
-              <a:rPr lang="en-US"/>
-              <a:t>17</a:t>
-            </a:fld>
-            <a:endParaRPr lang="en-US"/>
-          </a:p>
-        </p:txBody>
-      </p:sp>
-    </p:spTree>
-    <p:extLst>
-      <p:ext uri="{BB962C8B-B14F-4D97-AF65-F5344CB8AC3E}">
-        <p14:creationId xmlns:p14="http://schemas.microsoft.com/office/powerpoint/2010/main" val="1024086991"/>
-      </p:ext>
-    </p:extLst>
-  </p:cSld>
-  <p:clrMapOvr>
-    <a:masterClrMapping/>
-  </p:clrMapOvr>
-</p:notes>
-</file>
-
-<file path=ppt/notesSlides/notesSlide18.xml><?xml version="1.0" encoding="utf-8"?>
-<p:notes xmlns:a="http://schemas.openxmlformats.org/drawingml/2006/main" xmlns:r="http://schemas.openxmlformats.org/officeDocument/2006/relationships" xmlns:p="http://schemas.openxmlformats.org/presentationml/2006/main">
-  <p:cSld>
-    <p:spTree>
-      <p:nvGrpSpPr>
-        <p:cNvPr id="1" name=""/>
-        <p:cNvGrpSpPr/>
-        <p:nvPr/>
-      </p:nvGrpSpPr>
-      <p:grpSpPr>
-        <a:xfrm>
-          <a:off x="0" y="0"/>
-          <a:ext cx="0" cy="0"/>
-          <a:chOff x="0" y="0"/>
-          <a:chExt cx="0" cy="0"/>
-        </a:xfrm>
-      </p:grpSpPr>
-      <p:sp>
-        <p:nvSpPr>
-          <p:cNvPr id="2" name="Slide Image Placeholder 1"/>
-          <p:cNvSpPr>
-            <a:spLocks noGrp="1" noRot="1" noChangeAspect="1"/>
-          </p:cNvSpPr>
-          <p:nvPr>
-            <p:ph type="sldImg"/>
-          </p:nvPr>
-        </p:nvSpPr>
-        <p:spPr/>
-      </p:sp>
-      <p:sp>
-        <p:nvSpPr>
-          <p:cNvPr id="3" name="Notes Placeholder 2"/>
-          <p:cNvSpPr>
-            <a:spLocks noGrp="1"/>
-          </p:cNvSpPr>
-          <p:nvPr>
-            <p:ph type="body" idx="1"/>
-          </p:nvPr>
-        </p:nvSpPr>
-        <p:spPr/>
-        <p:txBody>
-          <a:bodyPr/>
-          <a:lstStyle/>
-          <a:p>
-            <a:r>
-              <a:rPr lang="en-US" dirty="0"/>
-              <a:t>Fly-through 10: grounding, bonding and cable shields. Plant grid, equipment and tray bonds, shield and armor termination (application guide p.23). Source: Southwire combined-cycle wire &amp; cable application guide and HRSG views.</a:t>
-            </a:r>
-            <a:endParaRPr lang="en-US" dirty="0"/>
-          </a:p>
-        </p:txBody>
-      </p:sp>
-      <p:sp>
-        <p:nvSpPr>
-          <p:cNvPr id="4" name="Slide Number Placeholder 3"/>
-          <p:cNvSpPr>
-            <a:spLocks noGrp="1"/>
-          </p:cNvSpPr>
-          <p:nvPr>
-            <p:ph type="sldNum" sz="quarter" idx="10"/>
-          </p:nvPr>
-        </p:nvSpPr>
-        <p:spPr/>
-        <p:txBody>
-          <a:bodyPr/>
-          <a:lstStyle/>
-          <a:p>
-            <a:fld id="{F7021451-1387-4CA6-816F-3879F97B5CBC}" type="slidenum">
-              <a:rPr lang="en-US"/>
-              <a:t>18</a:t>
-            </a:fld>
-            <a:endParaRPr lang="en-US"/>
-          </a:p>
-        </p:txBody>
-      </p:sp>
-    </p:spTree>
-    <p:extLst>
-      <p:ext uri="{BB962C8B-B14F-4D97-AF65-F5344CB8AC3E}">
-        <p14:creationId xmlns:p14="http://schemas.microsoft.com/office/powerpoint/2010/main" val="1024086991"/>
-      </p:ext>
-    </p:extLst>
-  </p:cSld>
-  <p:clrMapOvr>
-    <a:masterClrMapping/>
-  </p:clrMapOvr>
-</p:notes>
-</file>
-
-<file path=ppt/notesSlides/notesSlide19.xml><?xml version="1.0" encoding="utf-8"?>
-<p:notes xmlns:a="http://schemas.openxmlformats.org/drawingml/2006/main" xmlns:r="http://schemas.openxmlformats.org/officeDocument/2006/relationships" xmlns:p="http://schemas.openxmlformats.org/presentationml/2006/main">
-  <p:cSld>
-    <p:spTree>
-      <p:nvGrpSpPr>
-        <p:cNvPr id="1" name=""/>
-        <p:cNvGrpSpPr/>
-        <p:nvPr/>
-      </p:nvGrpSpPr>
-      <p:grpSpPr>
-        <a:xfrm>
-          <a:off x="0" y="0"/>
-          <a:ext cx="0" cy="0"/>
-          <a:chOff x="0" y="0"/>
-          <a:chExt cx="0" cy="0"/>
-        </a:xfrm>
-      </p:grpSpPr>
-      <p:sp>
-        <p:nvSpPr>
-          <p:cNvPr id="2" name="Slide Image Placeholder 1"/>
-          <p:cNvSpPr>
-            <a:spLocks noGrp="1" noRot="1" noChangeAspect="1"/>
-          </p:cNvSpPr>
-          <p:nvPr>
-            <p:ph type="sldImg"/>
-          </p:nvPr>
-        </p:nvSpPr>
-        <p:spPr/>
-      </p:sp>
-      <p:sp>
-        <p:nvSpPr>
-          <p:cNvPr id="3" name="Notes Placeholder 2"/>
-          <p:cNvSpPr>
-            <a:spLocks noGrp="1"/>
-          </p:cNvSpPr>
-          <p:nvPr>
-            <p:ph type="body" idx="1"/>
-          </p:nvPr>
-        </p:nvSpPr>
-        <p:spPr/>
-        <p:txBody>
-          <a:bodyPr/>
-          <a:lstStyle/>
-          <a:p>
-            <a:r>
-              <a:rPr lang="en-US" dirty="0"/>
-              <a:t>Placeholder categories. Swap in the official one-page PowerGen line card and attach it as a leave-behind.</a:t>
-            </a:r>
-            <a:endParaRPr lang="en-US" dirty="0"/>
-          </a:p>
-        </p:txBody>
-      </p:sp>
-      <p:sp>
-        <p:nvSpPr>
-          <p:cNvPr id="4" name="Slide Number Placeholder 3"/>
-          <p:cNvSpPr>
-            <a:spLocks noGrp="1"/>
-          </p:cNvSpPr>
-          <p:nvPr>
-            <p:ph type="sldNum" sz="quarter" idx="10"/>
-          </p:nvPr>
-        </p:nvSpPr>
-        <p:spPr/>
-        <p:txBody>
-          <a:bodyPr/>
-          <a:lstStyle/>
-          <a:p>
-            <a:fld id="{F7021451-1387-4CA6-816F-3879F97B5CBC}" type="slidenum">
-              <a:rPr lang="en-US"/>
-              <a:t>19</a:t>
             </a:fld>
             <a:endParaRPr lang="en-US"/>
           </a:p>
@@ -1764,270 +1316,6 @@
 </p:notes>
 </file>
 
-<file path=ppt/notesSlides/notesSlide20.xml><?xml version="1.0" encoding="utf-8"?>
-<p:notes xmlns:a="http://schemas.openxmlformats.org/drawingml/2006/main" xmlns:r="http://schemas.openxmlformats.org/officeDocument/2006/relationships" xmlns:p="http://schemas.openxmlformats.org/presentationml/2006/main">
-  <p:cSld>
-    <p:spTree>
-      <p:nvGrpSpPr>
-        <p:cNvPr id="1" name=""/>
-        <p:cNvGrpSpPr/>
-        <p:nvPr/>
-      </p:nvGrpSpPr>
-      <p:grpSpPr>
-        <a:xfrm>
-          <a:off x="0" y="0"/>
-          <a:ext cx="0" cy="0"/>
-          <a:chOff x="0" y="0"/>
-          <a:chExt cx="0" cy="0"/>
-        </a:xfrm>
-      </p:grpSpPr>
-      <p:sp>
-        <p:nvSpPr>
-          <p:cNvPr id="2" name="Slide Image Placeholder 1"/>
-          <p:cNvSpPr>
-            <a:spLocks noGrp="1" noRot="1" noChangeAspect="1"/>
-          </p:cNvSpPr>
-          <p:nvPr>
-            <p:ph type="sldImg"/>
-          </p:nvPr>
-        </p:nvSpPr>
-        <p:spPr/>
-      </p:sp>
-      <p:sp>
-        <p:nvSpPr>
-          <p:cNvPr id="3" name="Notes Placeholder 2"/>
-          <p:cNvSpPr>
-            <a:spLocks noGrp="1"/>
-          </p:cNvSpPr>
-          <p:nvPr>
-            <p:ph type="body" idx="1"/>
-          </p:nvPr>
-        </p:nvSpPr>
-        <p:spPr/>
-        <p:txBody>
-          <a:bodyPr/>
-          <a:lstStyle/>
-          <a:p>
-            <a:r>
-              <a:rPr lang="en-US" dirty="0"/>
-              <a:t>Backlogs: GE Vernova 116 GW (June 2026), Siemens Energy 69 GW (June 30), Mitsubishi Heavy 35 GW large-frame (Aug 6). Behind-the-meter figure is from Cleanview via press. Verify before presenting.</a:t>
-            </a:r>
-            <a:endParaRPr lang="en-US" dirty="0"/>
-          </a:p>
-        </p:txBody>
-      </p:sp>
-      <p:sp>
-        <p:nvSpPr>
-          <p:cNvPr id="4" name="Slide Number Placeholder 3"/>
-          <p:cNvSpPr>
-            <a:spLocks noGrp="1"/>
-          </p:cNvSpPr>
-          <p:nvPr>
-            <p:ph type="sldNum" sz="quarter" idx="10"/>
-          </p:nvPr>
-        </p:nvSpPr>
-        <p:spPr/>
-        <p:txBody>
-          <a:bodyPr/>
-          <a:lstStyle/>
-          <a:p>
-            <a:fld id="{F7021451-1387-4CA6-816F-3879F97B5CBC}" type="slidenum">
-              <a:rPr lang="en-US"/>
-              <a:t>20</a:t>
-            </a:fld>
-            <a:endParaRPr lang="en-US"/>
-          </a:p>
-        </p:txBody>
-      </p:sp>
-    </p:spTree>
-    <p:extLst>
-      <p:ext uri="{BB962C8B-B14F-4D97-AF65-F5344CB8AC3E}">
-        <p14:creationId xmlns:p14="http://schemas.microsoft.com/office/powerpoint/2010/main" val="1024086991"/>
-      </p:ext>
-    </p:extLst>
-  </p:cSld>
-  <p:clrMapOvr>
-    <a:masterClrMapping/>
-  </p:clrMapOvr>
-</p:notes>
-</file>
-
-<file path=ppt/notesSlides/notesSlide21.xml><?xml version="1.0" encoding="utf-8"?>
-<p:notes xmlns:a="http://schemas.openxmlformats.org/drawingml/2006/main" xmlns:r="http://schemas.openxmlformats.org/officeDocument/2006/relationships" xmlns:p="http://schemas.openxmlformats.org/presentationml/2006/main">
-  <p:cSld>
-    <p:spTree>
-      <p:nvGrpSpPr>
-        <p:cNvPr id="1" name=""/>
-        <p:cNvGrpSpPr/>
-        <p:nvPr/>
-      </p:nvGrpSpPr>
-      <p:grpSpPr>
-        <a:xfrm>
-          <a:off x="0" y="0"/>
-          <a:ext cx="0" cy="0"/>
-          <a:chOff x="0" y="0"/>
-          <a:chExt cx="0" cy="0"/>
-        </a:xfrm>
-      </p:grpSpPr>
-      <p:sp>
-        <p:nvSpPr>
-          <p:cNvPr id="2" name="Slide Image Placeholder 1"/>
-          <p:cNvSpPr>
-            <a:spLocks noGrp="1" noRot="1" noChangeAspect="1"/>
-          </p:cNvSpPr>
-          <p:nvPr>
-            <p:ph type="sldImg"/>
-          </p:nvPr>
-        </p:nvSpPr>
-        <p:spPr/>
-      </p:sp>
-      <p:sp>
-        <p:nvSpPr>
-          <p:cNvPr id="3" name="Notes Placeholder 2"/>
-          <p:cNvSpPr>
-            <a:spLocks noGrp="1"/>
-          </p:cNvSpPr>
-          <p:nvPr>
-            <p:ph type="body" idx="1"/>
-          </p:nvPr>
-        </p:nvSpPr>
-        <p:spPr/>
-        <p:txBody>
-          <a:bodyPr/>
-          <a:lstStyle/>
-          <a:p>
-            <a:r>
-              <a:rPr lang="en-US" dirty="0"/>
-              <a:t>The ask is from Stephan's reply to Marc. Agree with Marc on other expectations of AXE before Friday and add here.</a:t>
-            </a:r>
-            <a:endParaRPr lang="en-US" dirty="0"/>
-          </a:p>
-        </p:txBody>
-      </p:sp>
-      <p:sp>
-        <p:nvSpPr>
-          <p:cNvPr id="4" name="Slide Number Placeholder 3"/>
-          <p:cNvSpPr>
-            <a:spLocks noGrp="1"/>
-          </p:cNvSpPr>
-          <p:nvPr>
-            <p:ph type="sldNum" sz="quarter" idx="10"/>
-          </p:nvPr>
-        </p:nvSpPr>
-        <p:spPr/>
-        <p:txBody>
-          <a:bodyPr/>
-          <a:lstStyle/>
-          <a:p>
-            <a:fld id="{F7021451-1387-4CA6-816F-3879F97B5CBC}" type="slidenum">
-              <a:rPr lang="en-US"/>
-              <a:t>21</a:t>
-            </a:fld>
-            <a:endParaRPr lang="en-US"/>
-          </a:p>
-        </p:txBody>
-      </p:sp>
-    </p:spTree>
-    <p:extLst>
-      <p:ext uri="{BB962C8B-B14F-4D97-AF65-F5344CB8AC3E}">
-        <p14:creationId xmlns:p14="http://schemas.microsoft.com/office/powerpoint/2010/main" val="1024086991"/>
-      </p:ext>
-    </p:extLst>
-  </p:cSld>
-  <p:clrMapOvr>
-    <a:masterClrMapping/>
-  </p:clrMapOvr>
-</p:notes>
-</file>
-
-<file path=ppt/notesSlides/notesSlide22.xml><?xml version="1.0" encoding="utf-8"?>
-<p:notes xmlns:a="http://schemas.openxmlformats.org/drawingml/2006/main" xmlns:r="http://schemas.openxmlformats.org/officeDocument/2006/relationships" xmlns:p="http://schemas.openxmlformats.org/presentationml/2006/main">
-  <p:cSld>
-    <p:spTree>
-      <p:nvGrpSpPr>
-        <p:cNvPr id="1" name=""/>
-        <p:cNvGrpSpPr/>
-        <p:nvPr/>
-      </p:nvGrpSpPr>
-      <p:grpSpPr>
-        <a:xfrm>
-          <a:off x="0" y="0"/>
-          <a:ext cx="0" cy="0"/>
-          <a:chOff x="0" y="0"/>
-          <a:chExt cx="0" cy="0"/>
-        </a:xfrm>
-      </p:grpSpPr>
-      <p:sp>
-        <p:nvSpPr>
-          <p:cNvPr id="2" name="Slide Image Placeholder 1"/>
-          <p:cNvSpPr>
-            <a:spLocks noGrp="1" noRot="1" noChangeAspect="1"/>
-          </p:cNvSpPr>
-          <p:nvPr>
-            <p:ph type="sldImg"/>
-          </p:nvPr>
-        </p:nvSpPr>
-        <p:spPr/>
-      </p:sp>
-      <p:sp>
-        <p:nvSpPr>
-          <p:cNvPr id="3" name="Notes Placeholder 2"/>
-          <p:cNvSpPr>
-            <a:spLocks noGrp="1"/>
-          </p:cNvSpPr>
-          <p:nvPr>
-            <p:ph type="body" idx="1"/>
-          </p:nvPr>
-        </p:nvSpPr>
-        <p:spPr/>
-        <p:txBody>
-          <a:bodyPr/>
-          <a:lstStyle/>
-          <a:p>
-            <a:r>
-              <a:rPr lang="en-US" dirty="0"/>
-              <a:t>Phil and Bob help field questions.</a:t>
-            </a:r>
-            <a:endParaRPr lang="en-US" dirty="0"/>
-          </a:p>
-        </p:txBody>
-      </p:sp>
-      <p:sp>
-        <p:nvSpPr>
-          <p:cNvPr id="4" name="Slide Number Placeholder 3"/>
-          <p:cNvSpPr>
-            <a:spLocks noGrp="1"/>
-          </p:cNvSpPr>
-          <p:nvPr>
-            <p:ph type="sldNum" sz="quarter" idx="10"/>
-          </p:nvPr>
-        </p:nvSpPr>
-        <p:spPr/>
-        <p:txBody>
-          <a:bodyPr/>
-          <a:lstStyle/>
-          <a:p>
-            <a:fld id="{F7021451-1387-4CA6-816F-3879F97B5CBC}" type="slidenum">
-              <a:rPr lang="en-US"/>
-              <a:t>22</a:t>
-            </a:fld>
-            <a:endParaRPr lang="en-US"/>
-          </a:p>
-        </p:txBody>
-      </p:sp>
-    </p:spTree>
-    <p:extLst>
-      <p:ext uri="{BB962C8B-B14F-4D97-AF65-F5344CB8AC3E}">
-        <p14:creationId xmlns:p14="http://schemas.microsoft.com/office/powerpoint/2010/main" val="1024086991"/>
-      </p:ext>
-    </p:extLst>
-  </p:cSld>
-  <p:clrMapOvr>
-    <a:masterClrMapping/>
-  </p:clrMapOvr>
-</p:notes>
-</file>
-
 <file path=ppt/notesSlides/notesSlide3.xml><?xml version="1.0" encoding="utf-8"?>
 <p:notes xmlns:a="http://schemas.openxmlformats.org/drawingml/2006/main" xmlns:r="http://schemas.openxmlformats.org/officeDocument/2006/relationships" xmlns:p="http://schemas.openxmlformats.org/presentationml/2006/main">
   <p:cSld>
@@ -2602,7 +1890,7 @@
           <a:p>
             <a:r>
               <a:rPr lang="en-US" dirty="0"/>
-              <a:t>Fly-through 1: gas turbine auxiliaries. Follow the field cable from the electrical room to the turbine package (application guide p.4). Auxiliary motor power, package controls, process measurements. Source: Southwire combined-cycle wire &amp; cable application guide and HRSG views.</a:t>
+              <a:t>Areas 01 to 09: gas turbine auxiliaries (guide p.4), HRSGs and field instrumentation (p.7), steam turbine auxiliaries (p.8), fuel-gas metering and conditioning (p.19). Each tile shows the connections in the area and the stock cable Southwire references for them. Source: Southwire combined-cycle wire &amp; cable application guide.</a:t>
             </a:r>
             <a:endParaRPr lang="en-US" dirty="0"/>
           </a:p>
@@ -3145,7 +2433,7 @@
     <p:bg>
       <p:bgPr>
         <a:solidFill>
-          <a:srgbClr val="FFFFFF"/>
+          <a:srgbClr val="F4F6F8"/>
         </a:solidFill>
       </p:bgPr>
     </p:bg>
@@ -3163,9 +2451,80 @@
           <a:chExt cx="0" cy="0"/>
         </a:xfrm>
       </p:grpSpPr>
+      <p:sp>
+        <p:nvSpPr>
+          <p:cNvPr id="2" name="Text 0"/>
+          <p:cNvSpPr txBox="1"/>
+          <p:nvPr/>
+        </p:nvSpPr>
+        <p:spPr>
+          <a:xfrm>
+            <a:off x="457200" y="182880"/>
+            <a:ext cx="8229600" cy="548640"/>
+          </a:xfrm>
+          <a:prstGeom prst="rect">
+            <a:avLst/>
+          </a:prstGeom>
+          <a:noFill/>
+          <a:ln/>
+        </p:spPr>
+        <p:txBody>
+          <a:bodyPr wrap="square" lIns="0" tIns="0" rIns="0" bIns="0" rtlCol="0" anchor="ctr"/>
+          <a:lstStyle/>
+          <a:p>
+            <a:pPr indent="0" marL="0">
+              <a:buNone/>
+            </a:pPr>
+            <a:r>
+              <a:rPr lang="en-US" sz="2600" b="1" dirty="0">
+                <a:solidFill>
+                  <a:srgbClr val="0F1B2D"/>
+                </a:solidFill>
+                <a:latin typeface="Cambria" pitchFamily="34" charset="0"/>
+                <a:ea typeface="Cambria" pitchFamily="34" charset="-122"/>
+                <a:cs typeface="Cambria" pitchFamily="34" charset="-120"/>
+              </a:rPr>
+              <a:t>Catalog: distribution, grid and grounding</a:t>
+            </a:r>
+            <a:endParaRPr lang="en-US" sz="2600" dirty="0"/>
+          </a:p>
+        </p:txBody>
+      </p:sp>
+      <p:sp>
+        <p:nvSpPr>
+          <p:cNvPr id="3" name="Shape 1"/>
+          <p:cNvSpPr/>
+          <p:nvPr/>
+        </p:nvSpPr>
+        <p:spPr>
+          <a:xfrm>
+            <a:off x="548640" y="868680"/>
+            <a:ext cx="3794760" cy="2020824"/>
+          </a:xfrm>
+          <a:prstGeom prst="rect">
+            <a:avLst/>
+          </a:prstGeom>
+          <a:solidFill>
+            <a:srgbClr val="FFFFFF"/>
+          </a:solidFill>
+          <a:ln w="9525">
+            <a:solidFill>
+              <a:srgbClr val="E3E8EE"/>
+            </a:solidFill>
+            <a:prstDash val="solid"/>
+          </a:ln>
+          <a:effectLst>
+            <a:outerShdw sx="100000" sy="100000" kx="0" ky="0" algn="bl" rotWithShape="0" blurRad="76200" dist="25400" dir="5400000">
+              <a:srgbClr val="000000">
+                <a:alpha val="12000"/>
+              </a:srgbClr>
+            </a:outerShdw>
+          </a:effectLst>
+        </p:spPr>
+      </p:sp>
       <p:pic>
         <p:nvPicPr>
-          <p:cNvPr id="2" name="Image 0" descr="/home/user/ln/presentations/flythrough/hrsg_p2.jpg">    </p:cNvPr>
+          <p:cNvPr id="4" name="Image 0" descr="/home/user/ln/presentations/catalog/zone_p10.jpg">    </p:cNvPr>
           <p:cNvPicPr>
             <a:picLocks noChangeAspect="1"/>
           </p:cNvPicPr>
@@ -3179,8 +2538,176 @@
         </p:blipFill>
         <p:spPr>
           <a:xfrm>
-            <a:off x="1143000" y="0"/>
-            <a:ext cx="6858000" cy="5143500"/>
+            <a:off x="548640" y="868680"/>
+            <a:ext cx="3794760" cy="2020824"/>
+          </a:xfrm>
+          <a:prstGeom prst="rect">
+            <a:avLst/>
+          </a:prstGeom>
+        </p:spPr>
+      </p:pic>
+      <p:sp>
+        <p:nvSpPr>
+          <p:cNvPr id="5" name="Shape 2"/>
+          <p:cNvSpPr/>
+          <p:nvPr/>
+        </p:nvSpPr>
+        <p:spPr>
+          <a:xfrm>
+            <a:off x="4526280" y="868680"/>
+            <a:ext cx="3794760" cy="2020824"/>
+          </a:xfrm>
+          <a:prstGeom prst="rect">
+            <a:avLst/>
+          </a:prstGeom>
+          <a:solidFill>
+            <a:srgbClr val="FFFFFF"/>
+          </a:solidFill>
+          <a:ln w="9525">
+            <a:solidFill>
+              <a:srgbClr val="E3E8EE"/>
+            </a:solidFill>
+            <a:prstDash val="solid"/>
+          </a:ln>
+          <a:effectLst>
+            <a:outerShdw sx="100000" sy="100000" kx="0" ky="0" algn="bl" rotWithShape="0" blurRad="76200" dist="25400" dir="5400000">
+              <a:srgbClr val="000000">
+                <a:alpha val="12000"/>
+              </a:srgbClr>
+            </a:outerShdw>
+          </a:effectLst>
+        </p:spPr>
+      </p:sp>
+      <p:pic>
+        <p:nvPicPr>
+          <p:cNvPr id="6" name="Image 1" descr="/home/user/ln/presentations/catalog/zone_p20.jpg">    </p:cNvPr>
+          <p:cNvPicPr>
+            <a:picLocks noChangeAspect="1"/>
+          </p:cNvPicPr>
+          <p:nvPr/>
+        </p:nvPicPr>
+        <p:blipFill>
+          <a:blip r:embed="rId2"/>
+          <a:stretch>
+            <a:fillRect/>
+          </a:stretch>
+        </p:blipFill>
+        <p:spPr>
+          <a:xfrm>
+            <a:off x="4526280" y="868680"/>
+            <a:ext cx="3794760" cy="2020824"/>
+          </a:xfrm>
+          <a:prstGeom prst="rect">
+            <a:avLst/>
+          </a:prstGeom>
+        </p:spPr>
+      </p:pic>
+      <p:sp>
+        <p:nvSpPr>
+          <p:cNvPr id="7" name="Shape 3"/>
+          <p:cNvSpPr/>
+          <p:nvPr/>
+        </p:nvSpPr>
+        <p:spPr>
+          <a:xfrm>
+            <a:off x="548640" y="2999232"/>
+            <a:ext cx="3794760" cy="2020824"/>
+          </a:xfrm>
+          <a:prstGeom prst="rect">
+            <a:avLst/>
+          </a:prstGeom>
+          <a:solidFill>
+            <a:srgbClr val="FFFFFF"/>
+          </a:solidFill>
+          <a:ln w="9525">
+            <a:solidFill>
+              <a:srgbClr val="E3E8EE"/>
+            </a:solidFill>
+            <a:prstDash val="solid"/>
+          </a:ln>
+          <a:effectLst>
+            <a:outerShdw sx="100000" sy="100000" kx="0" ky="0" algn="bl" rotWithShape="0" blurRad="76200" dist="25400" dir="5400000">
+              <a:srgbClr val="000000">
+                <a:alpha val="12000"/>
+              </a:srgbClr>
+            </a:outerShdw>
+          </a:effectLst>
+        </p:spPr>
+      </p:sp>
+      <p:pic>
+        <p:nvPicPr>
+          <p:cNvPr id="8" name="Image 2" descr="/home/user/ln/presentations/catalog/zone_p21.jpg">    </p:cNvPr>
+          <p:cNvPicPr>
+            <a:picLocks noChangeAspect="1"/>
+          </p:cNvPicPr>
+          <p:nvPr/>
+        </p:nvPicPr>
+        <p:blipFill>
+          <a:blip r:embed="rId3"/>
+          <a:stretch>
+            <a:fillRect/>
+          </a:stretch>
+        </p:blipFill>
+        <p:spPr>
+          <a:xfrm>
+            <a:off x="548640" y="2999232"/>
+            <a:ext cx="3794760" cy="2020824"/>
+          </a:xfrm>
+          <a:prstGeom prst="rect">
+            <a:avLst/>
+          </a:prstGeom>
+        </p:spPr>
+      </p:pic>
+      <p:sp>
+        <p:nvSpPr>
+          <p:cNvPr id="9" name="Shape 4"/>
+          <p:cNvSpPr/>
+          <p:nvPr/>
+        </p:nvSpPr>
+        <p:spPr>
+          <a:xfrm>
+            <a:off x="4526280" y="2999232"/>
+            <a:ext cx="3794760" cy="2020824"/>
+          </a:xfrm>
+          <a:prstGeom prst="rect">
+            <a:avLst/>
+          </a:prstGeom>
+          <a:solidFill>
+            <a:srgbClr val="FFFFFF"/>
+          </a:solidFill>
+          <a:ln w="9525">
+            <a:solidFill>
+              <a:srgbClr val="E3E8EE"/>
+            </a:solidFill>
+            <a:prstDash val="solid"/>
+          </a:ln>
+          <a:effectLst>
+            <a:outerShdw sx="100000" sy="100000" kx="0" ky="0" algn="bl" rotWithShape="0" blurRad="76200" dist="25400" dir="5400000">
+              <a:srgbClr val="000000">
+                <a:alpha val="12000"/>
+              </a:srgbClr>
+            </a:outerShdw>
+          </a:effectLst>
+        </p:spPr>
+      </p:sp>
+      <p:pic>
+        <p:nvPicPr>
+          <p:cNvPr id="10" name="Image 3" descr="/home/user/ln/presentations/catalog/zone_p23.jpg">    </p:cNvPr>
+          <p:cNvPicPr>
+            <a:picLocks noChangeAspect="1"/>
+          </p:cNvPicPr>
+          <p:nvPr/>
+        </p:nvPicPr>
+        <p:blipFill>
+          <a:blip r:embed="rId4"/>
+          <a:stretch>
+            <a:fillRect/>
+          </a:stretch>
+        </p:blipFill>
+        <p:spPr>
+          <a:xfrm>
+            <a:off x="4526280" y="2999232"/>
+            <a:ext cx="3794760" cy="2020824"/>
           </a:xfrm>
           <a:prstGeom prst="rect">
             <a:avLst/>
@@ -3198,454 +2725,6 @@
 <file path=ppt/slides/slide11.xml><?xml version="1.0" encoding="utf-8"?>
 <p:sld xmlns:a="http://schemas.openxmlformats.org/drawingml/2006/main" xmlns:r="http://schemas.openxmlformats.org/officeDocument/2006/relationships" xmlns:p="http://schemas.openxmlformats.org/presentationml/2006/main">
   <p:cSld name="Slide 11">
-    <p:bg>
-      <p:bgPr>
-        <a:solidFill>
-          <a:srgbClr val="FFFFFF"/>
-        </a:solidFill>
-      </p:bgPr>
-    </p:bg>
-    <p:spTree>
-      <p:nvGrpSpPr>
-        <p:cNvPr id="1" name=""/>
-        <p:cNvGrpSpPr/>
-        <p:nvPr/>
-      </p:nvGrpSpPr>
-      <p:grpSpPr>
-        <a:xfrm>
-          <a:off x="0" y="0"/>
-          <a:ext cx="0" cy="0"/>
-          <a:chOff x="0" y="0"/>
-          <a:chExt cx="0" cy="0"/>
-        </a:xfrm>
-      </p:grpSpPr>
-      <p:pic>
-        <p:nvPicPr>
-          <p:cNvPr id="2" name="Image 0" descr="/home/user/ln/presentations/flythrough/hrsg_p3.jpg">    </p:cNvPr>
-          <p:cNvPicPr>
-            <a:picLocks noChangeAspect="1"/>
-          </p:cNvPicPr>
-          <p:nvPr/>
-        </p:nvPicPr>
-        <p:blipFill>
-          <a:blip r:embed="rId1"/>
-          <a:stretch>
-            <a:fillRect/>
-          </a:stretch>
-        </p:blipFill>
-        <p:spPr>
-          <a:xfrm>
-            <a:off x="1143000" y="0"/>
-            <a:ext cx="6858000" cy="5143500"/>
-          </a:xfrm>
-          <a:prstGeom prst="rect">
-            <a:avLst/>
-          </a:prstGeom>
-        </p:spPr>
-      </p:pic>
-    </p:spTree>
-  </p:cSld>
-  <p:clrMapOvr>
-    <a:masterClrMapping/>
-  </p:clrMapOvr>
-</p:sld>
-</file>
-
-<file path=ppt/slides/slide12.xml><?xml version="1.0" encoding="utf-8"?>
-<p:sld xmlns:a="http://schemas.openxmlformats.org/drawingml/2006/main" xmlns:r="http://schemas.openxmlformats.org/officeDocument/2006/relationships" xmlns:p="http://schemas.openxmlformats.org/presentationml/2006/main">
-  <p:cSld name="Slide 12">
-    <p:bg>
-      <p:bgPr>
-        <a:solidFill>
-          <a:srgbClr val="FFFFFF"/>
-        </a:solidFill>
-      </p:bgPr>
-    </p:bg>
-    <p:spTree>
-      <p:nvGrpSpPr>
-        <p:cNvPr id="1" name=""/>
-        <p:cNvGrpSpPr/>
-        <p:nvPr/>
-      </p:nvGrpSpPr>
-      <p:grpSpPr>
-        <a:xfrm>
-          <a:off x="0" y="0"/>
-          <a:ext cx="0" cy="0"/>
-          <a:chOff x="0" y="0"/>
-          <a:chExt cx="0" cy="0"/>
-        </a:xfrm>
-      </p:grpSpPr>
-      <p:pic>
-        <p:nvPicPr>
-          <p:cNvPr id="2" name="Image 0" descr="/home/user/ln/presentations/flythrough/cc_p07.jpg">    </p:cNvPr>
-          <p:cNvPicPr>
-            <a:picLocks noChangeAspect="1"/>
-          </p:cNvPicPr>
-          <p:nvPr/>
-        </p:nvPicPr>
-        <p:blipFill>
-          <a:blip r:embed="rId1"/>
-          <a:stretch>
-            <a:fillRect/>
-          </a:stretch>
-        </p:blipFill>
-        <p:spPr>
-          <a:xfrm>
-            <a:off x="0" y="0"/>
-            <a:ext cx="9144000" cy="5143500"/>
-          </a:xfrm>
-          <a:prstGeom prst="rect">
-            <a:avLst/>
-          </a:prstGeom>
-        </p:spPr>
-      </p:pic>
-    </p:spTree>
-  </p:cSld>
-  <p:clrMapOvr>
-    <a:masterClrMapping/>
-  </p:clrMapOvr>
-</p:sld>
-</file>
-
-<file path=ppt/slides/slide13.xml><?xml version="1.0" encoding="utf-8"?>
-<p:sld xmlns:a="http://schemas.openxmlformats.org/drawingml/2006/main" xmlns:r="http://schemas.openxmlformats.org/officeDocument/2006/relationships" xmlns:p="http://schemas.openxmlformats.org/presentationml/2006/main">
-  <p:cSld name="Slide 13">
-    <p:bg>
-      <p:bgPr>
-        <a:solidFill>
-          <a:srgbClr val="FFFFFF"/>
-        </a:solidFill>
-      </p:bgPr>
-    </p:bg>
-    <p:spTree>
-      <p:nvGrpSpPr>
-        <p:cNvPr id="1" name=""/>
-        <p:cNvGrpSpPr/>
-        <p:nvPr/>
-      </p:nvGrpSpPr>
-      <p:grpSpPr>
-        <a:xfrm>
-          <a:off x="0" y="0"/>
-          <a:ext cx="0" cy="0"/>
-          <a:chOff x="0" y="0"/>
-          <a:chExt cx="0" cy="0"/>
-        </a:xfrm>
-      </p:grpSpPr>
-      <p:pic>
-        <p:nvPicPr>
-          <p:cNvPr id="2" name="Image 0" descr="/home/user/ln/presentations/flythrough/cc_p08.jpg">    </p:cNvPr>
-          <p:cNvPicPr>
-            <a:picLocks noChangeAspect="1"/>
-          </p:cNvPicPr>
-          <p:nvPr/>
-        </p:nvPicPr>
-        <p:blipFill>
-          <a:blip r:embed="rId1"/>
-          <a:stretch>
-            <a:fillRect/>
-          </a:stretch>
-        </p:blipFill>
-        <p:spPr>
-          <a:xfrm>
-            <a:off x="0" y="0"/>
-            <a:ext cx="9144000" cy="5143500"/>
-          </a:xfrm>
-          <a:prstGeom prst="rect">
-            <a:avLst/>
-          </a:prstGeom>
-        </p:spPr>
-      </p:pic>
-    </p:spTree>
-  </p:cSld>
-  <p:clrMapOvr>
-    <a:masterClrMapping/>
-  </p:clrMapOvr>
-</p:sld>
-</file>
-
-<file path=ppt/slides/slide14.xml><?xml version="1.0" encoding="utf-8"?>
-<p:sld xmlns:a="http://schemas.openxmlformats.org/drawingml/2006/main" xmlns:r="http://schemas.openxmlformats.org/officeDocument/2006/relationships" xmlns:p="http://schemas.openxmlformats.org/presentationml/2006/main">
-  <p:cSld name="Slide 14">
-    <p:bg>
-      <p:bgPr>
-        <a:solidFill>
-          <a:srgbClr val="FFFFFF"/>
-        </a:solidFill>
-      </p:bgPr>
-    </p:bg>
-    <p:spTree>
-      <p:nvGrpSpPr>
-        <p:cNvPr id="1" name=""/>
-        <p:cNvGrpSpPr/>
-        <p:nvPr/>
-      </p:nvGrpSpPr>
-      <p:grpSpPr>
-        <a:xfrm>
-          <a:off x="0" y="0"/>
-          <a:ext cx="0" cy="0"/>
-          <a:chOff x="0" y="0"/>
-          <a:chExt cx="0" cy="0"/>
-        </a:xfrm>
-      </p:grpSpPr>
-      <p:pic>
-        <p:nvPicPr>
-          <p:cNvPr id="2" name="Image 0" descr="/home/user/ln/presentations/flythrough/cc_p19.jpg">    </p:cNvPr>
-          <p:cNvPicPr>
-            <a:picLocks noChangeAspect="1"/>
-          </p:cNvPicPr>
-          <p:nvPr/>
-        </p:nvPicPr>
-        <p:blipFill>
-          <a:blip r:embed="rId1"/>
-          <a:stretch>
-            <a:fillRect/>
-          </a:stretch>
-        </p:blipFill>
-        <p:spPr>
-          <a:xfrm>
-            <a:off x="0" y="0"/>
-            <a:ext cx="9144000" cy="5143500"/>
-          </a:xfrm>
-          <a:prstGeom prst="rect">
-            <a:avLst/>
-          </a:prstGeom>
-        </p:spPr>
-      </p:pic>
-    </p:spTree>
-  </p:cSld>
-  <p:clrMapOvr>
-    <a:masterClrMapping/>
-  </p:clrMapOvr>
-</p:sld>
-</file>
-
-<file path=ppt/slides/slide15.xml><?xml version="1.0" encoding="utf-8"?>
-<p:sld xmlns:a="http://schemas.openxmlformats.org/drawingml/2006/main" xmlns:r="http://schemas.openxmlformats.org/officeDocument/2006/relationships" xmlns:p="http://schemas.openxmlformats.org/presentationml/2006/main">
-  <p:cSld name="Slide 15">
-    <p:bg>
-      <p:bgPr>
-        <a:solidFill>
-          <a:srgbClr val="FFFFFF"/>
-        </a:solidFill>
-      </p:bgPr>
-    </p:bg>
-    <p:spTree>
-      <p:nvGrpSpPr>
-        <p:cNvPr id="1" name=""/>
-        <p:cNvGrpSpPr/>
-        <p:nvPr/>
-      </p:nvGrpSpPr>
-      <p:grpSpPr>
-        <a:xfrm>
-          <a:off x="0" y="0"/>
-          <a:ext cx="0" cy="0"/>
-          <a:chOff x="0" y="0"/>
-          <a:chExt cx="0" cy="0"/>
-        </a:xfrm>
-      </p:grpSpPr>
-      <p:pic>
-        <p:nvPicPr>
-          <p:cNvPr id="2" name="Image 0" descr="/home/user/ln/presentations/flythrough/cc_p10.jpg">    </p:cNvPr>
-          <p:cNvPicPr>
-            <a:picLocks noChangeAspect="1"/>
-          </p:cNvPicPr>
-          <p:nvPr/>
-        </p:nvPicPr>
-        <p:blipFill>
-          <a:blip r:embed="rId1"/>
-          <a:stretch>
-            <a:fillRect/>
-          </a:stretch>
-        </p:blipFill>
-        <p:spPr>
-          <a:xfrm>
-            <a:off x="0" y="0"/>
-            <a:ext cx="9144000" cy="5143500"/>
-          </a:xfrm>
-          <a:prstGeom prst="rect">
-            <a:avLst/>
-          </a:prstGeom>
-        </p:spPr>
-      </p:pic>
-    </p:spTree>
-  </p:cSld>
-  <p:clrMapOvr>
-    <a:masterClrMapping/>
-  </p:clrMapOvr>
-</p:sld>
-</file>
-
-<file path=ppt/slides/slide16.xml><?xml version="1.0" encoding="utf-8"?>
-<p:sld xmlns:a="http://schemas.openxmlformats.org/drawingml/2006/main" xmlns:r="http://schemas.openxmlformats.org/officeDocument/2006/relationships" xmlns:p="http://schemas.openxmlformats.org/presentationml/2006/main">
-  <p:cSld name="Slide 16">
-    <p:bg>
-      <p:bgPr>
-        <a:solidFill>
-          <a:srgbClr val="FFFFFF"/>
-        </a:solidFill>
-      </p:bgPr>
-    </p:bg>
-    <p:spTree>
-      <p:nvGrpSpPr>
-        <p:cNvPr id="1" name=""/>
-        <p:cNvGrpSpPr/>
-        <p:nvPr/>
-      </p:nvGrpSpPr>
-      <p:grpSpPr>
-        <a:xfrm>
-          <a:off x="0" y="0"/>
-          <a:ext cx="0" cy="0"/>
-          <a:chOff x="0" y="0"/>
-          <a:chExt cx="0" cy="0"/>
-        </a:xfrm>
-      </p:grpSpPr>
-      <p:pic>
-        <p:nvPicPr>
-          <p:cNvPr id="2" name="Image 0" descr="/home/user/ln/presentations/flythrough/cc_p20.jpg">    </p:cNvPr>
-          <p:cNvPicPr>
-            <a:picLocks noChangeAspect="1"/>
-          </p:cNvPicPr>
-          <p:nvPr/>
-        </p:nvPicPr>
-        <p:blipFill>
-          <a:blip r:embed="rId1"/>
-          <a:stretch>
-            <a:fillRect/>
-          </a:stretch>
-        </p:blipFill>
-        <p:spPr>
-          <a:xfrm>
-            <a:off x="0" y="0"/>
-            <a:ext cx="9144000" cy="5143500"/>
-          </a:xfrm>
-          <a:prstGeom prst="rect">
-            <a:avLst/>
-          </a:prstGeom>
-        </p:spPr>
-      </p:pic>
-    </p:spTree>
-  </p:cSld>
-  <p:clrMapOvr>
-    <a:masterClrMapping/>
-  </p:clrMapOvr>
-</p:sld>
-</file>
-
-<file path=ppt/slides/slide17.xml><?xml version="1.0" encoding="utf-8"?>
-<p:sld xmlns:a="http://schemas.openxmlformats.org/drawingml/2006/main" xmlns:r="http://schemas.openxmlformats.org/officeDocument/2006/relationships" xmlns:p="http://schemas.openxmlformats.org/presentationml/2006/main">
-  <p:cSld name="Slide 17">
-    <p:bg>
-      <p:bgPr>
-        <a:solidFill>
-          <a:srgbClr val="FFFFFF"/>
-        </a:solidFill>
-      </p:bgPr>
-    </p:bg>
-    <p:spTree>
-      <p:nvGrpSpPr>
-        <p:cNvPr id="1" name=""/>
-        <p:cNvGrpSpPr/>
-        <p:nvPr/>
-      </p:nvGrpSpPr>
-      <p:grpSpPr>
-        <a:xfrm>
-          <a:off x="0" y="0"/>
-          <a:ext cx="0" cy="0"/>
-          <a:chOff x="0" y="0"/>
-          <a:chExt cx="0" cy="0"/>
-        </a:xfrm>
-      </p:grpSpPr>
-      <p:pic>
-        <p:nvPicPr>
-          <p:cNvPr id="2" name="Image 0" descr="/home/user/ln/presentations/flythrough/cc_p21.jpg">    </p:cNvPr>
-          <p:cNvPicPr>
-            <a:picLocks noChangeAspect="1"/>
-          </p:cNvPicPr>
-          <p:nvPr/>
-        </p:nvPicPr>
-        <p:blipFill>
-          <a:blip r:embed="rId1"/>
-          <a:stretch>
-            <a:fillRect/>
-          </a:stretch>
-        </p:blipFill>
-        <p:spPr>
-          <a:xfrm>
-            <a:off x="0" y="0"/>
-            <a:ext cx="9144000" cy="5143500"/>
-          </a:xfrm>
-          <a:prstGeom prst="rect">
-            <a:avLst/>
-          </a:prstGeom>
-        </p:spPr>
-      </p:pic>
-    </p:spTree>
-  </p:cSld>
-  <p:clrMapOvr>
-    <a:masterClrMapping/>
-  </p:clrMapOvr>
-</p:sld>
-</file>
-
-<file path=ppt/slides/slide18.xml><?xml version="1.0" encoding="utf-8"?>
-<p:sld xmlns:a="http://schemas.openxmlformats.org/drawingml/2006/main" xmlns:r="http://schemas.openxmlformats.org/officeDocument/2006/relationships" xmlns:p="http://schemas.openxmlformats.org/presentationml/2006/main">
-  <p:cSld name="Slide 18">
-    <p:bg>
-      <p:bgPr>
-        <a:solidFill>
-          <a:srgbClr val="FFFFFF"/>
-        </a:solidFill>
-      </p:bgPr>
-    </p:bg>
-    <p:spTree>
-      <p:nvGrpSpPr>
-        <p:cNvPr id="1" name=""/>
-        <p:cNvGrpSpPr/>
-        <p:nvPr/>
-      </p:nvGrpSpPr>
-      <p:grpSpPr>
-        <a:xfrm>
-          <a:off x="0" y="0"/>
-          <a:ext cx="0" cy="0"/>
-          <a:chOff x="0" y="0"/>
-          <a:chExt cx="0" cy="0"/>
-        </a:xfrm>
-      </p:grpSpPr>
-      <p:pic>
-        <p:nvPicPr>
-          <p:cNvPr id="2" name="Image 0" descr="/home/user/ln/presentations/flythrough/cc_p23.jpg">    </p:cNvPr>
-          <p:cNvPicPr>
-            <a:picLocks noChangeAspect="1"/>
-          </p:cNvPicPr>
-          <p:nvPr/>
-        </p:nvPicPr>
-        <p:blipFill>
-          <a:blip r:embed="rId1"/>
-          <a:stretch>
-            <a:fillRect/>
-          </a:stretch>
-        </p:blipFill>
-        <p:spPr>
-          <a:xfrm>
-            <a:off x="0" y="0"/>
-            <a:ext cx="9144000" cy="5143500"/>
-          </a:xfrm>
-          <a:prstGeom prst="rect">
-            <a:avLst/>
-          </a:prstGeom>
-        </p:spPr>
-      </p:pic>
-    </p:spTree>
-  </p:cSld>
-  <p:clrMapOvr>
-    <a:masterClrMapping/>
-  </p:clrMapOvr>
-</p:sld>
-</file>
-
-<file path=ppt/slides/slide19.xml><?xml version="1.0" encoding="utf-8"?>
-<p:sld xmlns:a="http://schemas.openxmlformats.org/drawingml/2006/main" xmlns:r="http://schemas.openxmlformats.org/officeDocument/2006/relationships" xmlns:p="http://schemas.openxmlformats.org/presentationml/2006/main">
-  <p:cSld name="Slide 19">
     <p:bg>
       <p:bgPr>
         <a:solidFill>
@@ -4627,9 +3706,1311 @@
                 <a:ea typeface="Calibri" pitchFamily="34" charset="-122"/>
                 <a:cs typeface="Calibri" pitchFamily="34" charset="-120"/>
               </a:rPr>
-              <a:t>19</a:t>
+              <a:t>11</a:t>
             </a:r>
             <a:endParaRPr lang="en-US" sz="1000" dirty="0"/>
+          </a:p>
+        </p:txBody>
+      </p:sp>
+    </p:spTree>
+  </p:cSld>
+  <p:clrMapOvr>
+    <a:masterClrMapping/>
+  </p:clrMapOvr>
+</p:sld>
+</file>
+
+<file path=ppt/slides/slide12.xml><?xml version="1.0" encoding="utf-8"?>
+<p:sld xmlns:a="http://schemas.openxmlformats.org/drawingml/2006/main" xmlns:r="http://schemas.openxmlformats.org/officeDocument/2006/relationships" xmlns:p="http://schemas.openxmlformats.org/presentationml/2006/main">
+  <p:cSld name="Slide 12">
+    <p:bg>
+      <p:bgPr>
+        <a:solidFill>
+          <a:srgbClr val="F4F6F8"/>
+        </a:solidFill>
+      </p:bgPr>
+    </p:bg>
+    <p:spTree>
+      <p:nvGrpSpPr>
+        <p:cNvPr id="1" name=""/>
+        <p:cNvGrpSpPr/>
+        <p:nvPr/>
+      </p:nvGrpSpPr>
+      <p:grpSpPr>
+        <a:xfrm>
+          <a:off x="0" y="0"/>
+          <a:ext cx="0" cy="0"/>
+          <a:chOff x="0" y="0"/>
+          <a:chExt cx="0" cy="0"/>
+        </a:xfrm>
+      </p:grpSpPr>
+      <p:sp>
+        <p:nvSpPr>
+          <p:cNvPr id="2" name="Text 0"/>
+          <p:cNvSpPr txBox="1"/>
+          <p:nvPr/>
+        </p:nvSpPr>
+        <p:spPr>
+          <a:xfrm>
+            <a:off x="457200" y="320040"/>
+            <a:ext cx="8229600" cy="731520"/>
+          </a:xfrm>
+          <a:prstGeom prst="rect">
+            <a:avLst/>
+          </a:prstGeom>
+          <a:noFill/>
+          <a:ln/>
+        </p:spPr>
+        <p:txBody>
+          <a:bodyPr wrap="square" lIns="0" tIns="0" rIns="0" bIns="0" rtlCol="0" anchor="ctr"/>
+          <a:lstStyle/>
+          <a:p>
+            <a:pPr indent="0" marL="0">
+              <a:buNone/>
+            </a:pPr>
+            <a:r>
+              <a:rPr lang="en-US" sz="2600" b="1" dirty="0">
+                <a:solidFill>
+                  <a:srgbClr val="0F1B2D"/>
+                </a:solidFill>
+                <a:latin typeface="Cambria" pitchFamily="34" charset="0"/>
+                <a:ea typeface="Cambria" pitchFamily="34" charset="-122"/>
+                <a:cs typeface="Cambria" pitchFamily="34" charset="-120"/>
+              </a:rPr>
+              <a:t>OEM market: who builds the plant</a:t>
+            </a:r>
+            <a:endParaRPr lang="en-US" sz="2600" dirty="0"/>
+          </a:p>
+        </p:txBody>
+      </p:sp>
+      <p:sp>
+        <p:nvSpPr>
+          <p:cNvPr id="3" name="Shape 1"/>
+          <p:cNvSpPr/>
+          <p:nvPr/>
+        </p:nvSpPr>
+        <p:spPr>
+          <a:xfrm>
+            <a:off x="457200" y="1280160"/>
+            <a:ext cx="3840480" cy="2743200"/>
+          </a:xfrm>
+          <a:prstGeom prst="rect">
+            <a:avLst/>
+          </a:prstGeom>
+          <a:solidFill>
+            <a:srgbClr val="FFFFFF"/>
+          </a:solidFill>
+          <a:ln w="9525">
+            <a:solidFill>
+              <a:srgbClr val="E3E8EE"/>
+            </a:solidFill>
+            <a:prstDash val="solid"/>
+          </a:ln>
+          <a:effectLst>
+            <a:outerShdw sx="100000" sy="100000" kx="0" ky="0" algn="bl" rotWithShape="0" blurRad="76200" dist="25400" dir="5400000">
+              <a:srgbClr val="000000">
+                <a:alpha val="12000"/>
+              </a:srgbClr>
+            </a:outerShdw>
+          </a:effectLst>
+        </p:spPr>
+      </p:sp>
+      <p:sp>
+        <p:nvSpPr>
+          <p:cNvPr id="4" name="Text 2"/>
+          <p:cNvSpPr txBox="1"/>
+          <p:nvPr/>
+        </p:nvSpPr>
+        <p:spPr>
+          <a:xfrm>
+            <a:off x="640080" y="1371600"/>
+            <a:ext cx="3474720" cy="274320"/>
+          </a:xfrm>
+          <a:prstGeom prst="rect">
+            <a:avLst/>
+          </a:prstGeom>
+          <a:noFill/>
+          <a:ln/>
+        </p:spPr>
+        <p:txBody>
+          <a:bodyPr wrap="square" lIns="0" tIns="0" rIns="0" bIns="0" rtlCol="0" anchor="ctr"/>
+          <a:lstStyle/>
+          <a:p>
+            <a:pPr indent="0" marL="0">
+              <a:buNone/>
+            </a:pPr>
+            <a:r>
+              <a:rPr lang="en-US" sz="1400" b="1" dirty="0">
+                <a:solidFill>
+                  <a:srgbClr val="0F1B2D"/>
+                </a:solidFill>
+                <a:latin typeface="Cambria" pitchFamily="34" charset="0"/>
+                <a:ea typeface="Cambria" pitchFamily="34" charset="-122"/>
+                <a:cs typeface="Cambria" pitchFamily="34" charset="-120"/>
+              </a:rPr>
+              <a:t>Large gas turbine backlog (GW)</a:t>
+            </a:r>
+            <a:endParaRPr lang="en-US" sz="1400" dirty="0"/>
+          </a:p>
+        </p:txBody>
+      </p:sp>
+      <p:graphicFrame>
+        <p:nvGraphicFramePr>
+          <p:cNvPr id="5" name="Chart 0" descr=""/>
+          <p:cNvGraphicFramePr/>
+          <p:nvPr/>
+        </p:nvGraphicFramePr>
+        <p:xfrm>
+          <a:off x="548640" y="1691640"/>
+          <a:ext cx="3657600" cy="2240280"/>
+        </p:xfrm>
+        <a:graphic xmlns:a="http://schemas.openxmlformats.org/drawingml/2006/main">
+          <a:graphicData uri="http://schemas.openxmlformats.org/drawingml/2006/chart">
+            <c:chart xmlns:c="http://schemas.openxmlformats.org/drawingml/2006/chart" r:id="rId1"/>
+          </a:graphicData>
+        </a:graphic>
+      </p:graphicFrame>
+      <p:sp>
+        <p:nvSpPr>
+          <p:cNvPr id="6" name="Shape 3"/>
+          <p:cNvSpPr/>
+          <p:nvPr/>
+        </p:nvSpPr>
+        <p:spPr>
+          <a:xfrm>
+            <a:off x="4572000" y="1280160"/>
+            <a:ext cx="4114800" cy="822960"/>
+          </a:xfrm>
+          <a:prstGeom prst="rect">
+            <a:avLst/>
+          </a:prstGeom>
+          <a:solidFill>
+            <a:srgbClr val="FFFFFF"/>
+          </a:solidFill>
+          <a:ln w="9525">
+            <a:solidFill>
+              <a:srgbClr val="E3E8EE"/>
+            </a:solidFill>
+            <a:prstDash val="solid"/>
+          </a:ln>
+          <a:effectLst>
+            <a:outerShdw sx="100000" sy="100000" kx="0" ky="0" algn="bl" rotWithShape="0" blurRad="76200" dist="25400" dir="5400000">
+              <a:srgbClr val="000000">
+                <a:alpha val="12000"/>
+              </a:srgbClr>
+            </a:outerShdw>
+          </a:effectLst>
+        </p:spPr>
+      </p:sp>
+      <p:sp>
+        <p:nvSpPr>
+          <p:cNvPr id="7" name="Text 4"/>
+          <p:cNvSpPr txBox="1"/>
+          <p:nvPr/>
+        </p:nvSpPr>
+        <p:spPr>
+          <a:xfrm>
+            <a:off x="4709160" y="1325880"/>
+            <a:ext cx="3840480" cy="731520"/>
+          </a:xfrm>
+          <a:prstGeom prst="rect">
+            <a:avLst/>
+          </a:prstGeom>
+          <a:noFill/>
+          <a:ln/>
+        </p:spPr>
+        <p:txBody>
+          <a:bodyPr wrap="square" lIns="0" tIns="0" rIns="0" bIns="0" rtlCol="0" anchor="ctr"/>
+          <a:lstStyle/>
+          <a:p>
+            <a:pPr indent="0" marL="0">
+              <a:buNone/>
+            </a:pPr>
+            <a:r>
+              <a:rPr lang="en-US" sz="1300" b="1" dirty="0">
+                <a:solidFill>
+                  <a:srgbClr val="0F1B2D"/>
+                </a:solidFill>
+                <a:latin typeface="Cambria" pitchFamily="34" charset="0"/>
+                <a:ea typeface="Cambria" pitchFamily="34" charset="-122"/>
+                <a:cs typeface="Cambria" pitchFamily="34" charset="-120"/>
+              </a:rPr>
+              <a:t>Turbine OEMs</a:t>
+            </a:r>
+            <a:endParaRPr lang="en-US" sz="1300" dirty="0"/>
+          </a:p>
+          <a:p>
+            <a:pPr indent="0" marL="0">
+              <a:buNone/>
+            </a:pPr>
+            <a:r>
+              <a:rPr lang="en-US" sz="1100" dirty="0">
+                <a:solidFill>
+                  <a:srgbClr val="5B6B7F"/>
+                </a:solidFill>
+                <a:latin typeface="Calibri" pitchFamily="34" charset="0"/>
+                <a:ea typeface="Calibri" pitchFamily="34" charset="-122"/>
+                <a:cs typeface="Calibri" pitchFamily="34" charset="-120"/>
+              </a:rPr>
+              <a:t>GE Vernova, Siemens Energy, Mitsubishi Heavy</a:t>
+            </a:r>
+            <a:endParaRPr lang="en-US" sz="1300" dirty="0"/>
+          </a:p>
+          <a:p>
+            <a:pPr indent="0" marL="0">
+              <a:buNone/>
+            </a:pPr>
+            <a:r>
+              <a:rPr lang="en-US" sz="1100" b="1" dirty="0">
+                <a:solidFill>
+                  <a:srgbClr val="C8742B"/>
+                </a:solidFill>
+                <a:latin typeface="Calibri" pitchFamily="34" charset="0"/>
+                <a:ea typeface="Calibri" pitchFamily="34" charset="-122"/>
+                <a:cs typeface="Calibri" pitchFamily="34" charset="-120"/>
+              </a:rPr>
+              <a:t>Southwire: MV, LV and control cable for OEM-built equipment</a:t>
+            </a:r>
+            <a:endParaRPr lang="en-US" sz="1300" dirty="0"/>
+          </a:p>
+        </p:txBody>
+      </p:sp>
+      <p:sp>
+        <p:nvSpPr>
+          <p:cNvPr id="8" name="Shape 5"/>
+          <p:cNvSpPr/>
+          <p:nvPr/>
+        </p:nvSpPr>
+        <p:spPr>
+          <a:xfrm>
+            <a:off x="4572000" y="2240280"/>
+            <a:ext cx="4114800" cy="822960"/>
+          </a:xfrm>
+          <a:prstGeom prst="rect">
+            <a:avLst/>
+          </a:prstGeom>
+          <a:solidFill>
+            <a:srgbClr val="FFFFFF"/>
+          </a:solidFill>
+          <a:ln w="9525">
+            <a:solidFill>
+              <a:srgbClr val="E3E8EE"/>
+            </a:solidFill>
+            <a:prstDash val="solid"/>
+          </a:ln>
+          <a:effectLst>
+            <a:outerShdw sx="100000" sy="100000" kx="0" ky="0" algn="bl" rotWithShape="0" blurRad="76200" dist="25400" dir="5400000">
+              <a:srgbClr val="000000">
+                <a:alpha val="12000"/>
+              </a:srgbClr>
+            </a:outerShdw>
+          </a:effectLst>
+        </p:spPr>
+      </p:sp>
+      <p:sp>
+        <p:nvSpPr>
+          <p:cNvPr id="9" name="Text 6"/>
+          <p:cNvSpPr txBox="1"/>
+          <p:nvPr/>
+        </p:nvSpPr>
+        <p:spPr>
+          <a:xfrm>
+            <a:off x="4709160" y="2286000"/>
+            <a:ext cx="3840480" cy="731520"/>
+          </a:xfrm>
+          <a:prstGeom prst="rect">
+            <a:avLst/>
+          </a:prstGeom>
+          <a:noFill/>
+          <a:ln/>
+        </p:spPr>
+        <p:txBody>
+          <a:bodyPr wrap="square" lIns="0" tIns="0" rIns="0" bIns="0" rtlCol="0" anchor="ctr"/>
+          <a:lstStyle/>
+          <a:p>
+            <a:pPr indent="0" marL="0">
+              <a:buNone/>
+            </a:pPr>
+            <a:r>
+              <a:rPr lang="en-US" sz="1300" b="1" dirty="0">
+                <a:solidFill>
+                  <a:srgbClr val="0F1B2D"/>
+                </a:solidFill>
+                <a:latin typeface="Cambria" pitchFamily="34" charset="0"/>
+                <a:ea typeface="Cambria" pitchFamily="34" charset="-122"/>
+                <a:cs typeface="Cambria" pitchFamily="34" charset="-120"/>
+              </a:rPr>
+              <a:t>Packagers and engine makers</a:t>
+            </a:r>
+            <a:endParaRPr lang="en-US" sz="1300" dirty="0"/>
+          </a:p>
+          <a:p>
+            <a:pPr indent="0" marL="0">
+              <a:buNone/>
+            </a:pPr>
+            <a:r>
+              <a:rPr lang="en-US" sz="1100" dirty="0">
+                <a:solidFill>
+                  <a:srgbClr val="5B6B7F"/>
+                </a:solidFill>
+                <a:latin typeface="Calibri" pitchFamily="34" charset="0"/>
+                <a:ea typeface="Calibri" pitchFamily="34" charset="-122"/>
+                <a:cs typeface="Calibri" pitchFamily="34" charset="-120"/>
+              </a:rPr>
+              <a:t>Solar Turbines (Caterpillar), Wartsila, energy-as-a-service developers</a:t>
+            </a:r>
+            <a:endParaRPr lang="en-US" sz="1300" dirty="0"/>
+          </a:p>
+          <a:p>
+            <a:pPr indent="0" marL="0">
+              <a:buNone/>
+            </a:pPr>
+            <a:r>
+              <a:rPr lang="en-US" sz="1100" b="1" dirty="0">
+                <a:solidFill>
+                  <a:srgbClr val="C8742B"/>
+                </a:solidFill>
+                <a:latin typeface="Calibri" pitchFamily="34" charset="0"/>
+                <a:ea typeface="Calibri" pitchFamily="34" charset="-122"/>
+                <a:cs typeface="Calibri" pitchFamily="34" charset="-120"/>
+              </a:rPr>
+              <a:t>Southwire: packaged and pre-terminated cable</a:t>
+            </a:r>
+            <a:endParaRPr lang="en-US" sz="1300" dirty="0"/>
+          </a:p>
+        </p:txBody>
+      </p:sp>
+      <p:sp>
+        <p:nvSpPr>
+          <p:cNvPr id="10" name="Shape 7"/>
+          <p:cNvSpPr/>
+          <p:nvPr/>
+        </p:nvSpPr>
+        <p:spPr>
+          <a:xfrm>
+            <a:off x="4572000" y="3200400"/>
+            <a:ext cx="4114800" cy="822960"/>
+          </a:xfrm>
+          <a:prstGeom prst="rect">
+            <a:avLst/>
+          </a:prstGeom>
+          <a:solidFill>
+            <a:srgbClr val="0F1B2D"/>
+          </a:solidFill>
+          <a:ln w="9525">
+            <a:solidFill>
+              <a:srgbClr val="0F1B2D"/>
+            </a:solidFill>
+            <a:prstDash val="solid"/>
+          </a:ln>
+          <a:effectLst>
+            <a:outerShdw sx="100000" sy="100000" kx="0" ky="0" algn="bl" rotWithShape="0" blurRad="76200" dist="25400" dir="5400000">
+              <a:srgbClr val="000000">
+                <a:alpha val="12000"/>
+              </a:srgbClr>
+            </a:outerShdw>
+          </a:effectLst>
+        </p:spPr>
+      </p:sp>
+      <p:sp>
+        <p:nvSpPr>
+          <p:cNvPr id="11" name="Text 8"/>
+          <p:cNvSpPr txBox="1"/>
+          <p:nvPr/>
+        </p:nvSpPr>
+        <p:spPr>
+          <a:xfrm>
+            <a:off x="4709160" y="3246120"/>
+            <a:ext cx="3840480" cy="731520"/>
+          </a:xfrm>
+          <a:prstGeom prst="rect">
+            <a:avLst/>
+          </a:prstGeom>
+          <a:noFill/>
+          <a:ln/>
+        </p:spPr>
+        <p:txBody>
+          <a:bodyPr wrap="square" lIns="0" tIns="0" rIns="0" bIns="0" rtlCol="0" anchor="ctr"/>
+          <a:lstStyle/>
+          <a:p>
+            <a:pPr indent="0" marL="0">
+              <a:buNone/>
+            </a:pPr>
+            <a:r>
+              <a:rPr lang="en-US" sz="1300" b="1" dirty="0">
+                <a:solidFill>
+                  <a:srgbClr val="FFFFFF"/>
+                </a:solidFill>
+                <a:latin typeface="Cambria" pitchFamily="34" charset="0"/>
+                <a:ea typeface="Cambria" pitchFamily="34" charset="-122"/>
+                <a:cs typeface="Cambria" pitchFamily="34" charset="-120"/>
+              </a:rPr>
+              <a:t>Data center on-site power</a:t>
+            </a:r>
+            <a:endParaRPr lang="en-US" sz="1300" dirty="0"/>
+          </a:p>
+          <a:p>
+            <a:pPr indent="0" marL="0">
+              <a:buNone/>
+            </a:pPr>
+            <a:r>
+              <a:rPr lang="en-US" sz="1100" dirty="0">
+                <a:solidFill>
+                  <a:srgbClr val="CADCFC"/>
+                </a:solidFill>
+                <a:latin typeface="Calibri" pitchFamily="34" charset="0"/>
+                <a:ea typeface="Calibri" pitchFamily="34" charset="-122"/>
+                <a:cs typeface="Calibri" pitchFamily="34" charset="-120"/>
+              </a:rPr>
+              <a:t>~56 GW planned behind-the-meter, 46 projects</a:t>
+            </a:r>
+            <a:endParaRPr lang="en-US" sz="1300" dirty="0"/>
+          </a:p>
+          <a:p>
+            <a:pPr indent="0" marL="0">
+              <a:buNone/>
+            </a:pPr>
+            <a:r>
+              <a:rPr lang="en-US" sz="1100" b="1" dirty="0">
+                <a:solidFill>
+                  <a:srgbClr val="C8742B"/>
+                </a:solidFill>
+                <a:latin typeface="Calibri" pitchFamily="34" charset="0"/>
+                <a:ea typeface="Calibri" pitchFamily="34" charset="-122"/>
+                <a:cs typeface="Calibri" pitchFamily="34" charset="-120"/>
+              </a:rPr>
+              <a:t>Southwire: full plant cable package</a:t>
+            </a:r>
+            <a:endParaRPr lang="en-US" sz="1300" dirty="0"/>
+          </a:p>
+        </p:txBody>
+      </p:sp>
+      <p:sp>
+        <p:nvSpPr>
+          <p:cNvPr id="12" name="Text 9"/>
+          <p:cNvSpPr txBox="1"/>
+          <p:nvPr/>
+        </p:nvSpPr>
+        <p:spPr>
+          <a:xfrm>
+            <a:off x="457200" y="4114800"/>
+            <a:ext cx="8229600" cy="274320"/>
+          </a:xfrm>
+          <a:prstGeom prst="rect">
+            <a:avLst/>
+          </a:prstGeom>
+          <a:noFill/>
+          <a:ln/>
+        </p:spPr>
+        <p:txBody>
+          <a:bodyPr wrap="square" lIns="0" tIns="0" rIns="0" bIns="0" rtlCol="0" anchor="ctr"/>
+          <a:lstStyle/>
+          <a:p>
+            <a:pPr indent="0" marL="0">
+              <a:buNone/>
+            </a:pPr>
+            <a:r>
+              <a:rPr lang="en-US" sz="1300" i="1" dirty="0">
+                <a:solidFill>
+                  <a:srgbClr val="5B6B7F"/>
+                </a:solidFill>
+                <a:latin typeface="Calibri" pitchFamily="34" charset="0"/>
+                <a:ea typeface="Calibri" pitchFamily="34" charset="-122"/>
+                <a:cs typeface="Calibri" pitchFamily="34" charset="-120"/>
+              </a:rPr>
+              <a:t>Where AXE adds value: logistics, inventory and project coordination for OEMs and packagers (to discuss).</a:t>
+            </a:r>
+            <a:endParaRPr lang="en-US" sz="1300" dirty="0"/>
+          </a:p>
+        </p:txBody>
+      </p:sp>
+      <p:sp>
+        <p:nvSpPr>
+          <p:cNvPr id="13" name="Text 10"/>
+          <p:cNvSpPr txBox="1"/>
+          <p:nvPr/>
+        </p:nvSpPr>
+        <p:spPr>
+          <a:xfrm>
+            <a:off x="457200" y="4462272"/>
+            <a:ext cx="8229600" cy="201168"/>
+          </a:xfrm>
+          <a:prstGeom prst="rect">
+            <a:avLst/>
+          </a:prstGeom>
+          <a:noFill/>
+          <a:ln/>
+        </p:spPr>
+        <p:txBody>
+          <a:bodyPr wrap="square" lIns="0" tIns="0" rIns="0" bIns="0" rtlCol="0" anchor="ctr"/>
+          <a:lstStyle/>
+          <a:p>
+            <a:pPr indent="0" marL="0">
+              <a:buNone/>
+            </a:pPr>
+            <a:r>
+              <a:rPr lang="en-US" sz="900" dirty="0">
+                <a:solidFill>
+                  <a:srgbClr val="5B6B7F"/>
+                </a:solidFill>
+                <a:latin typeface="Calibri" pitchFamily="34" charset="0"/>
+                <a:ea typeface="Calibri" pitchFamily="34" charset="-122"/>
+                <a:cs typeface="Calibri" pitchFamily="34" charset="-120"/>
+              </a:rPr>
+              <a:t>Sources: OEM Q2 2026 reports (GE Vernova, Siemens Energy, Mitsubishi Heavy); Cleanview BTM tracker; press reports.</a:t>
+            </a:r>
+            <a:endParaRPr lang="en-US" sz="900" dirty="0"/>
+          </a:p>
+        </p:txBody>
+      </p:sp>
+      <p:sp>
+        <p:nvSpPr>
+          <p:cNvPr id="14" name="Text 11"/>
+          <p:cNvSpPr txBox="1"/>
+          <p:nvPr/>
+        </p:nvSpPr>
+        <p:spPr>
+          <a:xfrm>
+            <a:off x="457200" y="4754880"/>
+            <a:ext cx="5486400" cy="228600"/>
+          </a:xfrm>
+          <a:prstGeom prst="rect">
+            <a:avLst/>
+          </a:prstGeom>
+          <a:noFill/>
+          <a:ln/>
+        </p:spPr>
+        <p:txBody>
+          <a:bodyPr wrap="square" lIns="0" tIns="0" rIns="0" bIns="0" rtlCol="0" anchor="ctr"/>
+          <a:lstStyle/>
+          <a:p>
+            <a:pPr indent="0" marL="0">
+              <a:buNone/>
+            </a:pPr>
+            <a:r>
+              <a:rPr lang="en-US" sz="1000" dirty="0">
+                <a:solidFill>
+                  <a:srgbClr val="5B6B7F"/>
+                </a:solidFill>
+                <a:latin typeface="Calibri" pitchFamily="34" charset="0"/>
+                <a:ea typeface="Calibri" pitchFamily="34" charset="-122"/>
+                <a:cs typeface="Calibri" pitchFamily="34" charset="-120"/>
+              </a:rPr>
+              <a:t>Southwire PowerGen  |  Anixter Global Accounts</a:t>
+            </a:r>
+            <a:endParaRPr lang="en-US" sz="1000" dirty="0"/>
+          </a:p>
+        </p:txBody>
+      </p:sp>
+      <p:sp>
+        <p:nvSpPr>
+          <p:cNvPr id="15" name="Text 12"/>
+          <p:cNvSpPr txBox="1"/>
+          <p:nvPr/>
+        </p:nvSpPr>
+        <p:spPr>
+          <a:xfrm>
+            <a:off x="8229600" y="4754880"/>
+            <a:ext cx="457200" cy="228600"/>
+          </a:xfrm>
+          <a:prstGeom prst="rect">
+            <a:avLst/>
+          </a:prstGeom>
+          <a:noFill/>
+          <a:ln/>
+        </p:spPr>
+        <p:txBody>
+          <a:bodyPr wrap="square" lIns="0" tIns="0" rIns="0" bIns="0" rtlCol="0" anchor="ctr"/>
+          <a:lstStyle/>
+          <a:p>
+            <a:pPr algn="r" indent="0" marL="0">
+              <a:buNone/>
+            </a:pPr>
+            <a:r>
+              <a:rPr lang="en-US" sz="1000" dirty="0">
+                <a:solidFill>
+                  <a:srgbClr val="5B6B7F"/>
+                </a:solidFill>
+                <a:latin typeface="Calibri" pitchFamily="34" charset="0"/>
+                <a:ea typeface="Calibri" pitchFamily="34" charset="-122"/>
+                <a:cs typeface="Calibri" pitchFamily="34" charset="-120"/>
+              </a:rPr>
+              <a:t>12</a:t>
+            </a:r>
+            <a:endParaRPr lang="en-US" sz="1000" dirty="0"/>
+          </a:p>
+        </p:txBody>
+      </p:sp>
+    </p:spTree>
+  </p:cSld>
+  <p:clrMapOvr>
+    <a:masterClrMapping/>
+  </p:clrMapOvr>
+</p:sld>
+</file>
+
+<file path=ppt/slides/slide13.xml><?xml version="1.0" encoding="utf-8"?>
+<p:sld xmlns:a="http://schemas.openxmlformats.org/drawingml/2006/main" xmlns:r="http://schemas.openxmlformats.org/officeDocument/2006/relationships" xmlns:p="http://schemas.openxmlformats.org/presentationml/2006/main">
+  <p:cSld name="Slide 13">
+    <p:bg>
+      <p:bgPr>
+        <a:solidFill>
+          <a:srgbClr val="0F1B2D"/>
+        </a:solidFill>
+      </p:bgPr>
+    </p:bg>
+    <p:spTree>
+      <p:nvGrpSpPr>
+        <p:cNvPr id="1" name=""/>
+        <p:cNvGrpSpPr/>
+        <p:nvPr/>
+      </p:nvGrpSpPr>
+      <p:grpSpPr>
+        <a:xfrm>
+          <a:off x="0" y="0"/>
+          <a:ext cx="0" cy="0"/>
+          <a:chOff x="0" y="0"/>
+          <a:chExt cx="0" cy="0"/>
+        </a:xfrm>
+      </p:grpSpPr>
+      <p:sp>
+        <p:nvSpPr>
+          <p:cNvPr id="2" name="Text 0"/>
+          <p:cNvSpPr txBox="1"/>
+          <p:nvPr/>
+        </p:nvSpPr>
+        <p:spPr>
+          <a:xfrm>
+            <a:off x="457200" y="320040"/>
+            <a:ext cx="8229600" cy="731520"/>
+          </a:xfrm>
+          <a:prstGeom prst="rect">
+            <a:avLst/>
+          </a:prstGeom>
+          <a:noFill/>
+          <a:ln/>
+        </p:spPr>
+        <p:txBody>
+          <a:bodyPr wrap="square" lIns="0" tIns="0" rIns="0" bIns="0" rtlCol="0" anchor="ctr"/>
+          <a:lstStyle/>
+          <a:p>
+            <a:pPr indent="0" marL="0">
+              <a:buNone/>
+            </a:pPr>
+            <a:r>
+              <a:rPr lang="en-US" sz="2600" b="1" dirty="0">
+                <a:solidFill>
+                  <a:srgbClr val="FFFFFF"/>
+                </a:solidFill>
+                <a:latin typeface="Cambria" pitchFamily="34" charset="0"/>
+                <a:ea typeface="Cambria" pitchFamily="34" charset="-122"/>
+                <a:cs typeface="Cambria" pitchFamily="34" charset="-120"/>
+              </a:rPr>
+              <a:t>Key takeaways and partnership opportunities</a:t>
+            </a:r>
+            <a:endParaRPr lang="en-US" sz="2600" dirty="0"/>
+          </a:p>
+        </p:txBody>
+      </p:sp>
+      <p:sp>
+        <p:nvSpPr>
+          <p:cNvPr id="3" name="Shape 1"/>
+          <p:cNvSpPr/>
+          <p:nvPr/>
+        </p:nvSpPr>
+        <p:spPr>
+          <a:xfrm>
+            <a:off x="457200" y="1234440"/>
+            <a:ext cx="457200" cy="457200"/>
+          </a:xfrm>
+          <a:prstGeom prst="ellipse">
+            <a:avLst/>
+          </a:prstGeom>
+          <a:solidFill>
+            <a:srgbClr val="C8742B"/>
+          </a:solidFill>
+          <a:ln w="12700">
+            <a:solidFill>
+              <a:srgbClr val="C8742B"/>
+            </a:solidFill>
+            <a:prstDash val="solid"/>
+          </a:ln>
+        </p:spPr>
+      </p:sp>
+      <p:sp>
+        <p:nvSpPr>
+          <p:cNvPr id="4" name="Text 2"/>
+          <p:cNvSpPr txBox="1"/>
+          <p:nvPr/>
+        </p:nvSpPr>
+        <p:spPr>
+          <a:xfrm>
+            <a:off x="457200" y="1234440"/>
+            <a:ext cx="457200" cy="457200"/>
+          </a:xfrm>
+          <a:prstGeom prst="rect">
+            <a:avLst/>
+          </a:prstGeom>
+          <a:noFill/>
+          <a:ln/>
+        </p:spPr>
+        <p:txBody>
+          <a:bodyPr wrap="square" lIns="0" tIns="0" rIns="0" bIns="0" rtlCol="0" anchor="ctr"/>
+          <a:lstStyle/>
+          <a:p>
+            <a:pPr algn="ctr" indent="0" marL="0">
+              <a:buNone/>
+            </a:pPr>
+            <a:r>
+              <a:rPr lang="en-US" sz="1400" b="1" dirty="0">
+                <a:solidFill>
+                  <a:srgbClr val="FFFFFF"/>
+                </a:solidFill>
+                <a:latin typeface="Cambria" pitchFamily="34" charset="0"/>
+                <a:ea typeface="Cambria" pitchFamily="34" charset="-122"/>
+                <a:cs typeface="Cambria" pitchFamily="34" charset="-120"/>
+              </a:rPr>
+              <a:t>1</a:t>
+            </a:r>
+            <a:endParaRPr lang="en-US" sz="1400" dirty="0"/>
+          </a:p>
+        </p:txBody>
+      </p:sp>
+      <p:sp>
+        <p:nvSpPr>
+          <p:cNvPr id="5" name="Text 3"/>
+          <p:cNvSpPr txBox="1"/>
+          <p:nvPr/>
+        </p:nvSpPr>
+        <p:spPr>
+          <a:xfrm>
+            <a:off x="1097280" y="1234440"/>
+            <a:ext cx="7589520" cy="457200"/>
+          </a:xfrm>
+          <a:prstGeom prst="rect">
+            <a:avLst/>
+          </a:prstGeom>
+          <a:noFill/>
+          <a:ln/>
+        </p:spPr>
+        <p:txBody>
+          <a:bodyPr wrap="square" lIns="0" tIns="0" rIns="0" bIns="0" rtlCol="0" anchor="ctr"/>
+          <a:lstStyle/>
+          <a:p>
+            <a:pPr indent="0" marL="0">
+              <a:buNone/>
+            </a:pPr>
+            <a:r>
+              <a:rPr lang="en-US" sz="1700" dirty="0">
+                <a:solidFill>
+                  <a:srgbClr val="FFFFFF"/>
+                </a:solidFill>
+                <a:latin typeface="Calibri" pitchFamily="34" charset="0"/>
+                <a:ea typeface="Calibri" pitchFamily="34" charset="-122"/>
+                <a:cs typeface="Calibri" pitchFamily="34" charset="-120"/>
+              </a:rPr>
+              <a:t>Demand growth is long-lived and gas-heavy</a:t>
+            </a:r>
+            <a:endParaRPr lang="en-US" sz="1700" dirty="0"/>
+          </a:p>
+        </p:txBody>
+      </p:sp>
+      <p:sp>
+        <p:nvSpPr>
+          <p:cNvPr id="6" name="Shape 4"/>
+          <p:cNvSpPr/>
+          <p:nvPr/>
+        </p:nvSpPr>
+        <p:spPr>
+          <a:xfrm>
+            <a:off x="457200" y="1920240"/>
+            <a:ext cx="457200" cy="457200"/>
+          </a:xfrm>
+          <a:prstGeom prst="ellipse">
+            <a:avLst/>
+          </a:prstGeom>
+          <a:solidFill>
+            <a:srgbClr val="C8742B"/>
+          </a:solidFill>
+          <a:ln w="12700">
+            <a:solidFill>
+              <a:srgbClr val="C8742B"/>
+            </a:solidFill>
+            <a:prstDash val="solid"/>
+          </a:ln>
+        </p:spPr>
+      </p:sp>
+      <p:sp>
+        <p:nvSpPr>
+          <p:cNvPr id="7" name="Text 5"/>
+          <p:cNvSpPr txBox="1"/>
+          <p:nvPr/>
+        </p:nvSpPr>
+        <p:spPr>
+          <a:xfrm>
+            <a:off x="457200" y="1920240"/>
+            <a:ext cx="457200" cy="457200"/>
+          </a:xfrm>
+          <a:prstGeom prst="rect">
+            <a:avLst/>
+          </a:prstGeom>
+          <a:noFill/>
+          <a:ln/>
+        </p:spPr>
+        <p:txBody>
+          <a:bodyPr wrap="square" lIns="0" tIns="0" rIns="0" bIns="0" rtlCol="0" anchor="ctr"/>
+          <a:lstStyle/>
+          <a:p>
+            <a:pPr algn="ctr" indent="0" marL="0">
+              <a:buNone/>
+            </a:pPr>
+            <a:r>
+              <a:rPr lang="en-US" sz="1400" b="1" dirty="0">
+                <a:solidFill>
+                  <a:srgbClr val="FFFFFF"/>
+                </a:solidFill>
+                <a:latin typeface="Cambria" pitchFamily="34" charset="0"/>
+                <a:ea typeface="Cambria" pitchFamily="34" charset="-122"/>
+                <a:cs typeface="Cambria" pitchFamily="34" charset="-120"/>
+              </a:rPr>
+              <a:t>2</a:t>
+            </a:r>
+            <a:endParaRPr lang="en-US" sz="1400" dirty="0"/>
+          </a:p>
+        </p:txBody>
+      </p:sp>
+      <p:sp>
+        <p:nvSpPr>
+          <p:cNvPr id="8" name="Text 6"/>
+          <p:cNvSpPr txBox="1"/>
+          <p:nvPr/>
+        </p:nvSpPr>
+        <p:spPr>
+          <a:xfrm>
+            <a:off x="1097280" y="1920240"/>
+            <a:ext cx="7589520" cy="457200"/>
+          </a:xfrm>
+          <a:prstGeom prst="rect">
+            <a:avLst/>
+          </a:prstGeom>
+          <a:noFill/>
+          <a:ln/>
+        </p:spPr>
+        <p:txBody>
+          <a:bodyPr wrap="square" lIns="0" tIns="0" rIns="0" bIns="0" rtlCol="0" anchor="ctr"/>
+          <a:lstStyle/>
+          <a:p>
+            <a:pPr indent="0" marL="0">
+              <a:buNone/>
+            </a:pPr>
+            <a:r>
+              <a:rPr lang="en-US" sz="1700" dirty="0">
+                <a:solidFill>
+                  <a:srgbClr val="FFFFFF"/>
+                </a:solidFill>
+                <a:latin typeface="Calibri" pitchFamily="34" charset="0"/>
+                <a:ea typeface="Calibri" pitchFamily="34" charset="-122"/>
+                <a:cs typeface="Calibri" pitchFamily="34" charset="-120"/>
+              </a:rPr>
+              <a:t>Southwire is strong across the plant, and on the OEM side</a:t>
+            </a:r>
+            <a:endParaRPr lang="en-US" sz="1700" dirty="0"/>
+          </a:p>
+        </p:txBody>
+      </p:sp>
+      <p:sp>
+        <p:nvSpPr>
+          <p:cNvPr id="9" name="Shape 7"/>
+          <p:cNvSpPr/>
+          <p:nvPr/>
+        </p:nvSpPr>
+        <p:spPr>
+          <a:xfrm>
+            <a:off x="457200" y="2606040"/>
+            <a:ext cx="457200" cy="457200"/>
+          </a:xfrm>
+          <a:prstGeom prst="ellipse">
+            <a:avLst/>
+          </a:prstGeom>
+          <a:solidFill>
+            <a:srgbClr val="C8742B"/>
+          </a:solidFill>
+          <a:ln w="12700">
+            <a:solidFill>
+              <a:srgbClr val="C8742B"/>
+            </a:solidFill>
+            <a:prstDash val="solid"/>
+          </a:ln>
+        </p:spPr>
+      </p:sp>
+      <p:sp>
+        <p:nvSpPr>
+          <p:cNvPr id="10" name="Text 8"/>
+          <p:cNvSpPr txBox="1"/>
+          <p:nvPr/>
+        </p:nvSpPr>
+        <p:spPr>
+          <a:xfrm>
+            <a:off x="457200" y="2606040"/>
+            <a:ext cx="457200" cy="457200"/>
+          </a:xfrm>
+          <a:prstGeom prst="rect">
+            <a:avLst/>
+          </a:prstGeom>
+          <a:noFill/>
+          <a:ln/>
+        </p:spPr>
+        <p:txBody>
+          <a:bodyPr wrap="square" lIns="0" tIns="0" rIns="0" bIns="0" rtlCol="0" anchor="ctr"/>
+          <a:lstStyle/>
+          <a:p>
+            <a:pPr algn="ctr" indent="0" marL="0">
+              <a:buNone/>
+            </a:pPr>
+            <a:r>
+              <a:rPr lang="en-US" sz="1400" b="1" dirty="0">
+                <a:solidFill>
+                  <a:srgbClr val="FFFFFF"/>
+                </a:solidFill>
+                <a:latin typeface="Cambria" pitchFamily="34" charset="0"/>
+                <a:ea typeface="Cambria" pitchFamily="34" charset="-122"/>
+                <a:cs typeface="Cambria" pitchFamily="34" charset="-120"/>
+              </a:rPr>
+              <a:t>3</a:t>
+            </a:r>
+            <a:endParaRPr lang="en-US" sz="1400" dirty="0"/>
+          </a:p>
+        </p:txBody>
+      </p:sp>
+      <p:sp>
+        <p:nvSpPr>
+          <p:cNvPr id="11" name="Text 9"/>
+          <p:cNvSpPr txBox="1"/>
+          <p:nvPr/>
+        </p:nvSpPr>
+        <p:spPr>
+          <a:xfrm>
+            <a:off x="1097280" y="2606040"/>
+            <a:ext cx="7589520" cy="457200"/>
+          </a:xfrm>
+          <a:prstGeom prst="rect">
+            <a:avLst/>
+          </a:prstGeom>
+          <a:noFill/>
+          <a:ln/>
+        </p:spPr>
+        <p:txBody>
+          <a:bodyPr wrap="square" lIns="0" tIns="0" rIns="0" bIns="0" rtlCol="0" anchor="ctr"/>
+          <a:lstStyle/>
+          <a:p>
+            <a:pPr indent="0" marL="0">
+              <a:buNone/>
+            </a:pPr>
+            <a:r>
+              <a:rPr lang="en-US" sz="1700" dirty="0">
+                <a:solidFill>
+                  <a:srgbClr val="FFFFFF"/>
+                </a:solidFill>
+                <a:latin typeface="Calibri" pitchFamily="34" charset="0"/>
+                <a:ea typeface="Calibri" pitchFamily="34" charset="-122"/>
+                <a:cs typeface="Calibri" pitchFamily="34" charset="-120"/>
+              </a:rPr>
+              <a:t>A joint plan beats parallel pursuits of the same projects</a:t>
+            </a:r>
+            <a:endParaRPr lang="en-US" sz="1700" dirty="0"/>
+          </a:p>
+        </p:txBody>
+      </p:sp>
+      <p:sp>
+        <p:nvSpPr>
+          <p:cNvPr id="12" name="Shape 10"/>
+          <p:cNvSpPr/>
+          <p:nvPr/>
+        </p:nvSpPr>
+        <p:spPr>
+          <a:xfrm>
+            <a:off x="457200" y="3383280"/>
+            <a:ext cx="8229600" cy="1143000"/>
+          </a:xfrm>
+          <a:prstGeom prst="roundRect">
+            <a:avLst>
+              <a:gd name="adj" fmla="val 8000"/>
+            </a:avLst>
+          </a:prstGeom>
+          <a:solidFill>
+            <a:srgbClr val="C8742B"/>
+          </a:solidFill>
+          <a:ln w="12700">
+            <a:solidFill>
+              <a:srgbClr val="C8742B"/>
+            </a:solidFill>
+            <a:prstDash val="solid"/>
+          </a:ln>
+        </p:spPr>
+      </p:sp>
+      <p:sp>
+        <p:nvSpPr>
+          <p:cNvPr id="13" name="Text 11"/>
+          <p:cNvSpPr txBox="1"/>
+          <p:nvPr/>
+        </p:nvSpPr>
+        <p:spPr>
+          <a:xfrm>
+            <a:off x="685800" y="3456432"/>
+            <a:ext cx="2743200" cy="274320"/>
+          </a:xfrm>
+          <a:prstGeom prst="rect">
+            <a:avLst/>
+          </a:prstGeom>
+          <a:noFill/>
+          <a:ln/>
+        </p:spPr>
+        <p:txBody>
+          <a:bodyPr wrap="square" lIns="0" tIns="0" rIns="0" bIns="0" rtlCol="0" anchor="ctr"/>
+          <a:lstStyle/>
+          <a:p>
+            <a:pPr indent="0" marL="0">
+              <a:buNone/>
+            </a:pPr>
+            <a:r>
+              <a:rPr lang="en-US" sz="1200" b="1" spc="400" kern="0" dirty="0">
+                <a:solidFill>
+                  <a:srgbClr val="FFFFFF"/>
+                </a:solidFill>
+                <a:latin typeface="Calibri" pitchFamily="34" charset="0"/>
+                <a:ea typeface="Calibri" pitchFamily="34" charset="-122"/>
+                <a:cs typeface="Calibri" pitchFamily="34" charset="-120"/>
+              </a:rPr>
+              <a:t>OUR ASK</a:t>
+            </a:r>
+            <a:endParaRPr lang="en-US" sz="1200" dirty="0"/>
+          </a:p>
+        </p:txBody>
+      </p:sp>
+      <p:sp>
+        <p:nvSpPr>
+          <p:cNvPr id="14" name="Text 12"/>
+          <p:cNvSpPr txBox="1"/>
+          <p:nvPr/>
+        </p:nvSpPr>
+        <p:spPr>
+          <a:xfrm>
+            <a:off x="685800" y="3749040"/>
+            <a:ext cx="7772400" cy="685800"/>
+          </a:xfrm>
+          <a:prstGeom prst="rect">
+            <a:avLst/>
+          </a:prstGeom>
+          <a:noFill/>
+          <a:ln/>
+        </p:spPr>
+        <p:txBody>
+          <a:bodyPr wrap="square" lIns="0" tIns="0" rIns="0" bIns="0" rtlCol="0" anchor="t"/>
+          <a:lstStyle/>
+          <a:p>
+            <a:pPr indent="0" marL="0">
+              <a:buNone/>
+            </a:pPr>
+            <a:r>
+              <a:rPr lang="en-US" sz="1800" b="1" dirty="0">
+                <a:solidFill>
+                  <a:srgbClr val="FFFFFF"/>
+                </a:solidFill>
+                <a:latin typeface="Cambria" pitchFamily="34" charset="0"/>
+                <a:ea typeface="Cambria" pitchFamily="34" charset="-122"/>
+                <a:cs typeface="Cambria" pitchFamily="34" charset="-120"/>
+              </a:rPr>
+              <a:t>Loop Southwire into AXE's Gas Power Projects and build a joint strategy around their target list.</a:t>
+            </a:r>
+            <a:endParaRPr lang="en-US" sz="1800" dirty="0"/>
+          </a:p>
+        </p:txBody>
+      </p:sp>
+      <p:sp>
+        <p:nvSpPr>
+          <p:cNvPr id="15" name="Text 13"/>
+          <p:cNvSpPr txBox="1"/>
+          <p:nvPr/>
+        </p:nvSpPr>
+        <p:spPr>
+          <a:xfrm>
+            <a:off x="457200" y="4754880"/>
+            <a:ext cx="5486400" cy="228600"/>
+          </a:xfrm>
+          <a:prstGeom prst="rect">
+            <a:avLst/>
+          </a:prstGeom>
+          <a:noFill/>
+          <a:ln/>
+        </p:spPr>
+        <p:txBody>
+          <a:bodyPr wrap="square" lIns="0" tIns="0" rIns="0" bIns="0" rtlCol="0" anchor="ctr"/>
+          <a:lstStyle/>
+          <a:p>
+            <a:pPr indent="0" marL="0">
+              <a:buNone/>
+            </a:pPr>
+            <a:r>
+              <a:rPr lang="en-US" sz="1000" dirty="0">
+                <a:solidFill>
+                  <a:srgbClr val="9FB0C3"/>
+                </a:solidFill>
+                <a:latin typeface="Calibri" pitchFamily="34" charset="0"/>
+                <a:ea typeface="Calibri" pitchFamily="34" charset="-122"/>
+                <a:cs typeface="Calibri" pitchFamily="34" charset="-120"/>
+              </a:rPr>
+              <a:t>Southwire PowerGen  |  Anixter Global Accounts</a:t>
+            </a:r>
+            <a:endParaRPr lang="en-US" sz="1000" dirty="0"/>
+          </a:p>
+        </p:txBody>
+      </p:sp>
+      <p:sp>
+        <p:nvSpPr>
+          <p:cNvPr id="16" name="Text 14"/>
+          <p:cNvSpPr txBox="1"/>
+          <p:nvPr/>
+        </p:nvSpPr>
+        <p:spPr>
+          <a:xfrm>
+            <a:off x="8229600" y="4754880"/>
+            <a:ext cx="457200" cy="228600"/>
+          </a:xfrm>
+          <a:prstGeom prst="rect">
+            <a:avLst/>
+          </a:prstGeom>
+          <a:noFill/>
+          <a:ln/>
+        </p:spPr>
+        <p:txBody>
+          <a:bodyPr wrap="square" lIns="0" tIns="0" rIns="0" bIns="0" rtlCol="0" anchor="ctr"/>
+          <a:lstStyle/>
+          <a:p>
+            <a:pPr algn="r" indent="0" marL="0">
+              <a:buNone/>
+            </a:pPr>
+            <a:r>
+              <a:rPr lang="en-US" sz="1000" dirty="0">
+                <a:solidFill>
+                  <a:srgbClr val="9FB0C3"/>
+                </a:solidFill>
+                <a:latin typeface="Calibri" pitchFamily="34" charset="0"/>
+                <a:ea typeface="Calibri" pitchFamily="34" charset="-122"/>
+                <a:cs typeface="Calibri" pitchFamily="34" charset="-120"/>
+              </a:rPr>
+              <a:t>13</a:t>
+            </a:r>
+            <a:endParaRPr lang="en-US" sz="1000" dirty="0"/>
+          </a:p>
+        </p:txBody>
+      </p:sp>
+    </p:spTree>
+  </p:cSld>
+  <p:clrMapOvr>
+    <a:masterClrMapping/>
+  </p:clrMapOvr>
+</p:sld>
+</file>
+
+<file path=ppt/slides/slide14.xml><?xml version="1.0" encoding="utf-8"?>
+<p:sld xmlns:a="http://schemas.openxmlformats.org/drawingml/2006/main" xmlns:r="http://schemas.openxmlformats.org/officeDocument/2006/relationships" xmlns:p="http://schemas.openxmlformats.org/presentationml/2006/main">
+  <p:cSld name="Slide 14">
+    <p:bg>
+      <p:bgPr>
+        <a:solidFill>
+          <a:srgbClr val="0F1B2D"/>
+        </a:solidFill>
+      </p:bgPr>
+    </p:bg>
+    <p:spTree>
+      <p:nvGrpSpPr>
+        <p:cNvPr id="1" name=""/>
+        <p:cNvGrpSpPr/>
+        <p:nvPr/>
+      </p:nvGrpSpPr>
+      <p:grpSpPr>
+        <a:xfrm>
+          <a:off x="0" y="0"/>
+          <a:ext cx="0" cy="0"/>
+          <a:chOff x="0" y="0"/>
+          <a:chExt cx="0" cy="0"/>
+        </a:xfrm>
+      </p:grpSpPr>
+      <p:sp>
+        <p:nvSpPr>
+          <p:cNvPr id="2" name="Text 0"/>
+          <p:cNvSpPr txBox="1"/>
+          <p:nvPr/>
+        </p:nvSpPr>
+        <p:spPr>
+          <a:xfrm>
+            <a:off x="548640" y="1737360"/>
+            <a:ext cx="7315200" cy="914400"/>
+          </a:xfrm>
+          <a:prstGeom prst="rect">
+            <a:avLst/>
+          </a:prstGeom>
+          <a:noFill/>
+          <a:ln/>
+        </p:spPr>
+        <p:txBody>
+          <a:bodyPr wrap="square" lIns="0" tIns="0" rIns="0" bIns="0" rtlCol="0" anchor="ctr"/>
+          <a:lstStyle/>
+          <a:p>
+            <a:pPr indent="0" marL="0">
+              <a:buNone/>
+            </a:pPr>
+            <a:r>
+              <a:rPr lang="en-US" sz="4800" b="1" dirty="0">
+                <a:solidFill>
+                  <a:srgbClr val="FFFFFF"/>
+                </a:solidFill>
+                <a:latin typeface="Cambria" pitchFamily="34" charset="0"/>
+                <a:ea typeface="Cambria" pitchFamily="34" charset="-122"/>
+                <a:cs typeface="Cambria" pitchFamily="34" charset="-120"/>
+              </a:rPr>
+              <a:t>Questions</a:t>
+            </a:r>
+            <a:endParaRPr lang="en-US" sz="4800" dirty="0"/>
+          </a:p>
+        </p:txBody>
+      </p:sp>
+      <p:sp>
+        <p:nvSpPr>
+          <p:cNvPr id="3" name="Text 1"/>
+          <p:cNvSpPr txBox="1"/>
+          <p:nvPr/>
+        </p:nvSpPr>
+        <p:spPr>
+          <a:xfrm>
+            <a:off x="548640" y="2743200"/>
+            <a:ext cx="7315200" cy="365760"/>
+          </a:xfrm>
+          <a:prstGeom prst="rect">
+            <a:avLst/>
+          </a:prstGeom>
+          <a:noFill/>
+          <a:ln/>
+        </p:spPr>
+        <p:txBody>
+          <a:bodyPr wrap="square" lIns="0" tIns="0" rIns="0" bIns="0" rtlCol="0" anchor="ctr"/>
+          <a:lstStyle/>
+          <a:p>
+            <a:pPr indent="0" marL="0">
+              <a:buNone/>
+            </a:pPr>
+            <a:r>
+              <a:rPr lang="en-US" sz="1600" dirty="0">
+                <a:solidFill>
+                  <a:srgbClr val="CADCFC"/>
+                </a:solidFill>
+                <a:latin typeface="Calibri" pitchFamily="34" charset="0"/>
+                <a:ea typeface="Calibri" pitchFamily="34" charset="-122"/>
+                <a:cs typeface="Calibri" pitchFamily="34" charset="-120"/>
+              </a:rPr>
+              <a:t>Stephan Hardt  |  Marc Hall  |  Phil Metz  |  Bob</a:t>
+            </a:r>
+            <a:endParaRPr lang="en-US" sz="1600" dirty="0"/>
           </a:p>
         </p:txBody>
       </p:sp>
@@ -5834,1308 +6215,6 @@
 </p:sld>
 </file>
 
-<file path=ppt/slides/slide20.xml><?xml version="1.0" encoding="utf-8"?>
-<p:sld xmlns:a="http://schemas.openxmlformats.org/drawingml/2006/main" xmlns:r="http://schemas.openxmlformats.org/officeDocument/2006/relationships" xmlns:p="http://schemas.openxmlformats.org/presentationml/2006/main">
-  <p:cSld name="Slide 20">
-    <p:bg>
-      <p:bgPr>
-        <a:solidFill>
-          <a:srgbClr val="F4F6F8"/>
-        </a:solidFill>
-      </p:bgPr>
-    </p:bg>
-    <p:spTree>
-      <p:nvGrpSpPr>
-        <p:cNvPr id="1" name=""/>
-        <p:cNvGrpSpPr/>
-        <p:nvPr/>
-      </p:nvGrpSpPr>
-      <p:grpSpPr>
-        <a:xfrm>
-          <a:off x="0" y="0"/>
-          <a:ext cx="0" cy="0"/>
-          <a:chOff x="0" y="0"/>
-          <a:chExt cx="0" cy="0"/>
-        </a:xfrm>
-      </p:grpSpPr>
-      <p:sp>
-        <p:nvSpPr>
-          <p:cNvPr id="2" name="Text 0"/>
-          <p:cNvSpPr txBox="1"/>
-          <p:nvPr/>
-        </p:nvSpPr>
-        <p:spPr>
-          <a:xfrm>
-            <a:off x="457200" y="320040"/>
-            <a:ext cx="8229600" cy="731520"/>
-          </a:xfrm>
-          <a:prstGeom prst="rect">
-            <a:avLst/>
-          </a:prstGeom>
-          <a:noFill/>
-          <a:ln/>
-        </p:spPr>
-        <p:txBody>
-          <a:bodyPr wrap="square" lIns="0" tIns="0" rIns="0" bIns="0" rtlCol="0" anchor="ctr"/>
-          <a:lstStyle/>
-          <a:p>
-            <a:pPr indent="0" marL="0">
-              <a:buNone/>
-            </a:pPr>
-            <a:r>
-              <a:rPr lang="en-US" sz="2600" b="1" dirty="0">
-                <a:solidFill>
-                  <a:srgbClr val="0F1B2D"/>
-                </a:solidFill>
-                <a:latin typeface="Cambria" pitchFamily="34" charset="0"/>
-                <a:ea typeface="Cambria" pitchFamily="34" charset="-122"/>
-                <a:cs typeface="Cambria" pitchFamily="34" charset="-120"/>
-              </a:rPr>
-              <a:t>OEM market: who builds the plant</a:t>
-            </a:r>
-            <a:endParaRPr lang="en-US" sz="2600" dirty="0"/>
-          </a:p>
-        </p:txBody>
-      </p:sp>
-      <p:sp>
-        <p:nvSpPr>
-          <p:cNvPr id="3" name="Shape 1"/>
-          <p:cNvSpPr/>
-          <p:nvPr/>
-        </p:nvSpPr>
-        <p:spPr>
-          <a:xfrm>
-            <a:off x="457200" y="1280160"/>
-            <a:ext cx="3840480" cy="2743200"/>
-          </a:xfrm>
-          <a:prstGeom prst="rect">
-            <a:avLst/>
-          </a:prstGeom>
-          <a:solidFill>
-            <a:srgbClr val="FFFFFF"/>
-          </a:solidFill>
-          <a:ln w="9525">
-            <a:solidFill>
-              <a:srgbClr val="E3E8EE"/>
-            </a:solidFill>
-            <a:prstDash val="solid"/>
-          </a:ln>
-          <a:effectLst>
-            <a:outerShdw sx="100000" sy="100000" kx="0" ky="0" algn="bl" rotWithShape="0" blurRad="76200" dist="25400" dir="5400000">
-              <a:srgbClr val="000000">
-                <a:alpha val="12000"/>
-              </a:srgbClr>
-            </a:outerShdw>
-          </a:effectLst>
-        </p:spPr>
-      </p:sp>
-      <p:sp>
-        <p:nvSpPr>
-          <p:cNvPr id="4" name="Text 2"/>
-          <p:cNvSpPr txBox="1"/>
-          <p:nvPr/>
-        </p:nvSpPr>
-        <p:spPr>
-          <a:xfrm>
-            <a:off x="640080" y="1371600"/>
-            <a:ext cx="3474720" cy="274320"/>
-          </a:xfrm>
-          <a:prstGeom prst="rect">
-            <a:avLst/>
-          </a:prstGeom>
-          <a:noFill/>
-          <a:ln/>
-        </p:spPr>
-        <p:txBody>
-          <a:bodyPr wrap="square" lIns="0" tIns="0" rIns="0" bIns="0" rtlCol="0" anchor="ctr"/>
-          <a:lstStyle/>
-          <a:p>
-            <a:pPr indent="0" marL="0">
-              <a:buNone/>
-            </a:pPr>
-            <a:r>
-              <a:rPr lang="en-US" sz="1400" b="1" dirty="0">
-                <a:solidFill>
-                  <a:srgbClr val="0F1B2D"/>
-                </a:solidFill>
-                <a:latin typeface="Cambria" pitchFamily="34" charset="0"/>
-                <a:ea typeface="Cambria" pitchFamily="34" charset="-122"/>
-                <a:cs typeface="Cambria" pitchFamily="34" charset="-120"/>
-              </a:rPr>
-              <a:t>Large gas turbine backlog (GW)</a:t>
-            </a:r>
-            <a:endParaRPr lang="en-US" sz="1400" dirty="0"/>
-          </a:p>
-        </p:txBody>
-      </p:sp>
-      <p:graphicFrame>
-        <p:nvGraphicFramePr>
-          <p:cNvPr id="5" name="Chart 0" descr=""/>
-          <p:cNvGraphicFramePr/>
-          <p:nvPr/>
-        </p:nvGraphicFramePr>
-        <p:xfrm>
-          <a:off x="548640" y="1691640"/>
-          <a:ext cx="3657600" cy="2240280"/>
-        </p:xfrm>
-        <a:graphic xmlns:a="http://schemas.openxmlformats.org/drawingml/2006/main">
-          <a:graphicData uri="http://schemas.openxmlformats.org/drawingml/2006/chart">
-            <c:chart xmlns:c="http://schemas.openxmlformats.org/drawingml/2006/chart" r:id="rId1"/>
-          </a:graphicData>
-        </a:graphic>
-      </p:graphicFrame>
-      <p:sp>
-        <p:nvSpPr>
-          <p:cNvPr id="6" name="Shape 3"/>
-          <p:cNvSpPr/>
-          <p:nvPr/>
-        </p:nvSpPr>
-        <p:spPr>
-          <a:xfrm>
-            <a:off x="4572000" y="1280160"/>
-            <a:ext cx="4114800" cy="822960"/>
-          </a:xfrm>
-          <a:prstGeom prst="rect">
-            <a:avLst/>
-          </a:prstGeom>
-          <a:solidFill>
-            <a:srgbClr val="FFFFFF"/>
-          </a:solidFill>
-          <a:ln w="9525">
-            <a:solidFill>
-              <a:srgbClr val="E3E8EE"/>
-            </a:solidFill>
-            <a:prstDash val="solid"/>
-          </a:ln>
-          <a:effectLst>
-            <a:outerShdw sx="100000" sy="100000" kx="0" ky="0" algn="bl" rotWithShape="0" blurRad="76200" dist="25400" dir="5400000">
-              <a:srgbClr val="000000">
-                <a:alpha val="12000"/>
-              </a:srgbClr>
-            </a:outerShdw>
-          </a:effectLst>
-        </p:spPr>
-      </p:sp>
-      <p:sp>
-        <p:nvSpPr>
-          <p:cNvPr id="7" name="Text 4"/>
-          <p:cNvSpPr txBox="1"/>
-          <p:nvPr/>
-        </p:nvSpPr>
-        <p:spPr>
-          <a:xfrm>
-            <a:off x="4709160" y="1325880"/>
-            <a:ext cx="3840480" cy="731520"/>
-          </a:xfrm>
-          <a:prstGeom prst="rect">
-            <a:avLst/>
-          </a:prstGeom>
-          <a:noFill/>
-          <a:ln/>
-        </p:spPr>
-        <p:txBody>
-          <a:bodyPr wrap="square" lIns="0" tIns="0" rIns="0" bIns="0" rtlCol="0" anchor="ctr"/>
-          <a:lstStyle/>
-          <a:p>
-            <a:pPr indent="0" marL="0">
-              <a:buNone/>
-            </a:pPr>
-            <a:r>
-              <a:rPr lang="en-US" sz="1300" b="1" dirty="0">
-                <a:solidFill>
-                  <a:srgbClr val="0F1B2D"/>
-                </a:solidFill>
-                <a:latin typeface="Cambria" pitchFamily="34" charset="0"/>
-                <a:ea typeface="Cambria" pitchFamily="34" charset="-122"/>
-                <a:cs typeface="Cambria" pitchFamily="34" charset="-120"/>
-              </a:rPr>
-              <a:t>Turbine OEMs</a:t>
-            </a:r>
-            <a:endParaRPr lang="en-US" sz="1300" dirty="0"/>
-          </a:p>
-          <a:p>
-            <a:pPr indent="0" marL="0">
-              <a:buNone/>
-            </a:pPr>
-            <a:r>
-              <a:rPr lang="en-US" sz="1100" dirty="0">
-                <a:solidFill>
-                  <a:srgbClr val="5B6B7F"/>
-                </a:solidFill>
-                <a:latin typeface="Calibri" pitchFamily="34" charset="0"/>
-                <a:ea typeface="Calibri" pitchFamily="34" charset="-122"/>
-                <a:cs typeface="Calibri" pitchFamily="34" charset="-120"/>
-              </a:rPr>
-              <a:t>GE Vernova, Siemens Energy, Mitsubishi Heavy</a:t>
-            </a:r>
-            <a:endParaRPr lang="en-US" sz="1300" dirty="0"/>
-          </a:p>
-          <a:p>
-            <a:pPr indent="0" marL="0">
-              <a:buNone/>
-            </a:pPr>
-            <a:r>
-              <a:rPr lang="en-US" sz="1100" b="1" dirty="0">
-                <a:solidFill>
-                  <a:srgbClr val="C8742B"/>
-                </a:solidFill>
-                <a:latin typeface="Calibri" pitchFamily="34" charset="0"/>
-                <a:ea typeface="Calibri" pitchFamily="34" charset="-122"/>
-                <a:cs typeface="Calibri" pitchFamily="34" charset="-120"/>
-              </a:rPr>
-              <a:t>Southwire: MV, LV and control cable for OEM-built equipment</a:t>
-            </a:r>
-            <a:endParaRPr lang="en-US" sz="1300" dirty="0"/>
-          </a:p>
-        </p:txBody>
-      </p:sp>
-      <p:sp>
-        <p:nvSpPr>
-          <p:cNvPr id="8" name="Shape 5"/>
-          <p:cNvSpPr/>
-          <p:nvPr/>
-        </p:nvSpPr>
-        <p:spPr>
-          <a:xfrm>
-            <a:off x="4572000" y="2240280"/>
-            <a:ext cx="4114800" cy="822960"/>
-          </a:xfrm>
-          <a:prstGeom prst="rect">
-            <a:avLst/>
-          </a:prstGeom>
-          <a:solidFill>
-            <a:srgbClr val="FFFFFF"/>
-          </a:solidFill>
-          <a:ln w="9525">
-            <a:solidFill>
-              <a:srgbClr val="E3E8EE"/>
-            </a:solidFill>
-            <a:prstDash val="solid"/>
-          </a:ln>
-          <a:effectLst>
-            <a:outerShdw sx="100000" sy="100000" kx="0" ky="0" algn="bl" rotWithShape="0" blurRad="76200" dist="25400" dir="5400000">
-              <a:srgbClr val="000000">
-                <a:alpha val="12000"/>
-              </a:srgbClr>
-            </a:outerShdw>
-          </a:effectLst>
-        </p:spPr>
-      </p:sp>
-      <p:sp>
-        <p:nvSpPr>
-          <p:cNvPr id="9" name="Text 6"/>
-          <p:cNvSpPr txBox="1"/>
-          <p:nvPr/>
-        </p:nvSpPr>
-        <p:spPr>
-          <a:xfrm>
-            <a:off x="4709160" y="2286000"/>
-            <a:ext cx="3840480" cy="731520"/>
-          </a:xfrm>
-          <a:prstGeom prst="rect">
-            <a:avLst/>
-          </a:prstGeom>
-          <a:noFill/>
-          <a:ln/>
-        </p:spPr>
-        <p:txBody>
-          <a:bodyPr wrap="square" lIns="0" tIns="0" rIns="0" bIns="0" rtlCol="0" anchor="ctr"/>
-          <a:lstStyle/>
-          <a:p>
-            <a:pPr indent="0" marL="0">
-              <a:buNone/>
-            </a:pPr>
-            <a:r>
-              <a:rPr lang="en-US" sz="1300" b="1" dirty="0">
-                <a:solidFill>
-                  <a:srgbClr val="0F1B2D"/>
-                </a:solidFill>
-                <a:latin typeface="Cambria" pitchFamily="34" charset="0"/>
-                <a:ea typeface="Cambria" pitchFamily="34" charset="-122"/>
-                <a:cs typeface="Cambria" pitchFamily="34" charset="-120"/>
-              </a:rPr>
-              <a:t>Packagers and engine makers</a:t>
-            </a:r>
-            <a:endParaRPr lang="en-US" sz="1300" dirty="0"/>
-          </a:p>
-          <a:p>
-            <a:pPr indent="0" marL="0">
-              <a:buNone/>
-            </a:pPr>
-            <a:r>
-              <a:rPr lang="en-US" sz="1100" dirty="0">
-                <a:solidFill>
-                  <a:srgbClr val="5B6B7F"/>
-                </a:solidFill>
-                <a:latin typeface="Calibri" pitchFamily="34" charset="0"/>
-                <a:ea typeface="Calibri" pitchFamily="34" charset="-122"/>
-                <a:cs typeface="Calibri" pitchFamily="34" charset="-120"/>
-              </a:rPr>
-              <a:t>Solar Turbines (Caterpillar), Wartsila, energy-as-a-service developers</a:t>
-            </a:r>
-            <a:endParaRPr lang="en-US" sz="1300" dirty="0"/>
-          </a:p>
-          <a:p>
-            <a:pPr indent="0" marL="0">
-              <a:buNone/>
-            </a:pPr>
-            <a:r>
-              <a:rPr lang="en-US" sz="1100" b="1" dirty="0">
-                <a:solidFill>
-                  <a:srgbClr val="C8742B"/>
-                </a:solidFill>
-                <a:latin typeface="Calibri" pitchFamily="34" charset="0"/>
-                <a:ea typeface="Calibri" pitchFamily="34" charset="-122"/>
-                <a:cs typeface="Calibri" pitchFamily="34" charset="-120"/>
-              </a:rPr>
-              <a:t>Southwire: packaged and pre-terminated cable</a:t>
-            </a:r>
-            <a:endParaRPr lang="en-US" sz="1300" dirty="0"/>
-          </a:p>
-        </p:txBody>
-      </p:sp>
-      <p:sp>
-        <p:nvSpPr>
-          <p:cNvPr id="10" name="Shape 7"/>
-          <p:cNvSpPr/>
-          <p:nvPr/>
-        </p:nvSpPr>
-        <p:spPr>
-          <a:xfrm>
-            <a:off x="4572000" y="3200400"/>
-            <a:ext cx="4114800" cy="822960"/>
-          </a:xfrm>
-          <a:prstGeom prst="rect">
-            <a:avLst/>
-          </a:prstGeom>
-          <a:solidFill>
-            <a:srgbClr val="0F1B2D"/>
-          </a:solidFill>
-          <a:ln w="9525">
-            <a:solidFill>
-              <a:srgbClr val="0F1B2D"/>
-            </a:solidFill>
-            <a:prstDash val="solid"/>
-          </a:ln>
-          <a:effectLst>
-            <a:outerShdw sx="100000" sy="100000" kx="0" ky="0" algn="bl" rotWithShape="0" blurRad="76200" dist="25400" dir="5400000">
-              <a:srgbClr val="000000">
-                <a:alpha val="12000"/>
-              </a:srgbClr>
-            </a:outerShdw>
-          </a:effectLst>
-        </p:spPr>
-      </p:sp>
-      <p:sp>
-        <p:nvSpPr>
-          <p:cNvPr id="11" name="Text 8"/>
-          <p:cNvSpPr txBox="1"/>
-          <p:nvPr/>
-        </p:nvSpPr>
-        <p:spPr>
-          <a:xfrm>
-            <a:off x="4709160" y="3246120"/>
-            <a:ext cx="3840480" cy="731520"/>
-          </a:xfrm>
-          <a:prstGeom prst="rect">
-            <a:avLst/>
-          </a:prstGeom>
-          <a:noFill/>
-          <a:ln/>
-        </p:spPr>
-        <p:txBody>
-          <a:bodyPr wrap="square" lIns="0" tIns="0" rIns="0" bIns="0" rtlCol="0" anchor="ctr"/>
-          <a:lstStyle/>
-          <a:p>
-            <a:pPr indent="0" marL="0">
-              <a:buNone/>
-            </a:pPr>
-            <a:r>
-              <a:rPr lang="en-US" sz="1300" b="1" dirty="0">
-                <a:solidFill>
-                  <a:srgbClr val="FFFFFF"/>
-                </a:solidFill>
-                <a:latin typeface="Cambria" pitchFamily="34" charset="0"/>
-                <a:ea typeface="Cambria" pitchFamily="34" charset="-122"/>
-                <a:cs typeface="Cambria" pitchFamily="34" charset="-120"/>
-              </a:rPr>
-              <a:t>Data center on-site power</a:t>
-            </a:r>
-            <a:endParaRPr lang="en-US" sz="1300" dirty="0"/>
-          </a:p>
-          <a:p>
-            <a:pPr indent="0" marL="0">
-              <a:buNone/>
-            </a:pPr>
-            <a:r>
-              <a:rPr lang="en-US" sz="1100" dirty="0">
-                <a:solidFill>
-                  <a:srgbClr val="CADCFC"/>
-                </a:solidFill>
-                <a:latin typeface="Calibri" pitchFamily="34" charset="0"/>
-                <a:ea typeface="Calibri" pitchFamily="34" charset="-122"/>
-                <a:cs typeface="Calibri" pitchFamily="34" charset="-120"/>
-              </a:rPr>
-              <a:t>~56 GW planned behind-the-meter, 46 projects</a:t>
-            </a:r>
-            <a:endParaRPr lang="en-US" sz="1300" dirty="0"/>
-          </a:p>
-          <a:p>
-            <a:pPr indent="0" marL="0">
-              <a:buNone/>
-            </a:pPr>
-            <a:r>
-              <a:rPr lang="en-US" sz="1100" b="1" dirty="0">
-                <a:solidFill>
-                  <a:srgbClr val="C8742B"/>
-                </a:solidFill>
-                <a:latin typeface="Calibri" pitchFamily="34" charset="0"/>
-                <a:ea typeface="Calibri" pitchFamily="34" charset="-122"/>
-                <a:cs typeface="Calibri" pitchFamily="34" charset="-120"/>
-              </a:rPr>
-              <a:t>Southwire: full plant cable package</a:t>
-            </a:r>
-            <a:endParaRPr lang="en-US" sz="1300" dirty="0"/>
-          </a:p>
-        </p:txBody>
-      </p:sp>
-      <p:sp>
-        <p:nvSpPr>
-          <p:cNvPr id="12" name="Text 9"/>
-          <p:cNvSpPr txBox="1"/>
-          <p:nvPr/>
-        </p:nvSpPr>
-        <p:spPr>
-          <a:xfrm>
-            <a:off x="457200" y="4114800"/>
-            <a:ext cx="8229600" cy="274320"/>
-          </a:xfrm>
-          <a:prstGeom prst="rect">
-            <a:avLst/>
-          </a:prstGeom>
-          <a:noFill/>
-          <a:ln/>
-        </p:spPr>
-        <p:txBody>
-          <a:bodyPr wrap="square" lIns="0" tIns="0" rIns="0" bIns="0" rtlCol="0" anchor="ctr"/>
-          <a:lstStyle/>
-          <a:p>
-            <a:pPr indent="0" marL="0">
-              <a:buNone/>
-            </a:pPr>
-            <a:r>
-              <a:rPr lang="en-US" sz="1300" i="1" dirty="0">
-                <a:solidFill>
-                  <a:srgbClr val="5B6B7F"/>
-                </a:solidFill>
-                <a:latin typeface="Calibri" pitchFamily="34" charset="0"/>
-                <a:ea typeface="Calibri" pitchFamily="34" charset="-122"/>
-                <a:cs typeface="Calibri" pitchFamily="34" charset="-120"/>
-              </a:rPr>
-              <a:t>Where AXE adds value: logistics, inventory and project coordination for OEMs and packagers (to discuss).</a:t>
-            </a:r>
-            <a:endParaRPr lang="en-US" sz="1300" dirty="0"/>
-          </a:p>
-        </p:txBody>
-      </p:sp>
-      <p:sp>
-        <p:nvSpPr>
-          <p:cNvPr id="13" name="Text 10"/>
-          <p:cNvSpPr txBox="1"/>
-          <p:nvPr/>
-        </p:nvSpPr>
-        <p:spPr>
-          <a:xfrm>
-            <a:off x="457200" y="4462272"/>
-            <a:ext cx="8229600" cy="201168"/>
-          </a:xfrm>
-          <a:prstGeom prst="rect">
-            <a:avLst/>
-          </a:prstGeom>
-          <a:noFill/>
-          <a:ln/>
-        </p:spPr>
-        <p:txBody>
-          <a:bodyPr wrap="square" lIns="0" tIns="0" rIns="0" bIns="0" rtlCol="0" anchor="ctr"/>
-          <a:lstStyle/>
-          <a:p>
-            <a:pPr indent="0" marL="0">
-              <a:buNone/>
-            </a:pPr>
-            <a:r>
-              <a:rPr lang="en-US" sz="900" dirty="0">
-                <a:solidFill>
-                  <a:srgbClr val="5B6B7F"/>
-                </a:solidFill>
-                <a:latin typeface="Calibri" pitchFamily="34" charset="0"/>
-                <a:ea typeface="Calibri" pitchFamily="34" charset="-122"/>
-                <a:cs typeface="Calibri" pitchFamily="34" charset="-120"/>
-              </a:rPr>
-              <a:t>Sources: OEM Q2 2026 reports (GE Vernova, Siemens Energy, Mitsubishi Heavy); Cleanview BTM tracker; press reports.</a:t>
-            </a:r>
-            <a:endParaRPr lang="en-US" sz="900" dirty="0"/>
-          </a:p>
-        </p:txBody>
-      </p:sp>
-      <p:sp>
-        <p:nvSpPr>
-          <p:cNvPr id="14" name="Text 11"/>
-          <p:cNvSpPr txBox="1"/>
-          <p:nvPr/>
-        </p:nvSpPr>
-        <p:spPr>
-          <a:xfrm>
-            <a:off x="457200" y="4754880"/>
-            <a:ext cx="5486400" cy="228600"/>
-          </a:xfrm>
-          <a:prstGeom prst="rect">
-            <a:avLst/>
-          </a:prstGeom>
-          <a:noFill/>
-          <a:ln/>
-        </p:spPr>
-        <p:txBody>
-          <a:bodyPr wrap="square" lIns="0" tIns="0" rIns="0" bIns="0" rtlCol="0" anchor="ctr"/>
-          <a:lstStyle/>
-          <a:p>
-            <a:pPr indent="0" marL="0">
-              <a:buNone/>
-            </a:pPr>
-            <a:r>
-              <a:rPr lang="en-US" sz="1000" dirty="0">
-                <a:solidFill>
-                  <a:srgbClr val="5B6B7F"/>
-                </a:solidFill>
-                <a:latin typeface="Calibri" pitchFamily="34" charset="0"/>
-                <a:ea typeface="Calibri" pitchFamily="34" charset="-122"/>
-                <a:cs typeface="Calibri" pitchFamily="34" charset="-120"/>
-              </a:rPr>
-              <a:t>Southwire PowerGen  |  Anixter Global Accounts</a:t>
-            </a:r>
-            <a:endParaRPr lang="en-US" sz="1000" dirty="0"/>
-          </a:p>
-        </p:txBody>
-      </p:sp>
-      <p:sp>
-        <p:nvSpPr>
-          <p:cNvPr id="15" name="Text 12"/>
-          <p:cNvSpPr txBox="1"/>
-          <p:nvPr/>
-        </p:nvSpPr>
-        <p:spPr>
-          <a:xfrm>
-            <a:off x="8229600" y="4754880"/>
-            <a:ext cx="457200" cy="228600"/>
-          </a:xfrm>
-          <a:prstGeom prst="rect">
-            <a:avLst/>
-          </a:prstGeom>
-          <a:noFill/>
-          <a:ln/>
-        </p:spPr>
-        <p:txBody>
-          <a:bodyPr wrap="square" lIns="0" tIns="0" rIns="0" bIns="0" rtlCol="0" anchor="ctr"/>
-          <a:lstStyle/>
-          <a:p>
-            <a:pPr algn="r" indent="0" marL="0">
-              <a:buNone/>
-            </a:pPr>
-            <a:r>
-              <a:rPr lang="en-US" sz="1000" dirty="0">
-                <a:solidFill>
-                  <a:srgbClr val="5B6B7F"/>
-                </a:solidFill>
-                <a:latin typeface="Calibri" pitchFamily="34" charset="0"/>
-                <a:ea typeface="Calibri" pitchFamily="34" charset="-122"/>
-                <a:cs typeface="Calibri" pitchFamily="34" charset="-120"/>
-              </a:rPr>
-              <a:t>20</a:t>
-            </a:r>
-            <a:endParaRPr lang="en-US" sz="1000" dirty="0"/>
-          </a:p>
-        </p:txBody>
-      </p:sp>
-    </p:spTree>
-  </p:cSld>
-  <p:clrMapOvr>
-    <a:masterClrMapping/>
-  </p:clrMapOvr>
-</p:sld>
-</file>
-
-<file path=ppt/slides/slide21.xml><?xml version="1.0" encoding="utf-8"?>
-<p:sld xmlns:a="http://schemas.openxmlformats.org/drawingml/2006/main" xmlns:r="http://schemas.openxmlformats.org/officeDocument/2006/relationships" xmlns:p="http://schemas.openxmlformats.org/presentationml/2006/main">
-  <p:cSld name="Slide 21">
-    <p:bg>
-      <p:bgPr>
-        <a:solidFill>
-          <a:srgbClr val="0F1B2D"/>
-        </a:solidFill>
-      </p:bgPr>
-    </p:bg>
-    <p:spTree>
-      <p:nvGrpSpPr>
-        <p:cNvPr id="1" name=""/>
-        <p:cNvGrpSpPr/>
-        <p:nvPr/>
-      </p:nvGrpSpPr>
-      <p:grpSpPr>
-        <a:xfrm>
-          <a:off x="0" y="0"/>
-          <a:ext cx="0" cy="0"/>
-          <a:chOff x="0" y="0"/>
-          <a:chExt cx="0" cy="0"/>
-        </a:xfrm>
-      </p:grpSpPr>
-      <p:sp>
-        <p:nvSpPr>
-          <p:cNvPr id="2" name="Text 0"/>
-          <p:cNvSpPr txBox="1"/>
-          <p:nvPr/>
-        </p:nvSpPr>
-        <p:spPr>
-          <a:xfrm>
-            <a:off x="457200" y="320040"/>
-            <a:ext cx="8229600" cy="731520"/>
-          </a:xfrm>
-          <a:prstGeom prst="rect">
-            <a:avLst/>
-          </a:prstGeom>
-          <a:noFill/>
-          <a:ln/>
-        </p:spPr>
-        <p:txBody>
-          <a:bodyPr wrap="square" lIns="0" tIns="0" rIns="0" bIns="0" rtlCol="0" anchor="ctr"/>
-          <a:lstStyle/>
-          <a:p>
-            <a:pPr indent="0" marL="0">
-              <a:buNone/>
-            </a:pPr>
-            <a:r>
-              <a:rPr lang="en-US" sz="2600" b="1" dirty="0">
-                <a:solidFill>
-                  <a:srgbClr val="FFFFFF"/>
-                </a:solidFill>
-                <a:latin typeface="Cambria" pitchFamily="34" charset="0"/>
-                <a:ea typeface="Cambria" pitchFamily="34" charset="-122"/>
-                <a:cs typeface="Cambria" pitchFamily="34" charset="-120"/>
-              </a:rPr>
-              <a:t>Key takeaways and partnership opportunities</a:t>
-            </a:r>
-            <a:endParaRPr lang="en-US" sz="2600" dirty="0"/>
-          </a:p>
-        </p:txBody>
-      </p:sp>
-      <p:sp>
-        <p:nvSpPr>
-          <p:cNvPr id="3" name="Shape 1"/>
-          <p:cNvSpPr/>
-          <p:nvPr/>
-        </p:nvSpPr>
-        <p:spPr>
-          <a:xfrm>
-            <a:off x="457200" y="1234440"/>
-            <a:ext cx="457200" cy="457200"/>
-          </a:xfrm>
-          <a:prstGeom prst="ellipse">
-            <a:avLst/>
-          </a:prstGeom>
-          <a:solidFill>
-            <a:srgbClr val="C8742B"/>
-          </a:solidFill>
-          <a:ln w="12700">
-            <a:solidFill>
-              <a:srgbClr val="C8742B"/>
-            </a:solidFill>
-            <a:prstDash val="solid"/>
-          </a:ln>
-        </p:spPr>
-      </p:sp>
-      <p:sp>
-        <p:nvSpPr>
-          <p:cNvPr id="4" name="Text 2"/>
-          <p:cNvSpPr txBox="1"/>
-          <p:nvPr/>
-        </p:nvSpPr>
-        <p:spPr>
-          <a:xfrm>
-            <a:off x="457200" y="1234440"/>
-            <a:ext cx="457200" cy="457200"/>
-          </a:xfrm>
-          <a:prstGeom prst="rect">
-            <a:avLst/>
-          </a:prstGeom>
-          <a:noFill/>
-          <a:ln/>
-        </p:spPr>
-        <p:txBody>
-          <a:bodyPr wrap="square" lIns="0" tIns="0" rIns="0" bIns="0" rtlCol="0" anchor="ctr"/>
-          <a:lstStyle/>
-          <a:p>
-            <a:pPr algn="ctr" indent="0" marL="0">
-              <a:buNone/>
-            </a:pPr>
-            <a:r>
-              <a:rPr lang="en-US" sz="1400" b="1" dirty="0">
-                <a:solidFill>
-                  <a:srgbClr val="FFFFFF"/>
-                </a:solidFill>
-                <a:latin typeface="Cambria" pitchFamily="34" charset="0"/>
-                <a:ea typeface="Cambria" pitchFamily="34" charset="-122"/>
-                <a:cs typeface="Cambria" pitchFamily="34" charset="-120"/>
-              </a:rPr>
-              <a:t>1</a:t>
-            </a:r>
-            <a:endParaRPr lang="en-US" sz="1400" dirty="0"/>
-          </a:p>
-        </p:txBody>
-      </p:sp>
-      <p:sp>
-        <p:nvSpPr>
-          <p:cNvPr id="5" name="Text 3"/>
-          <p:cNvSpPr txBox="1"/>
-          <p:nvPr/>
-        </p:nvSpPr>
-        <p:spPr>
-          <a:xfrm>
-            <a:off x="1097280" y="1234440"/>
-            <a:ext cx="7589520" cy="457200"/>
-          </a:xfrm>
-          <a:prstGeom prst="rect">
-            <a:avLst/>
-          </a:prstGeom>
-          <a:noFill/>
-          <a:ln/>
-        </p:spPr>
-        <p:txBody>
-          <a:bodyPr wrap="square" lIns="0" tIns="0" rIns="0" bIns="0" rtlCol="0" anchor="ctr"/>
-          <a:lstStyle/>
-          <a:p>
-            <a:pPr indent="0" marL="0">
-              <a:buNone/>
-            </a:pPr>
-            <a:r>
-              <a:rPr lang="en-US" sz="1700" dirty="0">
-                <a:solidFill>
-                  <a:srgbClr val="FFFFFF"/>
-                </a:solidFill>
-                <a:latin typeface="Calibri" pitchFamily="34" charset="0"/>
-                <a:ea typeface="Calibri" pitchFamily="34" charset="-122"/>
-                <a:cs typeface="Calibri" pitchFamily="34" charset="-120"/>
-              </a:rPr>
-              <a:t>Demand growth is long-lived and gas-heavy</a:t>
-            </a:r>
-            <a:endParaRPr lang="en-US" sz="1700" dirty="0"/>
-          </a:p>
-        </p:txBody>
-      </p:sp>
-      <p:sp>
-        <p:nvSpPr>
-          <p:cNvPr id="6" name="Shape 4"/>
-          <p:cNvSpPr/>
-          <p:nvPr/>
-        </p:nvSpPr>
-        <p:spPr>
-          <a:xfrm>
-            <a:off x="457200" y="1920240"/>
-            <a:ext cx="457200" cy="457200"/>
-          </a:xfrm>
-          <a:prstGeom prst="ellipse">
-            <a:avLst/>
-          </a:prstGeom>
-          <a:solidFill>
-            <a:srgbClr val="C8742B"/>
-          </a:solidFill>
-          <a:ln w="12700">
-            <a:solidFill>
-              <a:srgbClr val="C8742B"/>
-            </a:solidFill>
-            <a:prstDash val="solid"/>
-          </a:ln>
-        </p:spPr>
-      </p:sp>
-      <p:sp>
-        <p:nvSpPr>
-          <p:cNvPr id="7" name="Text 5"/>
-          <p:cNvSpPr txBox="1"/>
-          <p:nvPr/>
-        </p:nvSpPr>
-        <p:spPr>
-          <a:xfrm>
-            <a:off x="457200" y="1920240"/>
-            <a:ext cx="457200" cy="457200"/>
-          </a:xfrm>
-          <a:prstGeom prst="rect">
-            <a:avLst/>
-          </a:prstGeom>
-          <a:noFill/>
-          <a:ln/>
-        </p:spPr>
-        <p:txBody>
-          <a:bodyPr wrap="square" lIns="0" tIns="0" rIns="0" bIns="0" rtlCol="0" anchor="ctr"/>
-          <a:lstStyle/>
-          <a:p>
-            <a:pPr algn="ctr" indent="0" marL="0">
-              <a:buNone/>
-            </a:pPr>
-            <a:r>
-              <a:rPr lang="en-US" sz="1400" b="1" dirty="0">
-                <a:solidFill>
-                  <a:srgbClr val="FFFFFF"/>
-                </a:solidFill>
-                <a:latin typeface="Cambria" pitchFamily="34" charset="0"/>
-                <a:ea typeface="Cambria" pitchFamily="34" charset="-122"/>
-                <a:cs typeface="Cambria" pitchFamily="34" charset="-120"/>
-              </a:rPr>
-              <a:t>2</a:t>
-            </a:r>
-            <a:endParaRPr lang="en-US" sz="1400" dirty="0"/>
-          </a:p>
-        </p:txBody>
-      </p:sp>
-      <p:sp>
-        <p:nvSpPr>
-          <p:cNvPr id="8" name="Text 6"/>
-          <p:cNvSpPr txBox="1"/>
-          <p:nvPr/>
-        </p:nvSpPr>
-        <p:spPr>
-          <a:xfrm>
-            <a:off x="1097280" y="1920240"/>
-            <a:ext cx="7589520" cy="457200"/>
-          </a:xfrm>
-          <a:prstGeom prst="rect">
-            <a:avLst/>
-          </a:prstGeom>
-          <a:noFill/>
-          <a:ln/>
-        </p:spPr>
-        <p:txBody>
-          <a:bodyPr wrap="square" lIns="0" tIns="0" rIns="0" bIns="0" rtlCol="0" anchor="ctr"/>
-          <a:lstStyle/>
-          <a:p>
-            <a:pPr indent="0" marL="0">
-              <a:buNone/>
-            </a:pPr>
-            <a:r>
-              <a:rPr lang="en-US" sz="1700" dirty="0">
-                <a:solidFill>
-                  <a:srgbClr val="FFFFFF"/>
-                </a:solidFill>
-                <a:latin typeface="Calibri" pitchFamily="34" charset="0"/>
-                <a:ea typeface="Calibri" pitchFamily="34" charset="-122"/>
-                <a:cs typeface="Calibri" pitchFamily="34" charset="-120"/>
-              </a:rPr>
-              <a:t>Southwire is strong across the plant, and on the OEM side</a:t>
-            </a:r>
-            <a:endParaRPr lang="en-US" sz="1700" dirty="0"/>
-          </a:p>
-        </p:txBody>
-      </p:sp>
-      <p:sp>
-        <p:nvSpPr>
-          <p:cNvPr id="9" name="Shape 7"/>
-          <p:cNvSpPr/>
-          <p:nvPr/>
-        </p:nvSpPr>
-        <p:spPr>
-          <a:xfrm>
-            <a:off x="457200" y="2606040"/>
-            <a:ext cx="457200" cy="457200"/>
-          </a:xfrm>
-          <a:prstGeom prst="ellipse">
-            <a:avLst/>
-          </a:prstGeom>
-          <a:solidFill>
-            <a:srgbClr val="C8742B"/>
-          </a:solidFill>
-          <a:ln w="12700">
-            <a:solidFill>
-              <a:srgbClr val="C8742B"/>
-            </a:solidFill>
-            <a:prstDash val="solid"/>
-          </a:ln>
-        </p:spPr>
-      </p:sp>
-      <p:sp>
-        <p:nvSpPr>
-          <p:cNvPr id="10" name="Text 8"/>
-          <p:cNvSpPr txBox="1"/>
-          <p:nvPr/>
-        </p:nvSpPr>
-        <p:spPr>
-          <a:xfrm>
-            <a:off x="457200" y="2606040"/>
-            <a:ext cx="457200" cy="457200"/>
-          </a:xfrm>
-          <a:prstGeom prst="rect">
-            <a:avLst/>
-          </a:prstGeom>
-          <a:noFill/>
-          <a:ln/>
-        </p:spPr>
-        <p:txBody>
-          <a:bodyPr wrap="square" lIns="0" tIns="0" rIns="0" bIns="0" rtlCol="0" anchor="ctr"/>
-          <a:lstStyle/>
-          <a:p>
-            <a:pPr algn="ctr" indent="0" marL="0">
-              <a:buNone/>
-            </a:pPr>
-            <a:r>
-              <a:rPr lang="en-US" sz="1400" b="1" dirty="0">
-                <a:solidFill>
-                  <a:srgbClr val="FFFFFF"/>
-                </a:solidFill>
-                <a:latin typeface="Cambria" pitchFamily="34" charset="0"/>
-                <a:ea typeface="Cambria" pitchFamily="34" charset="-122"/>
-                <a:cs typeface="Cambria" pitchFamily="34" charset="-120"/>
-              </a:rPr>
-              <a:t>3</a:t>
-            </a:r>
-            <a:endParaRPr lang="en-US" sz="1400" dirty="0"/>
-          </a:p>
-        </p:txBody>
-      </p:sp>
-      <p:sp>
-        <p:nvSpPr>
-          <p:cNvPr id="11" name="Text 9"/>
-          <p:cNvSpPr txBox="1"/>
-          <p:nvPr/>
-        </p:nvSpPr>
-        <p:spPr>
-          <a:xfrm>
-            <a:off x="1097280" y="2606040"/>
-            <a:ext cx="7589520" cy="457200"/>
-          </a:xfrm>
-          <a:prstGeom prst="rect">
-            <a:avLst/>
-          </a:prstGeom>
-          <a:noFill/>
-          <a:ln/>
-        </p:spPr>
-        <p:txBody>
-          <a:bodyPr wrap="square" lIns="0" tIns="0" rIns="0" bIns="0" rtlCol="0" anchor="ctr"/>
-          <a:lstStyle/>
-          <a:p>
-            <a:pPr indent="0" marL="0">
-              <a:buNone/>
-            </a:pPr>
-            <a:r>
-              <a:rPr lang="en-US" sz="1700" dirty="0">
-                <a:solidFill>
-                  <a:srgbClr val="FFFFFF"/>
-                </a:solidFill>
-                <a:latin typeface="Calibri" pitchFamily="34" charset="0"/>
-                <a:ea typeface="Calibri" pitchFamily="34" charset="-122"/>
-                <a:cs typeface="Calibri" pitchFamily="34" charset="-120"/>
-              </a:rPr>
-              <a:t>A joint plan beats parallel pursuits of the same projects</a:t>
-            </a:r>
-            <a:endParaRPr lang="en-US" sz="1700" dirty="0"/>
-          </a:p>
-        </p:txBody>
-      </p:sp>
-      <p:sp>
-        <p:nvSpPr>
-          <p:cNvPr id="12" name="Shape 10"/>
-          <p:cNvSpPr/>
-          <p:nvPr/>
-        </p:nvSpPr>
-        <p:spPr>
-          <a:xfrm>
-            <a:off x="457200" y="3383280"/>
-            <a:ext cx="8229600" cy="1143000"/>
-          </a:xfrm>
-          <a:prstGeom prst="roundRect">
-            <a:avLst>
-              <a:gd name="adj" fmla="val 8000"/>
-            </a:avLst>
-          </a:prstGeom>
-          <a:solidFill>
-            <a:srgbClr val="C8742B"/>
-          </a:solidFill>
-          <a:ln w="12700">
-            <a:solidFill>
-              <a:srgbClr val="C8742B"/>
-            </a:solidFill>
-            <a:prstDash val="solid"/>
-          </a:ln>
-        </p:spPr>
-      </p:sp>
-      <p:sp>
-        <p:nvSpPr>
-          <p:cNvPr id="13" name="Text 11"/>
-          <p:cNvSpPr txBox="1"/>
-          <p:nvPr/>
-        </p:nvSpPr>
-        <p:spPr>
-          <a:xfrm>
-            <a:off x="685800" y="3456432"/>
-            <a:ext cx="2743200" cy="274320"/>
-          </a:xfrm>
-          <a:prstGeom prst="rect">
-            <a:avLst/>
-          </a:prstGeom>
-          <a:noFill/>
-          <a:ln/>
-        </p:spPr>
-        <p:txBody>
-          <a:bodyPr wrap="square" lIns="0" tIns="0" rIns="0" bIns="0" rtlCol="0" anchor="ctr"/>
-          <a:lstStyle/>
-          <a:p>
-            <a:pPr indent="0" marL="0">
-              <a:buNone/>
-            </a:pPr>
-            <a:r>
-              <a:rPr lang="en-US" sz="1200" b="1" spc="400" kern="0" dirty="0">
-                <a:solidFill>
-                  <a:srgbClr val="FFFFFF"/>
-                </a:solidFill>
-                <a:latin typeface="Calibri" pitchFamily="34" charset="0"/>
-                <a:ea typeface="Calibri" pitchFamily="34" charset="-122"/>
-                <a:cs typeface="Calibri" pitchFamily="34" charset="-120"/>
-              </a:rPr>
-              <a:t>OUR ASK</a:t>
-            </a:r>
-            <a:endParaRPr lang="en-US" sz="1200" dirty="0"/>
-          </a:p>
-        </p:txBody>
-      </p:sp>
-      <p:sp>
-        <p:nvSpPr>
-          <p:cNvPr id="14" name="Text 12"/>
-          <p:cNvSpPr txBox="1"/>
-          <p:nvPr/>
-        </p:nvSpPr>
-        <p:spPr>
-          <a:xfrm>
-            <a:off x="685800" y="3749040"/>
-            <a:ext cx="7772400" cy="685800"/>
-          </a:xfrm>
-          <a:prstGeom prst="rect">
-            <a:avLst/>
-          </a:prstGeom>
-          <a:noFill/>
-          <a:ln/>
-        </p:spPr>
-        <p:txBody>
-          <a:bodyPr wrap="square" lIns="0" tIns="0" rIns="0" bIns="0" rtlCol="0" anchor="t"/>
-          <a:lstStyle/>
-          <a:p>
-            <a:pPr indent="0" marL="0">
-              <a:buNone/>
-            </a:pPr>
-            <a:r>
-              <a:rPr lang="en-US" sz="1800" b="1" dirty="0">
-                <a:solidFill>
-                  <a:srgbClr val="FFFFFF"/>
-                </a:solidFill>
-                <a:latin typeface="Cambria" pitchFamily="34" charset="0"/>
-                <a:ea typeface="Cambria" pitchFamily="34" charset="-122"/>
-                <a:cs typeface="Cambria" pitchFamily="34" charset="-120"/>
-              </a:rPr>
-              <a:t>Loop Southwire into AXE's Gas Power Projects and build a joint strategy around their target list.</a:t>
-            </a:r>
-            <a:endParaRPr lang="en-US" sz="1800" dirty="0"/>
-          </a:p>
-        </p:txBody>
-      </p:sp>
-      <p:sp>
-        <p:nvSpPr>
-          <p:cNvPr id="15" name="Text 13"/>
-          <p:cNvSpPr txBox="1"/>
-          <p:nvPr/>
-        </p:nvSpPr>
-        <p:spPr>
-          <a:xfrm>
-            <a:off x="457200" y="4754880"/>
-            <a:ext cx="5486400" cy="228600"/>
-          </a:xfrm>
-          <a:prstGeom prst="rect">
-            <a:avLst/>
-          </a:prstGeom>
-          <a:noFill/>
-          <a:ln/>
-        </p:spPr>
-        <p:txBody>
-          <a:bodyPr wrap="square" lIns="0" tIns="0" rIns="0" bIns="0" rtlCol="0" anchor="ctr"/>
-          <a:lstStyle/>
-          <a:p>
-            <a:pPr indent="0" marL="0">
-              <a:buNone/>
-            </a:pPr>
-            <a:r>
-              <a:rPr lang="en-US" sz="1000" dirty="0">
-                <a:solidFill>
-                  <a:srgbClr val="9FB0C3"/>
-                </a:solidFill>
-                <a:latin typeface="Calibri" pitchFamily="34" charset="0"/>
-                <a:ea typeface="Calibri" pitchFamily="34" charset="-122"/>
-                <a:cs typeface="Calibri" pitchFamily="34" charset="-120"/>
-              </a:rPr>
-              <a:t>Southwire PowerGen  |  Anixter Global Accounts</a:t>
-            </a:r>
-            <a:endParaRPr lang="en-US" sz="1000" dirty="0"/>
-          </a:p>
-        </p:txBody>
-      </p:sp>
-      <p:sp>
-        <p:nvSpPr>
-          <p:cNvPr id="16" name="Text 14"/>
-          <p:cNvSpPr txBox="1"/>
-          <p:nvPr/>
-        </p:nvSpPr>
-        <p:spPr>
-          <a:xfrm>
-            <a:off x="8229600" y="4754880"/>
-            <a:ext cx="457200" cy="228600"/>
-          </a:xfrm>
-          <a:prstGeom prst="rect">
-            <a:avLst/>
-          </a:prstGeom>
-          <a:noFill/>
-          <a:ln/>
-        </p:spPr>
-        <p:txBody>
-          <a:bodyPr wrap="square" lIns="0" tIns="0" rIns="0" bIns="0" rtlCol="0" anchor="ctr"/>
-          <a:lstStyle/>
-          <a:p>
-            <a:pPr algn="r" indent="0" marL="0">
-              <a:buNone/>
-            </a:pPr>
-            <a:r>
-              <a:rPr lang="en-US" sz="1000" dirty="0">
-                <a:solidFill>
-                  <a:srgbClr val="9FB0C3"/>
-                </a:solidFill>
-                <a:latin typeface="Calibri" pitchFamily="34" charset="0"/>
-                <a:ea typeface="Calibri" pitchFamily="34" charset="-122"/>
-                <a:cs typeface="Calibri" pitchFamily="34" charset="-120"/>
-              </a:rPr>
-              <a:t>21</a:t>
-            </a:r>
-            <a:endParaRPr lang="en-US" sz="1000" dirty="0"/>
-          </a:p>
-        </p:txBody>
-      </p:sp>
-    </p:spTree>
-  </p:cSld>
-  <p:clrMapOvr>
-    <a:masterClrMapping/>
-  </p:clrMapOvr>
-</p:sld>
-</file>
-
-<file path=ppt/slides/slide22.xml><?xml version="1.0" encoding="utf-8"?>
-<p:sld xmlns:a="http://schemas.openxmlformats.org/drawingml/2006/main" xmlns:r="http://schemas.openxmlformats.org/officeDocument/2006/relationships" xmlns:p="http://schemas.openxmlformats.org/presentationml/2006/main">
-  <p:cSld name="Slide 22">
-    <p:bg>
-      <p:bgPr>
-        <a:solidFill>
-          <a:srgbClr val="0F1B2D"/>
-        </a:solidFill>
-      </p:bgPr>
-    </p:bg>
-    <p:spTree>
-      <p:nvGrpSpPr>
-        <p:cNvPr id="1" name=""/>
-        <p:cNvGrpSpPr/>
-        <p:nvPr/>
-      </p:nvGrpSpPr>
-      <p:grpSpPr>
-        <a:xfrm>
-          <a:off x="0" y="0"/>
-          <a:ext cx="0" cy="0"/>
-          <a:chOff x="0" y="0"/>
-          <a:chExt cx="0" cy="0"/>
-        </a:xfrm>
-      </p:grpSpPr>
-      <p:sp>
-        <p:nvSpPr>
-          <p:cNvPr id="2" name="Text 0"/>
-          <p:cNvSpPr txBox="1"/>
-          <p:nvPr/>
-        </p:nvSpPr>
-        <p:spPr>
-          <a:xfrm>
-            <a:off x="548640" y="1737360"/>
-            <a:ext cx="7315200" cy="914400"/>
-          </a:xfrm>
-          <a:prstGeom prst="rect">
-            <a:avLst/>
-          </a:prstGeom>
-          <a:noFill/>
-          <a:ln/>
-        </p:spPr>
-        <p:txBody>
-          <a:bodyPr wrap="square" lIns="0" tIns="0" rIns="0" bIns="0" rtlCol="0" anchor="ctr"/>
-          <a:lstStyle/>
-          <a:p>
-            <a:pPr indent="0" marL="0">
-              <a:buNone/>
-            </a:pPr>
-            <a:r>
-              <a:rPr lang="en-US" sz="4800" b="1" dirty="0">
-                <a:solidFill>
-                  <a:srgbClr val="FFFFFF"/>
-                </a:solidFill>
-                <a:latin typeface="Cambria" pitchFamily="34" charset="0"/>
-                <a:ea typeface="Cambria" pitchFamily="34" charset="-122"/>
-                <a:cs typeface="Cambria" pitchFamily="34" charset="-120"/>
-              </a:rPr>
-              <a:t>Questions</a:t>
-            </a:r>
-            <a:endParaRPr lang="en-US" sz="4800" dirty="0"/>
-          </a:p>
-        </p:txBody>
-      </p:sp>
-      <p:sp>
-        <p:nvSpPr>
-          <p:cNvPr id="3" name="Text 1"/>
-          <p:cNvSpPr txBox="1"/>
-          <p:nvPr/>
-        </p:nvSpPr>
-        <p:spPr>
-          <a:xfrm>
-            <a:off x="548640" y="2743200"/>
-            <a:ext cx="7315200" cy="365760"/>
-          </a:xfrm>
-          <a:prstGeom prst="rect">
-            <a:avLst/>
-          </a:prstGeom>
-          <a:noFill/>
-          <a:ln/>
-        </p:spPr>
-        <p:txBody>
-          <a:bodyPr wrap="square" lIns="0" tIns="0" rIns="0" bIns="0" rtlCol="0" anchor="ctr"/>
-          <a:lstStyle/>
-          <a:p>
-            <a:pPr indent="0" marL="0">
-              <a:buNone/>
-            </a:pPr>
-            <a:r>
-              <a:rPr lang="en-US" sz="1600" dirty="0">
-                <a:solidFill>
-                  <a:srgbClr val="CADCFC"/>
-                </a:solidFill>
-                <a:latin typeface="Calibri" pitchFamily="34" charset="0"/>
-                <a:ea typeface="Calibri" pitchFamily="34" charset="-122"/>
-                <a:cs typeface="Calibri" pitchFamily="34" charset="-120"/>
-              </a:rPr>
-              <a:t>Stephan Hardt  |  Marc Hall  |  Phil Metz  |  Bob</a:t>
-            </a:r>
-            <a:endParaRPr lang="en-US" sz="1600" dirty="0"/>
-          </a:p>
-        </p:txBody>
-      </p:sp>
-    </p:spTree>
-  </p:cSld>
-  <p:clrMapOvr>
-    <a:masterClrMapping/>
-  </p:clrMapOvr>
-</p:sld>
-</file>
-
 <file path=ppt/slides/slide3.xml><?xml version="1.0" encoding="utf-8"?>
 <p:sld xmlns:a="http://schemas.openxmlformats.org/drawingml/2006/main" xmlns:r="http://schemas.openxmlformats.org/officeDocument/2006/relationships" xmlns:p="http://schemas.openxmlformats.org/presentationml/2006/main">
   <p:cSld name="Slide 3">
@@ -11600,7 +10679,7 @@
     <p:bg>
       <p:bgPr>
         <a:solidFill>
-          <a:srgbClr val="FFFFFF"/>
+          <a:srgbClr val="F4F6F8"/>
         </a:solidFill>
       </p:bgPr>
     </p:bg>
@@ -11618,9 +10697,80 @@
           <a:chExt cx="0" cy="0"/>
         </a:xfrm>
       </p:grpSpPr>
+      <p:sp>
+        <p:nvSpPr>
+          <p:cNvPr id="2" name="Text 0"/>
+          <p:cNvSpPr txBox="1"/>
+          <p:nvPr/>
+        </p:nvSpPr>
+        <p:spPr>
+          <a:xfrm>
+            <a:off x="457200" y="182880"/>
+            <a:ext cx="8229600" cy="548640"/>
+          </a:xfrm>
+          <a:prstGeom prst="rect">
+            <a:avLst/>
+          </a:prstGeom>
+          <a:noFill/>
+          <a:ln/>
+        </p:spPr>
+        <p:txBody>
+          <a:bodyPr wrap="square" lIns="0" tIns="0" rIns="0" bIns="0" rtlCol="0" anchor="ctr"/>
+          <a:lstStyle/>
+          <a:p>
+            <a:pPr indent="0" marL="0">
+              <a:buNone/>
+            </a:pPr>
+            <a:r>
+              <a:rPr lang="en-US" sz="2600" b="1" dirty="0">
+                <a:solidFill>
+                  <a:srgbClr val="0F1B2D"/>
+                </a:solidFill>
+                <a:latin typeface="Cambria" pitchFamily="34" charset="0"/>
+                <a:ea typeface="Cambria" pitchFamily="34" charset="-122"/>
+                <a:cs typeface="Cambria" pitchFamily="34" charset="-120"/>
+              </a:rPr>
+              <a:t>Catalog: generation and process zones</a:t>
+            </a:r>
+            <a:endParaRPr lang="en-US" sz="2600" dirty="0"/>
+          </a:p>
+        </p:txBody>
+      </p:sp>
+      <p:sp>
+        <p:nvSpPr>
+          <p:cNvPr id="3" name="Shape 1"/>
+          <p:cNvSpPr/>
+          <p:nvPr/>
+        </p:nvSpPr>
+        <p:spPr>
+          <a:xfrm>
+            <a:off x="548640" y="868680"/>
+            <a:ext cx="3794760" cy="2020824"/>
+          </a:xfrm>
+          <a:prstGeom prst="rect">
+            <a:avLst/>
+          </a:prstGeom>
+          <a:solidFill>
+            <a:srgbClr val="FFFFFF"/>
+          </a:solidFill>
+          <a:ln w="9525">
+            <a:solidFill>
+              <a:srgbClr val="E3E8EE"/>
+            </a:solidFill>
+            <a:prstDash val="solid"/>
+          </a:ln>
+          <a:effectLst>
+            <a:outerShdw sx="100000" sy="100000" kx="0" ky="0" algn="bl" rotWithShape="0" blurRad="76200" dist="25400" dir="5400000">
+              <a:srgbClr val="000000">
+                <a:alpha val="12000"/>
+              </a:srgbClr>
+            </a:outerShdw>
+          </a:effectLst>
+        </p:spPr>
+      </p:sp>
       <p:pic>
         <p:nvPicPr>
-          <p:cNvPr id="2" name="Image 0" descr="/home/user/ln/presentations/flythrough/cc_p04.jpg">    </p:cNvPr>
+          <p:cNvPr id="4" name="Image 0" descr="/home/user/ln/presentations/catalog/zone_p04.jpg">    </p:cNvPr>
           <p:cNvPicPr>
             <a:picLocks noChangeAspect="1"/>
           </p:cNvPicPr>
@@ -11634,8 +10784,176 @@
         </p:blipFill>
         <p:spPr>
           <a:xfrm>
-            <a:off x="0" y="0"/>
-            <a:ext cx="9144000" cy="5143500"/>
+            <a:off x="548640" y="868680"/>
+            <a:ext cx="3794760" cy="2020824"/>
+          </a:xfrm>
+          <a:prstGeom prst="rect">
+            <a:avLst/>
+          </a:prstGeom>
+        </p:spPr>
+      </p:pic>
+      <p:sp>
+        <p:nvSpPr>
+          <p:cNvPr id="5" name="Shape 2"/>
+          <p:cNvSpPr/>
+          <p:nvPr/>
+        </p:nvSpPr>
+        <p:spPr>
+          <a:xfrm>
+            <a:off x="4526280" y="868680"/>
+            <a:ext cx="3794760" cy="2020824"/>
+          </a:xfrm>
+          <a:prstGeom prst="rect">
+            <a:avLst/>
+          </a:prstGeom>
+          <a:solidFill>
+            <a:srgbClr val="FFFFFF"/>
+          </a:solidFill>
+          <a:ln w="9525">
+            <a:solidFill>
+              <a:srgbClr val="E3E8EE"/>
+            </a:solidFill>
+            <a:prstDash val="solid"/>
+          </a:ln>
+          <a:effectLst>
+            <a:outerShdw sx="100000" sy="100000" kx="0" ky="0" algn="bl" rotWithShape="0" blurRad="76200" dist="25400" dir="5400000">
+              <a:srgbClr val="000000">
+                <a:alpha val="12000"/>
+              </a:srgbClr>
+            </a:outerShdw>
+          </a:effectLst>
+        </p:spPr>
+      </p:sp>
+      <p:pic>
+        <p:nvPicPr>
+          <p:cNvPr id="6" name="Image 1" descr="/home/user/ln/presentations/catalog/zone_p07.jpg">    </p:cNvPr>
+          <p:cNvPicPr>
+            <a:picLocks noChangeAspect="1"/>
+          </p:cNvPicPr>
+          <p:nvPr/>
+        </p:nvPicPr>
+        <p:blipFill>
+          <a:blip r:embed="rId2"/>
+          <a:stretch>
+            <a:fillRect/>
+          </a:stretch>
+        </p:blipFill>
+        <p:spPr>
+          <a:xfrm>
+            <a:off x="4526280" y="868680"/>
+            <a:ext cx="3794760" cy="2020824"/>
+          </a:xfrm>
+          <a:prstGeom prst="rect">
+            <a:avLst/>
+          </a:prstGeom>
+        </p:spPr>
+      </p:pic>
+      <p:sp>
+        <p:nvSpPr>
+          <p:cNvPr id="7" name="Shape 3"/>
+          <p:cNvSpPr/>
+          <p:nvPr/>
+        </p:nvSpPr>
+        <p:spPr>
+          <a:xfrm>
+            <a:off x="548640" y="2999232"/>
+            <a:ext cx="3794760" cy="2020824"/>
+          </a:xfrm>
+          <a:prstGeom prst="rect">
+            <a:avLst/>
+          </a:prstGeom>
+          <a:solidFill>
+            <a:srgbClr val="FFFFFF"/>
+          </a:solidFill>
+          <a:ln w="9525">
+            <a:solidFill>
+              <a:srgbClr val="E3E8EE"/>
+            </a:solidFill>
+            <a:prstDash val="solid"/>
+          </a:ln>
+          <a:effectLst>
+            <a:outerShdw sx="100000" sy="100000" kx="0" ky="0" algn="bl" rotWithShape="0" blurRad="76200" dist="25400" dir="5400000">
+              <a:srgbClr val="000000">
+                <a:alpha val="12000"/>
+              </a:srgbClr>
+            </a:outerShdw>
+          </a:effectLst>
+        </p:spPr>
+      </p:sp>
+      <p:pic>
+        <p:nvPicPr>
+          <p:cNvPr id="8" name="Image 2" descr="/home/user/ln/presentations/catalog/zone_p08.jpg">    </p:cNvPr>
+          <p:cNvPicPr>
+            <a:picLocks noChangeAspect="1"/>
+          </p:cNvPicPr>
+          <p:nvPr/>
+        </p:nvPicPr>
+        <p:blipFill>
+          <a:blip r:embed="rId3"/>
+          <a:stretch>
+            <a:fillRect/>
+          </a:stretch>
+        </p:blipFill>
+        <p:spPr>
+          <a:xfrm>
+            <a:off x="548640" y="2999232"/>
+            <a:ext cx="3794760" cy="2020824"/>
+          </a:xfrm>
+          <a:prstGeom prst="rect">
+            <a:avLst/>
+          </a:prstGeom>
+        </p:spPr>
+      </p:pic>
+      <p:sp>
+        <p:nvSpPr>
+          <p:cNvPr id="9" name="Shape 4"/>
+          <p:cNvSpPr/>
+          <p:nvPr/>
+        </p:nvSpPr>
+        <p:spPr>
+          <a:xfrm>
+            <a:off x="4526280" y="2999232"/>
+            <a:ext cx="3794760" cy="2020824"/>
+          </a:xfrm>
+          <a:prstGeom prst="rect">
+            <a:avLst/>
+          </a:prstGeom>
+          <a:solidFill>
+            <a:srgbClr val="FFFFFF"/>
+          </a:solidFill>
+          <a:ln w="9525">
+            <a:solidFill>
+              <a:srgbClr val="E3E8EE"/>
+            </a:solidFill>
+            <a:prstDash val="solid"/>
+          </a:ln>
+          <a:effectLst>
+            <a:outerShdw sx="100000" sy="100000" kx="0" ky="0" algn="bl" rotWithShape="0" blurRad="76200" dist="25400" dir="5400000">
+              <a:srgbClr val="000000">
+                <a:alpha val="12000"/>
+              </a:srgbClr>
+            </a:outerShdw>
+          </a:effectLst>
+        </p:spPr>
+      </p:sp>
+      <p:pic>
+        <p:nvPicPr>
+          <p:cNvPr id="10" name="Image 3" descr="/home/user/ln/presentations/catalog/zone_p19.jpg">    </p:cNvPr>
+          <p:cNvPicPr>
+            <a:picLocks noChangeAspect="1"/>
+          </p:cNvPicPr>
+          <p:nvPr/>
+        </p:nvPicPr>
+        <p:blipFill>
+          <a:blip r:embed="rId4"/>
+          <a:stretch>
+            <a:fillRect/>
+          </a:stretch>
+        </p:blipFill>
+        <p:spPr>
+          <a:xfrm>
+            <a:off x="4526280" y="2999232"/>
+            <a:ext cx="3794760" cy="2020824"/>
           </a:xfrm>
           <a:prstGeom prst="rect">
             <a:avLst/>

</xml_diff>

<commit_message>
OEM slide: add switchgear and e-house builders and accountability ask
Co-Authored-By: Claude Sonnet 5.5 <noreply@anthropic.com>
Claude-Session: https://claude.ai/code/session_015HKS2PnjCizKc2aENrrpqs
</commit_message>
<xml_diff>
--- a/presentations/Anixter_PowerGen_Presentation_DRAFT.pptx
+++ b/presentations/Anixter_PowerGen_Presentation_DRAFT.pptx
@@ -1010,7 +1010,7 @@
           <a:p>
             <a:r>
               <a:rPr lang="en-US" dirty="0"/>
-              <a:t>Backlogs: GE Vernova 116 GW (June 2026), Siemens Energy 69 GW (June 30), Mitsubishi Heavy 35 GW large-frame (Aug 6). Behind-the-meter figure is from Cleanview via press. Verify before presenting.</a:t>
+              <a:t>Accountability ask: Southwire and AXE agree on named owners, dates and a monthly progress check for switchgear and e-house builders (Powell, Fibrebond, Panelmatic, and the other names Corey mentioned in last Monday's meeting: add them to the tier). Confirm spellings. Backlogs: GE Vernova 116 GW (June 2026), Siemens Energy 69 GW (June 30), Mitsubishi Heavy 35 GW large-frame (Aug 6). Behind-the-meter figure is from Cleanview via press. Verify before presenting.</a:t>
             </a:r>
             <a:endParaRPr lang="en-US" dirty="0"/>
           </a:p>
@@ -3792,7 +3792,7 @@
         <p:spPr>
           <a:xfrm>
             <a:off x="457200" y="1280160"/>
-            <a:ext cx="3840480" cy="2743200"/>
+            <a:ext cx="3840480" cy="2852928"/>
           </a:xfrm>
           <a:prstGeom prst="rect">
             <a:avLst/>
@@ -3879,7 +3879,7 @@
         <p:spPr>
           <a:xfrm>
             <a:off x="4572000" y="1280160"/>
-            <a:ext cx="4114800" cy="822960"/>
+            <a:ext cx="4114800" cy="658368"/>
           </a:xfrm>
           <a:prstGeom prst="rect">
             <a:avLst/>
@@ -3910,8 +3910,8 @@
         </p:nvSpPr>
         <p:spPr>
           <a:xfrm>
-            <a:off x="4709160" y="1325880"/>
-            <a:ext cx="3840480" cy="731520"/>
+            <a:off x="4709160" y="1307592"/>
+            <a:ext cx="3840480" cy="603504"/>
           </a:xfrm>
           <a:prstGeom prst="rect">
             <a:avLst/>
@@ -3969,7 +3969,7 @@
                 <a:ea typeface="Calibri" pitchFamily="34" charset="-122"/>
                 <a:cs typeface="Calibri" pitchFamily="34" charset="-120"/>
               </a:rPr>
-              <a:t>Southwire: MV, LV and control cable for OEM-built equipment</a:t>
+              <a:t>Southwire: cable for OEM-built equipment</a:t>
             </a:r>
             <a:endParaRPr lang="en-US" sz="1300" dirty="0"/>
           </a:p>
@@ -3983,8 +3983,8 @@
         </p:nvSpPr>
         <p:spPr>
           <a:xfrm>
-            <a:off x="4572000" y="2240280"/>
-            <a:ext cx="4114800" cy="822960"/>
+            <a:off x="4572000" y="2011680"/>
+            <a:ext cx="4114800" cy="658368"/>
           </a:xfrm>
           <a:prstGeom prst="rect">
             <a:avLst/>
@@ -4015,8 +4015,8 @@
         </p:nvSpPr>
         <p:spPr>
           <a:xfrm>
-            <a:off x="4709160" y="2286000"/>
-            <a:ext cx="3840480" cy="731520"/>
+            <a:off x="4709160" y="2039112"/>
+            <a:ext cx="3840480" cy="603504"/>
           </a:xfrm>
           <a:prstGeom prst="rect">
             <a:avLst/>
@@ -4057,7 +4057,7 @@
                 <a:ea typeface="Calibri" pitchFamily="34" charset="-122"/>
                 <a:cs typeface="Calibri" pitchFamily="34" charset="-120"/>
               </a:rPr>
-              <a:t>Solar Turbines (Caterpillar), Wartsila, energy-as-a-service developers</a:t>
+              <a:t>Solar Turbines, Wartsila, energy-as-a-service</a:t>
             </a:r>
             <a:endParaRPr lang="en-US" sz="1300" dirty="0"/>
           </a:p>
@@ -4074,7 +4074,7 @@
                 <a:ea typeface="Calibri" pitchFamily="34" charset="-122"/>
                 <a:cs typeface="Calibri" pitchFamily="34" charset="-120"/>
               </a:rPr>
-              <a:t>Southwire: packaged and pre-terminated cable</a:t>
+              <a:t>Southwire: packaged, pre-terminated cable</a:t>
             </a:r>
             <a:endParaRPr lang="en-US" sz="1300" dirty="0"/>
           </a:p>
@@ -4088,8 +4088,113 @@
         </p:nvSpPr>
         <p:spPr>
           <a:xfrm>
-            <a:off x="4572000" y="3200400"/>
-            <a:ext cx="4114800" cy="822960"/>
+            <a:off x="4572000" y="2743200"/>
+            <a:ext cx="4114800" cy="658368"/>
+          </a:xfrm>
+          <a:prstGeom prst="rect">
+            <a:avLst/>
+          </a:prstGeom>
+          <a:solidFill>
+            <a:srgbClr val="FFFFFF"/>
+          </a:solidFill>
+          <a:ln w="9525">
+            <a:solidFill>
+              <a:srgbClr val="E3E8EE"/>
+            </a:solidFill>
+            <a:prstDash val="solid"/>
+          </a:ln>
+          <a:effectLst>
+            <a:outerShdw sx="100000" sy="100000" kx="0" ky="0" algn="bl" rotWithShape="0" blurRad="76200" dist="25400" dir="5400000">
+              <a:srgbClr val="000000">
+                <a:alpha val="12000"/>
+              </a:srgbClr>
+            </a:outerShdw>
+          </a:effectLst>
+        </p:spPr>
+      </p:sp>
+      <p:sp>
+        <p:nvSpPr>
+          <p:cNvPr id="11" name="Text 8"/>
+          <p:cNvSpPr txBox="1"/>
+          <p:nvPr/>
+        </p:nvSpPr>
+        <p:spPr>
+          <a:xfrm>
+            <a:off x="4709160" y="2770632"/>
+            <a:ext cx="3840480" cy="603504"/>
+          </a:xfrm>
+          <a:prstGeom prst="rect">
+            <a:avLst/>
+          </a:prstGeom>
+          <a:noFill/>
+          <a:ln/>
+        </p:spPr>
+        <p:txBody>
+          <a:bodyPr wrap="square" lIns="0" tIns="0" rIns="0" bIns="0" rtlCol="0" anchor="ctr"/>
+          <a:lstStyle/>
+          <a:p>
+            <a:pPr indent="0" marL="0">
+              <a:buNone/>
+            </a:pPr>
+            <a:r>
+              <a:rPr lang="en-US" sz="1300" b="1" dirty="0">
+                <a:solidFill>
+                  <a:srgbClr val="0F1B2D"/>
+                </a:solidFill>
+                <a:latin typeface="Cambria" pitchFamily="34" charset="0"/>
+                <a:ea typeface="Cambria" pitchFamily="34" charset="-122"/>
+                <a:cs typeface="Cambria" pitchFamily="34" charset="-120"/>
+              </a:rPr>
+              <a:t>Switchgear and e-house builders</a:t>
+            </a:r>
+            <a:endParaRPr lang="en-US" sz="1300" dirty="0"/>
+          </a:p>
+          <a:p>
+            <a:pPr indent="0" marL="0">
+              <a:buNone/>
+            </a:pPr>
+            <a:r>
+              <a:rPr lang="en-US" sz="1100" dirty="0">
+                <a:solidFill>
+                  <a:srgbClr val="5B6B7F"/>
+                </a:solidFill>
+                <a:latin typeface="Calibri" pitchFamily="34" charset="0"/>
+                <a:ea typeface="Calibri" pitchFamily="34" charset="-122"/>
+                <a:cs typeface="Calibri" pitchFamily="34" charset="-120"/>
+              </a:rPr>
+              <a:t>Powell, Fibrebond, Panelmatic, others [add]</a:t>
+            </a:r>
+            <a:endParaRPr lang="en-US" sz="1300" dirty="0"/>
+          </a:p>
+          <a:p>
+            <a:pPr indent="0" marL="0">
+              <a:buNone/>
+            </a:pPr>
+            <a:r>
+              <a:rPr lang="en-US" sz="1100" b="1" dirty="0">
+                <a:solidFill>
+                  <a:srgbClr val="C8742B"/>
+                </a:solidFill>
+                <a:latin typeface="Calibri" pitchFamily="34" charset="0"/>
+                <a:ea typeface="Calibri" pitchFamily="34" charset="-122"/>
+                <a:cs typeface="Calibri" pitchFamily="34" charset="-120"/>
+              </a:rPr>
+              <a:t>Southwire: panel, control and power wire</a:t>
+            </a:r>
+            <a:endParaRPr lang="en-US" sz="1300" dirty="0"/>
+          </a:p>
+        </p:txBody>
+      </p:sp>
+      <p:sp>
+        <p:nvSpPr>
+          <p:cNvPr id="12" name="Shape 9"/>
+          <p:cNvSpPr/>
+          <p:nvPr/>
+        </p:nvSpPr>
+        <p:spPr>
+          <a:xfrm>
+            <a:off x="4572000" y="3474720"/>
+            <a:ext cx="4114800" cy="658368"/>
           </a:xfrm>
           <a:prstGeom prst="rect">
             <a:avLst/>
@@ -4114,14 +4219,14 @@
       </p:sp>
       <p:sp>
         <p:nvSpPr>
-          <p:cNvPr id="11" name="Text 8"/>
-          <p:cNvSpPr txBox="1"/>
-          <p:nvPr/>
-        </p:nvSpPr>
-        <p:spPr>
-          <a:xfrm>
-            <a:off x="4709160" y="3246120"/>
-            <a:ext cx="3840480" cy="731520"/>
+          <p:cNvPr id="13" name="Text 10"/>
+          <p:cNvSpPr txBox="1"/>
+          <p:nvPr/>
+        </p:nvSpPr>
+        <p:spPr>
+          <a:xfrm>
+            <a:off x="4709160" y="3502152"/>
+            <a:ext cx="3840480" cy="603504"/>
           </a:xfrm>
           <a:prstGeom prst="rect">
             <a:avLst/>
@@ -4187,13 +4292,13 @@
       </p:sp>
       <p:sp>
         <p:nvSpPr>
-          <p:cNvPr id="12" name="Text 9"/>
-          <p:cNvSpPr txBox="1"/>
-          <p:nvPr/>
-        </p:nvSpPr>
-        <p:spPr>
-          <a:xfrm>
-            <a:off x="457200" y="4114800"/>
+          <p:cNvPr id="14" name="Text 11"/>
+          <p:cNvSpPr txBox="1"/>
+          <p:nvPr/>
+        </p:nvSpPr>
+        <p:spPr>
+          <a:xfrm>
+            <a:off x="457200" y="4206240"/>
             <a:ext cx="8229600" cy="274320"/>
           </a:xfrm>
           <a:prstGeom prst="rect">
@@ -4210,23 +4315,23 @@
               <a:buNone/>
             </a:pPr>
             <a:r>
-              <a:rPr lang="en-US" sz="1300" i="1" dirty="0">
-                <a:solidFill>
-                  <a:srgbClr val="5B6B7F"/>
+              <a:rPr lang="en-US" sz="1200" b="1" dirty="0">
+                <a:solidFill>
+                  <a:srgbClr val="C8742B"/>
                 </a:solidFill>
                 <a:latin typeface="Calibri" pitchFamily="34" charset="0"/>
                 <a:ea typeface="Calibri" pitchFamily="34" charset="-122"/>
                 <a:cs typeface="Calibri" pitchFamily="34" charset="-120"/>
               </a:rPr>
-              <a:t>Where AXE adds value: logistics, inventory and project coordination for OEMs and packagers (to discuss).</a:t>
-            </a:r>
-            <a:endParaRPr lang="en-US" sz="1300" dirty="0"/>
-          </a:p>
-        </p:txBody>
-      </p:sp>
-      <p:sp>
-        <p:nvSpPr>
-          <p:cNvPr id="13" name="Text 10"/>
+              <a:t>Ask of AXE: name an owner per account, set dates for first joint calls, report progress monthly.</a:t>
+            </a:r>
+            <a:endParaRPr lang="en-US" sz="1200" dirty="0"/>
+          </a:p>
+        </p:txBody>
+      </p:sp>
+      <p:sp>
+        <p:nvSpPr>
+          <p:cNvPr id="15" name="Text 12"/>
           <p:cNvSpPr txBox="1"/>
           <p:nvPr/>
         </p:nvSpPr>
@@ -4265,7 +4370,7 @@
       </p:sp>
       <p:sp>
         <p:nvSpPr>
-          <p:cNvPr id="14" name="Text 11"/>
+          <p:cNvPr id="16" name="Text 13"/>
           <p:cNvSpPr txBox="1"/>
           <p:nvPr/>
         </p:nvSpPr>
@@ -4304,7 +4409,7 @@
       </p:sp>
       <p:sp>
         <p:nvSpPr>
-          <p:cNvPr id="15" name="Text 12"/>
+          <p:cNvPr id="17" name="Text 14"/>
           <p:cNvSpPr txBox="1"/>
           <p:nvPr/>
         </p:nvSpPr>

</xml_diff>